<commit_message>
Add SE department logo on every slide; drop personal footer text
Replaces the per-slide footer ("Нестеренко В.В. · ХНУРЕ, ІПЗм-24-1 · 2026")
with the Software Engineering department logo anchored bottom-left, so
every slide carries the chair's branding while keeping the page number
on the right.

Co-Authored-By: Claude Opus 4.7 (1M context) <noreply@anthropic.com>
</commit_message>
<xml_diff>
--- a/thesis/Nesterenko_Presentation.pptx
+++ b/thesis/Nesterenko_Presentation.pptx
@@ -10162,48 +10162,33 @@
           </a:p>
         </p:txBody>
       </p:sp>
-      <p:sp>
-        <p:nvSpPr>
-          <p:cNvPr id="53" name="Text 48"/>
-          <p:cNvSpPr/>
-          <p:nvPr/>
-        </p:nvSpPr>
-        <p:spPr>
-          <a:xfrm>
-            <a:off x="411480" y="4850892"/>
-            <a:ext cx="6858000" cy="228600"/>
-          </a:xfrm>
-          <a:prstGeom prst="rect">
-            <a:avLst/>
-          </a:prstGeom>
-          <a:noFill/>
-          <a:ln/>
-        </p:spPr>
-        <p:txBody>
-          <a:bodyPr wrap="square" lIns="0" tIns="0" rIns="0" bIns="0" rtlCol="0" anchor="ctr"/>
-          <a:lstStyle/>
-          <a:p>
-            <a:pPr algn="l" indent="0" marL="0">
-              <a:buNone/>
-            </a:pPr>
-            <a:r>
-              <a:rPr lang="en-US" sz="900" dirty="0">
-                <a:solidFill>
-                  <a:srgbClr val="64748B"/>
-                </a:solidFill>
-                <a:latin typeface="Calibri" pitchFamily="34" charset="0"/>
-                <a:ea typeface="Calibri" pitchFamily="34" charset="-122"/>
-                <a:cs typeface="Calibri" pitchFamily="34" charset="-120"/>
-              </a:rPr>
-              <a:t>Нестеренко В.В.   ·   ХНУРЕ, ІПЗм-24-1   ·   2026</a:t>
-            </a:r>
-            <a:endParaRPr lang="en-US" sz="900" dirty="0"/>
-          </a:p>
-        </p:txBody>
-      </p:sp>
-      <p:sp>
-        <p:nvSpPr>
-          <p:cNvPr id="54" name="Text 49"/>
+      <p:pic>
+        <p:nvPicPr>
+          <p:cNvPr id="53" name="Image 3" descr="D:\repos\kb-semantic-search-benchmark\thesis\scripts\_logo_hex.png">    </p:cNvPr>
+          <p:cNvPicPr>
+            <a:picLocks noChangeAspect="1"/>
+          </p:cNvPicPr>
+          <p:nvPr/>
+        </p:nvPicPr>
+        <p:blipFill>
+          <a:blip r:embed="rId4"/>
+          <a:stretch>
+            <a:fillRect/>
+          </a:stretch>
+        </p:blipFill>
+        <p:spPr>
+          <a:xfrm>
+            <a:off x="411480" y="4686300"/>
+            <a:ext cx="502920" cy="338328"/>
+          </a:xfrm>
+          <a:prstGeom prst="rect">
+            <a:avLst/>
+          </a:prstGeom>
+        </p:spPr>
+      </p:pic>
+      <p:sp>
+        <p:nvSpPr>
+          <p:cNvPr id="54" name="Text 48"/>
           <p:cNvSpPr/>
           <p:nvPr/>
         </p:nvSpPr>
@@ -11849,48 +11834,33 @@
           </a:p>
         </p:txBody>
       </p:sp>
-      <p:sp>
-        <p:nvSpPr>
-          <p:cNvPr id="47" name="Text 41"/>
-          <p:cNvSpPr/>
-          <p:nvPr/>
-        </p:nvSpPr>
-        <p:spPr>
-          <a:xfrm>
-            <a:off x="411480" y="4850892"/>
-            <a:ext cx="6858000" cy="228600"/>
-          </a:xfrm>
-          <a:prstGeom prst="rect">
-            <a:avLst/>
-          </a:prstGeom>
-          <a:noFill/>
-          <a:ln/>
-        </p:spPr>
-        <p:txBody>
-          <a:bodyPr wrap="square" lIns="0" tIns="0" rIns="0" bIns="0" rtlCol="0" anchor="ctr"/>
-          <a:lstStyle/>
-          <a:p>
-            <a:pPr algn="l" indent="0" marL="0">
-              <a:buNone/>
-            </a:pPr>
-            <a:r>
-              <a:rPr lang="en-US" sz="900" dirty="0">
-                <a:solidFill>
-                  <a:srgbClr val="64748B"/>
-                </a:solidFill>
-                <a:latin typeface="Calibri" pitchFamily="34" charset="0"/>
-                <a:ea typeface="Calibri" pitchFamily="34" charset="-122"/>
-                <a:cs typeface="Calibri" pitchFamily="34" charset="-120"/>
-              </a:rPr>
-              <a:t>Нестеренко В.В.   ·   ХНУРЕ, ІПЗм-24-1   ·   2026</a:t>
-            </a:r>
-            <a:endParaRPr lang="en-US" sz="900" dirty="0"/>
-          </a:p>
-        </p:txBody>
-      </p:sp>
-      <p:sp>
-        <p:nvSpPr>
-          <p:cNvPr id="48" name="Text 42"/>
+      <p:pic>
+        <p:nvPicPr>
+          <p:cNvPr id="47" name="Image 3" descr="D:\repos\kb-semantic-search-benchmark\thesis\scripts\_logo_hex.png">    </p:cNvPr>
+          <p:cNvPicPr>
+            <a:picLocks noChangeAspect="1"/>
+          </p:cNvPicPr>
+          <p:nvPr/>
+        </p:nvPicPr>
+        <p:blipFill>
+          <a:blip r:embed="rId5"/>
+          <a:stretch>
+            <a:fillRect/>
+          </a:stretch>
+        </p:blipFill>
+        <p:spPr>
+          <a:xfrm>
+            <a:off x="411480" y="4686300"/>
+            <a:ext cx="502920" cy="338328"/>
+          </a:xfrm>
+          <a:prstGeom prst="rect">
+            <a:avLst/>
+          </a:prstGeom>
+        </p:spPr>
+      </p:pic>
+      <p:sp>
+        <p:nvSpPr>
+          <p:cNvPr id="48" name="Text 41"/>
           <p:cNvSpPr/>
           <p:nvPr/>
         </p:nvSpPr>
@@ -13537,48 +13507,33 @@
           </a:p>
         </p:txBody>
       </p:sp>
-      <p:sp>
-        <p:nvSpPr>
-          <p:cNvPr id="46" name="Text 41"/>
-          <p:cNvSpPr/>
-          <p:nvPr/>
-        </p:nvSpPr>
-        <p:spPr>
-          <a:xfrm>
-            <a:off x="411480" y="4850892"/>
-            <a:ext cx="6858000" cy="228600"/>
-          </a:xfrm>
-          <a:prstGeom prst="rect">
-            <a:avLst/>
-          </a:prstGeom>
-          <a:noFill/>
-          <a:ln/>
-        </p:spPr>
-        <p:txBody>
-          <a:bodyPr wrap="square" lIns="0" tIns="0" rIns="0" bIns="0" rtlCol="0" anchor="ctr"/>
-          <a:lstStyle/>
-          <a:p>
-            <a:pPr algn="l" indent="0" marL="0">
-              <a:buNone/>
-            </a:pPr>
-            <a:r>
-              <a:rPr lang="en-US" sz="900" dirty="0">
-                <a:solidFill>
-                  <a:srgbClr val="64748B"/>
-                </a:solidFill>
-                <a:latin typeface="Calibri" pitchFamily="34" charset="0"/>
-                <a:ea typeface="Calibri" pitchFamily="34" charset="-122"/>
-                <a:cs typeface="Calibri" pitchFamily="34" charset="-120"/>
-              </a:rPr>
-              <a:t>Нестеренко В.В.   ·   ХНУРЕ, ІПЗм-24-1   ·   2026</a:t>
-            </a:r>
-            <a:endParaRPr lang="en-US" sz="900" dirty="0"/>
-          </a:p>
-        </p:txBody>
-      </p:sp>
-      <p:sp>
-        <p:nvSpPr>
-          <p:cNvPr id="47" name="Text 42"/>
+      <p:pic>
+        <p:nvPicPr>
+          <p:cNvPr id="46" name="Image 3" descr="D:\repos\kb-semantic-search-benchmark\thesis\scripts\_logo_hex.png">    </p:cNvPr>
+          <p:cNvPicPr>
+            <a:picLocks noChangeAspect="1"/>
+          </p:cNvPicPr>
+          <p:nvPr/>
+        </p:nvPicPr>
+        <p:blipFill>
+          <a:blip r:embed="rId4"/>
+          <a:stretch>
+            <a:fillRect/>
+          </a:stretch>
+        </p:blipFill>
+        <p:spPr>
+          <a:xfrm>
+            <a:off x="411480" y="4686300"/>
+            <a:ext cx="502920" cy="338328"/>
+          </a:xfrm>
+          <a:prstGeom prst="rect">
+            <a:avLst/>
+          </a:prstGeom>
+        </p:spPr>
+      </p:pic>
+      <p:sp>
+        <p:nvSpPr>
+          <p:cNvPr id="47" name="Text 41"/>
           <p:cNvSpPr/>
           <p:nvPr/>
         </p:nvSpPr>
@@ -14939,48 +14894,33 @@
           </a:p>
         </p:txBody>
       </p:sp>
-      <p:sp>
-        <p:nvSpPr>
-          <p:cNvPr id="40" name="Text 37"/>
-          <p:cNvSpPr/>
-          <p:nvPr/>
-        </p:nvSpPr>
-        <p:spPr>
-          <a:xfrm>
-            <a:off x="411480" y="4850892"/>
-            <a:ext cx="6858000" cy="228600"/>
-          </a:xfrm>
-          <a:prstGeom prst="rect">
-            <a:avLst/>
-          </a:prstGeom>
-          <a:noFill/>
-          <a:ln/>
-        </p:spPr>
-        <p:txBody>
-          <a:bodyPr wrap="square" lIns="0" tIns="0" rIns="0" bIns="0" rtlCol="0" anchor="ctr"/>
-          <a:lstStyle/>
-          <a:p>
-            <a:pPr algn="l" indent="0" marL="0">
-              <a:buNone/>
-            </a:pPr>
-            <a:r>
-              <a:rPr lang="en-US" sz="900" dirty="0">
-                <a:solidFill>
-                  <a:srgbClr val="64748B"/>
-                </a:solidFill>
-                <a:latin typeface="Calibri" pitchFamily="34" charset="0"/>
-                <a:ea typeface="Calibri" pitchFamily="34" charset="-122"/>
-                <a:cs typeface="Calibri" pitchFamily="34" charset="-120"/>
-              </a:rPr>
-              <a:t>Нестеренко В.В.   ·   ХНУРЕ, ІПЗм-24-1   ·   2026</a:t>
-            </a:r>
-            <a:endParaRPr lang="en-US" sz="900" dirty="0"/>
-          </a:p>
-        </p:txBody>
-      </p:sp>
-      <p:sp>
-        <p:nvSpPr>
-          <p:cNvPr id="41" name="Text 38"/>
+      <p:pic>
+        <p:nvPicPr>
+          <p:cNvPr id="40" name="Image 0" descr="D:\repos\kb-semantic-search-benchmark\thesis\scripts\_logo_hex.png">    </p:cNvPr>
+          <p:cNvPicPr>
+            <a:picLocks noChangeAspect="1"/>
+          </p:cNvPicPr>
+          <p:nvPr/>
+        </p:nvPicPr>
+        <p:blipFill>
+          <a:blip r:embed="rId2"/>
+          <a:stretch>
+            <a:fillRect/>
+          </a:stretch>
+        </p:blipFill>
+        <p:spPr>
+          <a:xfrm>
+            <a:off x="411480" y="4686300"/>
+            <a:ext cx="502920" cy="338328"/>
+          </a:xfrm>
+          <a:prstGeom prst="rect">
+            <a:avLst/>
+          </a:prstGeom>
+        </p:spPr>
+      </p:pic>
+      <p:sp>
+        <p:nvSpPr>
+          <p:cNvPr id="41" name="Text 37"/>
           <p:cNvSpPr/>
           <p:nvPr/>
         </p:nvSpPr>
@@ -15503,48 +15443,33 @@
           </a:graphicData>
         </a:graphic>
       </p:graphicFrame>
-      <p:sp>
-        <p:nvSpPr>
-          <p:cNvPr id="17" name="Text 11"/>
-          <p:cNvSpPr/>
-          <p:nvPr/>
-        </p:nvSpPr>
-        <p:spPr>
-          <a:xfrm>
-            <a:off x="411480" y="4850892"/>
-            <a:ext cx="6858000" cy="228600"/>
-          </a:xfrm>
-          <a:prstGeom prst="rect">
-            <a:avLst/>
-          </a:prstGeom>
-          <a:noFill/>
-          <a:ln/>
-        </p:spPr>
-        <p:txBody>
-          <a:bodyPr wrap="square" lIns="0" tIns="0" rIns="0" bIns="0" rtlCol="0" anchor="ctr"/>
-          <a:lstStyle/>
-          <a:p>
-            <a:pPr algn="l" indent="0" marL="0">
-              <a:buNone/>
-            </a:pPr>
-            <a:r>
-              <a:rPr lang="en-US" sz="900" dirty="0">
-                <a:solidFill>
-                  <a:srgbClr val="64748B"/>
-                </a:solidFill>
-                <a:latin typeface="Calibri" pitchFamily="34" charset="0"/>
-                <a:ea typeface="Calibri" pitchFamily="34" charset="-122"/>
-                <a:cs typeface="Calibri" pitchFamily="34" charset="-120"/>
-              </a:rPr>
-              <a:t>Нестеренко В.В.   ·   ХНУРЕ, ІПЗм-24-1   ·   2026</a:t>
-            </a:r>
-            <a:endParaRPr lang="en-US" sz="900" dirty="0"/>
-          </a:p>
-        </p:txBody>
-      </p:sp>
-      <p:sp>
-        <p:nvSpPr>
-          <p:cNvPr id="18" name="Text 12"/>
+      <p:pic>
+        <p:nvPicPr>
+          <p:cNvPr id="17" name="Image 0" descr="D:\repos\kb-semantic-search-benchmark\thesis\scripts\_logo_hex.png">    </p:cNvPr>
+          <p:cNvPicPr>
+            <a:picLocks noChangeAspect="1"/>
+          </p:cNvPicPr>
+          <p:nvPr/>
+        </p:nvPicPr>
+        <p:blipFill>
+          <a:blip r:embed="rId5"/>
+          <a:stretch>
+            <a:fillRect/>
+          </a:stretch>
+        </p:blipFill>
+        <p:spPr>
+          <a:xfrm>
+            <a:off x="411480" y="4686300"/>
+            <a:ext cx="502920" cy="338328"/>
+          </a:xfrm>
+          <a:prstGeom prst="rect">
+            <a:avLst/>
+          </a:prstGeom>
+        </p:spPr>
+      </p:pic>
+      <p:sp>
+        <p:nvSpPr>
+          <p:cNvPr id="18" name="Text 11"/>
           <p:cNvSpPr/>
           <p:nvPr/>
         </p:nvSpPr>
@@ -16479,48 +16404,33 @@
           </a:graphicData>
         </a:graphic>
       </p:graphicFrame>
-      <p:sp>
-        <p:nvSpPr>
-          <p:cNvPr id="28" name="Text 25"/>
-          <p:cNvSpPr/>
-          <p:nvPr/>
-        </p:nvSpPr>
-        <p:spPr>
-          <a:xfrm>
-            <a:off x="411480" y="4850892"/>
-            <a:ext cx="6858000" cy="228600"/>
-          </a:xfrm>
-          <a:prstGeom prst="rect">
-            <a:avLst/>
-          </a:prstGeom>
-          <a:noFill/>
-          <a:ln/>
-        </p:spPr>
-        <p:txBody>
-          <a:bodyPr wrap="square" lIns="0" tIns="0" rIns="0" bIns="0" rtlCol="0" anchor="ctr"/>
-          <a:lstStyle/>
-          <a:p>
-            <a:pPr algn="l" indent="0" marL="0">
-              <a:buNone/>
-            </a:pPr>
-            <a:r>
-              <a:rPr lang="en-US" sz="900" dirty="0">
-                <a:solidFill>
-                  <a:srgbClr val="64748B"/>
-                </a:solidFill>
-                <a:latin typeface="Calibri" pitchFamily="34" charset="0"/>
-                <a:ea typeface="Calibri" pitchFamily="34" charset="-122"/>
-                <a:cs typeface="Calibri" pitchFamily="34" charset="-120"/>
-              </a:rPr>
-              <a:t>Нестеренко В.В.   ·   ХНУРЕ, ІПЗм-24-1   ·   2026</a:t>
-            </a:r>
-            <a:endParaRPr lang="en-US" sz="900" dirty="0"/>
-          </a:p>
-        </p:txBody>
-      </p:sp>
-      <p:sp>
-        <p:nvSpPr>
-          <p:cNvPr id="29" name="Text 26"/>
+      <p:pic>
+        <p:nvPicPr>
+          <p:cNvPr id="28" name="Image 0" descr="D:\repos\kb-semantic-search-benchmark\thesis\scripts\_logo_hex.png">    </p:cNvPr>
+          <p:cNvPicPr>
+            <a:picLocks noChangeAspect="1"/>
+          </p:cNvPicPr>
+          <p:nvPr/>
+        </p:nvPicPr>
+        <p:blipFill>
+          <a:blip r:embed="rId2"/>
+          <a:stretch>
+            <a:fillRect/>
+          </a:stretch>
+        </p:blipFill>
+        <p:spPr>
+          <a:xfrm>
+            <a:off x="411480" y="4686300"/>
+            <a:ext cx="502920" cy="338328"/>
+          </a:xfrm>
+          <a:prstGeom prst="rect">
+            <a:avLst/>
+          </a:prstGeom>
+        </p:spPr>
+      </p:pic>
+      <p:sp>
+        <p:nvSpPr>
+          <p:cNvPr id="29" name="Text 25"/>
           <p:cNvSpPr/>
           <p:nvPr/>
         </p:nvSpPr>
@@ -17904,48 +17814,33 @@
           </a:p>
         </p:txBody>
       </p:sp>
-      <p:sp>
-        <p:nvSpPr>
-          <p:cNvPr id="40" name="Text 37"/>
-          <p:cNvSpPr/>
-          <p:nvPr/>
-        </p:nvSpPr>
-        <p:spPr>
-          <a:xfrm>
-            <a:off x="411480" y="4850892"/>
-            <a:ext cx="6858000" cy="228600"/>
-          </a:xfrm>
-          <a:prstGeom prst="rect">
-            <a:avLst/>
-          </a:prstGeom>
-          <a:noFill/>
-          <a:ln/>
-        </p:spPr>
-        <p:txBody>
-          <a:bodyPr wrap="square" lIns="0" tIns="0" rIns="0" bIns="0" rtlCol="0" anchor="ctr"/>
-          <a:lstStyle/>
-          <a:p>
-            <a:pPr algn="l" indent="0" marL="0">
-              <a:buNone/>
-            </a:pPr>
-            <a:r>
-              <a:rPr lang="en-US" sz="900" dirty="0">
-                <a:solidFill>
-                  <a:srgbClr val="64748B"/>
-                </a:solidFill>
-                <a:latin typeface="Calibri" pitchFamily="34" charset="0"/>
-                <a:ea typeface="Calibri" pitchFamily="34" charset="-122"/>
-                <a:cs typeface="Calibri" pitchFamily="34" charset="-120"/>
-              </a:rPr>
-              <a:t>Нестеренко В.В.   ·   ХНУРЕ, ІПЗм-24-1   ·   2026</a:t>
-            </a:r>
-            <a:endParaRPr lang="en-US" sz="900" dirty="0"/>
-          </a:p>
-        </p:txBody>
-      </p:sp>
-      <p:sp>
-        <p:nvSpPr>
-          <p:cNvPr id="41" name="Text 38"/>
+      <p:pic>
+        <p:nvPicPr>
+          <p:cNvPr id="40" name="Image 0" descr="D:\repos\kb-semantic-search-benchmark\thesis\scripts\_logo_hex.png">    </p:cNvPr>
+          <p:cNvPicPr>
+            <a:picLocks noChangeAspect="1"/>
+          </p:cNvPicPr>
+          <p:nvPr/>
+        </p:nvPicPr>
+        <p:blipFill>
+          <a:blip r:embed="rId2"/>
+          <a:stretch>
+            <a:fillRect/>
+          </a:stretch>
+        </p:blipFill>
+        <p:spPr>
+          <a:xfrm>
+            <a:off x="411480" y="4686300"/>
+            <a:ext cx="502920" cy="338328"/>
+          </a:xfrm>
+          <a:prstGeom prst="rect">
+            <a:avLst/>
+          </a:prstGeom>
+        </p:spPr>
+      </p:pic>
+      <p:sp>
+        <p:nvSpPr>
+          <p:cNvPr id="41" name="Text 37"/>
           <p:cNvSpPr/>
           <p:nvPr/>
         </p:nvSpPr>
@@ -18909,48 +18804,33 @@
           </a:p>
         </p:txBody>
       </p:sp>
-      <p:sp>
-        <p:nvSpPr>
-          <p:cNvPr id="25" name="Text 23"/>
-          <p:cNvSpPr/>
-          <p:nvPr/>
-        </p:nvSpPr>
-        <p:spPr>
-          <a:xfrm>
-            <a:off x="411480" y="4850892"/>
-            <a:ext cx="6858000" cy="228600"/>
-          </a:xfrm>
-          <a:prstGeom prst="rect">
-            <a:avLst/>
-          </a:prstGeom>
-          <a:noFill/>
-          <a:ln/>
-        </p:spPr>
-        <p:txBody>
-          <a:bodyPr wrap="square" lIns="0" tIns="0" rIns="0" bIns="0" rtlCol="0" anchor="ctr"/>
-          <a:lstStyle/>
-          <a:p>
-            <a:pPr algn="l" indent="0" marL="0">
-              <a:buNone/>
-            </a:pPr>
-            <a:r>
-              <a:rPr lang="en-US" sz="900" dirty="0">
-                <a:solidFill>
-                  <a:srgbClr val="64748B"/>
-                </a:solidFill>
-                <a:latin typeface="Calibri" pitchFamily="34" charset="0"/>
-                <a:ea typeface="Calibri" pitchFamily="34" charset="-122"/>
-                <a:cs typeface="Calibri" pitchFamily="34" charset="-120"/>
-              </a:rPr>
-              <a:t>Нестеренко В.В.   ·   ХНУРЕ, ІПЗм-24-1   ·   2026</a:t>
-            </a:r>
-            <a:endParaRPr lang="en-US" sz="900" dirty="0"/>
-          </a:p>
-        </p:txBody>
-      </p:sp>
-      <p:sp>
-        <p:nvSpPr>
-          <p:cNvPr id="26" name="Text 24"/>
+      <p:pic>
+        <p:nvPicPr>
+          <p:cNvPr id="25" name="Image 0" descr="D:\repos\kb-semantic-search-benchmark\thesis\scripts\_logo_hex.png">    </p:cNvPr>
+          <p:cNvPicPr>
+            <a:picLocks noChangeAspect="1"/>
+          </p:cNvPicPr>
+          <p:nvPr/>
+        </p:nvPicPr>
+        <p:blipFill>
+          <a:blip r:embed="rId1"/>
+          <a:stretch>
+            <a:fillRect/>
+          </a:stretch>
+        </p:blipFill>
+        <p:spPr>
+          <a:xfrm>
+            <a:off x="411480" y="4686300"/>
+            <a:ext cx="502920" cy="338328"/>
+          </a:xfrm>
+          <a:prstGeom prst="rect">
+            <a:avLst/>
+          </a:prstGeom>
+        </p:spPr>
+      </p:pic>
+      <p:sp>
+        <p:nvSpPr>
+          <p:cNvPr id="26" name="Text 23"/>
           <p:cNvSpPr/>
           <p:nvPr/>
         </p:nvSpPr>
@@ -20049,9 +19929,33 @@
           </a:p>
         </p:txBody>
       </p:sp>
-      <p:sp>
-        <p:nvSpPr>
-          <p:cNvPr id="35" name="Text 28"/>
+      <p:pic>
+        <p:nvPicPr>
+          <p:cNvPr id="35" name="Image 5" descr="D:\repos\kb-semantic-search-benchmark\thesis\scripts\_logo_hex.png">    </p:cNvPr>
+          <p:cNvPicPr>
+            <a:picLocks noChangeAspect="1"/>
+          </p:cNvPicPr>
+          <p:nvPr/>
+        </p:nvPicPr>
+        <p:blipFill>
+          <a:blip r:embed="rId6"/>
+          <a:stretch>
+            <a:fillRect/>
+          </a:stretch>
+        </p:blipFill>
+        <p:spPr>
+          <a:xfrm>
+            <a:off x="411480" y="4686300"/>
+            <a:ext cx="502920" cy="338328"/>
+          </a:xfrm>
+          <a:prstGeom prst="rect">
+            <a:avLst/>
+          </a:prstGeom>
+        </p:spPr>
+      </p:pic>
+      <p:sp>
+        <p:nvSpPr>
+          <p:cNvPr id="36" name="Text 28"/>
           <p:cNvSpPr/>
           <p:nvPr/>
         </p:nvSpPr>
@@ -21384,48 +21288,33 @@
           </a:p>
         </p:txBody>
       </p:sp>
-      <p:sp>
-        <p:nvSpPr>
-          <p:cNvPr id="39" name="Text 36"/>
-          <p:cNvSpPr/>
-          <p:nvPr/>
-        </p:nvSpPr>
-        <p:spPr>
-          <a:xfrm>
-            <a:off x="411480" y="4850892"/>
-            <a:ext cx="6858000" cy="228600"/>
-          </a:xfrm>
-          <a:prstGeom prst="rect">
-            <a:avLst/>
-          </a:prstGeom>
-          <a:noFill/>
-          <a:ln/>
-        </p:spPr>
-        <p:txBody>
-          <a:bodyPr wrap="square" lIns="0" tIns="0" rIns="0" bIns="0" rtlCol="0" anchor="ctr"/>
-          <a:lstStyle/>
-          <a:p>
-            <a:pPr algn="l" indent="0" marL="0">
-              <a:buNone/>
-            </a:pPr>
-            <a:r>
-              <a:rPr lang="en-US" sz="900" dirty="0">
-                <a:solidFill>
-                  <a:srgbClr val="64748B"/>
-                </a:solidFill>
-                <a:latin typeface="Calibri" pitchFamily="34" charset="0"/>
-                <a:ea typeface="Calibri" pitchFamily="34" charset="-122"/>
-                <a:cs typeface="Calibri" pitchFamily="34" charset="-120"/>
-              </a:rPr>
-              <a:t>Нестеренко В.В.   ·   ХНУРЕ, ІПЗм-24-1   ·   2026</a:t>
-            </a:r>
-            <a:endParaRPr lang="en-US" sz="900" dirty="0"/>
-          </a:p>
-        </p:txBody>
-      </p:sp>
-      <p:sp>
-        <p:nvSpPr>
-          <p:cNvPr id="40" name="Text 37"/>
+      <p:pic>
+        <p:nvPicPr>
+          <p:cNvPr id="39" name="Image 1" descr="D:\repos\kb-semantic-search-benchmark\thesis\scripts\_logo_hex.png">    </p:cNvPr>
+          <p:cNvPicPr>
+            <a:picLocks noChangeAspect="1"/>
+          </p:cNvPicPr>
+          <p:nvPr/>
+        </p:nvPicPr>
+        <p:blipFill>
+          <a:blip r:embed="rId2"/>
+          <a:stretch>
+            <a:fillRect/>
+          </a:stretch>
+        </p:blipFill>
+        <p:spPr>
+          <a:xfrm>
+            <a:off x="411480" y="4686300"/>
+            <a:ext cx="502920" cy="338328"/>
+          </a:xfrm>
+          <a:prstGeom prst="rect">
+            <a:avLst/>
+          </a:prstGeom>
+        </p:spPr>
+      </p:pic>
+      <p:sp>
+        <p:nvSpPr>
+          <p:cNvPr id="40" name="Text 36"/>
           <p:cNvSpPr/>
           <p:nvPr/>
         </p:nvSpPr>
@@ -23047,48 +22936,33 @@
           </a:p>
         </p:txBody>
       </p:sp>
-      <p:sp>
-        <p:nvSpPr>
-          <p:cNvPr id="41" name="Text 38"/>
-          <p:cNvSpPr/>
-          <p:nvPr/>
-        </p:nvSpPr>
-        <p:spPr>
-          <a:xfrm>
-            <a:off x="411480" y="4850892"/>
-            <a:ext cx="6858000" cy="228600"/>
-          </a:xfrm>
-          <a:prstGeom prst="rect">
-            <a:avLst/>
-          </a:prstGeom>
-          <a:noFill/>
-          <a:ln/>
-        </p:spPr>
-        <p:txBody>
-          <a:bodyPr wrap="square" lIns="0" tIns="0" rIns="0" bIns="0" rtlCol="0" anchor="ctr"/>
-          <a:lstStyle/>
-          <a:p>
-            <a:pPr algn="l" indent="0" marL="0">
-              <a:buNone/>
-            </a:pPr>
-            <a:r>
-              <a:rPr lang="en-US" sz="900" dirty="0">
-                <a:solidFill>
-                  <a:srgbClr val="64748B"/>
-                </a:solidFill>
-                <a:latin typeface="Calibri" pitchFamily="34" charset="0"/>
-                <a:ea typeface="Calibri" pitchFamily="34" charset="-122"/>
-                <a:cs typeface="Calibri" pitchFamily="34" charset="-120"/>
-              </a:rPr>
-              <a:t>Нестеренко В.В.   ·   ХНУРЕ, ІПЗм-24-1   ·   2026</a:t>
-            </a:r>
-            <a:endParaRPr lang="en-US" sz="900" dirty="0"/>
-          </a:p>
-        </p:txBody>
-      </p:sp>
-      <p:sp>
-        <p:nvSpPr>
-          <p:cNvPr id="42" name="Text 39"/>
+      <p:pic>
+        <p:nvPicPr>
+          <p:cNvPr id="41" name="Image 1" descr="D:\repos\kb-semantic-search-benchmark\thesis\scripts\_logo_hex.png">    </p:cNvPr>
+          <p:cNvPicPr>
+            <a:picLocks noChangeAspect="1"/>
+          </p:cNvPicPr>
+          <p:nvPr/>
+        </p:nvPicPr>
+        <p:blipFill>
+          <a:blip r:embed="rId2"/>
+          <a:stretch>
+            <a:fillRect/>
+          </a:stretch>
+        </p:blipFill>
+        <p:spPr>
+          <a:xfrm>
+            <a:off x="411480" y="4686300"/>
+            <a:ext cx="502920" cy="338328"/>
+          </a:xfrm>
+          <a:prstGeom prst="rect">
+            <a:avLst/>
+          </a:prstGeom>
+        </p:spPr>
+      </p:pic>
+      <p:sp>
+        <p:nvSpPr>
+          <p:cNvPr id="42" name="Text 38"/>
           <p:cNvSpPr/>
           <p:nvPr/>
         </p:nvSpPr>
@@ -24352,48 +24226,33 @@
           </a:p>
         </p:txBody>
       </p:sp>
-      <p:sp>
-        <p:nvSpPr>
-          <p:cNvPr id="39" name="Text 37"/>
-          <p:cNvSpPr/>
-          <p:nvPr/>
-        </p:nvSpPr>
-        <p:spPr>
-          <a:xfrm>
-            <a:off x="411480" y="4850892"/>
-            <a:ext cx="6858000" cy="228600"/>
-          </a:xfrm>
-          <a:prstGeom prst="rect">
-            <a:avLst/>
-          </a:prstGeom>
-          <a:noFill/>
-          <a:ln/>
-        </p:spPr>
-        <p:txBody>
-          <a:bodyPr wrap="square" lIns="0" tIns="0" rIns="0" bIns="0" rtlCol="0" anchor="ctr"/>
-          <a:lstStyle/>
-          <a:p>
-            <a:pPr algn="l" indent="0" marL="0">
-              <a:buNone/>
-            </a:pPr>
-            <a:r>
-              <a:rPr lang="en-US" sz="900" dirty="0">
-                <a:solidFill>
-                  <a:srgbClr val="64748B"/>
-                </a:solidFill>
-                <a:latin typeface="Calibri" pitchFamily="34" charset="0"/>
-                <a:ea typeface="Calibri" pitchFamily="34" charset="-122"/>
-                <a:cs typeface="Calibri" pitchFamily="34" charset="-120"/>
-              </a:rPr>
-              <a:t>Нестеренко В.В.   ·   ХНУРЕ, ІПЗм-24-1   ·   2026</a:t>
-            </a:r>
-            <a:endParaRPr lang="en-US" sz="900" dirty="0"/>
-          </a:p>
-        </p:txBody>
-      </p:sp>
-      <p:sp>
-        <p:nvSpPr>
-          <p:cNvPr id="40" name="Text 38"/>
+      <p:pic>
+        <p:nvPicPr>
+          <p:cNvPr id="39" name="Image 0" descr="D:\repos\kb-semantic-search-benchmark\thesis\scripts\_logo_hex.png">    </p:cNvPr>
+          <p:cNvPicPr>
+            <a:picLocks noChangeAspect="1"/>
+          </p:cNvPicPr>
+          <p:nvPr/>
+        </p:nvPicPr>
+        <p:blipFill>
+          <a:blip r:embed="rId1"/>
+          <a:stretch>
+            <a:fillRect/>
+          </a:stretch>
+        </p:blipFill>
+        <p:spPr>
+          <a:xfrm>
+            <a:off x="411480" y="4686300"/>
+            <a:ext cx="502920" cy="338328"/>
+          </a:xfrm>
+          <a:prstGeom prst="rect">
+            <a:avLst/>
+          </a:prstGeom>
+        </p:spPr>
+      </p:pic>
+      <p:sp>
+        <p:nvSpPr>
+          <p:cNvPr id="40" name="Text 37"/>
           <p:cNvSpPr/>
           <p:nvPr/>
         </p:nvSpPr>
@@ -26324,48 +26183,33 @@
           </a:graphicData>
         </a:graphic>
       </p:graphicFrame>
-      <p:sp>
-        <p:nvSpPr>
-          <p:cNvPr id="54" name="Text 50"/>
-          <p:cNvSpPr/>
-          <p:nvPr/>
-        </p:nvSpPr>
-        <p:spPr>
-          <a:xfrm>
-            <a:off x="411480" y="4850892"/>
-            <a:ext cx="6858000" cy="228600"/>
-          </a:xfrm>
-          <a:prstGeom prst="rect">
-            <a:avLst/>
-          </a:prstGeom>
-          <a:noFill/>
-          <a:ln/>
-        </p:spPr>
-        <p:txBody>
-          <a:bodyPr wrap="square" lIns="0" tIns="0" rIns="0" bIns="0" rtlCol="0" anchor="ctr"/>
-          <a:lstStyle/>
-          <a:p>
-            <a:pPr algn="l" indent="0" marL="0">
-              <a:buNone/>
-            </a:pPr>
-            <a:r>
-              <a:rPr lang="en-US" sz="900" dirty="0">
-                <a:solidFill>
-                  <a:srgbClr val="64748B"/>
-                </a:solidFill>
-                <a:latin typeface="Calibri" pitchFamily="34" charset="0"/>
-                <a:ea typeface="Calibri" pitchFamily="34" charset="-122"/>
-                <a:cs typeface="Calibri" pitchFamily="34" charset="-120"/>
-              </a:rPr>
-              <a:t>Нестеренко В.В.   ·   ХНУРЕ, ІПЗм-24-1   ·   2026</a:t>
-            </a:r>
-            <a:endParaRPr lang="en-US" sz="900" dirty="0"/>
-          </a:p>
-        </p:txBody>
-      </p:sp>
-      <p:sp>
-        <p:nvSpPr>
-          <p:cNvPr id="55" name="Text 51"/>
+      <p:pic>
+        <p:nvPicPr>
+          <p:cNvPr id="54" name="Image 0" descr="D:\repos\kb-semantic-search-benchmark\thesis\scripts\_logo_hex.png">    </p:cNvPr>
+          <p:cNvPicPr>
+            <a:picLocks noChangeAspect="1"/>
+          </p:cNvPicPr>
+          <p:nvPr/>
+        </p:nvPicPr>
+        <p:blipFill>
+          <a:blip r:embed="rId3"/>
+          <a:stretch>
+            <a:fillRect/>
+          </a:stretch>
+        </p:blipFill>
+        <p:spPr>
+          <a:xfrm>
+            <a:off x="411480" y="4686300"/>
+            <a:ext cx="502920" cy="338328"/>
+          </a:xfrm>
+          <a:prstGeom prst="rect">
+            <a:avLst/>
+          </a:prstGeom>
+        </p:spPr>
+      </p:pic>
+      <p:sp>
+        <p:nvSpPr>
+          <p:cNvPr id="55" name="Text 50"/>
           <p:cNvSpPr/>
           <p:nvPr/>
         </p:nvSpPr>
@@ -28025,48 +27869,33 @@
           </a:p>
         </p:txBody>
       </p:sp>
-      <p:sp>
-        <p:nvSpPr>
-          <p:cNvPr id="45" name="Text 40"/>
-          <p:cNvSpPr/>
-          <p:nvPr/>
-        </p:nvSpPr>
-        <p:spPr>
-          <a:xfrm>
-            <a:off x="411480" y="4850892"/>
-            <a:ext cx="6858000" cy="228600"/>
-          </a:xfrm>
-          <a:prstGeom prst="rect">
-            <a:avLst/>
-          </a:prstGeom>
-          <a:noFill/>
-          <a:ln/>
-        </p:spPr>
-        <p:txBody>
-          <a:bodyPr wrap="square" lIns="0" tIns="0" rIns="0" bIns="0" rtlCol="0" anchor="ctr"/>
-          <a:lstStyle/>
-          <a:p>
-            <a:pPr algn="l" indent="0" marL="0">
-              <a:buNone/>
-            </a:pPr>
-            <a:r>
-              <a:rPr lang="en-US" sz="900" dirty="0">
-                <a:solidFill>
-                  <a:srgbClr val="64748B"/>
-                </a:solidFill>
-                <a:latin typeface="Calibri" pitchFamily="34" charset="0"/>
-                <a:ea typeface="Calibri" pitchFamily="34" charset="-122"/>
-                <a:cs typeface="Calibri" pitchFamily="34" charset="-120"/>
-              </a:rPr>
-              <a:t>Нестеренко В.В.   ·   ХНУРЕ, ІПЗм-24-1   ·   2026</a:t>
-            </a:r>
-            <a:endParaRPr lang="en-US" sz="900" dirty="0"/>
-          </a:p>
-        </p:txBody>
-      </p:sp>
-      <p:sp>
-        <p:nvSpPr>
-          <p:cNvPr id="46" name="Text 41"/>
+      <p:pic>
+        <p:nvPicPr>
+          <p:cNvPr id="45" name="Image 3" descr="D:\repos\kb-semantic-search-benchmark\thesis\scripts\_logo_hex.png">    </p:cNvPr>
+          <p:cNvPicPr>
+            <a:picLocks noChangeAspect="1"/>
+          </p:cNvPicPr>
+          <p:nvPr/>
+        </p:nvPicPr>
+        <p:blipFill>
+          <a:blip r:embed="rId4"/>
+          <a:stretch>
+            <a:fillRect/>
+          </a:stretch>
+        </p:blipFill>
+        <p:spPr>
+          <a:xfrm>
+            <a:off x="411480" y="4686300"/>
+            <a:ext cx="502920" cy="338328"/>
+          </a:xfrm>
+          <a:prstGeom prst="rect">
+            <a:avLst/>
+          </a:prstGeom>
+        </p:spPr>
+      </p:pic>
+      <p:sp>
+        <p:nvSpPr>
+          <p:cNvPr id="46" name="Text 40"/>
           <p:cNvSpPr/>
           <p:nvPr/>
         </p:nvSpPr>
@@ -29385,48 +29214,33 @@
           </a:p>
         </p:txBody>
       </p:sp>
-      <p:sp>
-        <p:nvSpPr>
-          <p:cNvPr id="37" name="Text 35"/>
-          <p:cNvSpPr/>
-          <p:nvPr/>
-        </p:nvSpPr>
-        <p:spPr>
-          <a:xfrm>
-            <a:off x="411480" y="4850892"/>
-            <a:ext cx="6858000" cy="228600"/>
-          </a:xfrm>
-          <a:prstGeom prst="rect">
-            <a:avLst/>
-          </a:prstGeom>
-          <a:noFill/>
-          <a:ln/>
-        </p:spPr>
-        <p:txBody>
-          <a:bodyPr wrap="square" lIns="0" tIns="0" rIns="0" bIns="0" rtlCol="0" anchor="ctr"/>
-          <a:lstStyle/>
-          <a:p>
-            <a:pPr algn="l" indent="0" marL="0">
-              <a:buNone/>
-            </a:pPr>
-            <a:r>
-              <a:rPr lang="en-US" sz="900" dirty="0">
-                <a:solidFill>
-                  <a:srgbClr val="64748B"/>
-                </a:solidFill>
-                <a:latin typeface="Calibri" pitchFamily="34" charset="0"/>
-                <a:ea typeface="Calibri" pitchFamily="34" charset="-122"/>
-                <a:cs typeface="Calibri" pitchFamily="34" charset="-120"/>
-              </a:rPr>
-              <a:t>Нестеренко В.В.   ·   ХНУРЕ, ІПЗм-24-1   ·   2026</a:t>
-            </a:r>
-            <a:endParaRPr lang="en-US" sz="900" dirty="0"/>
-          </a:p>
-        </p:txBody>
-      </p:sp>
-      <p:sp>
-        <p:nvSpPr>
-          <p:cNvPr id="38" name="Text 36"/>
+      <p:pic>
+        <p:nvPicPr>
+          <p:cNvPr id="37" name="Image 0" descr="D:\repos\kb-semantic-search-benchmark\thesis\scripts\_logo_hex.png">    </p:cNvPr>
+          <p:cNvPicPr>
+            <a:picLocks noChangeAspect="1"/>
+          </p:cNvPicPr>
+          <p:nvPr/>
+        </p:nvPicPr>
+        <p:blipFill>
+          <a:blip r:embed="rId1"/>
+          <a:stretch>
+            <a:fillRect/>
+          </a:stretch>
+        </p:blipFill>
+        <p:spPr>
+          <a:xfrm>
+            <a:off x="411480" y="4686300"/>
+            <a:ext cx="502920" cy="338328"/>
+          </a:xfrm>
+          <a:prstGeom prst="rect">
+            <a:avLst/>
+          </a:prstGeom>
+        </p:spPr>
+      </p:pic>
+      <p:sp>
+        <p:nvSpPr>
+          <p:cNvPr id="38" name="Text 35"/>
           <p:cNvSpPr/>
           <p:nvPr/>
         </p:nvSpPr>
@@ -32085,48 +31899,33 @@
           </a:graphicData>
         </a:graphic>
       </p:graphicFrame>
-      <p:sp>
-        <p:nvSpPr>
-          <p:cNvPr id="31" name="Text 27"/>
-          <p:cNvSpPr/>
-          <p:nvPr/>
-        </p:nvSpPr>
-        <p:spPr>
-          <a:xfrm>
-            <a:off x="411480" y="4850892"/>
-            <a:ext cx="6858000" cy="228600"/>
-          </a:xfrm>
-          <a:prstGeom prst="rect">
-            <a:avLst/>
-          </a:prstGeom>
-          <a:noFill/>
-          <a:ln/>
-        </p:spPr>
-        <p:txBody>
-          <a:bodyPr wrap="square" lIns="0" tIns="0" rIns="0" bIns="0" rtlCol="0" anchor="ctr"/>
-          <a:lstStyle/>
-          <a:p>
-            <a:pPr algn="l" indent="0" marL="0">
-              <a:buNone/>
-            </a:pPr>
-            <a:r>
-              <a:rPr lang="en-US" sz="900" dirty="0">
-                <a:solidFill>
-                  <a:srgbClr val="64748B"/>
-                </a:solidFill>
-                <a:latin typeface="Calibri" pitchFamily="34" charset="0"/>
-                <a:ea typeface="Calibri" pitchFamily="34" charset="-122"/>
-                <a:cs typeface="Calibri" pitchFamily="34" charset="-120"/>
-              </a:rPr>
-              <a:t>Нестеренко В.В.   ·   ХНУРЕ, ІПЗм-24-1   ·   2026</a:t>
-            </a:r>
-            <a:endParaRPr lang="en-US" sz="900" dirty="0"/>
-          </a:p>
-        </p:txBody>
-      </p:sp>
-      <p:sp>
-        <p:nvSpPr>
-          <p:cNvPr id="32" name="Text 28"/>
+      <p:pic>
+        <p:nvPicPr>
+          <p:cNvPr id="31" name="Image 0" descr="D:\repos\kb-semantic-search-benchmark\thesis\scripts\_logo_hex.png">    </p:cNvPr>
+          <p:cNvPicPr>
+            <a:picLocks noChangeAspect="1"/>
+          </p:cNvPicPr>
+          <p:nvPr/>
+        </p:nvPicPr>
+        <p:blipFill>
+          <a:blip r:embed="rId2"/>
+          <a:stretch>
+            <a:fillRect/>
+          </a:stretch>
+        </p:blipFill>
+        <p:spPr>
+          <a:xfrm>
+            <a:off x="411480" y="4686300"/>
+            <a:ext cx="502920" cy="338328"/>
+          </a:xfrm>
+          <a:prstGeom prst="rect">
+            <a:avLst/>
+          </a:prstGeom>
+        </p:spPr>
+      </p:pic>
+      <p:sp>
+        <p:nvSpPr>
+          <p:cNvPr id="32" name="Text 27"/>
           <p:cNvSpPr/>
           <p:nvPr/>
         </p:nvSpPr>
@@ -33765,48 +33564,33 @@
           </a:p>
         </p:txBody>
       </p:sp>
-      <p:sp>
-        <p:nvSpPr>
-          <p:cNvPr id="47" name="Text 34"/>
-          <p:cNvSpPr/>
-          <p:nvPr/>
-        </p:nvSpPr>
-        <p:spPr>
-          <a:xfrm>
-            <a:off x="411480" y="4850892"/>
-            <a:ext cx="6858000" cy="228600"/>
-          </a:xfrm>
-          <a:prstGeom prst="rect">
-            <a:avLst/>
-          </a:prstGeom>
-          <a:noFill/>
-          <a:ln/>
-        </p:spPr>
-        <p:txBody>
-          <a:bodyPr wrap="square" lIns="0" tIns="0" rIns="0" bIns="0" rtlCol="0" anchor="ctr"/>
-          <a:lstStyle/>
-          <a:p>
-            <a:pPr algn="l" indent="0" marL="0">
-              <a:buNone/>
-            </a:pPr>
-            <a:r>
-              <a:rPr lang="en-US" sz="900" dirty="0">
-                <a:solidFill>
-                  <a:srgbClr val="64748B"/>
-                </a:solidFill>
-                <a:latin typeface="Calibri" pitchFamily="34" charset="0"/>
-                <a:ea typeface="Calibri" pitchFamily="34" charset="-122"/>
-                <a:cs typeface="Calibri" pitchFamily="34" charset="-120"/>
-              </a:rPr>
-              <a:t>Нестеренко В.В.   ·   ХНУРЕ, ІПЗм-24-1   ·   2026</a:t>
-            </a:r>
-            <a:endParaRPr lang="en-US" sz="900" dirty="0"/>
-          </a:p>
-        </p:txBody>
-      </p:sp>
-      <p:sp>
-        <p:nvSpPr>
-          <p:cNvPr id="48" name="Text 35"/>
+      <p:pic>
+        <p:nvPicPr>
+          <p:cNvPr id="47" name="Image 11" descr="D:\repos\kb-semantic-search-benchmark\thesis\scripts\_logo_hex.png">    </p:cNvPr>
+          <p:cNvPicPr>
+            <a:picLocks noChangeAspect="1"/>
+          </p:cNvPicPr>
+          <p:nvPr/>
+        </p:nvPicPr>
+        <p:blipFill>
+          <a:blip r:embed="rId12"/>
+          <a:stretch>
+            <a:fillRect/>
+          </a:stretch>
+        </p:blipFill>
+        <p:spPr>
+          <a:xfrm>
+            <a:off x="411480" y="4686300"/>
+            <a:ext cx="502920" cy="338328"/>
+          </a:xfrm>
+          <a:prstGeom prst="rect">
+            <a:avLst/>
+          </a:prstGeom>
+        </p:spPr>
+      </p:pic>
+      <p:sp>
+        <p:nvSpPr>
+          <p:cNvPr id="48" name="Text 34"/>
           <p:cNvSpPr/>
           <p:nvPr/>
         </p:nvSpPr>

</xml_diff>

<commit_message>
Tighten layout density on slides 3, 4, 9
Slide 3 (timeline): year labels were pressed against the research-gap
callout above and there was a ~0.7" empty band before the bottom strip.
Pushed the timeline track down to y=2.95 and the strip up to y=4.70 so
the slide reads as one balanced block.

Slide 4 (problem statement): criteria in the dark panel started at
y=2.90 with a 0.4" gap to the description and ended well above the
panel bottom. Reseat to y=2.60 with 0.50" step so the 5 dots span the
full panel height.

Slide 9 (system architecture): flow nodes were 1.85" tall and finished
~0.4" above the footer logo. Bumped flowH to 2.10" and tightened gaps
between flow → user/UI overlays → components strip.

Co-Authored-By: Claude Opus 4.7 (1M context) <noreply@anthropic.com>
</commit_message>
<xml_diff>
--- a/thesis/Nesterenko_Presentation.pptx
+++ b/thesis/Nesterenko_Presentation.pptx
@@ -21489,7 +21489,7 @@
         </p:nvSpPr>
         <p:spPr>
           <a:xfrm>
-            <a:off x="777240" y="2331720"/>
+            <a:off x="777240" y="2697480"/>
             <a:ext cx="7589520" cy="22860"/>
           </a:xfrm>
           <a:prstGeom prst="rect">
@@ -21509,7 +21509,7 @@
         </p:nvSpPr>
         <p:spPr>
           <a:xfrm>
-            <a:off x="320040" y="1737360"/>
+            <a:off x="320040" y="2103120"/>
             <a:ext cx="914400" cy="274320"/>
           </a:xfrm>
           <a:prstGeom prst="rect">
@@ -21548,7 +21548,7 @@
         </p:nvSpPr>
         <p:spPr>
           <a:xfrm>
-            <a:off x="640080" y="2208276"/>
+            <a:off x="640080" y="2574036"/>
             <a:ext cx="274320" cy="274320"/>
           </a:xfrm>
           <a:prstGeom prst="ellipse">
@@ -21573,7 +21573,7 @@
         </p:nvSpPr>
         <p:spPr>
           <a:xfrm>
-            <a:off x="0" y="2560320"/>
+            <a:off x="0" y="2926080"/>
             <a:ext cx="1554480" cy="274320"/>
           </a:xfrm>
           <a:prstGeom prst="rect">
@@ -21612,7 +21612,7 @@
         </p:nvSpPr>
         <p:spPr>
           <a:xfrm>
-            <a:off x="0" y="2834640"/>
+            <a:off x="0" y="3200400"/>
             <a:ext cx="1554480" cy="201168"/>
           </a:xfrm>
           <a:prstGeom prst="rect">
@@ -21651,8 +21651,8 @@
         </p:nvSpPr>
         <p:spPr>
           <a:xfrm>
-            <a:off x="-91440" y="3044952"/>
-            <a:ext cx="1737360" cy="594360"/>
+            <a:off x="-91440" y="3410712"/>
+            <a:ext cx="1737360" cy="868680"/>
           </a:xfrm>
           <a:prstGeom prst="rect">
             <a:avLst/>
@@ -21668,7 +21668,7 @@
               <a:buNone/>
             </a:pPr>
             <a:r>
-              <a:rPr lang="en-US" sz="950" dirty="0">
+              <a:rPr lang="en-US" sz="1000" dirty="0">
                 <a:solidFill>
                   <a:srgbClr val="475569"/>
                 </a:solidFill>
@@ -21678,14 +21678,14 @@
               </a:rPr>
               <a:t>Статистичні</a:t>
             </a:r>
-            <a:endParaRPr lang="en-US" sz="950" dirty="0"/>
+            <a:endParaRPr lang="en-US" sz="1000" dirty="0"/>
           </a:p>
           <a:p>
             <a:pPr algn="ctr" indent="0" marL="0">
               <a:buNone/>
             </a:pPr>
             <a:r>
-              <a:rPr lang="en-US" sz="950" dirty="0">
+              <a:rPr lang="en-US" sz="1000" dirty="0">
                 <a:solidFill>
                   <a:srgbClr val="475569"/>
                 </a:solidFill>
@@ -21695,7 +21695,7 @@
               </a:rPr>
               <a:t>векторні подання</a:t>
             </a:r>
-            <a:endParaRPr lang="en-US" sz="950" dirty="0"/>
+            <a:endParaRPr lang="en-US" sz="1000" dirty="0"/>
           </a:p>
         </p:txBody>
       </p:sp>
@@ -21707,7 +21707,7 @@
         </p:nvSpPr>
         <p:spPr>
           <a:xfrm>
-            <a:off x="1837944" y="1737360"/>
+            <a:off x="1837944" y="2103120"/>
             <a:ext cx="914400" cy="274320"/>
           </a:xfrm>
           <a:prstGeom prst="rect">
@@ -21746,7 +21746,7 @@
         </p:nvSpPr>
         <p:spPr>
           <a:xfrm>
-            <a:off x="2157984" y="2208276"/>
+            <a:off x="2157984" y="2574036"/>
             <a:ext cx="274320" cy="274320"/>
           </a:xfrm>
           <a:prstGeom prst="ellipse">
@@ -21771,7 +21771,7 @@
         </p:nvSpPr>
         <p:spPr>
           <a:xfrm>
-            <a:off x="1517904" y="2560320"/>
+            <a:off x="1517904" y="2926080"/>
             <a:ext cx="1554480" cy="274320"/>
           </a:xfrm>
           <a:prstGeom prst="rect">
@@ -21810,7 +21810,7 @@
         </p:nvSpPr>
         <p:spPr>
           <a:xfrm>
-            <a:off x="1517904" y="2834640"/>
+            <a:off x="1517904" y="3200400"/>
             <a:ext cx="1554480" cy="201168"/>
           </a:xfrm>
           <a:prstGeom prst="rect">
@@ -21849,8 +21849,8 @@
         </p:nvSpPr>
         <p:spPr>
           <a:xfrm>
-            <a:off x="1426464" y="3044952"/>
-            <a:ext cx="1737360" cy="594360"/>
+            <a:off x="1426464" y="3410712"/>
+            <a:ext cx="1737360" cy="868680"/>
           </a:xfrm>
           <a:prstGeom prst="rect">
             <a:avLst/>
@@ -21866,7 +21866,7 @@
               <a:buNone/>
             </a:pPr>
             <a:r>
-              <a:rPr lang="en-US" sz="950" dirty="0">
+              <a:rPr lang="en-US" sz="1000" dirty="0">
                 <a:solidFill>
                   <a:srgbClr val="475569"/>
                 </a:solidFill>
@@ -21876,14 +21876,14 @@
               </a:rPr>
               <a:t>Трансформери,</a:t>
             </a:r>
-            <a:endParaRPr lang="en-US" sz="950" dirty="0"/>
+            <a:endParaRPr lang="en-US" sz="1000" dirty="0"/>
           </a:p>
           <a:p>
             <a:pPr algn="ctr" indent="0" marL="0">
               <a:buNone/>
             </a:pPr>
             <a:r>
-              <a:rPr lang="en-US" sz="950" dirty="0">
+              <a:rPr lang="en-US" sz="1000" dirty="0">
                 <a:solidFill>
                   <a:srgbClr val="475569"/>
                 </a:solidFill>
@@ -21893,7 +21893,7 @@
               </a:rPr>
               <a:t>контекстність</a:t>
             </a:r>
-            <a:endParaRPr lang="en-US" sz="950" dirty="0"/>
+            <a:endParaRPr lang="en-US" sz="1000" dirty="0"/>
           </a:p>
         </p:txBody>
       </p:sp>
@@ -21905,7 +21905,7 @@
         </p:nvSpPr>
         <p:spPr>
           <a:xfrm>
-            <a:off x="3355848" y="1737360"/>
+            <a:off x="3355848" y="2103120"/>
             <a:ext cx="914400" cy="274320"/>
           </a:xfrm>
           <a:prstGeom prst="rect">
@@ -21944,7 +21944,7 @@
         </p:nvSpPr>
         <p:spPr>
           <a:xfrm>
-            <a:off x="3675888" y="2208276"/>
+            <a:off x="3675888" y="2574036"/>
             <a:ext cx="274320" cy="274320"/>
           </a:xfrm>
           <a:prstGeom prst="ellipse">
@@ -21969,7 +21969,7 @@
         </p:nvSpPr>
         <p:spPr>
           <a:xfrm>
-            <a:off x="3035808" y="2560320"/>
+            <a:off x="3035808" y="2926080"/>
             <a:ext cx="1554480" cy="274320"/>
           </a:xfrm>
           <a:prstGeom prst="rect">
@@ -22008,7 +22008,7 @@
         </p:nvSpPr>
         <p:spPr>
           <a:xfrm>
-            <a:off x="3035808" y="2834640"/>
+            <a:off x="3035808" y="3200400"/>
             <a:ext cx="1554480" cy="201168"/>
           </a:xfrm>
           <a:prstGeom prst="rect">
@@ -22047,8 +22047,8 @@
         </p:nvSpPr>
         <p:spPr>
           <a:xfrm>
-            <a:off x="2944368" y="3044952"/>
-            <a:ext cx="1737360" cy="594360"/>
+            <a:off x="2944368" y="3410712"/>
+            <a:ext cx="1737360" cy="868680"/>
           </a:xfrm>
           <a:prstGeom prst="rect">
             <a:avLst/>
@@ -22064,7 +22064,7 @@
               <a:buNone/>
             </a:pPr>
             <a:r>
-              <a:rPr lang="en-US" sz="950" dirty="0">
+              <a:rPr lang="en-US" sz="1000" dirty="0">
                 <a:solidFill>
                   <a:srgbClr val="475569"/>
                 </a:solidFill>
@@ -22074,14 +22074,14 @@
               </a:rPr>
               <a:t>Семантичні</a:t>
             </a:r>
-            <a:endParaRPr lang="en-US" sz="950" dirty="0"/>
+            <a:endParaRPr lang="en-US" sz="1000" dirty="0"/>
           </a:p>
           <a:p>
             <a:pPr algn="ctr" indent="0" marL="0">
               <a:buNone/>
             </a:pPr>
             <a:r>
-              <a:rPr lang="en-US" sz="950" dirty="0">
+              <a:rPr lang="en-US" sz="1000" dirty="0">
                 <a:solidFill>
                   <a:srgbClr val="475569"/>
                 </a:solidFill>
@@ -22091,7 +22091,7 @@
               </a:rPr>
               <a:t>векторизатори</a:t>
             </a:r>
-            <a:endParaRPr lang="en-US" sz="950" dirty="0"/>
+            <a:endParaRPr lang="en-US" sz="1000" dirty="0"/>
           </a:p>
         </p:txBody>
       </p:sp>
@@ -22103,7 +22103,7 @@
         </p:nvSpPr>
         <p:spPr>
           <a:xfrm>
-            <a:off x="4873752" y="1737360"/>
+            <a:off x="4873752" y="2103120"/>
             <a:ext cx="914400" cy="274320"/>
           </a:xfrm>
           <a:prstGeom prst="rect">
@@ -22142,7 +22142,7 @@
         </p:nvSpPr>
         <p:spPr>
           <a:xfrm>
-            <a:off x="5193792" y="2208276"/>
+            <a:off x="5193792" y="2574036"/>
             <a:ext cx="274320" cy="274320"/>
           </a:xfrm>
           <a:prstGeom prst="ellipse">
@@ -22167,7 +22167,7 @@
         </p:nvSpPr>
         <p:spPr>
           <a:xfrm>
-            <a:off x="4553712" y="2560320"/>
+            <a:off x="4553712" y="2926080"/>
             <a:ext cx="1554480" cy="274320"/>
           </a:xfrm>
           <a:prstGeom prst="rect">
@@ -22206,7 +22206,7 @@
         </p:nvSpPr>
         <p:spPr>
           <a:xfrm>
-            <a:off x="4553712" y="2834640"/>
+            <a:off x="4553712" y="3200400"/>
             <a:ext cx="1554480" cy="201168"/>
           </a:xfrm>
           <a:prstGeom prst="rect">
@@ -22245,8 +22245,8 @@
         </p:nvSpPr>
         <p:spPr>
           <a:xfrm>
-            <a:off x="4462272" y="3044952"/>
-            <a:ext cx="1737360" cy="594360"/>
+            <a:off x="4462272" y="3410712"/>
+            <a:ext cx="1737360" cy="868680"/>
           </a:xfrm>
           <a:prstGeom prst="rect">
             <a:avLst/>
@@ -22262,7 +22262,7 @@
               <a:buNone/>
             </a:pPr>
             <a:r>
-              <a:rPr lang="en-US" sz="950" dirty="0">
+              <a:rPr lang="en-US" sz="1000" dirty="0">
                 <a:solidFill>
                   <a:srgbClr val="475569"/>
                 </a:solidFill>
@@ -22272,14 +22272,14 @@
               </a:rPr>
               <a:t>Multilingual,</a:t>
             </a:r>
-            <a:endParaRPr lang="en-US" sz="950" dirty="0"/>
+            <a:endParaRPr lang="en-US" sz="1000" dirty="0"/>
           </a:p>
           <a:p>
             <a:pPr algn="ctr" indent="0" marL="0">
               <a:buNone/>
             </a:pPr>
             <a:r>
-              <a:rPr lang="en-US" sz="950" dirty="0">
+              <a:rPr lang="en-US" sz="1000" dirty="0">
                 <a:solidFill>
                   <a:srgbClr val="475569"/>
                 </a:solidFill>
@@ -22289,7 +22289,7 @@
               </a:rPr>
               <a:t>contrastive</a:t>
             </a:r>
-            <a:endParaRPr lang="en-US" sz="950" dirty="0"/>
+            <a:endParaRPr lang="en-US" sz="1000" dirty="0"/>
           </a:p>
         </p:txBody>
       </p:sp>
@@ -22301,7 +22301,7 @@
         </p:nvSpPr>
         <p:spPr>
           <a:xfrm>
-            <a:off x="6391656" y="1737360"/>
+            <a:off x="6391656" y="2103120"/>
             <a:ext cx="914400" cy="274320"/>
           </a:xfrm>
           <a:prstGeom prst="rect">
@@ -22340,7 +22340,7 @@
         </p:nvSpPr>
         <p:spPr>
           <a:xfrm>
-            <a:off x="6711696" y="2208276"/>
+            <a:off x="6711696" y="2574036"/>
             <a:ext cx="274320" cy="274320"/>
           </a:xfrm>
           <a:prstGeom prst="ellipse">
@@ -22365,7 +22365,7 @@
         </p:nvSpPr>
         <p:spPr>
           <a:xfrm>
-            <a:off x="6071616" y="2560320"/>
+            <a:off x="6071616" y="2926080"/>
             <a:ext cx="1554480" cy="274320"/>
           </a:xfrm>
           <a:prstGeom prst="rect">
@@ -22404,7 +22404,7 @@
         </p:nvSpPr>
         <p:spPr>
           <a:xfrm>
-            <a:off x="6071616" y="2834640"/>
+            <a:off x="6071616" y="3200400"/>
             <a:ext cx="1554480" cy="201168"/>
           </a:xfrm>
           <a:prstGeom prst="rect">
@@ -22443,8 +22443,8 @@
         </p:nvSpPr>
         <p:spPr>
           <a:xfrm>
-            <a:off x="5980176" y="3044952"/>
-            <a:ext cx="1737360" cy="594360"/>
+            <a:off x="5980176" y="3410712"/>
+            <a:ext cx="1737360" cy="868680"/>
           </a:xfrm>
           <a:prstGeom prst="rect">
             <a:avLst/>
@@ -22460,7 +22460,7 @@
               <a:buNone/>
             </a:pPr>
             <a:r>
-              <a:rPr lang="en-US" sz="950" dirty="0">
+              <a:rPr lang="en-US" sz="1000" dirty="0">
                 <a:solidFill>
                   <a:srgbClr val="475569"/>
                 </a:solidFill>
@@ -22470,14 +22470,14 @@
               </a:rPr>
               <a:t>Multi-functionality,</a:t>
             </a:r>
-            <a:endParaRPr lang="en-US" sz="950" dirty="0"/>
+            <a:endParaRPr lang="en-US" sz="1000" dirty="0"/>
           </a:p>
           <a:p>
             <a:pPr algn="ctr" indent="0" marL="0">
               <a:buNone/>
             </a:pPr>
             <a:r>
-              <a:rPr lang="en-US" sz="950" dirty="0">
+              <a:rPr lang="en-US" sz="1000" dirty="0">
                 <a:solidFill>
                   <a:srgbClr val="475569"/>
                 </a:solidFill>
@@ -22487,7 +22487,7 @@
               </a:rPr>
               <a:t>long context</a:t>
             </a:r>
-            <a:endParaRPr lang="en-US" sz="950" dirty="0"/>
+            <a:endParaRPr lang="en-US" sz="1000" dirty="0"/>
           </a:p>
         </p:txBody>
       </p:sp>
@@ -22499,7 +22499,7 @@
         </p:nvSpPr>
         <p:spPr>
           <a:xfrm>
-            <a:off x="7909560" y="1737360"/>
+            <a:off x="7909560" y="2103120"/>
             <a:ext cx="914400" cy="274320"/>
           </a:xfrm>
           <a:prstGeom prst="rect">
@@ -22538,7 +22538,7 @@
         </p:nvSpPr>
         <p:spPr>
           <a:xfrm>
-            <a:off x="8229600" y="2208276"/>
+            <a:off x="8229600" y="2574036"/>
             <a:ext cx="274320" cy="274320"/>
           </a:xfrm>
           <a:prstGeom prst="ellipse">
@@ -22563,7 +22563,7 @@
         </p:nvSpPr>
         <p:spPr>
           <a:xfrm>
-            <a:off x="7589520" y="2560320"/>
+            <a:off x="7589520" y="2926080"/>
             <a:ext cx="1554480" cy="274320"/>
           </a:xfrm>
           <a:prstGeom prst="rect">
@@ -22602,7 +22602,7 @@
         </p:nvSpPr>
         <p:spPr>
           <a:xfrm>
-            <a:off x="7589520" y="2834640"/>
+            <a:off x="7589520" y="3200400"/>
             <a:ext cx="1554480" cy="201168"/>
           </a:xfrm>
           <a:prstGeom prst="rect">
@@ -22641,8 +22641,8 @@
         </p:nvSpPr>
         <p:spPr>
           <a:xfrm>
-            <a:off x="7498080" y="3044952"/>
-            <a:ext cx="1737360" cy="594360"/>
+            <a:off x="7498080" y="3410712"/>
+            <a:ext cx="1737360" cy="868680"/>
           </a:xfrm>
           <a:prstGeom prst="rect">
             <a:avLst/>
@@ -22658,7 +22658,7 @@
               <a:buNone/>
             </a:pPr>
             <a:r>
-              <a:rPr lang="en-US" sz="950" dirty="0">
+              <a:rPr lang="en-US" sz="1000" dirty="0">
                 <a:solidFill>
                   <a:srgbClr val="475569"/>
                 </a:solidFill>
@@ -22668,14 +22668,14 @@
               </a:rPr>
               <a:t>Decoder-based,</a:t>
             </a:r>
-            <a:endParaRPr lang="en-US" sz="950" dirty="0"/>
+            <a:endParaRPr lang="en-US" sz="1000" dirty="0"/>
           </a:p>
           <a:p>
             <a:pPr algn="ctr" indent="0" marL="0">
               <a:buNone/>
             </a:pPr>
             <a:r>
-              <a:rPr lang="en-US" sz="950" dirty="0">
+              <a:rPr lang="en-US" sz="1000" dirty="0">
                 <a:solidFill>
                   <a:srgbClr val="475569"/>
                 </a:solidFill>
@@ -22685,7 +22685,7 @@
               </a:rPr>
               <a:t>instruction-aware</a:t>
             </a:r>
-            <a:endParaRPr lang="en-US" sz="950" dirty="0"/>
+            <a:endParaRPr lang="en-US" sz="1000" dirty="0"/>
           </a:p>
         </p:txBody>
       </p:sp>
@@ -22836,12 +22836,12 @@
         </p:nvSpPr>
         <p:spPr>
           <a:xfrm>
-            <a:off x="411480" y="4315968"/>
-            <a:ext cx="8321040" cy="411480"/>
+            <a:off x="411480" y="4297680"/>
+            <a:ext cx="8321040" cy="365760"/>
           </a:xfrm>
           <a:prstGeom prst="roundRect">
             <a:avLst>
-              <a:gd name="adj" fmla="val 13333"/>
+              <a:gd name="adj" fmla="val 15000"/>
             </a:avLst>
           </a:prstGeom>
           <a:solidFill>
@@ -22863,8 +22863,8 @@
         </p:nvSpPr>
         <p:spPr>
           <a:xfrm>
-            <a:off x="411480" y="4315968"/>
-            <a:ext cx="8321040" cy="411480"/>
+            <a:off x="411480" y="4297680"/>
+            <a:ext cx="8321040" cy="365760"/>
           </a:xfrm>
           <a:prstGeom prst="rect">
             <a:avLst/>
@@ -23199,7 +23199,7 @@
         <p:spPr>
           <a:xfrm>
             <a:off x="685800" y="1463040"/>
-            <a:ext cx="2788920" cy="1188720"/>
+            <a:ext cx="2788920" cy="868680"/>
           </a:xfrm>
           <a:prstGeom prst="rect">
             <a:avLst/>
@@ -23240,7 +23240,7 @@
         </p:nvSpPr>
         <p:spPr>
           <a:xfrm>
-            <a:off x="685800" y="2761488"/>
+            <a:off x="685800" y="2487168"/>
             <a:ext cx="91440" cy="91440"/>
           </a:xfrm>
           <a:prstGeom prst="ellipse">
@@ -23260,7 +23260,7 @@
         </p:nvSpPr>
         <p:spPr>
           <a:xfrm>
-            <a:off x="868680" y="2651760"/>
+            <a:off x="868680" y="2377440"/>
             <a:ext cx="2606040" cy="320040"/>
           </a:xfrm>
           <a:prstGeom prst="rect">
@@ -23299,7 +23299,7 @@
         </p:nvSpPr>
         <p:spPr>
           <a:xfrm>
-            <a:off x="685800" y="3127248"/>
+            <a:off x="685800" y="2944368"/>
             <a:ext cx="91440" cy="91440"/>
           </a:xfrm>
           <a:prstGeom prst="ellipse">
@@ -23319,7 +23319,7 @@
         </p:nvSpPr>
         <p:spPr>
           <a:xfrm>
-            <a:off x="868680" y="3017520"/>
+            <a:off x="868680" y="2834640"/>
             <a:ext cx="2606040" cy="320040"/>
           </a:xfrm>
           <a:prstGeom prst="rect">
@@ -23358,7 +23358,7 @@
         </p:nvSpPr>
         <p:spPr>
           <a:xfrm>
-            <a:off x="685800" y="3493008"/>
+            <a:off x="685800" y="3401568"/>
             <a:ext cx="91440" cy="91440"/>
           </a:xfrm>
           <a:prstGeom prst="ellipse">
@@ -23378,7 +23378,7 @@
         </p:nvSpPr>
         <p:spPr>
           <a:xfrm>
-            <a:off x="868680" y="3383280"/>
+            <a:off x="868680" y="3291840"/>
             <a:ext cx="2606040" cy="320040"/>
           </a:xfrm>
           <a:prstGeom prst="rect">
@@ -23476,7 +23476,7 @@
         </p:nvSpPr>
         <p:spPr>
           <a:xfrm>
-            <a:off x="685800" y="4224528"/>
+            <a:off x="685800" y="4315968"/>
             <a:ext cx="91440" cy="91440"/>
           </a:xfrm>
           <a:prstGeom prst="ellipse">
@@ -23496,7 +23496,7 @@
         </p:nvSpPr>
         <p:spPr>
           <a:xfrm>
-            <a:off x="868680" y="4114800"/>
+            <a:off x="868680" y="4206240"/>
             <a:ext cx="2606040" cy="320040"/>
           </a:xfrm>
           <a:prstGeom prst="rect">
@@ -32100,8 +32100,8 @@
         </p:nvSpPr>
         <p:spPr>
           <a:xfrm>
-            <a:off x="411480" y="1188720"/>
-            <a:ext cx="1335024" cy="1691640"/>
+            <a:off x="411480" y="1097280"/>
+            <a:ext cx="1335024" cy="1920240"/>
           </a:xfrm>
           <a:prstGeom prst="roundRect">
             <a:avLst>
@@ -32134,7 +32134,7 @@
         </p:nvSpPr>
         <p:spPr>
           <a:xfrm>
-            <a:off x="411480" y="1188720"/>
+            <a:off x="411480" y="1097280"/>
             <a:ext cx="1335024" cy="91440"/>
           </a:xfrm>
           <a:prstGeom prst="rect">
@@ -32154,7 +32154,7 @@
         </p:nvSpPr>
         <p:spPr>
           <a:xfrm>
-            <a:off x="804672" y="1463040"/>
+            <a:off x="804672" y="1371600"/>
             <a:ext cx="548640" cy="548640"/>
           </a:xfrm>
           <a:prstGeom prst="ellipse">
@@ -32187,7 +32187,7 @@
         </p:blipFill>
         <p:spPr>
           <a:xfrm>
-            <a:off x="914400" y="1572768"/>
+            <a:off x="914400" y="1481328"/>
             <a:ext cx="329184" cy="329184"/>
           </a:xfrm>
           <a:prstGeom prst="rect">
@@ -32203,7 +32203,7 @@
         </p:nvSpPr>
         <p:spPr>
           <a:xfrm>
-            <a:off x="411480" y="2057400"/>
+            <a:off x="411480" y="1965960"/>
             <a:ext cx="1335024" cy="292608"/>
           </a:xfrm>
           <a:prstGeom prst="rect">
@@ -32242,7 +32242,7 @@
         </p:nvSpPr>
         <p:spPr>
           <a:xfrm>
-            <a:off x="502920" y="2377440"/>
+            <a:off x="502920" y="2286000"/>
             <a:ext cx="1152144" cy="457200"/>
           </a:xfrm>
           <a:prstGeom prst="rect">
@@ -32306,7 +32306,7 @@
         </p:blipFill>
         <p:spPr>
           <a:xfrm>
-            <a:off x="1792224" y="1924812"/>
+            <a:off x="1792224" y="1947672"/>
             <a:ext cx="329184" cy="219456"/>
           </a:xfrm>
           <a:prstGeom prst="rect">
@@ -32322,8 +32322,8 @@
         </p:nvSpPr>
         <p:spPr>
           <a:xfrm>
-            <a:off x="2157984" y="1188720"/>
-            <a:ext cx="1335024" cy="1691640"/>
+            <a:off x="2157984" y="1097280"/>
+            <a:ext cx="1335024" cy="1920240"/>
           </a:xfrm>
           <a:prstGeom prst="roundRect">
             <a:avLst>
@@ -32356,7 +32356,7 @@
         </p:nvSpPr>
         <p:spPr>
           <a:xfrm>
-            <a:off x="2157984" y="1188720"/>
+            <a:off x="2157984" y="1097280"/>
             <a:ext cx="1335024" cy="91440"/>
           </a:xfrm>
           <a:prstGeom prst="rect">
@@ -32376,7 +32376,7 @@
         </p:nvSpPr>
         <p:spPr>
           <a:xfrm>
-            <a:off x="2551176" y="1463040"/>
+            <a:off x="2551176" y="1371600"/>
             <a:ext cx="548640" cy="548640"/>
           </a:xfrm>
           <a:prstGeom prst="ellipse">
@@ -32409,7 +32409,7 @@
         </p:blipFill>
         <p:spPr>
           <a:xfrm>
-            <a:off x="2660904" y="1572768"/>
+            <a:off x="2660904" y="1481328"/>
             <a:ext cx="329184" cy="329184"/>
           </a:xfrm>
           <a:prstGeom prst="rect">
@@ -32425,7 +32425,7 @@
         </p:nvSpPr>
         <p:spPr>
           <a:xfrm>
-            <a:off x="2157984" y="2057400"/>
+            <a:off x="2157984" y="1965960"/>
             <a:ext cx="1335024" cy="292608"/>
           </a:xfrm>
           <a:prstGeom prst="rect">
@@ -32464,7 +32464,7 @@
         </p:nvSpPr>
         <p:spPr>
           <a:xfrm>
-            <a:off x="2249424" y="2377440"/>
+            <a:off x="2249424" y="2286000"/>
             <a:ext cx="1152144" cy="457200"/>
           </a:xfrm>
           <a:prstGeom prst="rect">
@@ -32528,7 +32528,7 @@
         </p:blipFill>
         <p:spPr>
           <a:xfrm>
-            <a:off x="3538728" y="1924812"/>
+            <a:off x="3538728" y="1947672"/>
             <a:ext cx="329184" cy="219456"/>
           </a:xfrm>
           <a:prstGeom prst="rect">
@@ -32544,8 +32544,8 @@
         </p:nvSpPr>
         <p:spPr>
           <a:xfrm>
-            <a:off x="3904488" y="1188720"/>
-            <a:ext cx="1335024" cy="1691640"/>
+            <a:off x="3904488" y="1097280"/>
+            <a:ext cx="1335024" cy="1920240"/>
           </a:xfrm>
           <a:prstGeom prst="roundRect">
             <a:avLst>
@@ -32578,7 +32578,7 @@
         </p:nvSpPr>
         <p:spPr>
           <a:xfrm>
-            <a:off x="3904488" y="1188720"/>
+            <a:off x="3904488" y="1097280"/>
             <a:ext cx="1335024" cy="91440"/>
           </a:xfrm>
           <a:prstGeom prst="rect">
@@ -32598,7 +32598,7 @@
         </p:nvSpPr>
         <p:spPr>
           <a:xfrm>
-            <a:off x="4297680" y="1463040"/>
+            <a:off x="4297680" y="1371600"/>
             <a:ext cx="548640" cy="548640"/>
           </a:xfrm>
           <a:prstGeom prst="ellipse">
@@ -32631,7 +32631,7 @@
         </p:blipFill>
         <p:spPr>
           <a:xfrm>
-            <a:off x="4407408" y="1572768"/>
+            <a:off x="4407408" y="1481328"/>
             <a:ext cx="329184" cy="329184"/>
           </a:xfrm>
           <a:prstGeom prst="rect">
@@ -32647,7 +32647,7 @@
         </p:nvSpPr>
         <p:spPr>
           <a:xfrm>
-            <a:off x="3904488" y="2057400"/>
+            <a:off x="3904488" y="1965960"/>
             <a:ext cx="1335024" cy="292608"/>
           </a:xfrm>
           <a:prstGeom prst="rect">
@@ -32686,7 +32686,7 @@
         </p:nvSpPr>
         <p:spPr>
           <a:xfrm>
-            <a:off x="3995928" y="2377440"/>
+            <a:off x="3995928" y="2286000"/>
             <a:ext cx="1152144" cy="457200"/>
           </a:xfrm>
           <a:prstGeom prst="rect">
@@ -32750,7 +32750,7 @@
         </p:blipFill>
         <p:spPr>
           <a:xfrm>
-            <a:off x="5285232" y="1924812"/>
+            <a:off x="5285232" y="1947672"/>
             <a:ext cx="329184" cy="219456"/>
           </a:xfrm>
           <a:prstGeom prst="rect">
@@ -32766,8 +32766,8 @@
         </p:nvSpPr>
         <p:spPr>
           <a:xfrm>
-            <a:off x="5650992" y="1188720"/>
-            <a:ext cx="1335024" cy="1691640"/>
+            <a:off x="5650992" y="1097280"/>
+            <a:ext cx="1335024" cy="1920240"/>
           </a:xfrm>
           <a:prstGeom prst="roundRect">
             <a:avLst>
@@ -32800,7 +32800,7 @@
         </p:nvSpPr>
         <p:spPr>
           <a:xfrm>
-            <a:off x="5650992" y="1188720"/>
+            <a:off x="5650992" y="1097280"/>
             <a:ext cx="1335024" cy="91440"/>
           </a:xfrm>
           <a:prstGeom prst="rect">
@@ -32820,7 +32820,7 @@
         </p:nvSpPr>
         <p:spPr>
           <a:xfrm>
-            <a:off x="6044184" y="1463040"/>
+            <a:off x="6044184" y="1371600"/>
             <a:ext cx="548640" cy="548640"/>
           </a:xfrm>
           <a:prstGeom prst="ellipse">
@@ -32853,7 +32853,7 @@
         </p:blipFill>
         <p:spPr>
           <a:xfrm>
-            <a:off x="6153912" y="1572768"/>
+            <a:off x="6153912" y="1481328"/>
             <a:ext cx="329184" cy="329184"/>
           </a:xfrm>
           <a:prstGeom prst="rect">
@@ -32869,7 +32869,7 @@
         </p:nvSpPr>
         <p:spPr>
           <a:xfrm>
-            <a:off x="5650992" y="2057400"/>
+            <a:off x="5650992" y="1965960"/>
             <a:ext cx="1335024" cy="292608"/>
           </a:xfrm>
           <a:prstGeom prst="rect">
@@ -32908,7 +32908,7 @@
         </p:nvSpPr>
         <p:spPr>
           <a:xfrm>
-            <a:off x="5742432" y="2377440"/>
+            <a:off x="5742432" y="2286000"/>
             <a:ext cx="1152144" cy="457200"/>
           </a:xfrm>
           <a:prstGeom prst="rect">
@@ -32972,7 +32972,7 @@
         </p:blipFill>
         <p:spPr>
           <a:xfrm>
-            <a:off x="7031736" y="1924812"/>
+            <a:off x="7031736" y="1947672"/>
             <a:ext cx="329184" cy="219456"/>
           </a:xfrm>
           <a:prstGeom prst="rect">
@@ -32988,8 +32988,8 @@
         </p:nvSpPr>
         <p:spPr>
           <a:xfrm>
-            <a:off x="7397496" y="1188720"/>
-            <a:ext cx="1335024" cy="1691640"/>
+            <a:off x="7397496" y="1097280"/>
+            <a:ext cx="1335024" cy="1920240"/>
           </a:xfrm>
           <a:prstGeom prst="roundRect">
             <a:avLst>
@@ -33022,7 +33022,7 @@
         </p:nvSpPr>
         <p:spPr>
           <a:xfrm>
-            <a:off x="7397496" y="1188720"/>
+            <a:off x="7397496" y="1097280"/>
             <a:ext cx="1335024" cy="91440"/>
           </a:xfrm>
           <a:prstGeom prst="rect">
@@ -33042,7 +33042,7 @@
         </p:nvSpPr>
         <p:spPr>
           <a:xfrm>
-            <a:off x="7790688" y="1463040"/>
+            <a:off x="7790688" y="1371600"/>
             <a:ext cx="548640" cy="548640"/>
           </a:xfrm>
           <a:prstGeom prst="ellipse">
@@ -33075,7 +33075,7 @@
         </p:blipFill>
         <p:spPr>
           <a:xfrm>
-            <a:off x="7900416" y="1572768"/>
+            <a:off x="7900416" y="1481328"/>
             <a:ext cx="329184" cy="329184"/>
           </a:xfrm>
           <a:prstGeom prst="rect">
@@ -33091,7 +33091,7 @@
         </p:nvSpPr>
         <p:spPr>
           <a:xfrm>
-            <a:off x="7397496" y="2057400"/>
+            <a:off x="7397496" y="1965960"/>
             <a:ext cx="1335024" cy="292608"/>
           </a:xfrm>
           <a:prstGeom prst="rect">
@@ -33130,7 +33130,7 @@
         </p:nvSpPr>
         <p:spPr>
           <a:xfrm>
-            <a:off x="7488936" y="2377440"/>
+            <a:off x="7488936" y="2286000"/>
             <a:ext cx="1152144" cy="457200"/>
           </a:xfrm>
           <a:prstGeom prst="rect">
@@ -33186,7 +33186,7 @@
         </p:nvSpPr>
         <p:spPr>
           <a:xfrm>
-            <a:off x="411480" y="3246120"/>
+            <a:off x="411480" y="3291840"/>
             <a:ext cx="2011680" cy="502920"/>
           </a:xfrm>
           <a:prstGeom prst="roundRect">
@@ -33228,7 +33228,7 @@
         </p:blipFill>
         <p:spPr>
           <a:xfrm>
-            <a:off x="521208" y="3355848"/>
+            <a:off x="521208" y="3401568"/>
             <a:ext cx="274320" cy="274320"/>
           </a:xfrm>
           <a:prstGeom prst="rect">
@@ -33244,7 +33244,7 @@
         </p:nvSpPr>
         <p:spPr>
           <a:xfrm>
-            <a:off x="868680" y="3246120"/>
+            <a:off x="868680" y="3291840"/>
             <a:ext cx="1463040" cy="502920"/>
           </a:xfrm>
           <a:prstGeom prst="rect">
@@ -33283,7 +33283,7 @@
         </p:nvSpPr>
         <p:spPr>
           <a:xfrm>
-            <a:off x="6720840" y="3246120"/>
+            <a:off x="6720840" y="3291840"/>
             <a:ext cx="2011680" cy="502920"/>
           </a:xfrm>
           <a:prstGeom prst="roundRect">
@@ -33325,7 +33325,7 @@
         </p:blipFill>
         <p:spPr>
           <a:xfrm>
-            <a:off x="6830568" y="3355848"/>
+            <a:off x="6830568" y="3401568"/>
             <a:ext cx="274320" cy="274320"/>
           </a:xfrm>
           <a:prstGeom prst="rect">
@@ -33341,7 +33341,7 @@
         </p:nvSpPr>
         <p:spPr>
           <a:xfrm>
-            <a:off x="7178040" y="3246120"/>
+            <a:off x="7178040" y="3291840"/>
             <a:ext cx="1463040" cy="502920"/>
           </a:xfrm>
           <a:prstGeom prst="rect">
@@ -33380,12 +33380,12 @@
         </p:nvSpPr>
         <p:spPr>
           <a:xfrm>
-            <a:off x="411480" y="3931920"/>
-            <a:ext cx="8321040" cy="411480"/>
+            <a:off x="411480" y="3977640"/>
+            <a:ext cx="8321040" cy="457200"/>
           </a:xfrm>
           <a:prstGeom prst="roundRect">
             <a:avLst>
-              <a:gd name="adj" fmla="val 13333"/>
+              <a:gd name="adj" fmla="val 12000"/>
             </a:avLst>
           </a:prstGeom>
           <a:solidFill>
@@ -33407,8 +33407,8 @@
         </p:nvSpPr>
         <p:spPr>
           <a:xfrm>
-            <a:off x="411480" y="3931920"/>
-            <a:ext cx="8321040" cy="411480"/>
+            <a:off x="411480" y="3977640"/>
+            <a:ext cx="8321040" cy="457200"/>
           </a:xfrm>
           <a:prstGeom prst="rect">
             <a:avLst/>

</xml_diff>

<commit_message>
Fix slide 8 weights table overflow
The MCDA weights table (sum of colW = 3.85") was rendering past the
right edge of its 3.30" parent card. Rebalanced the slide so the left
methods panel is 4.80" (was 5.30") and the right table card is 4.10"
(was 3.60"); kept the original column widths so headers/values fit on
one line. Moved the @k qualifier from each column header into the
section title to reduce visual noise.

Co-Authored-By: Claude Opus 4.7 (1M context) <noreply@anthropic.com>
</commit_message>
<xml_diff>
--- a/thesis/Nesterenko_Presentation.pptx
+++ b/thesis/Nesterenko_Presentation.pptx
@@ -29416,7 +29416,7 @@
         <p:spPr>
           <a:xfrm>
             <a:off x="411480" y="960120"/>
-            <a:ext cx="4846320" cy="1097280"/>
+            <a:ext cx="4389120" cy="1097280"/>
           </a:xfrm>
           <a:prstGeom prst="roundRect">
             <a:avLst>
@@ -29509,7 +29509,7 @@
         <p:spPr>
           <a:xfrm>
             <a:off x="1280160" y="1069848"/>
-            <a:ext cx="3840480" cy="292608"/>
+            <a:ext cx="3383280" cy="292608"/>
           </a:xfrm>
           <a:prstGeom prst="rect">
             <a:avLst/>
@@ -29548,7 +29548,7 @@
         <p:spPr>
           <a:xfrm>
             <a:off x="1280160" y="1371600"/>
-            <a:ext cx="3840480" cy="292608"/>
+            <a:ext cx="3383280" cy="292608"/>
           </a:xfrm>
           <a:prstGeom prst="rect">
             <a:avLst/>
@@ -29568,7 +29568,7 @@
         <p:spPr>
           <a:xfrm>
             <a:off x="1280160" y="1371600"/>
-            <a:ext cx="3840480" cy="292608"/>
+            <a:ext cx="3383280" cy="292608"/>
           </a:xfrm>
           <a:prstGeom prst="rect">
             <a:avLst/>
@@ -29607,7 +29607,7 @@
         <p:spPr>
           <a:xfrm>
             <a:off x="1280160" y="1691640"/>
-            <a:ext cx="3840480" cy="320040"/>
+            <a:ext cx="3383280" cy="320040"/>
           </a:xfrm>
           <a:prstGeom prst="rect">
             <a:avLst/>
@@ -29646,7 +29646,7 @@
         <p:spPr>
           <a:xfrm>
             <a:off x="411480" y="2167128"/>
-            <a:ext cx="4846320" cy="1097280"/>
+            <a:ext cx="4389120" cy="1097280"/>
           </a:xfrm>
           <a:prstGeom prst="roundRect">
             <a:avLst>
@@ -29739,7 +29739,7 @@
         <p:spPr>
           <a:xfrm>
             <a:off x="1280160" y="2276856"/>
-            <a:ext cx="3840480" cy="292608"/>
+            <a:ext cx="3383280" cy="292608"/>
           </a:xfrm>
           <a:prstGeom prst="rect">
             <a:avLst/>
@@ -29778,7 +29778,7 @@
         <p:spPr>
           <a:xfrm>
             <a:off x="1280160" y="2578608"/>
-            <a:ext cx="3840480" cy="292608"/>
+            <a:ext cx="3383280" cy="292608"/>
           </a:xfrm>
           <a:prstGeom prst="rect">
             <a:avLst/>
@@ -29798,7 +29798,7 @@
         <p:spPr>
           <a:xfrm>
             <a:off x="1280160" y="2578608"/>
-            <a:ext cx="3840480" cy="292608"/>
+            <a:ext cx="3383280" cy="292608"/>
           </a:xfrm>
           <a:prstGeom prst="rect">
             <a:avLst/>
@@ -29837,7 +29837,7 @@
         <p:spPr>
           <a:xfrm>
             <a:off x="1280160" y="2898648"/>
-            <a:ext cx="3840480" cy="320040"/>
+            <a:ext cx="3383280" cy="320040"/>
           </a:xfrm>
           <a:prstGeom prst="rect">
             <a:avLst/>
@@ -29876,7 +29876,7 @@
         <p:spPr>
           <a:xfrm>
             <a:off x="411480" y="3374136"/>
-            <a:ext cx="4846320" cy="1097280"/>
+            <a:ext cx="4389120" cy="1097280"/>
           </a:xfrm>
           <a:prstGeom prst="roundRect">
             <a:avLst>
@@ -29969,7 +29969,7 @@
         <p:spPr>
           <a:xfrm>
             <a:off x="1280160" y="3483864"/>
-            <a:ext cx="3840480" cy="292608"/>
+            <a:ext cx="3383280" cy="292608"/>
           </a:xfrm>
           <a:prstGeom prst="rect">
             <a:avLst/>
@@ -30008,7 +30008,7 @@
         <p:spPr>
           <a:xfrm>
             <a:off x="1280160" y="3785616"/>
-            <a:ext cx="3840480" cy="292608"/>
+            <a:ext cx="3383280" cy="292608"/>
           </a:xfrm>
           <a:prstGeom prst="rect">
             <a:avLst/>
@@ -30028,7 +30028,7 @@
         <p:spPr>
           <a:xfrm>
             <a:off x="1280160" y="3785616"/>
-            <a:ext cx="3840480" cy="292608"/>
+            <a:ext cx="3383280" cy="292608"/>
           </a:xfrm>
           <a:prstGeom prst="rect">
             <a:avLst/>
@@ -30067,7 +30067,7 @@
         <p:spPr>
           <a:xfrm>
             <a:off x="1280160" y="4105656"/>
-            <a:ext cx="3840480" cy="320040"/>
+            <a:ext cx="3383280" cy="320040"/>
           </a:xfrm>
           <a:prstGeom prst="rect">
             <a:avLst/>
@@ -30105,12 +30105,12 @@
         </p:nvSpPr>
         <p:spPr>
           <a:xfrm>
-            <a:off x="5440680" y="960120"/>
-            <a:ext cx="3291840" cy="3703320"/>
+            <a:off x="4983480" y="960120"/>
+            <a:ext cx="3749040" cy="3703320"/>
           </a:xfrm>
           <a:prstGeom prst="roundRect">
             <a:avLst>
-              <a:gd name="adj" fmla="val 1667"/>
+              <a:gd name="adj" fmla="val 1481"/>
             </a:avLst>
           </a:prstGeom>
           <a:solidFill>
@@ -30139,8 +30139,8 @@
         </p:nvSpPr>
         <p:spPr>
           <a:xfrm>
-            <a:off x="5577840" y="1051560"/>
-            <a:ext cx="3017520" cy="274320"/>
+            <a:off x="5120640" y="1051560"/>
+            <a:ext cx="3474720" cy="274320"/>
           </a:xfrm>
           <a:prstGeom prst="rect">
             <a:avLst/>
@@ -30164,7 +30164,7 @@
                 <a:ea typeface="Calibri" pitchFamily="34" charset="-122"/>
                 <a:cs typeface="Calibri" pitchFamily="34" charset="-120"/>
               </a:rPr>
-              <a:t>ПРОФІЛІ ВАГ КРИТЕРІЇВ ЗА ДОМЕНАМИ</a:t>
+              <a:t>ПРОФІЛІ ВАГ КРИТЕРІЇВ ЗА ДОМЕНАМИ  (k = 10)</a:t>
             </a:r>
             <a:endParaRPr lang="en-US" sz="900" dirty="0"/>
           </a:p>
@@ -30185,8 +30185,8 @@
           </p:nvPr>
         </p:nvGraphicFramePr>
         <p:xfrm>
-          <a:off x="5577840" y="1371600"/>
-          <a:ext cx="3017520" cy="914400"/>
+          <a:off x="5120640" y="1371600"/>
+          <a:ext cx="3474720" cy="914400"/>
         </p:xfrm>
         <a:graphic>
           <a:graphicData uri="http://schemas.openxmlformats.org/drawingml/2006/table">
@@ -30286,7 +30286,7 @@
                           <a:ea typeface="Calibri" pitchFamily="34" charset="-122"/>
                           <a:cs typeface="Calibri" pitchFamily="34" charset="-120"/>
                         </a:rPr>
-                        <a:t>nDCG@k</a:t>
+                        <a:t>nDCG</a:t>
                       </a:r>
                       <a:endParaRPr lang="en-US" sz="1000" dirty="0">
                         <a:latin typeface="Calibri" charset="0"/>
@@ -30354,7 +30354,7 @@
                           <a:ea typeface="Calibri" pitchFamily="34" charset="-122"/>
                           <a:cs typeface="Calibri" pitchFamily="34" charset="-120"/>
                         </a:rPr>
-                        <a:t>MRR@k</a:t>
+                        <a:t>MRR</a:t>
                       </a:r>
                       <a:endParaRPr lang="en-US" sz="1000" dirty="0">
                         <a:latin typeface="Calibri" charset="0"/>
@@ -30422,7 +30422,7 @@
                           <a:ea typeface="Calibri" pitchFamily="34" charset="-122"/>
                           <a:cs typeface="Calibri" pitchFamily="34" charset="-120"/>
                         </a:rPr>
-                        <a:t>Recall@k</a:t>
+                        <a:t>Recall</a:t>
                       </a:r>
                       <a:endParaRPr lang="en-US" sz="1000" dirty="0">
                         <a:latin typeface="Calibri" charset="0"/>
@@ -30490,7 +30490,7 @@
                           <a:ea typeface="Calibri" pitchFamily="34" charset="-122"/>
                           <a:cs typeface="Calibri" pitchFamily="34" charset="-120"/>
                         </a:rPr>
-                        <a:t>P@k</a:t>
+                        <a:t>P</a:t>
                       </a:r>
                       <a:endParaRPr lang="en-US" sz="1000" dirty="0">
                         <a:latin typeface="Calibri" charset="0"/>
@@ -31852,8 +31852,8 @@
         </p:nvSpPr>
         <p:spPr>
           <a:xfrm>
-            <a:off x="5577840" y="2880360"/>
-            <a:ext cx="3017520" cy="228600"/>
+            <a:off x="5120640" y="2880360"/>
+            <a:ext cx="3474720" cy="228600"/>
           </a:xfrm>
           <a:prstGeom prst="rect">
             <a:avLst/>
@@ -31890,8 +31890,8 @@
           <p:nvPr/>
         </p:nvGraphicFramePr>
         <p:xfrm>
-          <a:off x="5532120" y="3154680"/>
-          <a:ext cx="3108960" cy="1508760"/>
+          <a:off x="5074920" y="3154680"/>
+          <a:ext cx="3566160" cy="1508760"/>
         </p:xfrm>
         <a:graphic xmlns:a="http://schemas.openxmlformats.org/drawingml/2006/main">
           <a:graphicData uri="http://schemas.openxmlformats.org/drawingml/2006/chart">

</xml_diff>

<commit_message>
Fix slide 16 insight cards: note text overflowing card bottom
Each of the five "Ключові висновки" cards reserved only h=0.10" for the
9.5 pt description, so text rendered below the card border (most visible
on the bottom card "поступається навіть BM25"). Tightened the three-row
internal layout — label 0.18", model 0.24", note 0.20" — and shaved the
font sizes one notch (label 9→8.5, model 13→12, note 9.5→9) so every
line lands inside the 0.67" card body.

Co-Authored-By: Claude Opus 4.7 (1M context) <noreply@anthropic.com>
</commit_message>
<xml_diff>
--- a/thesis/Nesterenko_Presentation.pptx
+++ b/thesis/Nesterenko_Presentation.pptx
@@ -17021,8 +17021,8 @@
         </p:nvSpPr>
         <p:spPr>
           <a:xfrm>
-            <a:off x="6062472" y="1325880"/>
-            <a:ext cx="2560320" cy="201168"/>
+            <a:off x="6062472" y="1316736"/>
+            <a:ext cx="2560320" cy="164592"/>
           </a:xfrm>
           <a:prstGeom prst="rect">
             <a:avLst/>
@@ -17038,7 +17038,7 @@
               <a:buNone/>
             </a:pPr>
             <a:r>
-              <a:rPr lang="en-US" sz="900" b="1" spc="150" kern="0" dirty="0">
+              <a:rPr lang="en-US" sz="850" b="1" spc="150" kern="0" dirty="0">
                 <a:solidFill>
                   <a:srgbClr val="64748B"/>
                 </a:solidFill>
@@ -17048,85 +17048,85 @@
               </a:rPr>
               <a:t>Лідер якості</a:t>
             </a:r>
+            <a:endParaRPr lang="en-US" sz="850" dirty="0"/>
+          </a:p>
+        </p:txBody>
+      </p:sp>
+      <p:sp>
+        <p:nvSpPr>
+          <p:cNvPr id="18" name="Text 15"/>
+          <p:cNvSpPr/>
+          <p:nvPr/>
+        </p:nvSpPr>
+        <p:spPr>
+          <a:xfrm>
+            <a:off x="6062472" y="1472184"/>
+            <a:ext cx="2560320" cy="219456"/>
+          </a:xfrm>
+          <a:prstGeom prst="rect">
+            <a:avLst/>
+          </a:prstGeom>
+          <a:noFill/>
+          <a:ln/>
+        </p:spPr>
+        <p:txBody>
+          <a:bodyPr wrap="square" lIns="0" tIns="0" rIns="0" bIns="0" rtlCol="0" anchor="t"/>
+          <a:lstStyle/>
+          <a:p>
+            <a:pPr algn="l" indent="0" marL="0">
+              <a:buNone/>
+            </a:pPr>
+            <a:r>
+              <a:rPr lang="en-US" sz="1200" b="1" dirty="0">
+                <a:solidFill>
+                  <a:srgbClr val="F59E0B"/>
+                </a:solidFill>
+                <a:latin typeface="Calibri" pitchFamily="34" charset="0"/>
+                <a:ea typeface="Calibri" pitchFamily="34" charset="-122"/>
+                <a:cs typeface="Calibri" pitchFamily="34" charset="-120"/>
+              </a:rPr>
+              <a:t>BGE-M3</a:t>
+            </a:r>
+            <a:endParaRPr lang="en-US" sz="1200" dirty="0"/>
+          </a:p>
+        </p:txBody>
+      </p:sp>
+      <p:sp>
+        <p:nvSpPr>
+          <p:cNvPr id="19" name="Text 16"/>
+          <p:cNvSpPr/>
+          <p:nvPr/>
+        </p:nvSpPr>
+        <p:spPr>
+          <a:xfrm>
+            <a:off x="6062472" y="1691640"/>
+            <a:ext cx="2560320" cy="182880"/>
+          </a:xfrm>
+          <a:prstGeom prst="rect">
+            <a:avLst/>
+          </a:prstGeom>
+          <a:noFill/>
+          <a:ln/>
+        </p:spPr>
+        <p:txBody>
+          <a:bodyPr wrap="square" lIns="0" tIns="0" rIns="0" bIns="0" rtlCol="0" anchor="t"/>
+          <a:lstStyle/>
+          <a:p>
+            <a:pPr algn="l" indent="0" marL="0">
+              <a:buNone/>
+            </a:pPr>
+            <a:r>
+              <a:rPr lang="en-US" sz="900" dirty="0">
+                <a:solidFill>
+                  <a:srgbClr val="475569"/>
+                </a:solidFill>
+                <a:latin typeface="Calibri" pitchFamily="34" charset="0"/>
+                <a:ea typeface="Calibri" pitchFamily="34" charset="-122"/>
+                <a:cs typeface="Calibri" pitchFamily="34" charset="-120"/>
+              </a:rPr>
+              <a:t>найвища nDCG (0.672 на Tech), ~228 мс</a:t>
+            </a:r>
             <a:endParaRPr lang="en-US" sz="900" dirty="0"/>
-          </a:p>
-        </p:txBody>
-      </p:sp>
-      <p:sp>
-        <p:nvSpPr>
-          <p:cNvPr id="18" name="Text 15"/>
-          <p:cNvSpPr/>
-          <p:nvPr/>
-        </p:nvSpPr>
-        <p:spPr>
-          <a:xfrm>
-            <a:off x="6062472" y="1527048"/>
-            <a:ext cx="2560320" cy="256032"/>
-          </a:xfrm>
-          <a:prstGeom prst="rect">
-            <a:avLst/>
-          </a:prstGeom>
-          <a:noFill/>
-          <a:ln/>
-        </p:spPr>
-        <p:txBody>
-          <a:bodyPr wrap="square" lIns="0" tIns="0" rIns="0" bIns="0" rtlCol="0" anchor="t"/>
-          <a:lstStyle/>
-          <a:p>
-            <a:pPr algn="l" indent="0" marL="0">
-              <a:buNone/>
-            </a:pPr>
-            <a:r>
-              <a:rPr lang="en-US" sz="1300" b="1" dirty="0">
-                <a:solidFill>
-                  <a:srgbClr val="F59E0B"/>
-                </a:solidFill>
-                <a:latin typeface="Calibri" pitchFamily="34" charset="0"/>
-                <a:ea typeface="Calibri" pitchFamily="34" charset="-122"/>
-                <a:cs typeface="Calibri" pitchFamily="34" charset="-120"/>
-              </a:rPr>
-              <a:t>BGE-M3</a:t>
-            </a:r>
-            <a:endParaRPr lang="en-US" sz="1300" dirty="0"/>
-          </a:p>
-        </p:txBody>
-      </p:sp>
-      <p:sp>
-        <p:nvSpPr>
-          <p:cNvPr id="19" name="Text 16"/>
-          <p:cNvSpPr/>
-          <p:nvPr/>
-        </p:nvSpPr>
-        <p:spPr>
-          <a:xfrm>
-            <a:off x="6062472" y="1783080"/>
-            <a:ext cx="2560320" cy="91440"/>
-          </a:xfrm>
-          <a:prstGeom prst="rect">
-            <a:avLst/>
-          </a:prstGeom>
-          <a:noFill/>
-          <a:ln/>
-        </p:spPr>
-        <p:txBody>
-          <a:bodyPr wrap="square" lIns="0" tIns="0" rIns="0" bIns="0" rtlCol="0" anchor="t"/>
-          <a:lstStyle/>
-          <a:p>
-            <a:pPr algn="l" indent="0" marL="0">
-              <a:buNone/>
-            </a:pPr>
-            <a:r>
-              <a:rPr lang="en-US" sz="950" dirty="0">
-                <a:solidFill>
-                  <a:srgbClr val="475569"/>
-                </a:solidFill>
-                <a:latin typeface="Calibri" pitchFamily="34" charset="0"/>
-                <a:ea typeface="Calibri" pitchFamily="34" charset="-122"/>
-                <a:cs typeface="Calibri" pitchFamily="34" charset="-120"/>
-              </a:rPr>
-              <a:t>найвища nDCG (0.672 на Tech), ~228 мс</a:t>
-            </a:r>
-            <a:endParaRPr lang="en-US" sz="950" dirty="0"/>
           </a:p>
         </p:txBody>
       </p:sp>
@@ -17192,8 +17192,8 @@
         </p:nvSpPr>
         <p:spPr>
           <a:xfrm>
-            <a:off x="6062472" y="2011680"/>
-            <a:ext cx="2560320" cy="201168"/>
+            <a:off x="6062472" y="2002536"/>
+            <a:ext cx="2560320" cy="164592"/>
           </a:xfrm>
           <a:prstGeom prst="rect">
             <a:avLst/>
@@ -17209,7 +17209,7 @@
               <a:buNone/>
             </a:pPr>
             <a:r>
-              <a:rPr lang="en-US" sz="900" b="1" spc="150" kern="0" dirty="0">
+              <a:rPr lang="en-US" sz="850" b="1" spc="150" kern="0" dirty="0">
                 <a:solidFill>
                   <a:srgbClr val="64748B"/>
                 </a:solidFill>
@@ -17219,85 +17219,85 @@
               </a:rPr>
               <a:t>Найшвидший</a:t>
             </a:r>
+            <a:endParaRPr lang="en-US" sz="850" dirty="0"/>
+          </a:p>
+        </p:txBody>
+      </p:sp>
+      <p:sp>
+        <p:nvSpPr>
+          <p:cNvPr id="23" name="Text 20"/>
+          <p:cNvSpPr/>
+          <p:nvPr/>
+        </p:nvSpPr>
+        <p:spPr>
+          <a:xfrm>
+            <a:off x="6062472" y="2157984"/>
+            <a:ext cx="2560320" cy="219456"/>
+          </a:xfrm>
+          <a:prstGeom prst="rect">
+            <a:avLst/>
+          </a:prstGeom>
+          <a:noFill/>
+          <a:ln/>
+        </p:spPr>
+        <p:txBody>
+          <a:bodyPr wrap="square" lIns="0" tIns="0" rIns="0" bIns="0" rtlCol="0" anchor="t"/>
+          <a:lstStyle/>
+          <a:p>
+            <a:pPr algn="l" indent="0" marL="0">
+              <a:buNone/>
+            </a:pPr>
+            <a:r>
+              <a:rPr lang="en-US" sz="1200" b="1" dirty="0">
+                <a:solidFill>
+                  <a:srgbClr val="64748B"/>
+                </a:solidFill>
+                <a:latin typeface="Calibri" pitchFamily="34" charset="0"/>
+                <a:ea typeface="Calibri" pitchFamily="34" charset="-122"/>
+                <a:cs typeface="Calibri" pitchFamily="34" charset="-120"/>
+              </a:rPr>
+              <a:t>BM25</a:t>
+            </a:r>
+            <a:endParaRPr lang="en-US" sz="1200" dirty="0"/>
+          </a:p>
+        </p:txBody>
+      </p:sp>
+      <p:sp>
+        <p:nvSpPr>
+          <p:cNvPr id="24" name="Text 21"/>
+          <p:cNvSpPr/>
+          <p:nvPr/>
+        </p:nvSpPr>
+        <p:spPr>
+          <a:xfrm>
+            <a:off x="6062472" y="2377440"/>
+            <a:ext cx="2560320" cy="182880"/>
+          </a:xfrm>
+          <a:prstGeom prst="rect">
+            <a:avLst/>
+          </a:prstGeom>
+          <a:noFill/>
+          <a:ln/>
+        </p:spPr>
+        <p:txBody>
+          <a:bodyPr wrap="square" lIns="0" tIns="0" rIns="0" bIns="0" rtlCol="0" anchor="t"/>
+          <a:lstStyle/>
+          <a:p>
+            <a:pPr algn="l" indent="0" marL="0">
+              <a:buNone/>
+            </a:pPr>
+            <a:r>
+              <a:rPr lang="en-US" sz="900" dirty="0">
+                <a:solidFill>
+                  <a:srgbClr val="475569"/>
+                </a:solidFill>
+                <a:latin typeface="Calibri" pitchFamily="34" charset="0"/>
+                <a:ea typeface="Calibri" pitchFamily="34" charset="-122"/>
+                <a:cs typeface="Calibri" pitchFamily="34" charset="-120"/>
+              </a:rPr>
+              <a:t>&lt;3 мс, але якість обмежена</a:t>
+            </a:r>
             <a:endParaRPr lang="en-US" sz="900" dirty="0"/>
-          </a:p>
-        </p:txBody>
-      </p:sp>
-      <p:sp>
-        <p:nvSpPr>
-          <p:cNvPr id="23" name="Text 20"/>
-          <p:cNvSpPr/>
-          <p:nvPr/>
-        </p:nvSpPr>
-        <p:spPr>
-          <a:xfrm>
-            <a:off x="6062472" y="2212848"/>
-            <a:ext cx="2560320" cy="256032"/>
-          </a:xfrm>
-          <a:prstGeom prst="rect">
-            <a:avLst/>
-          </a:prstGeom>
-          <a:noFill/>
-          <a:ln/>
-        </p:spPr>
-        <p:txBody>
-          <a:bodyPr wrap="square" lIns="0" tIns="0" rIns="0" bIns="0" rtlCol="0" anchor="t"/>
-          <a:lstStyle/>
-          <a:p>
-            <a:pPr algn="l" indent="0" marL="0">
-              <a:buNone/>
-            </a:pPr>
-            <a:r>
-              <a:rPr lang="en-US" sz="1300" b="1" dirty="0">
-                <a:solidFill>
-                  <a:srgbClr val="64748B"/>
-                </a:solidFill>
-                <a:latin typeface="Calibri" pitchFamily="34" charset="0"/>
-                <a:ea typeface="Calibri" pitchFamily="34" charset="-122"/>
-                <a:cs typeface="Calibri" pitchFamily="34" charset="-120"/>
-              </a:rPr>
-              <a:t>BM25</a:t>
-            </a:r>
-            <a:endParaRPr lang="en-US" sz="1300" dirty="0"/>
-          </a:p>
-        </p:txBody>
-      </p:sp>
-      <p:sp>
-        <p:nvSpPr>
-          <p:cNvPr id="24" name="Text 21"/>
-          <p:cNvSpPr/>
-          <p:nvPr/>
-        </p:nvSpPr>
-        <p:spPr>
-          <a:xfrm>
-            <a:off x="6062472" y="2468880"/>
-            <a:ext cx="2560320" cy="91440"/>
-          </a:xfrm>
-          <a:prstGeom prst="rect">
-            <a:avLst/>
-          </a:prstGeom>
-          <a:noFill/>
-          <a:ln/>
-        </p:spPr>
-        <p:txBody>
-          <a:bodyPr wrap="square" lIns="0" tIns="0" rIns="0" bIns="0" rtlCol="0" anchor="t"/>
-          <a:lstStyle/>
-          <a:p>
-            <a:pPr algn="l" indent="0" marL="0">
-              <a:buNone/>
-            </a:pPr>
-            <a:r>
-              <a:rPr lang="en-US" sz="950" dirty="0">
-                <a:solidFill>
-                  <a:srgbClr val="475569"/>
-                </a:solidFill>
-                <a:latin typeface="Calibri" pitchFamily="34" charset="0"/>
-                <a:ea typeface="Calibri" pitchFamily="34" charset="-122"/>
-                <a:cs typeface="Calibri" pitchFamily="34" charset="-120"/>
-              </a:rPr>
-              <a:t>&lt;3 мс, але якість обмежена</a:t>
-            </a:r>
-            <a:endParaRPr lang="en-US" sz="950" dirty="0"/>
           </a:p>
         </p:txBody>
       </p:sp>
@@ -17363,8 +17363,8 @@
         </p:nvSpPr>
         <p:spPr>
           <a:xfrm>
-            <a:off x="6062472" y="2697480"/>
-            <a:ext cx="2560320" cy="201168"/>
+            <a:off x="6062472" y="2688336"/>
+            <a:ext cx="2560320" cy="164592"/>
           </a:xfrm>
           <a:prstGeom prst="rect">
             <a:avLst/>
@@ -17380,7 +17380,7 @@
               <a:buNone/>
             </a:pPr>
             <a:r>
-              <a:rPr lang="en-US" sz="900" b="1" spc="150" kern="0" dirty="0">
+              <a:rPr lang="en-US" sz="850" b="1" spc="150" kern="0" dirty="0">
                 <a:solidFill>
                   <a:srgbClr val="64748B"/>
                 </a:solidFill>
@@ -17390,85 +17390,85 @@
               </a:rPr>
               <a:t>Альтернатива</a:t>
             </a:r>
+            <a:endParaRPr lang="en-US" sz="850" dirty="0"/>
+          </a:p>
+        </p:txBody>
+      </p:sp>
+      <p:sp>
+        <p:nvSpPr>
+          <p:cNvPr id="28" name="Text 25"/>
+          <p:cNvSpPr/>
+          <p:nvPr/>
+        </p:nvSpPr>
+        <p:spPr>
+          <a:xfrm>
+            <a:off x="6062472" y="2843784"/>
+            <a:ext cx="2560320" cy="219456"/>
+          </a:xfrm>
+          <a:prstGeom prst="rect">
+            <a:avLst/>
+          </a:prstGeom>
+          <a:noFill/>
+          <a:ln/>
+        </p:spPr>
+        <p:txBody>
+          <a:bodyPr wrap="square" lIns="0" tIns="0" rIns="0" bIns="0" rtlCol="0" anchor="t"/>
+          <a:lstStyle/>
+          <a:p>
+            <a:pPr algn="l" indent="0" marL="0">
+              <a:buNone/>
+            </a:pPr>
+            <a:r>
+              <a:rPr lang="en-US" sz="1200" b="1" dirty="0">
+                <a:solidFill>
+                  <a:srgbClr val="0891B2"/>
+                </a:solidFill>
+                <a:latin typeface="Calibri" pitchFamily="34" charset="0"/>
+                <a:ea typeface="Calibri" pitchFamily="34" charset="-122"/>
+                <a:cs typeface="Calibri" pitchFamily="34" charset="-120"/>
+              </a:rPr>
+              <a:t>E5-base</a:t>
+            </a:r>
+            <a:endParaRPr lang="en-US" sz="1200" dirty="0"/>
+          </a:p>
+        </p:txBody>
+      </p:sp>
+      <p:sp>
+        <p:nvSpPr>
+          <p:cNvPr id="29" name="Text 26"/>
+          <p:cNvSpPr/>
+          <p:nvPr/>
+        </p:nvSpPr>
+        <p:spPr>
+          <a:xfrm>
+            <a:off x="6062472" y="3063240"/>
+            <a:ext cx="2560320" cy="182880"/>
+          </a:xfrm>
+          <a:prstGeom prst="rect">
+            <a:avLst/>
+          </a:prstGeom>
+          <a:noFill/>
+          <a:ln/>
+        </p:spPr>
+        <p:txBody>
+          <a:bodyPr wrap="square" lIns="0" tIns="0" rIns="0" bIns="0" rtlCol="0" anchor="t"/>
+          <a:lstStyle/>
+          <a:p>
+            <a:pPr algn="l" indent="0" marL="0">
+              <a:buNone/>
+            </a:pPr>
+            <a:r>
+              <a:rPr lang="en-US" sz="900" dirty="0">
+                <a:solidFill>
+                  <a:srgbClr val="475569"/>
+                </a:solidFill>
+                <a:latin typeface="Calibri" pitchFamily="34" charset="0"/>
+                <a:ea typeface="Calibri" pitchFamily="34" charset="-122"/>
+                <a:cs typeface="Calibri" pitchFamily="34" charset="-120"/>
+              </a:rPr>
+              <a:t>~3× швидше за BGE-M3, ~70 мс</a:t>
+            </a:r>
             <a:endParaRPr lang="en-US" sz="900" dirty="0"/>
-          </a:p>
-        </p:txBody>
-      </p:sp>
-      <p:sp>
-        <p:nvSpPr>
-          <p:cNvPr id="28" name="Text 25"/>
-          <p:cNvSpPr/>
-          <p:nvPr/>
-        </p:nvSpPr>
-        <p:spPr>
-          <a:xfrm>
-            <a:off x="6062472" y="2898648"/>
-            <a:ext cx="2560320" cy="256032"/>
-          </a:xfrm>
-          <a:prstGeom prst="rect">
-            <a:avLst/>
-          </a:prstGeom>
-          <a:noFill/>
-          <a:ln/>
-        </p:spPr>
-        <p:txBody>
-          <a:bodyPr wrap="square" lIns="0" tIns="0" rIns="0" bIns="0" rtlCol="0" anchor="t"/>
-          <a:lstStyle/>
-          <a:p>
-            <a:pPr algn="l" indent="0" marL="0">
-              <a:buNone/>
-            </a:pPr>
-            <a:r>
-              <a:rPr lang="en-US" sz="1300" b="1" dirty="0">
-                <a:solidFill>
-                  <a:srgbClr val="0891B2"/>
-                </a:solidFill>
-                <a:latin typeface="Calibri" pitchFamily="34" charset="0"/>
-                <a:ea typeface="Calibri" pitchFamily="34" charset="-122"/>
-                <a:cs typeface="Calibri" pitchFamily="34" charset="-120"/>
-              </a:rPr>
-              <a:t>E5-base</a:t>
-            </a:r>
-            <a:endParaRPr lang="en-US" sz="1300" dirty="0"/>
-          </a:p>
-        </p:txBody>
-      </p:sp>
-      <p:sp>
-        <p:nvSpPr>
-          <p:cNvPr id="29" name="Text 26"/>
-          <p:cNvSpPr/>
-          <p:nvPr/>
-        </p:nvSpPr>
-        <p:spPr>
-          <a:xfrm>
-            <a:off x="6062472" y="3154680"/>
-            <a:ext cx="2560320" cy="91440"/>
-          </a:xfrm>
-          <a:prstGeom prst="rect">
-            <a:avLst/>
-          </a:prstGeom>
-          <a:noFill/>
-          <a:ln/>
-        </p:spPr>
-        <p:txBody>
-          <a:bodyPr wrap="square" lIns="0" tIns="0" rIns="0" bIns="0" rtlCol="0" anchor="t"/>
-          <a:lstStyle/>
-          <a:p>
-            <a:pPr algn="l" indent="0" marL="0">
-              <a:buNone/>
-            </a:pPr>
-            <a:r>
-              <a:rPr lang="en-US" sz="950" dirty="0">
-                <a:solidFill>
-                  <a:srgbClr val="475569"/>
-                </a:solidFill>
-                <a:latin typeface="Calibri" pitchFamily="34" charset="0"/>
-                <a:ea typeface="Calibri" pitchFamily="34" charset="-122"/>
-                <a:cs typeface="Calibri" pitchFamily="34" charset="-120"/>
-              </a:rPr>
-              <a:t>~3× швидше за BGE-M3, ~70 мс</a:t>
-            </a:r>
-            <a:endParaRPr lang="en-US" sz="950" dirty="0"/>
           </a:p>
         </p:txBody>
       </p:sp>
@@ -17534,8 +17534,8 @@
         </p:nvSpPr>
         <p:spPr>
           <a:xfrm>
-            <a:off x="6062472" y="3383280"/>
-            <a:ext cx="2560320" cy="201168"/>
+            <a:off x="6062472" y="3374136"/>
+            <a:ext cx="2560320" cy="164592"/>
           </a:xfrm>
           <a:prstGeom prst="rect">
             <a:avLst/>
@@ -17551,7 +17551,7 @@
               <a:buNone/>
             </a:pPr>
             <a:r>
-              <a:rPr lang="en-US" sz="900" b="1" spc="150" kern="0" dirty="0">
+              <a:rPr lang="en-US" sz="850" b="1" spc="150" kern="0" dirty="0">
                 <a:solidFill>
                   <a:srgbClr val="64748B"/>
                 </a:solidFill>
@@ -17561,85 +17561,85 @@
               </a:rPr>
               <a:t>Лідер на Legal</a:t>
             </a:r>
+            <a:endParaRPr lang="en-US" sz="850" dirty="0"/>
+          </a:p>
+        </p:txBody>
+      </p:sp>
+      <p:sp>
+        <p:nvSpPr>
+          <p:cNvPr id="33" name="Text 30"/>
+          <p:cNvSpPr/>
+          <p:nvPr/>
+        </p:nvSpPr>
+        <p:spPr>
+          <a:xfrm>
+            <a:off x="6062472" y="3529584"/>
+            <a:ext cx="2560320" cy="219456"/>
+          </a:xfrm>
+          <a:prstGeom prst="rect">
+            <a:avLst/>
+          </a:prstGeom>
+          <a:noFill/>
+          <a:ln/>
+        </p:spPr>
+        <p:txBody>
+          <a:bodyPr wrap="square" lIns="0" tIns="0" rIns="0" bIns="0" rtlCol="0" anchor="t"/>
+          <a:lstStyle/>
+          <a:p>
+            <a:pPr algn="l" indent="0" marL="0">
+              <a:buNone/>
+            </a:pPr>
+            <a:r>
+              <a:rPr lang="en-US" sz="1200" b="1" dirty="0">
+                <a:solidFill>
+                  <a:srgbClr val="1E40AF"/>
+                </a:solidFill>
+                <a:latin typeface="Calibri" pitchFamily="34" charset="0"/>
+                <a:ea typeface="Calibri" pitchFamily="34" charset="-122"/>
+                <a:cs typeface="Calibri" pitchFamily="34" charset="-120"/>
+              </a:rPr>
+              <a:t>Qwen3</a:t>
+            </a:r>
+            <a:endParaRPr lang="en-US" sz="1200" dirty="0"/>
+          </a:p>
+        </p:txBody>
+      </p:sp>
+      <p:sp>
+        <p:nvSpPr>
+          <p:cNvPr id="34" name="Text 31"/>
+          <p:cNvSpPr/>
+          <p:nvPr/>
+        </p:nvSpPr>
+        <p:spPr>
+          <a:xfrm>
+            <a:off x="6062472" y="3749040"/>
+            <a:ext cx="2560320" cy="182880"/>
+          </a:xfrm>
+          <a:prstGeom prst="rect">
+            <a:avLst/>
+          </a:prstGeom>
+          <a:noFill/>
+          <a:ln/>
+        </p:spPr>
+        <p:txBody>
+          <a:bodyPr wrap="square" lIns="0" tIns="0" rIns="0" bIns="0" rtlCol="0" anchor="t"/>
+          <a:lstStyle/>
+          <a:p>
+            <a:pPr algn="l" indent="0" marL="0">
+              <a:buNone/>
+            </a:pPr>
+            <a:r>
+              <a:rPr lang="en-US" sz="900" dirty="0">
+                <a:solidFill>
+                  <a:srgbClr val="475569"/>
+                </a:solidFill>
+                <a:latin typeface="Calibri" pitchFamily="34" charset="0"/>
+                <a:ea typeface="Calibri" pitchFamily="34" charset="-122"/>
+                <a:cs typeface="Calibri" pitchFamily="34" charset="-120"/>
+              </a:rPr>
+              <a:t>nDCG=0.320, але ~2× повільніший</a:t>
+            </a:r>
             <a:endParaRPr lang="en-US" sz="900" dirty="0"/>
-          </a:p>
-        </p:txBody>
-      </p:sp>
-      <p:sp>
-        <p:nvSpPr>
-          <p:cNvPr id="33" name="Text 30"/>
-          <p:cNvSpPr/>
-          <p:nvPr/>
-        </p:nvSpPr>
-        <p:spPr>
-          <a:xfrm>
-            <a:off x="6062472" y="3584448"/>
-            <a:ext cx="2560320" cy="256032"/>
-          </a:xfrm>
-          <a:prstGeom prst="rect">
-            <a:avLst/>
-          </a:prstGeom>
-          <a:noFill/>
-          <a:ln/>
-        </p:spPr>
-        <p:txBody>
-          <a:bodyPr wrap="square" lIns="0" tIns="0" rIns="0" bIns="0" rtlCol="0" anchor="t"/>
-          <a:lstStyle/>
-          <a:p>
-            <a:pPr algn="l" indent="0" marL="0">
-              <a:buNone/>
-            </a:pPr>
-            <a:r>
-              <a:rPr lang="en-US" sz="1300" b="1" dirty="0">
-                <a:solidFill>
-                  <a:srgbClr val="1E40AF"/>
-                </a:solidFill>
-                <a:latin typeface="Calibri" pitchFamily="34" charset="0"/>
-                <a:ea typeface="Calibri" pitchFamily="34" charset="-122"/>
-                <a:cs typeface="Calibri" pitchFamily="34" charset="-120"/>
-              </a:rPr>
-              <a:t>Qwen3</a:t>
-            </a:r>
-            <a:endParaRPr lang="en-US" sz="1300" dirty="0"/>
-          </a:p>
-        </p:txBody>
-      </p:sp>
-      <p:sp>
-        <p:nvSpPr>
-          <p:cNvPr id="34" name="Text 31"/>
-          <p:cNvSpPr/>
-          <p:nvPr/>
-        </p:nvSpPr>
-        <p:spPr>
-          <a:xfrm>
-            <a:off x="6062472" y="3840480"/>
-            <a:ext cx="2560320" cy="91440"/>
-          </a:xfrm>
-          <a:prstGeom prst="rect">
-            <a:avLst/>
-          </a:prstGeom>
-          <a:noFill/>
-          <a:ln/>
-        </p:spPr>
-        <p:txBody>
-          <a:bodyPr wrap="square" lIns="0" tIns="0" rIns="0" bIns="0" rtlCol="0" anchor="t"/>
-          <a:lstStyle/>
-          <a:p>
-            <a:pPr algn="l" indent="0" marL="0">
-              <a:buNone/>
-            </a:pPr>
-            <a:r>
-              <a:rPr lang="en-US" sz="950" dirty="0">
-                <a:solidFill>
-                  <a:srgbClr val="475569"/>
-                </a:solidFill>
-                <a:latin typeface="Calibri" pitchFamily="34" charset="0"/>
-                <a:ea typeface="Calibri" pitchFamily="34" charset="-122"/>
-                <a:cs typeface="Calibri" pitchFamily="34" charset="-120"/>
-              </a:rPr>
-              <a:t>nDCG=0.320, але ~2× повільніший</a:t>
-            </a:r>
-            <a:endParaRPr lang="en-US" sz="950" dirty="0"/>
           </a:p>
         </p:txBody>
       </p:sp>
@@ -17705,8 +17705,8 @@
         </p:nvSpPr>
         <p:spPr>
           <a:xfrm>
-            <a:off x="6062472" y="4069080"/>
-            <a:ext cx="2560320" cy="201168"/>
+            <a:off x="6062472" y="4059936"/>
+            <a:ext cx="2560320" cy="164592"/>
           </a:xfrm>
           <a:prstGeom prst="rect">
             <a:avLst/>
@@ -17722,7 +17722,7 @@
               <a:buNone/>
             </a:pPr>
             <a:r>
-              <a:rPr lang="en-US" sz="900" b="1" spc="150" kern="0" dirty="0">
+              <a:rPr lang="en-US" sz="850" b="1" spc="150" kern="0" dirty="0">
                 <a:solidFill>
                   <a:srgbClr val="64748B"/>
                 </a:solidFill>
@@ -17732,85 +17732,85 @@
               </a:rPr>
               <a:t>Найслабший</a:t>
             </a:r>
+            <a:endParaRPr lang="en-US" sz="850" dirty="0"/>
+          </a:p>
+        </p:txBody>
+      </p:sp>
+      <p:sp>
+        <p:nvSpPr>
+          <p:cNvPr id="38" name="Text 35"/>
+          <p:cNvSpPr/>
+          <p:nvPr/>
+        </p:nvSpPr>
+        <p:spPr>
+          <a:xfrm>
+            <a:off x="6062472" y="4215384"/>
+            <a:ext cx="2560320" cy="219456"/>
+          </a:xfrm>
+          <a:prstGeom prst="rect">
+            <a:avLst/>
+          </a:prstGeom>
+          <a:noFill/>
+          <a:ln/>
+        </p:spPr>
+        <p:txBody>
+          <a:bodyPr wrap="square" lIns="0" tIns="0" rIns="0" bIns="0" rtlCol="0" anchor="t"/>
+          <a:lstStyle/>
+          <a:p>
+            <a:pPr algn="l" indent="0" marL="0">
+              <a:buNone/>
+            </a:pPr>
+            <a:r>
+              <a:rPr lang="en-US" sz="1200" b="1" dirty="0">
+                <a:solidFill>
+                  <a:srgbClr val="7C3AED"/>
+                </a:solidFill>
+                <a:latin typeface="Calibri" pitchFamily="34" charset="0"/>
+                <a:ea typeface="Calibri" pitchFamily="34" charset="-122"/>
+                <a:cs typeface="Calibri" pitchFamily="34" charset="-120"/>
+              </a:rPr>
+              <a:t>nomic</a:t>
+            </a:r>
+            <a:endParaRPr lang="en-US" sz="1200" dirty="0"/>
+          </a:p>
+        </p:txBody>
+      </p:sp>
+      <p:sp>
+        <p:nvSpPr>
+          <p:cNvPr id="39" name="Text 36"/>
+          <p:cNvSpPr/>
+          <p:nvPr/>
+        </p:nvSpPr>
+        <p:spPr>
+          <a:xfrm>
+            <a:off x="6062472" y="4434840"/>
+            <a:ext cx="2560320" cy="182880"/>
+          </a:xfrm>
+          <a:prstGeom prst="rect">
+            <a:avLst/>
+          </a:prstGeom>
+          <a:noFill/>
+          <a:ln/>
+        </p:spPr>
+        <p:txBody>
+          <a:bodyPr wrap="square" lIns="0" tIns="0" rIns="0" bIns="0" rtlCol="0" anchor="t"/>
+          <a:lstStyle/>
+          <a:p>
+            <a:pPr algn="l" indent="0" marL="0">
+              <a:buNone/>
+            </a:pPr>
+            <a:r>
+              <a:rPr lang="en-US" sz="900" dirty="0">
+                <a:solidFill>
+                  <a:srgbClr val="475569"/>
+                </a:solidFill>
+                <a:latin typeface="Calibri" pitchFamily="34" charset="0"/>
+                <a:ea typeface="Calibri" pitchFamily="34" charset="-122"/>
+                <a:cs typeface="Calibri" pitchFamily="34" charset="-120"/>
+              </a:rPr>
+              <a:t>поступається навіть BM25</a:t>
+            </a:r>
             <a:endParaRPr lang="en-US" sz="900" dirty="0"/>
-          </a:p>
-        </p:txBody>
-      </p:sp>
-      <p:sp>
-        <p:nvSpPr>
-          <p:cNvPr id="38" name="Text 35"/>
-          <p:cNvSpPr/>
-          <p:nvPr/>
-        </p:nvSpPr>
-        <p:spPr>
-          <a:xfrm>
-            <a:off x="6062472" y="4270248"/>
-            <a:ext cx="2560320" cy="256032"/>
-          </a:xfrm>
-          <a:prstGeom prst="rect">
-            <a:avLst/>
-          </a:prstGeom>
-          <a:noFill/>
-          <a:ln/>
-        </p:spPr>
-        <p:txBody>
-          <a:bodyPr wrap="square" lIns="0" tIns="0" rIns="0" bIns="0" rtlCol="0" anchor="t"/>
-          <a:lstStyle/>
-          <a:p>
-            <a:pPr algn="l" indent="0" marL="0">
-              <a:buNone/>
-            </a:pPr>
-            <a:r>
-              <a:rPr lang="en-US" sz="1300" b="1" dirty="0">
-                <a:solidFill>
-                  <a:srgbClr val="7C3AED"/>
-                </a:solidFill>
-                <a:latin typeface="Calibri" pitchFamily="34" charset="0"/>
-                <a:ea typeface="Calibri" pitchFamily="34" charset="-122"/>
-                <a:cs typeface="Calibri" pitchFamily="34" charset="-120"/>
-              </a:rPr>
-              <a:t>nomic</a:t>
-            </a:r>
-            <a:endParaRPr lang="en-US" sz="1300" dirty="0"/>
-          </a:p>
-        </p:txBody>
-      </p:sp>
-      <p:sp>
-        <p:nvSpPr>
-          <p:cNvPr id="39" name="Text 36"/>
-          <p:cNvSpPr/>
-          <p:nvPr/>
-        </p:nvSpPr>
-        <p:spPr>
-          <a:xfrm>
-            <a:off x="6062472" y="4526280"/>
-            <a:ext cx="2560320" cy="91440"/>
-          </a:xfrm>
-          <a:prstGeom prst="rect">
-            <a:avLst/>
-          </a:prstGeom>
-          <a:noFill/>
-          <a:ln/>
-        </p:spPr>
-        <p:txBody>
-          <a:bodyPr wrap="square" lIns="0" tIns="0" rIns="0" bIns="0" rtlCol="0" anchor="t"/>
-          <a:lstStyle/>
-          <a:p>
-            <a:pPr algn="l" indent="0" marL="0">
-              <a:buNone/>
-            </a:pPr>
-            <a:r>
-              <a:rPr lang="en-US" sz="950" dirty="0">
-                <a:solidFill>
-                  <a:srgbClr val="475569"/>
-                </a:solidFill>
-                <a:latin typeface="Calibri" pitchFamily="34" charset="0"/>
-                <a:ea typeface="Calibri" pitchFamily="34" charset="-122"/>
-                <a:cs typeface="Calibri" pitchFamily="34" charset="-120"/>
-              </a:rPr>
-              <a:t>поступається навіть BM25</a:t>
-            </a:r>
-            <a:endParaRPr lang="en-US" sz="950" dirty="0"/>
           </a:p>
         </p:txBody>
       </p:sp>

</xml_diff>

<commit_message>
Switch title and conclusion slides to light background
Slide 1 (title): replaced the dark navy backdrop with a white surface,
softer pastel circles on the right, an amber pill for the work-type
tag, and a slim navy bar down the left margin. Reads as a modern
academic title page rather than the previous "tech keynote" look.

Slide 18 (conclusions): same light treatment — 4 recommendation cards
now have white interiors with colored side stripes and tinted icon
disks, "Дякую за увагу!" rendered in gold serif italic. Goal-achieved
banner kept as a gold band for emphasis.

Co-Authored-By: Claude Opus 4.7 (1M context) <noreply@anthropic.com>
</commit_message>
<xml_diff>
--- a/thesis/Nesterenko_Presentation.pptx
+++ b/thesis/Nesterenko_Presentation.pptx
@@ -8101,7 +8101,7 @@
     <p:bg>
       <p:bgPr>
         <a:solidFill>
-          <a:srgbClr val="0F172A"/>
+          <a:srgbClr val="FFFFFF"/>
         </a:solidFill>
       </p:bgPr>
     </p:bg>
@@ -8127,15 +8127,35 @@
         </p:nvSpPr>
         <p:spPr>
           <a:xfrm>
-            <a:off x="6949440" y="-1280160"/>
-            <a:ext cx="3840480" cy="3840480"/>
+            <a:off x="7040880" y="-1280160"/>
+            <a:ext cx="4023360" cy="4023360"/>
           </a:xfrm>
           <a:prstGeom prst="ellipse">
             <a:avLst/>
           </a:prstGeom>
           <a:solidFill>
-            <a:srgbClr val="1E3A8A">
-              <a:alpha val="70000"/>
+            <a:srgbClr val="EFF6FF"/>
+          </a:solidFill>
+          <a:ln/>
+        </p:spPr>
+      </p:sp>
+      <p:sp>
+        <p:nvSpPr>
+          <p:cNvPr id="3" name="Shape 1"/>
+          <p:cNvSpPr/>
+          <p:nvPr/>
+        </p:nvSpPr>
+        <p:spPr>
+          <a:xfrm>
+            <a:off x="7680960" y="-640080"/>
+            <a:ext cx="2651760" cy="2651760"/>
+          </a:xfrm>
+          <a:prstGeom prst="ellipse">
+            <a:avLst/>
+          </a:prstGeom>
+          <a:solidFill>
+            <a:srgbClr val="1E40AF">
+              <a:alpha val="12000"/>
             </a:srgbClr>
           </a:solidFill>
           <a:ln/>
@@ -8143,21 +8163,21 @@
       </p:sp>
       <p:sp>
         <p:nvSpPr>
-          <p:cNvPr id="3" name="Shape 1"/>
-          <p:cNvSpPr/>
-          <p:nvPr/>
-        </p:nvSpPr>
-        <p:spPr>
-          <a:xfrm>
-            <a:off x="7498080" y="-731520"/>
-            <a:ext cx="2743200" cy="2743200"/>
+          <p:cNvPr id="4" name="Shape 2"/>
+          <p:cNvSpPr/>
+          <p:nvPr/>
+        </p:nvSpPr>
+        <p:spPr>
+          <a:xfrm>
+            <a:off x="8138160" y="-182880"/>
+            <a:ext cx="1463040" cy="1463040"/>
           </a:xfrm>
           <a:prstGeom prst="ellipse">
             <a:avLst/>
           </a:prstGeom>
           <a:solidFill>
-            <a:srgbClr val="1E40AF">
-              <a:alpha val="50000"/>
+            <a:srgbClr val="F59E0B">
+              <a:alpha val="22000"/>
             </a:srgbClr>
           </a:solidFill>
           <a:ln/>
@@ -8165,44 +8185,20 @@
       </p:sp>
       <p:sp>
         <p:nvSpPr>
-          <p:cNvPr id="4" name="Shape 2"/>
-          <p:cNvSpPr/>
-          <p:nvPr/>
-        </p:nvSpPr>
-        <p:spPr>
-          <a:xfrm>
-            <a:off x="7863840" y="-365760"/>
-            <a:ext cx="1645920" cy="1645920"/>
-          </a:xfrm>
-          <a:prstGeom prst="ellipse">
+          <p:cNvPr id="5" name="Shape 3"/>
+          <p:cNvSpPr/>
+          <p:nvPr/>
+        </p:nvSpPr>
+        <p:spPr>
+          <a:xfrm>
+            <a:off x="0" y="0"/>
+            <a:ext cx="164592" cy="5143500"/>
+          </a:xfrm>
+          <a:prstGeom prst="rect">
             <a:avLst/>
           </a:prstGeom>
           <a:solidFill>
-            <a:srgbClr val="F59E0B">
-              <a:alpha val="40000"/>
-            </a:srgbClr>
-          </a:solidFill>
-          <a:ln/>
-        </p:spPr>
-      </p:sp>
-      <p:sp>
-        <p:nvSpPr>
-          <p:cNvPr id="5" name="Shape 3"/>
-          <p:cNvSpPr/>
-          <p:nvPr/>
-        </p:nvSpPr>
-        <p:spPr>
-          <a:xfrm>
-            <a:off x="-365760" y="3840480"/>
-            <a:ext cx="1280160" cy="1280160"/>
-          </a:xfrm>
-          <a:prstGeom prst="rect">
-            <a:avLst/>
-          </a:prstGeom>
-          <a:solidFill>
-            <a:srgbClr val="0891B2">
-              <a:alpha val="50000"/>
-            </a:srgbClr>
+            <a:srgbClr val="1E40AF"/>
           </a:solidFill>
           <a:ln/>
         </p:spPr>
@@ -8224,9 +8220,9 @@
             </a:avLst>
           </a:prstGeom>
           <a:solidFill>
-            <a:srgbClr val="0F172A"/>
+            <a:srgbClr val="FEF3C7"/>
           </a:solidFill>
-          <a:ln w="12700">
+          <a:ln w="9525">
             <a:solidFill>
               <a:srgbClr val="F59E0B"/>
             </a:solidFill>
@@ -8261,7 +8257,7 @@
             <a:r>
               <a:rPr lang="en-US" sz="1000" b="1" spc="200" kern="0" dirty="0">
                 <a:solidFill>
-                  <a:srgbClr val="F59E0B"/>
+                  <a:srgbClr val="D97706"/>
                 </a:solidFill>
                 <a:latin typeface="Calibri" pitchFamily="34" charset="0"/>
                 <a:ea typeface="Calibri" pitchFamily="34" charset="-122"/>
@@ -8300,7 +8296,7 @@
             <a:r>
               <a:rPr lang="en-US" sz="2600" b="1" dirty="0">
                 <a:solidFill>
-                  <a:srgbClr val="F1F5F9"/>
+                  <a:srgbClr val="0F172A"/>
                 </a:solidFill>
                 <a:latin typeface="Calibri" pitchFamily="34" charset="0"/>
                 <a:ea typeface="Calibri" pitchFamily="34" charset="-122"/>
@@ -8362,7 +8358,7 @@
             <a:r>
               <a:rPr lang="en-US" sz="1300" dirty="0">
                 <a:solidFill>
-                  <a:srgbClr val="94A3B8"/>
+                  <a:srgbClr val="64748B"/>
                 </a:solidFill>
                 <a:latin typeface="Calibri" pitchFamily="34" charset="0"/>
                 <a:ea typeface="Calibri" pitchFamily="34" charset="-122"/>
@@ -8379,7 +8375,7 @@
             <a:r>
               <a:rPr lang="en-US" sz="1400" b="1" dirty="0">
                 <a:solidFill>
-                  <a:srgbClr val="F1F5F9"/>
+                  <a:srgbClr val="0F172A"/>
                 </a:solidFill>
                 <a:latin typeface="Calibri" pitchFamily="34" charset="0"/>
                 <a:ea typeface="Calibri" pitchFamily="34" charset="-122"/>
@@ -8399,7 +8395,7 @@
             <a:r>
               <a:rPr lang="en-US" sz="1300" dirty="0">
                 <a:solidFill>
-                  <a:srgbClr val="94A3B8"/>
+                  <a:srgbClr val="64748B"/>
                 </a:solidFill>
                 <a:latin typeface="Calibri" pitchFamily="34" charset="0"/>
                 <a:ea typeface="Calibri" pitchFamily="34" charset="-122"/>
@@ -8416,7 +8412,7 @@
             <a:r>
               <a:rPr lang="en-US" sz="1400" b="1" dirty="0">
                 <a:solidFill>
-                  <a:srgbClr val="F1F5F9"/>
+                  <a:srgbClr val="0F172A"/>
                 </a:solidFill>
                 <a:latin typeface="Calibri" pitchFamily="34" charset="0"/>
                 <a:ea typeface="Calibri" pitchFamily="34" charset="-122"/>
@@ -8455,7 +8451,7 @@
             <a:r>
               <a:rPr lang="en-US" sz="1300" dirty="0">
                 <a:solidFill>
-                  <a:srgbClr val="94A3B8"/>
+                  <a:srgbClr val="64748B"/>
                 </a:solidFill>
                 <a:latin typeface="Calibri" pitchFamily="34" charset="0"/>
                 <a:ea typeface="Calibri" pitchFamily="34" charset="-122"/>
@@ -8472,7 +8468,7 @@
             <a:r>
               <a:rPr lang="en-US" sz="1400" b="1" dirty="0">
                 <a:solidFill>
-                  <a:srgbClr val="F1F5F9"/>
+                  <a:srgbClr val="0F172A"/>
                 </a:solidFill>
                 <a:latin typeface="Calibri" pitchFamily="34" charset="0"/>
                 <a:ea typeface="Calibri" pitchFamily="34" charset="-122"/>
@@ -8535,7 +8531,7 @@
             <a:r>
               <a:rPr lang="en-US" sz="1100" dirty="0">
                 <a:solidFill>
-                  <a:srgbClr val="94A3B8"/>
+                  <a:srgbClr val="475569"/>
                 </a:solidFill>
                 <a:latin typeface="Calibri" pitchFamily="34" charset="0"/>
                 <a:ea typeface="Calibri" pitchFamily="34" charset="-122"/>
@@ -18881,7 +18877,7 @@
     <p:bg>
       <p:bgPr>
         <a:solidFill>
-          <a:srgbClr val="0F172A"/>
+          <a:srgbClr val="FFFFFF"/>
         </a:solidFill>
       </p:bgPr>
     </p:bg>
@@ -18914,8 +18910,28 @@
             <a:avLst/>
           </a:prstGeom>
           <a:solidFill>
-            <a:srgbClr val="1E40AF">
-              <a:alpha val="30000"/>
+            <a:srgbClr val="EFF6FF"/>
+          </a:solidFill>
+          <a:ln/>
+        </p:spPr>
+      </p:sp>
+      <p:sp>
+        <p:nvSpPr>
+          <p:cNvPr id="3" name="Shape 1"/>
+          <p:cNvSpPr/>
+          <p:nvPr/>
+        </p:nvSpPr>
+        <p:spPr>
+          <a:xfrm>
+            <a:off x="7315200" y="3657600"/>
+            <a:ext cx="3200400" cy="3200400"/>
+          </a:xfrm>
+          <a:prstGeom prst="ellipse">
+            <a:avLst/>
+          </a:prstGeom>
+          <a:solidFill>
+            <a:srgbClr val="F59E0B">
+              <a:alpha val="20000"/>
             </a:srgbClr>
           </a:solidFill>
           <a:ln/>
@@ -18923,28 +18939,6 @@
       </p:sp>
       <p:sp>
         <p:nvSpPr>
-          <p:cNvPr id="3" name="Shape 1"/>
-          <p:cNvSpPr/>
-          <p:nvPr/>
-        </p:nvSpPr>
-        <p:spPr>
-          <a:xfrm>
-            <a:off x="7315200" y="3657600"/>
-            <a:ext cx="3200400" cy="3200400"/>
-          </a:xfrm>
-          <a:prstGeom prst="ellipse">
-            <a:avLst/>
-          </a:prstGeom>
-          <a:solidFill>
-            <a:srgbClr val="F59E0B">
-              <a:alpha val="25000"/>
-            </a:srgbClr>
-          </a:solidFill>
-          <a:ln/>
-        </p:spPr>
-      </p:sp>
-      <p:sp>
-        <p:nvSpPr>
           <p:cNvPr id="4" name="Text 2"/>
           <p:cNvSpPr/>
           <p:nvPr/>
@@ -18970,7 +18964,7 @@
             <a:r>
               <a:rPr lang="en-US" sz="850" b="1" spc="300" kern="0" dirty="0">
                 <a:solidFill>
-                  <a:srgbClr val="94A3B8"/>
+                  <a:srgbClr val="64748B"/>
                 </a:solidFill>
                 <a:latin typeface="Calibri" pitchFamily="34" charset="0"/>
                 <a:ea typeface="Calibri" pitchFamily="34" charset="-122"/>
@@ -19029,7 +19023,7 @@
             <a:r>
               <a:rPr lang="en-US" sz="2200" b="1" dirty="0">
                 <a:solidFill>
-                  <a:srgbClr val="F1F5F9"/>
+                  <a:srgbClr val="0F172A"/>
                 </a:solidFill>
                 <a:latin typeface="Calibri" pitchFamily="34" charset="0"/>
                 <a:ea typeface="Calibri" pitchFamily="34" charset="-122"/>
@@ -19155,9 +19149,9 @@
             </a:avLst>
           </a:prstGeom>
           <a:solidFill>
-            <a:srgbClr val="1E293B"/>
+            <a:srgbClr val="FFFFFF"/>
           </a:solidFill>
-          <a:ln w="12700">
+          <a:ln w="15875">
             <a:solidFill>
               <a:srgbClr val="F59E0B"/>
             </a:solidFill>
@@ -19173,10 +19167,10 @@
         </p:nvSpPr>
         <p:spPr>
           <a:xfrm>
-            <a:off x="594360" y="1810512"/>
-            <a:ext cx="502920" cy="502920"/>
-          </a:xfrm>
-          <a:prstGeom prst="ellipse">
+            <a:off x="411480" y="1645920"/>
+            <a:ext cx="91440" cy="1257300"/>
+          </a:xfrm>
+          <a:prstGeom prst="rect">
             <a:avLst/>
           </a:prstGeom>
           <a:solidFill>
@@ -19185,9 +19179,29 @@
           <a:ln/>
         </p:spPr>
       </p:sp>
+      <p:sp>
+        <p:nvSpPr>
+          <p:cNvPr id="12" name="Shape 9"/>
+          <p:cNvSpPr/>
+          <p:nvPr/>
+        </p:nvSpPr>
+        <p:spPr>
+          <a:xfrm>
+            <a:off x="640080" y="1810512"/>
+            <a:ext cx="502920" cy="502920"/>
+          </a:xfrm>
+          <a:prstGeom prst="ellipse">
+            <a:avLst/>
+          </a:prstGeom>
+          <a:solidFill>
+            <a:srgbClr val="F59E0B"/>
+          </a:solidFill>
+          <a:ln/>
+        </p:spPr>
+      </p:sp>
       <p:pic>
         <p:nvPicPr>
-          <p:cNvPr id="12" name="Image 1" descr="preencoded.png">    </p:cNvPr>
+          <p:cNvPr id="13" name="Image 1" descr="preencoded.png">    </p:cNvPr>
           <p:cNvPicPr>
             <a:picLocks noChangeAspect="1"/>
           </p:cNvPicPr>
@@ -19201,7 +19215,7 @@
         </p:blipFill>
         <p:spPr>
           <a:xfrm>
-            <a:off x="694944" y="1911096"/>
+            <a:off x="740664" y="1911096"/>
             <a:ext cx="292608" cy="292608"/>
           </a:xfrm>
           <a:prstGeom prst="rect">
@@ -19211,14 +19225,14 @@
       </p:pic>
       <p:sp>
         <p:nvSpPr>
-          <p:cNvPr id="13" name="Text 9"/>
-          <p:cNvSpPr/>
-          <p:nvPr/>
-        </p:nvSpPr>
-        <p:spPr>
-          <a:xfrm>
-            <a:off x="1188720" y="1737360"/>
-            <a:ext cx="3154680" cy="320040"/>
+          <p:cNvPr id="14" name="Text 10"/>
+          <p:cNvSpPr/>
+          <p:nvPr/>
+        </p:nvSpPr>
+        <p:spPr>
+          <a:xfrm>
+            <a:off x="1234440" y="1737360"/>
+            <a:ext cx="3108960" cy="320040"/>
           </a:xfrm>
           <a:prstGeom prst="rect">
             <a:avLst/>
@@ -19250,14 +19264,14 @@
       </p:sp>
       <p:sp>
         <p:nvSpPr>
-          <p:cNvPr id="14" name="Text 10"/>
-          <p:cNvSpPr/>
-          <p:nvPr/>
-        </p:nvSpPr>
-        <p:spPr>
-          <a:xfrm>
-            <a:off x="1188720" y="2066544"/>
-            <a:ext cx="3154680" cy="228600"/>
+          <p:cNvPr id="15" name="Text 11"/>
+          <p:cNvSpPr/>
+          <p:nvPr/>
+        </p:nvSpPr>
+        <p:spPr>
+          <a:xfrm>
+            <a:off x="1234440" y="2066544"/>
+            <a:ext cx="3108960" cy="228600"/>
           </a:xfrm>
           <a:prstGeom prst="rect">
             <a:avLst/>
@@ -19275,7 +19289,7 @@
             <a:r>
               <a:rPr lang="en-US" sz="1000" b="1" dirty="0">
                 <a:solidFill>
-                  <a:srgbClr val="F1F5F9"/>
+                  <a:srgbClr val="1E293B"/>
                 </a:solidFill>
                 <a:latin typeface="Calibri" pitchFamily="34" charset="0"/>
                 <a:ea typeface="Calibri" pitchFamily="34" charset="-122"/>
@@ -19289,14 +19303,14 @@
       </p:sp>
       <p:sp>
         <p:nvSpPr>
-          <p:cNvPr id="15" name="Text 11"/>
-          <p:cNvSpPr/>
-          <p:nvPr/>
-        </p:nvSpPr>
-        <p:spPr>
-          <a:xfrm>
-            <a:off x="594360" y="2423160"/>
-            <a:ext cx="3703320" cy="388620"/>
+          <p:cNvPr id="16" name="Text 12"/>
+          <p:cNvSpPr/>
+          <p:nvPr/>
+        </p:nvSpPr>
+        <p:spPr>
+          <a:xfrm>
+            <a:off x="640080" y="2423160"/>
+            <a:ext cx="3657600" cy="388620"/>
           </a:xfrm>
           <a:prstGeom prst="rect">
             <a:avLst/>
@@ -19314,7 +19328,7 @@
             <a:r>
               <a:rPr lang="en-US" sz="1000" dirty="0">
                 <a:solidFill>
-                  <a:srgbClr val="94A3B8"/>
+                  <a:srgbClr val="475569"/>
                 </a:solidFill>
                 <a:latin typeface="Calibri" pitchFamily="34" charset="0"/>
                 <a:ea typeface="Calibri" pitchFamily="34" charset="-122"/>
@@ -19328,7 +19342,7 @@
       </p:sp>
       <p:sp>
         <p:nvSpPr>
-          <p:cNvPr id="16" name="Shape 12"/>
+          <p:cNvPr id="17" name="Shape 13"/>
           <p:cNvSpPr/>
           <p:nvPr/>
         </p:nvSpPr>
@@ -19343,11 +19357,11 @@
             </a:avLst>
           </a:prstGeom>
           <a:solidFill>
-            <a:srgbClr val="1E293B"/>
+            <a:srgbClr val="FFFFFF"/>
           </a:solidFill>
-          <a:ln w="12700">
+          <a:ln w="15875">
             <a:solidFill>
-              <a:srgbClr val="06B6D4"/>
+              <a:srgbClr val="0891B2"/>
             </a:solidFill>
             <a:prstDash val="solid"/>
           </a:ln>
@@ -19355,27 +19369,47 @@
       </p:sp>
       <p:sp>
         <p:nvSpPr>
-          <p:cNvPr id="17" name="Shape 13"/>
-          <p:cNvSpPr/>
-          <p:nvPr/>
-        </p:nvSpPr>
-        <p:spPr>
-          <a:xfrm>
-            <a:off x="4846320" y="1810512"/>
+          <p:cNvPr id="18" name="Shape 14"/>
+          <p:cNvSpPr/>
+          <p:nvPr/>
+        </p:nvSpPr>
+        <p:spPr>
+          <a:xfrm>
+            <a:off x="4663440" y="1645920"/>
+            <a:ext cx="91440" cy="1257300"/>
+          </a:xfrm>
+          <a:prstGeom prst="rect">
+            <a:avLst/>
+          </a:prstGeom>
+          <a:solidFill>
+            <a:srgbClr val="0891B2"/>
+          </a:solidFill>
+          <a:ln/>
+        </p:spPr>
+      </p:sp>
+      <p:sp>
+        <p:nvSpPr>
+          <p:cNvPr id="19" name="Shape 15"/>
+          <p:cNvSpPr/>
+          <p:nvPr/>
+        </p:nvSpPr>
+        <p:spPr>
+          <a:xfrm>
+            <a:off x="4892040" y="1810512"/>
             <a:ext cx="502920" cy="502920"/>
           </a:xfrm>
           <a:prstGeom prst="ellipse">
             <a:avLst/>
           </a:prstGeom>
           <a:solidFill>
-            <a:srgbClr val="06B6D4"/>
+            <a:srgbClr val="0891B2"/>
           </a:solidFill>
           <a:ln/>
         </p:spPr>
       </p:sp>
       <p:pic>
         <p:nvPicPr>
-          <p:cNvPr id="18" name="Image 2" descr="preencoded.png">    </p:cNvPr>
+          <p:cNvPr id="20" name="Image 2" descr="preencoded.png">    </p:cNvPr>
           <p:cNvPicPr>
             <a:picLocks noChangeAspect="1"/>
           </p:cNvPicPr>
@@ -19389,7 +19423,7 @@
         </p:blipFill>
         <p:spPr>
           <a:xfrm>
-            <a:off x="4946904" y="1911096"/>
+            <a:off x="4992624" y="1911096"/>
             <a:ext cx="292608" cy="292608"/>
           </a:xfrm>
           <a:prstGeom prst="rect">
@@ -19399,14 +19433,14 @@
       </p:pic>
       <p:sp>
         <p:nvSpPr>
-          <p:cNvPr id="19" name="Text 14"/>
-          <p:cNvSpPr/>
-          <p:nvPr/>
-        </p:nvSpPr>
-        <p:spPr>
-          <a:xfrm>
-            <a:off x="5440680" y="1737360"/>
-            <a:ext cx="3154680" cy="320040"/>
+          <p:cNvPr id="21" name="Text 16"/>
+          <p:cNvSpPr/>
+          <p:nvPr/>
+        </p:nvSpPr>
+        <p:spPr>
+          <a:xfrm>
+            <a:off x="5486400" y="1737360"/>
+            <a:ext cx="3108960" cy="320040"/>
           </a:xfrm>
           <a:prstGeom prst="rect">
             <a:avLst/>
@@ -19424,7 +19458,7 @@
             <a:r>
               <a:rPr lang="en-US" sz="1600" b="1" dirty="0">
                 <a:solidFill>
-                  <a:srgbClr val="06B6D4"/>
+                  <a:srgbClr val="0891B2"/>
                 </a:solidFill>
                 <a:latin typeface="Calibri" pitchFamily="34" charset="0"/>
                 <a:ea typeface="Calibri" pitchFamily="34" charset="-122"/>
@@ -19438,14 +19472,14 @@
       </p:sp>
       <p:sp>
         <p:nvSpPr>
-          <p:cNvPr id="20" name="Text 15"/>
-          <p:cNvSpPr/>
-          <p:nvPr/>
-        </p:nvSpPr>
-        <p:spPr>
-          <a:xfrm>
-            <a:off x="5440680" y="2066544"/>
-            <a:ext cx="3154680" cy="228600"/>
+          <p:cNvPr id="22" name="Text 17"/>
+          <p:cNvSpPr/>
+          <p:nvPr/>
+        </p:nvSpPr>
+        <p:spPr>
+          <a:xfrm>
+            <a:off x="5486400" y="2066544"/>
+            <a:ext cx="3108960" cy="228600"/>
           </a:xfrm>
           <a:prstGeom prst="rect">
             <a:avLst/>
@@ -19463,7 +19497,7 @@
             <a:r>
               <a:rPr lang="en-US" sz="1000" b="1" dirty="0">
                 <a:solidFill>
-                  <a:srgbClr val="F1F5F9"/>
+                  <a:srgbClr val="1E293B"/>
                 </a:solidFill>
                 <a:latin typeface="Calibri" pitchFamily="34" charset="0"/>
                 <a:ea typeface="Calibri" pitchFamily="34" charset="-122"/>
@@ -19477,14 +19511,14 @@
       </p:sp>
       <p:sp>
         <p:nvSpPr>
-          <p:cNvPr id="21" name="Text 16"/>
-          <p:cNvSpPr/>
-          <p:nvPr/>
-        </p:nvSpPr>
-        <p:spPr>
-          <a:xfrm>
-            <a:off x="4846320" y="2423160"/>
-            <a:ext cx="3703320" cy="388620"/>
+          <p:cNvPr id="23" name="Text 18"/>
+          <p:cNvSpPr/>
+          <p:nvPr/>
+        </p:nvSpPr>
+        <p:spPr>
+          <a:xfrm>
+            <a:off x="4892040" y="2423160"/>
+            <a:ext cx="3657600" cy="388620"/>
           </a:xfrm>
           <a:prstGeom prst="rect">
             <a:avLst/>
@@ -19502,7 +19536,7 @@
             <a:r>
               <a:rPr lang="en-US" sz="1000" dirty="0">
                 <a:solidFill>
-                  <a:srgbClr val="94A3B8"/>
+                  <a:srgbClr val="475569"/>
                 </a:solidFill>
                 <a:latin typeface="Calibri" pitchFamily="34" charset="0"/>
                 <a:ea typeface="Calibri" pitchFamily="34" charset="-122"/>
@@ -19516,7 +19550,7 @@
       </p:sp>
       <p:sp>
         <p:nvSpPr>
-          <p:cNvPr id="22" name="Shape 17"/>
+          <p:cNvPr id="24" name="Shape 19"/>
           <p:cNvSpPr/>
           <p:nvPr/>
         </p:nvSpPr>
@@ -19531,11 +19565,11 @@
             </a:avLst>
           </a:prstGeom>
           <a:solidFill>
-            <a:srgbClr val="1E293B"/>
+            <a:srgbClr val="FFFFFF"/>
           </a:solidFill>
-          <a:ln w="12700">
+          <a:ln w="15875">
             <a:solidFill>
-              <a:srgbClr val="3B82F6"/>
+              <a:srgbClr val="1E40AF"/>
             </a:solidFill>
             <a:prstDash val="solid"/>
           </a:ln>
@@ -19543,27 +19577,47 @@
       </p:sp>
       <p:sp>
         <p:nvSpPr>
-          <p:cNvPr id="23" name="Shape 18"/>
-          <p:cNvSpPr/>
-          <p:nvPr/>
-        </p:nvSpPr>
-        <p:spPr>
-          <a:xfrm>
-            <a:off x="594360" y="3204972"/>
+          <p:cNvPr id="25" name="Shape 20"/>
+          <p:cNvSpPr/>
+          <p:nvPr/>
+        </p:nvSpPr>
+        <p:spPr>
+          <a:xfrm>
+            <a:off x="411480" y="3040380"/>
+            <a:ext cx="91440" cy="1257300"/>
+          </a:xfrm>
+          <a:prstGeom prst="rect">
+            <a:avLst/>
+          </a:prstGeom>
+          <a:solidFill>
+            <a:srgbClr val="1E40AF"/>
+          </a:solidFill>
+          <a:ln/>
+        </p:spPr>
+      </p:sp>
+      <p:sp>
+        <p:nvSpPr>
+          <p:cNvPr id="26" name="Shape 21"/>
+          <p:cNvSpPr/>
+          <p:nvPr/>
+        </p:nvSpPr>
+        <p:spPr>
+          <a:xfrm>
+            <a:off x="640080" y="3204972"/>
             <a:ext cx="502920" cy="502920"/>
           </a:xfrm>
           <a:prstGeom prst="ellipse">
             <a:avLst/>
           </a:prstGeom>
           <a:solidFill>
-            <a:srgbClr val="3B82F6"/>
+            <a:srgbClr val="1E40AF"/>
           </a:solidFill>
           <a:ln/>
         </p:spPr>
       </p:sp>
       <p:pic>
         <p:nvPicPr>
-          <p:cNvPr id="24" name="Image 3" descr="preencoded.png">    </p:cNvPr>
+          <p:cNvPr id="27" name="Image 3" descr="preencoded.png">    </p:cNvPr>
           <p:cNvPicPr>
             <a:picLocks noChangeAspect="1"/>
           </p:cNvPicPr>
@@ -19577,7 +19631,7 @@
         </p:blipFill>
         <p:spPr>
           <a:xfrm>
-            <a:off x="694944" y="3305556"/>
+            <a:off x="740664" y="3305556"/>
             <a:ext cx="292608" cy="292608"/>
           </a:xfrm>
           <a:prstGeom prst="rect">
@@ -19587,14 +19641,14 @@
       </p:pic>
       <p:sp>
         <p:nvSpPr>
-          <p:cNvPr id="25" name="Text 19"/>
-          <p:cNvSpPr/>
-          <p:nvPr/>
-        </p:nvSpPr>
-        <p:spPr>
-          <a:xfrm>
-            <a:off x="1188720" y="3131820"/>
-            <a:ext cx="3154680" cy="320040"/>
+          <p:cNvPr id="28" name="Text 22"/>
+          <p:cNvSpPr/>
+          <p:nvPr/>
+        </p:nvSpPr>
+        <p:spPr>
+          <a:xfrm>
+            <a:off x="1234440" y="3131820"/>
+            <a:ext cx="3108960" cy="320040"/>
           </a:xfrm>
           <a:prstGeom prst="rect">
             <a:avLst/>
@@ -19612,7 +19666,7 @@
             <a:r>
               <a:rPr lang="en-US" sz="1600" b="1" dirty="0">
                 <a:solidFill>
-                  <a:srgbClr val="3B82F6"/>
+                  <a:srgbClr val="1E40AF"/>
                 </a:solidFill>
                 <a:latin typeface="Calibri" pitchFamily="34" charset="0"/>
                 <a:ea typeface="Calibri" pitchFamily="34" charset="-122"/>
@@ -19626,14 +19680,14 @@
       </p:sp>
       <p:sp>
         <p:nvSpPr>
-          <p:cNvPr id="26" name="Text 20"/>
-          <p:cNvSpPr/>
-          <p:nvPr/>
-        </p:nvSpPr>
-        <p:spPr>
-          <a:xfrm>
-            <a:off x="1188720" y="3461004"/>
-            <a:ext cx="3154680" cy="228600"/>
+          <p:cNvPr id="29" name="Text 23"/>
+          <p:cNvSpPr/>
+          <p:nvPr/>
+        </p:nvSpPr>
+        <p:spPr>
+          <a:xfrm>
+            <a:off x="1234440" y="3461004"/>
+            <a:ext cx="3108960" cy="228600"/>
           </a:xfrm>
           <a:prstGeom prst="rect">
             <a:avLst/>
@@ -19651,7 +19705,7 @@
             <a:r>
               <a:rPr lang="en-US" sz="1000" b="1" dirty="0">
                 <a:solidFill>
-                  <a:srgbClr val="F1F5F9"/>
+                  <a:srgbClr val="1E293B"/>
                 </a:solidFill>
                 <a:latin typeface="Calibri" pitchFamily="34" charset="0"/>
                 <a:ea typeface="Calibri" pitchFamily="34" charset="-122"/>
@@ -19665,14 +19719,14 @@
       </p:sp>
       <p:sp>
         <p:nvSpPr>
-          <p:cNvPr id="27" name="Text 21"/>
-          <p:cNvSpPr/>
-          <p:nvPr/>
-        </p:nvSpPr>
-        <p:spPr>
-          <a:xfrm>
-            <a:off x="594360" y="3817620"/>
-            <a:ext cx="3703320" cy="388620"/>
+          <p:cNvPr id="30" name="Text 24"/>
+          <p:cNvSpPr/>
+          <p:nvPr/>
+        </p:nvSpPr>
+        <p:spPr>
+          <a:xfrm>
+            <a:off x="640080" y="3817620"/>
+            <a:ext cx="3657600" cy="388620"/>
           </a:xfrm>
           <a:prstGeom prst="rect">
             <a:avLst/>
@@ -19690,7 +19744,7 @@
             <a:r>
               <a:rPr lang="en-US" sz="1000" dirty="0">
                 <a:solidFill>
-                  <a:srgbClr val="94A3B8"/>
+                  <a:srgbClr val="475569"/>
                 </a:solidFill>
                 <a:latin typeface="Calibri" pitchFamily="34" charset="0"/>
                 <a:ea typeface="Calibri" pitchFamily="34" charset="-122"/>
@@ -19704,7 +19758,7 @@
       </p:sp>
       <p:sp>
         <p:nvSpPr>
-          <p:cNvPr id="28" name="Shape 22"/>
+          <p:cNvPr id="31" name="Shape 25"/>
           <p:cNvSpPr/>
           <p:nvPr/>
         </p:nvSpPr>
@@ -19719,11 +19773,11 @@
             </a:avLst>
           </a:prstGeom>
           <a:solidFill>
-            <a:srgbClr val="1E293B"/>
+            <a:srgbClr val="FFFFFF"/>
           </a:solidFill>
-          <a:ln w="12700">
+          <a:ln w="15875">
             <a:solidFill>
-              <a:srgbClr val="94A3B8"/>
+              <a:srgbClr val="64748B"/>
             </a:solidFill>
             <a:prstDash val="solid"/>
           </a:ln>
@@ -19731,27 +19785,47 @@
       </p:sp>
       <p:sp>
         <p:nvSpPr>
-          <p:cNvPr id="29" name="Shape 23"/>
-          <p:cNvSpPr/>
-          <p:nvPr/>
-        </p:nvSpPr>
-        <p:spPr>
-          <a:xfrm>
-            <a:off x="4846320" y="3204972"/>
+          <p:cNvPr id="32" name="Shape 26"/>
+          <p:cNvSpPr/>
+          <p:nvPr/>
+        </p:nvSpPr>
+        <p:spPr>
+          <a:xfrm>
+            <a:off x="4663440" y="3040380"/>
+            <a:ext cx="91440" cy="1257300"/>
+          </a:xfrm>
+          <a:prstGeom prst="rect">
+            <a:avLst/>
+          </a:prstGeom>
+          <a:solidFill>
+            <a:srgbClr val="64748B"/>
+          </a:solidFill>
+          <a:ln/>
+        </p:spPr>
+      </p:sp>
+      <p:sp>
+        <p:nvSpPr>
+          <p:cNvPr id="33" name="Shape 27"/>
+          <p:cNvSpPr/>
+          <p:nvPr/>
+        </p:nvSpPr>
+        <p:spPr>
+          <a:xfrm>
+            <a:off x="4892040" y="3204972"/>
             <a:ext cx="502920" cy="502920"/>
           </a:xfrm>
           <a:prstGeom prst="ellipse">
             <a:avLst/>
           </a:prstGeom>
           <a:solidFill>
-            <a:srgbClr val="94A3B8"/>
+            <a:srgbClr val="64748B"/>
           </a:solidFill>
           <a:ln/>
         </p:spPr>
       </p:sp>
       <p:pic>
         <p:nvPicPr>
-          <p:cNvPr id="30" name="Image 4" descr="preencoded.png">    </p:cNvPr>
+          <p:cNvPr id="34" name="Image 4" descr="preencoded.png">    </p:cNvPr>
           <p:cNvPicPr>
             <a:picLocks noChangeAspect="1"/>
           </p:cNvPicPr>
@@ -19765,7 +19839,7 @@
         </p:blipFill>
         <p:spPr>
           <a:xfrm>
-            <a:off x="4946904" y="3305556"/>
+            <a:off x="4992624" y="3305556"/>
             <a:ext cx="292608" cy="292608"/>
           </a:xfrm>
           <a:prstGeom prst="rect">
@@ -19775,14 +19849,14 @@
       </p:pic>
       <p:sp>
         <p:nvSpPr>
-          <p:cNvPr id="31" name="Text 24"/>
-          <p:cNvSpPr/>
-          <p:nvPr/>
-        </p:nvSpPr>
-        <p:spPr>
-          <a:xfrm>
-            <a:off x="5440680" y="3131820"/>
-            <a:ext cx="3154680" cy="320040"/>
+          <p:cNvPr id="35" name="Text 28"/>
+          <p:cNvSpPr/>
+          <p:nvPr/>
+        </p:nvSpPr>
+        <p:spPr>
+          <a:xfrm>
+            <a:off x="5486400" y="3131820"/>
+            <a:ext cx="3108960" cy="320040"/>
           </a:xfrm>
           <a:prstGeom prst="rect">
             <a:avLst/>
@@ -19800,7 +19874,7 @@
             <a:r>
               <a:rPr lang="en-US" sz="1600" b="1" dirty="0">
                 <a:solidFill>
-                  <a:srgbClr val="94A3B8"/>
+                  <a:srgbClr val="64748B"/>
                 </a:solidFill>
                 <a:latin typeface="Calibri" pitchFamily="34" charset="0"/>
                 <a:ea typeface="Calibri" pitchFamily="34" charset="-122"/>
@@ -19814,14 +19888,14 @@
       </p:sp>
       <p:sp>
         <p:nvSpPr>
-          <p:cNvPr id="32" name="Text 25"/>
-          <p:cNvSpPr/>
-          <p:nvPr/>
-        </p:nvSpPr>
-        <p:spPr>
-          <a:xfrm>
-            <a:off x="5440680" y="3461004"/>
-            <a:ext cx="3154680" cy="228600"/>
+          <p:cNvPr id="36" name="Text 29"/>
+          <p:cNvSpPr/>
+          <p:nvPr/>
+        </p:nvSpPr>
+        <p:spPr>
+          <a:xfrm>
+            <a:off x="5486400" y="3461004"/>
+            <a:ext cx="3108960" cy="228600"/>
           </a:xfrm>
           <a:prstGeom prst="rect">
             <a:avLst/>
@@ -19839,7 +19913,7 @@
             <a:r>
               <a:rPr lang="en-US" sz="1000" b="1" dirty="0">
                 <a:solidFill>
-                  <a:srgbClr val="F1F5F9"/>
+                  <a:srgbClr val="1E293B"/>
                 </a:solidFill>
                 <a:latin typeface="Calibri" pitchFamily="34" charset="0"/>
                 <a:ea typeface="Calibri" pitchFamily="34" charset="-122"/>
@@ -19853,14 +19927,14 @@
       </p:sp>
       <p:sp>
         <p:nvSpPr>
-          <p:cNvPr id="33" name="Text 26"/>
-          <p:cNvSpPr/>
-          <p:nvPr/>
-        </p:nvSpPr>
-        <p:spPr>
-          <a:xfrm>
-            <a:off x="4846320" y="3817620"/>
-            <a:ext cx="3703320" cy="388620"/>
+          <p:cNvPr id="37" name="Text 30"/>
+          <p:cNvSpPr/>
+          <p:nvPr/>
+        </p:nvSpPr>
+        <p:spPr>
+          <a:xfrm>
+            <a:off x="4892040" y="3817620"/>
+            <a:ext cx="3657600" cy="388620"/>
           </a:xfrm>
           <a:prstGeom prst="rect">
             <a:avLst/>
@@ -19878,7 +19952,7 @@
             <a:r>
               <a:rPr lang="en-US" sz="1000" dirty="0">
                 <a:solidFill>
-                  <a:srgbClr val="94A3B8"/>
+                  <a:srgbClr val="475569"/>
                 </a:solidFill>
                 <a:latin typeface="Calibri" pitchFamily="34" charset="0"/>
                 <a:ea typeface="Calibri" pitchFamily="34" charset="-122"/>
@@ -19892,7 +19966,7 @@
       </p:sp>
       <p:sp>
         <p:nvSpPr>
-          <p:cNvPr id="34" name="Text 27"/>
+          <p:cNvPr id="38" name="Text 31"/>
           <p:cNvSpPr/>
           <p:nvPr/>
         </p:nvSpPr>
@@ -19917,7 +19991,7 @@
             <a:r>
               <a:rPr lang="en-US" sz="2400" b="1" i="1" dirty="0">
                 <a:solidFill>
-                  <a:srgbClr val="F59E0B"/>
+                  <a:srgbClr val="D97706"/>
                 </a:solidFill>
                 <a:latin typeface="Cambria" pitchFamily="34" charset="0"/>
                 <a:ea typeface="Cambria" pitchFamily="34" charset="-122"/>
@@ -19931,7 +20005,7 @@
       </p:sp>
       <p:pic>
         <p:nvPicPr>
-          <p:cNvPr id="35" name="Image 5" descr="D:\repos\kb-semantic-search-benchmark\thesis\scripts\_logo_hex.png">    </p:cNvPr>
+          <p:cNvPr id="39" name="Image 5" descr="D:\repos\kb-semantic-search-benchmark\thesis\scripts\_logo_hex.png">    </p:cNvPr>
           <p:cNvPicPr>
             <a:picLocks noChangeAspect="1"/>
           </p:cNvPicPr>
@@ -19955,7 +20029,7 @@
       </p:pic>
       <p:sp>
         <p:nvSpPr>
-          <p:cNvPr id="36" name="Text 28"/>
+          <p:cNvPr id="40" name="Text 32"/>
           <p:cNvSpPr/>
           <p:nvPr/>
         </p:nvSpPr>
@@ -19980,7 +20054,7 @@
             <a:r>
               <a:rPr lang="en-US" sz="900" dirty="0">
                 <a:solidFill>
-                  <a:srgbClr val="94A3B8"/>
+                  <a:srgbClr val="64748B"/>
                 </a:solidFill>
                 <a:latin typeface="Calibri" pitchFamily="34" charset="0"/>
                 <a:ea typeface="Calibri" pitchFamily="34" charset="-122"/>

</xml_diff>

<commit_message>
Slide 11: drop chunks visualization, emphasize balanced 100/100/100 queries
The chunks doughnut was visually highlighting an asymmetric corpus
distribution (12% / 70% / 18%), which distracted from the central fact
that the evaluation budget is balanced. Replaced the right-hand column
with a "ЗБАЛАНСОВАНА ОЦІНКА" callout — three equal "100" stats per
domain, total 300 queries, with the explanation that per-query metrics
(nDCG, MRR, Recall, P) are computed on these. Domain cards now show
documents + queries (no chunks). Subtitle similarly trimmed.

Co-Authored-By: Claude Opus 4.7 (1M context) <noreply@anthropic.com>
</commit_message>
<xml_diff>
--- a/thesis/Nesterenko_Presentation.pptx
+++ b/thesis/Nesterenko_Presentation.pptx
@@ -649,604 +649,6 @@
     <c:autoTitleDeleted val="1"/>
     <c:plotArea>
       <c:layout/>
-      <c:barChart>
-        <c:barDir val="col"/>
-        <c:grouping val="clustered"/>
-        <c:varyColors val="0"/>
-        <c:ser>
-          <c:idx val="0"/>
-          <c:order val="0"/>
-          <c:tx>
-            <c:strRef>
-              <c:f>Sheet1!$B$1</c:f>
-              <c:strCache>
-                <c:ptCount val="1"/>
-                <c:pt idx="0">
-                  <c:v>BGE-M3</c:v>
-                </c:pt>
-              </c:strCache>
-            </c:strRef>
-          </c:tx>
-          <c:spPr>
-            <a:solidFill>
-              <a:srgbClr val="F59E0B"/>
-            </a:solidFill>
-            <a:effectLst/>
-          </c:spPr>
-          <c:invertIfNegative val="0"/>
-          <c:dLbls>
-            <c:numFmt formatCode="0.00" sourceLinked="0"/>
-            <c:txPr>
-              <a:bodyPr/>
-              <a:lstStyle/>
-              <a:p>
-                <a:pPr>
-                  <a:defRPr b="0" i="0" strike="noStrike" sz="750" u="none">
-                    <a:solidFill>
-                      <a:srgbClr val="1E293B"/>
-                    </a:solidFill>
-                    <a:latin typeface="Calibri"/>
-                  </a:defRPr>
-                </a:pPr>
-              </a:p>
-            </c:txPr>
-            <c:showLegendKey val="0"/>
-            <c:showVal val="1"/>
-            <c:showCatName val="0"/>
-            <c:showSerName val="0"/>
-            <c:showPercent val="0"/>
-            <c:showBubbleSize val="0"/>
-            <c:showLeaderLines val="0"/>
-          </c:dLbls>
-          <c:cat>
-            <c:multiLvlStrRef>
-              <c:f>Sheet1!$A$2:$A$4</c:f>
-              <c:multiLvlStrCache>
-                <c:ptCount val="3"/>
-                <c:lvl>
-                  <c:pt idx="0">
-                    <c:v>Технічний</c:v>
-                  </c:pt>
-                  <c:pt idx="1">
-                    <c:v>Юридичний</c:v>
-                  </c:pt>
-                  <c:pt idx="2">
-                    <c:v>Медичний</c:v>
-                  </c:pt>
-                </c:lvl>
-              </c:multiLvlStrCache>
-            </c:multiLvlStrRef>
-          </c:cat>
-          <c:val>
-            <c:numRef>
-              <c:f>Sheet1!$B$2:$B$4</c:f>
-              <c:numCache>
-                <c:formatCode>General</c:formatCode>
-                <c:ptCount val="3"/>
-                <c:pt idx="0">
-                  <c:v>0.904</c:v>
-                </c:pt>
-                <c:pt idx="1">
-                  <c:v>0.872</c:v>
-                </c:pt>
-                <c:pt idx="2">
-                  <c:v>0.912</c:v>
-                </c:pt>
-              </c:numCache>
-            </c:numRef>
-          </c:val>
-        </c:ser>
-        <c:ser>
-          <c:idx val="1"/>
-          <c:order val="1"/>
-          <c:tx>
-            <c:strRef>
-              <c:f>Sheet1!$C$1</c:f>
-              <c:strCache>
-                <c:ptCount val="1"/>
-                <c:pt idx="0">
-                  <c:v>Qwen3</c:v>
-                </c:pt>
-              </c:strCache>
-            </c:strRef>
-          </c:tx>
-          <c:spPr>
-            <a:solidFill>
-              <a:srgbClr val="1E40AF"/>
-            </a:solidFill>
-            <a:effectLst/>
-          </c:spPr>
-          <c:invertIfNegative val="0"/>
-          <c:dLbls>
-            <c:numFmt formatCode="0.00" sourceLinked="0"/>
-            <c:txPr>
-              <a:bodyPr/>
-              <a:lstStyle/>
-              <a:p>
-                <a:pPr>
-                  <a:defRPr b="0" i="0" strike="noStrike" sz="750" u="none">
-                    <a:solidFill>
-                      <a:srgbClr val="1E293B"/>
-                    </a:solidFill>
-                    <a:latin typeface="Calibri"/>
-                  </a:defRPr>
-                </a:pPr>
-              </a:p>
-            </c:txPr>
-            <c:showLegendKey val="0"/>
-            <c:showVal val="1"/>
-            <c:showCatName val="0"/>
-            <c:showSerName val="0"/>
-            <c:showPercent val="0"/>
-            <c:showBubbleSize val="0"/>
-            <c:showLeaderLines val="0"/>
-          </c:dLbls>
-          <c:cat>
-            <c:multiLvlStrRef>
-              <c:f>Sheet1!$A$2:$A$4</c:f>
-              <c:multiLvlStrCache>
-                <c:ptCount val="3"/>
-                <c:lvl>
-                  <c:pt idx="0">
-                    <c:v>Технічний</c:v>
-                  </c:pt>
-                  <c:pt idx="1">
-                    <c:v>Юридичний</c:v>
-                  </c:pt>
-                  <c:pt idx="2">
-                    <c:v>Медичний</c:v>
-                  </c:pt>
-                </c:lvl>
-              </c:multiLvlStrCache>
-            </c:multiLvlStrRef>
-          </c:cat>
-          <c:val>
-            <c:numRef>
-              <c:f>Sheet1!$C$2:$C$4</c:f>
-              <c:numCache>
-                <c:formatCode>General</c:formatCode>
-                <c:ptCount val="3"/>
-                <c:pt idx="0">
-                  <c:v>0.825</c:v>
-                </c:pt>
-                <c:pt idx="1">
-                  <c:v>0.914</c:v>
-                </c:pt>
-                <c:pt idx="2">
-                  <c:v>0.802</c:v>
-                </c:pt>
-              </c:numCache>
-            </c:numRef>
-          </c:val>
-        </c:ser>
-        <c:ser>
-          <c:idx val="2"/>
-          <c:order val="2"/>
-          <c:tx>
-            <c:strRef>
-              <c:f>Sheet1!$D$1</c:f>
-              <c:strCache>
-                <c:ptCount val="1"/>
-                <c:pt idx="0">
-                  <c:v>E5-base</c:v>
-                </c:pt>
-              </c:strCache>
-            </c:strRef>
-          </c:tx>
-          <c:spPr>
-            <a:solidFill>
-              <a:srgbClr val="0891B2"/>
-            </a:solidFill>
-            <a:effectLst/>
-          </c:spPr>
-          <c:invertIfNegative val="0"/>
-          <c:dLbls>
-            <c:numFmt formatCode="0.00" sourceLinked="0"/>
-            <c:txPr>
-              <a:bodyPr/>
-              <a:lstStyle/>
-              <a:p>
-                <a:pPr>
-                  <a:defRPr b="0" i="0" strike="noStrike" sz="750" u="none">
-                    <a:solidFill>
-                      <a:srgbClr val="1E293B"/>
-                    </a:solidFill>
-                    <a:latin typeface="Calibri"/>
-                  </a:defRPr>
-                </a:pPr>
-              </a:p>
-            </c:txPr>
-            <c:showLegendKey val="0"/>
-            <c:showVal val="1"/>
-            <c:showCatName val="0"/>
-            <c:showSerName val="0"/>
-            <c:showPercent val="0"/>
-            <c:showBubbleSize val="0"/>
-            <c:showLeaderLines val="0"/>
-          </c:dLbls>
-          <c:cat>
-            <c:multiLvlStrRef>
-              <c:f>Sheet1!$A$2:$A$4</c:f>
-              <c:multiLvlStrCache>
-                <c:ptCount val="3"/>
-                <c:lvl>
-                  <c:pt idx="0">
-                    <c:v>Технічний</c:v>
-                  </c:pt>
-                  <c:pt idx="1">
-                    <c:v>Юридичний</c:v>
-                  </c:pt>
-                  <c:pt idx="2">
-                    <c:v>Медичний</c:v>
-                  </c:pt>
-                </c:lvl>
-              </c:multiLvlStrCache>
-            </c:multiLvlStrRef>
-          </c:cat>
-          <c:val>
-            <c:numRef>
-              <c:f>Sheet1!$D$2:$D$4</c:f>
-              <c:numCache>
-                <c:formatCode>General</c:formatCode>
-                <c:ptCount val="3"/>
-                <c:pt idx="0">
-                  <c:v>0.875</c:v>
-                </c:pt>
-                <c:pt idx="1">
-                  <c:v>0.844</c:v>
-                </c:pt>
-                <c:pt idx="2">
-                  <c:v>0.901</c:v>
-                </c:pt>
-              </c:numCache>
-            </c:numRef>
-          </c:val>
-        </c:ser>
-        <c:ser>
-          <c:idx val="3"/>
-          <c:order val="3"/>
-          <c:tx>
-            <c:strRef>
-              <c:f>Sheet1!$E$1</c:f>
-              <c:strCache>
-                <c:ptCount val="1"/>
-                <c:pt idx="0">
-                  <c:v>BM25</c:v>
-                </c:pt>
-              </c:strCache>
-            </c:strRef>
-          </c:tx>
-          <c:spPr>
-            <a:solidFill>
-              <a:srgbClr val="64748B"/>
-            </a:solidFill>
-            <a:effectLst/>
-          </c:spPr>
-          <c:invertIfNegative val="0"/>
-          <c:dLbls>
-            <c:numFmt formatCode="0.00" sourceLinked="0"/>
-            <c:txPr>
-              <a:bodyPr/>
-              <a:lstStyle/>
-              <a:p>
-                <a:pPr>
-                  <a:defRPr b="0" i="0" strike="noStrike" sz="750" u="none">
-                    <a:solidFill>
-                      <a:srgbClr val="1E293B"/>
-                    </a:solidFill>
-                    <a:latin typeface="Calibri"/>
-                  </a:defRPr>
-                </a:pPr>
-              </a:p>
-            </c:txPr>
-            <c:showLegendKey val="0"/>
-            <c:showVal val="1"/>
-            <c:showCatName val="0"/>
-            <c:showSerName val="0"/>
-            <c:showPercent val="0"/>
-            <c:showBubbleSize val="0"/>
-            <c:showLeaderLines val="0"/>
-          </c:dLbls>
-          <c:cat>
-            <c:multiLvlStrRef>
-              <c:f>Sheet1!$A$2:$A$4</c:f>
-              <c:multiLvlStrCache>
-                <c:ptCount val="3"/>
-                <c:lvl>
-                  <c:pt idx="0">
-                    <c:v>Технічний</c:v>
-                  </c:pt>
-                  <c:pt idx="1">
-                    <c:v>Юридичний</c:v>
-                  </c:pt>
-                  <c:pt idx="2">
-                    <c:v>Медичний</c:v>
-                  </c:pt>
-                </c:lvl>
-              </c:multiLvlStrCache>
-            </c:multiLvlStrRef>
-          </c:cat>
-          <c:val>
-            <c:numRef>
-              <c:f>Sheet1!$E$2:$E$4</c:f>
-              <c:numCache>
-                <c:formatCode>General</c:formatCode>
-                <c:ptCount val="3"/>
-                <c:pt idx="0">
-                  <c:v>0.795</c:v>
-                </c:pt>
-                <c:pt idx="1">
-                  <c:v>0.741</c:v>
-                </c:pt>
-                <c:pt idx="2">
-                  <c:v>0.817</c:v>
-                </c:pt>
-              </c:numCache>
-            </c:numRef>
-          </c:val>
-        </c:ser>
-        <c:ser>
-          <c:idx val="4"/>
-          <c:order val="4"/>
-          <c:tx>
-            <c:strRef>
-              <c:f>Sheet1!$F$1</c:f>
-              <c:strCache>
-                <c:ptCount val="1"/>
-                <c:pt idx="0">
-                  <c:v>nomic</c:v>
-                </c:pt>
-              </c:strCache>
-            </c:strRef>
-          </c:tx>
-          <c:spPr>
-            <a:solidFill>
-              <a:srgbClr val="7C3AED"/>
-            </a:solidFill>
-            <a:effectLst/>
-          </c:spPr>
-          <c:invertIfNegative val="0"/>
-          <c:dLbls>
-            <c:numFmt formatCode="0.00" sourceLinked="0"/>
-            <c:txPr>
-              <a:bodyPr/>
-              <a:lstStyle/>
-              <a:p>
-                <a:pPr>
-                  <a:defRPr b="0" i="0" strike="noStrike" sz="750" u="none">
-                    <a:solidFill>
-                      <a:srgbClr val="1E293B"/>
-                    </a:solidFill>
-                    <a:latin typeface="Calibri"/>
-                  </a:defRPr>
-                </a:pPr>
-              </a:p>
-            </c:txPr>
-            <c:showLegendKey val="0"/>
-            <c:showVal val="1"/>
-            <c:showCatName val="0"/>
-            <c:showSerName val="0"/>
-            <c:showPercent val="0"/>
-            <c:showBubbleSize val="0"/>
-            <c:showLeaderLines val="0"/>
-          </c:dLbls>
-          <c:cat>
-            <c:multiLvlStrRef>
-              <c:f>Sheet1!$A$2:$A$4</c:f>
-              <c:multiLvlStrCache>
-                <c:ptCount val="3"/>
-                <c:lvl>
-                  <c:pt idx="0">
-                    <c:v>Технічний</c:v>
-                  </c:pt>
-                  <c:pt idx="1">
-                    <c:v>Юридичний</c:v>
-                  </c:pt>
-                  <c:pt idx="2">
-                    <c:v>Медичний</c:v>
-                  </c:pt>
-                </c:lvl>
-              </c:multiLvlStrCache>
-            </c:multiLvlStrRef>
-          </c:cat>
-          <c:val>
-            <c:numRef>
-              <c:f>Sheet1!$F$2:$F$4</c:f>
-              <c:numCache>
-                <c:formatCode>General</c:formatCode>
-                <c:ptCount val="3"/>
-                <c:pt idx="0">
-                  <c:v>0.611</c:v>
-                </c:pt>
-                <c:pt idx="1">
-                  <c:v>0.503</c:v>
-                </c:pt>
-                <c:pt idx="2">
-                  <c:v>0.568</c:v>
-                </c:pt>
-              </c:numCache>
-            </c:numRef>
-          </c:val>
-        </c:ser>
-        <c:dLbls>
-          <c:numFmt formatCode="0.00" sourceLinked="0"/>
-          <c:txPr>
-            <a:bodyPr/>
-            <a:lstStyle/>
-            <a:p>
-              <a:pPr>
-                <a:defRPr b="0" i="0" strike="noStrike" sz="750" u="none">
-                  <a:solidFill>
-                    <a:srgbClr val="1E293B"/>
-                  </a:solidFill>
-                  <a:latin typeface="Calibri"/>
-                </a:defRPr>
-              </a:pPr>
-            </a:p>
-          </c:txPr>
-          <c:showLegendKey val="0"/>
-          <c:showVal val="1"/>
-          <c:showCatName val="0"/>
-          <c:showSerName val="0"/>
-          <c:showPercent val="0"/>
-          <c:showBubbleSize val="0"/>
-          <c:showLeaderLines val="0"/>
-        </c:dLbls>
-        <c:gapWidth val="150"/>
-        <c:overlap val="0"/>
-        <c:axId val="2094734554"/>
-        <c:axId val="2094734552"/>
-        <c:axId val="2094734556"/>
-      </c:barChart>
-      <c:catAx>
-        <c:axId val="2094734554"/>
-        <c:scaling>
-          <c:orientation val="minMax"/>
-        </c:scaling>
-        <c:delete val="0"/>
-        <c:axPos val="b"/>
-        <c:numFmt formatCode="General" sourceLinked="1"/>
-        <c:majorTickMark val="out"/>
-        <c:minorTickMark val="none"/>
-        <c:tickLblPos val="low"/>
-        <c:spPr>
-          <a:ln w="12700" cap="flat">
-            <a:solidFill>
-              <a:srgbClr val="888888"/>
-            </a:solidFill>
-            <a:prstDash val="solid"/>
-            <a:round/>
-          </a:ln>
-        </c:spPr>
-        <c:txPr>
-          <a:bodyPr/>
-          <a:lstStyle/>
-          <a:p>
-            <a:pPr>
-              <a:defRPr sz="1000" b="0" i="0" u="none" strike="noStrike">
-                <a:solidFill>
-                  <a:srgbClr val="1E293B"/>
-                </a:solidFill>
-                <a:latin typeface="Calibri"/>
-              </a:defRPr>
-            </a:pPr>
-            <a:endParaRPr lang="en-US"/>
-          </a:p>
-        </c:txPr>
-        <c:crossAx val="2094734552"/>
-        <c:crosses val="autoZero"/>
-        <c:auto val="1"/>
-        <c:lblAlgn val="ctr"/>
-        <c:noMultiLvlLbl val="1"/>
-      </c:catAx>
-      <c:valAx>
-        <c:axId val="2094734552"/>
-        <c:scaling>
-          <c:orientation val="minMax"/>
-          <c:max val="1"/>
-          <c:min val="0"/>
-        </c:scaling>
-        <c:delete val="0"/>
-        <c:axPos val="l"/>
-        <c:majorGridlines>
-          <c:spPr>
-            <a:ln w="6350" cap="flat">
-              <a:solidFill>
-                <a:srgbClr val="E2E8F0"/>
-              </a:solidFill>
-              <a:prstDash val="solid"/>
-              <a:round/>
-            </a:ln>
-          </c:spPr>
-        </c:majorGridlines>
-        <c:numFmt formatCode="General" sourceLinked="0"/>
-        <c:majorTickMark val="out"/>
-        <c:minorTickMark val="none"/>
-        <c:tickLblPos val="nextTo"/>
-        <c:spPr>
-          <a:ln w="12700" cap="flat">
-            <a:solidFill>
-              <a:srgbClr val="888888"/>
-            </a:solidFill>
-            <a:prstDash val="solid"/>
-            <a:round/>
-          </a:ln>
-        </c:spPr>
-        <c:txPr>
-          <a:bodyPr/>
-          <a:lstStyle/>
-          <a:p>
-            <a:pPr>
-              <a:defRPr sz="900" b="0" i="0" u="none" strike="noStrike">
-                <a:solidFill>
-                  <a:srgbClr val="475569"/>
-                </a:solidFill>
-                <a:latin typeface="Calibri"/>
-              </a:defRPr>
-            </a:pPr>
-            <a:endParaRPr lang="en-US"/>
-          </a:p>
-        </c:txPr>
-        <c:crossAx val="2094734554"/>
-        <c:crosses val="autoZero"/>
-        <c:crossBetween val="between"/>
-      </c:valAx>
-      <c:spPr>
-        <a:solidFill>
-          <a:srgbClr val="F8FAFC"/>
-        </a:solidFill>
-        <a:ln>
-          <a:noFill/>
-        </a:ln>
-        <a:effectLst/>
-      </c:spPr>
-    </c:plotArea>
-    <c:legend>
-      <c:legendPos val="b"/>
-      <c:overlay val="0"/>
-      <c:txPr>
-        <a:bodyPr/>
-        <a:lstStyle/>
-        <a:p>
-          <a:pPr>
-            <a:defRPr sz="900">
-              <a:solidFill>
-                <a:srgbClr val="1E293B"/>
-              </a:solidFill>
-              <a:latin typeface="Calibri"/>
-              <a:cs typeface="Calibri"/>
-            </a:defRPr>
-          </a:pPr>
-          <a:endParaRPr lang="en-US"/>
-        </a:p>
-      </c:txPr>
-    </c:legend>
-    <c:plotVisOnly val="1"/>
-    <c:dispBlanksAs val="span"/>
-  </c:chart>
-  <c:spPr>
-    <a:solidFill>
-      <a:srgbClr val="F8FAFC"/>
-    </a:solidFill>
-    <a:ln>
-      <a:noFill/>
-    </a:ln>
-    <a:effectLst/>
-  </c:spPr>
-  <c:externalData r:id="rId1">
-    <c:autoUpdate val="0"/>
-  </c:externalData>
-</c:chartSpace>
-</file>
-
-<file path=ppt/charts/chart11.xml><?xml version="1.0" encoding="utf-8"?>
-<c:chartSpace xmlns:c="http://schemas.openxmlformats.org/drawingml/2006/chart" xmlns:a="http://schemas.openxmlformats.org/drawingml/2006/main" xmlns:r="http://schemas.openxmlformats.org/officeDocument/2006/relationships">
-  <c:date1904 val="0"/>
-  <c:roundedCorners val="1"/>
-  <c:chart>
-    <c:autoTitleDeleted val="1"/>
-    <c:plotArea>
-      <c:layout/>
       <c:scatterChart>
         <c:scatterStyle val="lineMarker"/>
         <c:varyColors val="0"/>
@@ -2681,258 +2083,6 @@
     <c:autoTitleDeleted val="1"/>
     <c:plotArea>
       <c:layout/>
-      <c:doughnutChart>
-        <c:varyColors val="1"/>
-        <c:ser>
-          <c:idx val="0"/>
-          <c:order val="0"/>
-          <c:tx>
-            <c:strRef>
-              <c:f>Sheet1!$B$1</c:f>
-              <c:strCache>
-                <c:ptCount val="1"/>
-                <c:pt idx="0">
-                  <c:v>Чанки</c:v>
-                </c:pt>
-              </c:strCache>
-            </c:strRef>
-          </c:tx>
-          <c:spPr>
-            <a:solidFill>
-              <a:schemeClr val="accent1"/>
-            </a:solidFill>
-            <a:ln w="9525" cap="flat">
-              <a:solidFill>
-                <a:srgbClr val="F9F9F9"/>
-              </a:solidFill>
-              <a:prstDash val="solid"/>
-              <a:round/>
-            </a:ln>
-            <a:effectLst/>
-          </c:spPr>
-          <c:dPt>
-            <c:idx val="0"/>
-            <c:bubble3D val="0"/>
-            <c:spPr>
-              <a:solidFill>
-                <a:srgbClr val="1E40AF"/>
-              </a:solidFill>
-              <a:effectLst/>
-            </c:spPr>
-          </c:dPt>
-          <c:dPt>
-            <c:idx val="1"/>
-            <c:bubble3D val="0"/>
-            <c:spPr>
-              <a:solidFill>
-                <a:srgbClr val="7C3AED"/>
-              </a:solidFill>
-              <a:effectLst/>
-            </c:spPr>
-          </c:dPt>
-          <c:dPt>
-            <c:idx val="2"/>
-            <c:bubble3D val="0"/>
-            <c:spPr>
-              <a:solidFill>
-                <a:srgbClr val="E11D48"/>
-              </a:solidFill>
-              <a:effectLst/>
-            </c:spPr>
-          </c:dPt>
-          <c:dLbls>
-            <c:dLbl>
-              <c:idx val="0"/>
-              <c:numFmt formatCode="0%" sourceLinked="0"/>
-              <c:spPr/>
-              <c:txPr>
-                <a:bodyPr/>
-                <a:lstStyle/>
-                <a:p>
-                  <a:pPr>
-                    <a:defRPr sz="1000" b="1" i="0" u="none" strike="noStrike">
-                      <a:solidFill>
-                        <a:srgbClr val="1E293B"/>
-                      </a:solidFill>
-                      <a:latin typeface="Calibri"/>
-                    </a:defRPr>
-                  </a:pPr>
-                </a:p>
-              </c:txPr>
-              <c:showLegendKey val="0"/>
-              <c:showVal val="0"/>
-              <c:showCatName val="0"/>
-              <c:showSerName val="0"/>
-              <c:showPercent val="1"/>
-              <c:showBubbleSize val="0"/>
-            </c:dLbl>
-            <c:dLbl>
-              <c:idx val="1"/>
-              <c:numFmt formatCode="0%" sourceLinked="0"/>
-              <c:spPr/>
-              <c:txPr>
-                <a:bodyPr/>
-                <a:lstStyle/>
-                <a:p>
-                  <a:pPr>
-                    <a:defRPr sz="1000" b="1" i="0" u="none" strike="noStrike">
-                      <a:solidFill>
-                        <a:srgbClr val="1E293B"/>
-                      </a:solidFill>
-                      <a:latin typeface="Calibri"/>
-                    </a:defRPr>
-                  </a:pPr>
-                </a:p>
-              </c:txPr>
-              <c:showLegendKey val="0"/>
-              <c:showVal val="0"/>
-              <c:showCatName val="0"/>
-              <c:showSerName val="0"/>
-              <c:showPercent val="1"/>
-              <c:showBubbleSize val="0"/>
-            </c:dLbl>
-            <c:dLbl>
-              <c:idx val="2"/>
-              <c:numFmt formatCode="0%" sourceLinked="0"/>
-              <c:spPr/>
-              <c:txPr>
-                <a:bodyPr/>
-                <a:lstStyle/>
-                <a:p>
-                  <a:pPr>
-                    <a:defRPr sz="1000" b="1" i="0" u="none" strike="noStrike">
-                      <a:solidFill>
-                        <a:srgbClr val="1E293B"/>
-                      </a:solidFill>
-                      <a:latin typeface="Calibri"/>
-                    </a:defRPr>
-                  </a:pPr>
-                </a:p>
-              </c:txPr>
-              <c:showLegendKey val="0"/>
-              <c:showVal val="0"/>
-              <c:showCatName val="0"/>
-              <c:showSerName val="0"/>
-              <c:showPercent val="1"/>
-              <c:showBubbleSize val="0"/>
-            </c:dLbl>
-            <c:numFmt formatCode="0%" sourceLinked="0"/>
-            <c:txPr>
-              <a:bodyPr/>
-              <a:lstStyle/>
-              <a:p>
-                <a:pPr>
-                  <a:defRPr sz="1800" b="1" i="0" u="none" strike="noStrike">
-                    <a:solidFill>
-                      <a:srgbClr val="000000"/>
-                    </a:solidFill>
-                    <a:latin typeface="Arial"/>
-                  </a:defRPr>
-                </a:pPr>
-              </a:p>
-            </c:txPr>
-            <c:showLegendKey val="0"/>
-            <c:showVal val="0"/>
-            <c:showCatName val="1"/>
-            <c:showSerName val="0"/>
-            <c:showPercent val="1"/>
-            <c:showBubbleSize val="0"/>
-            <c:showLeaderLines val="0"/>
-          </c:dLbls>
-          <c:cat>
-            <c:strRef>
-              <c:f>Sheet1!$A$2:$A$4</c:f>
-              <c:strCache>
-                <c:ptCount val="3"/>
-                <c:pt idx="0">
-                  <c:v>Технічний (178)</c:v>
-                </c:pt>
-                <c:pt idx="1">
-                  <c:v>Юридичний (1046)</c:v>
-                </c:pt>
-                <c:pt idx="2">
-                  <c:v>Медичний (267)</c:v>
-                </c:pt>
-              </c:strCache>
-            </c:strRef>
-          </c:cat>
-          <c:val>
-            <c:numRef>
-              <c:f>Sheet1!$B$2:$B$4</c:f>
-              <c:numCache>
-                <c:ptCount val="3"/>
-                <c:pt idx="0">
-                  <c:v>178</c:v>
-                </c:pt>
-                <c:pt idx="1">
-                  <c:v>1046</c:v>
-                </c:pt>
-                <c:pt idx="2">
-                  <c:v>267</c:v>
-                </c:pt>
-              </c:numCache>
-            </c:numRef>
-          </c:val>
-        </c:ser>
-        <c:firstSliceAng val="0"/>
-        <c:holeSize val="60"/>
-      </c:doughnutChart>
-      <c:spPr>
-        <a:solidFill>
-          <a:srgbClr val="F8FAFC"/>
-        </a:solidFill>
-        <a:ln>
-          <a:noFill/>
-        </a:ln>
-        <a:effectLst/>
-      </c:spPr>
-    </c:plotArea>
-    <c:legend>
-      <c:legendPos val="b"/>
-      <c:overlay val="0"/>
-      <c:txPr>
-        <a:bodyPr/>
-        <a:lstStyle/>
-        <a:p>
-          <a:pPr>
-            <a:defRPr sz="900">
-              <a:solidFill>
-                <a:srgbClr val="475569"/>
-              </a:solidFill>
-              <a:latin typeface="Calibri"/>
-              <a:cs typeface="Calibri"/>
-            </a:defRPr>
-          </a:pPr>
-          <a:endParaRPr lang="en-US"/>
-        </a:p>
-      </c:txPr>
-    </c:legend>
-    <c:plotVisOnly val="1"/>
-    <c:dispBlanksAs val="span"/>
-  </c:chart>
-  <c:spPr>
-    <a:solidFill>
-      <a:srgbClr val="F8FAFC"/>
-    </a:solidFill>
-    <a:ln>
-      <a:noFill/>
-    </a:ln>
-    <a:effectLst/>
-  </c:spPr>
-  <c:externalData r:id="rId1">
-    <c:autoUpdate val="0"/>
-  </c:externalData>
-</c:chartSpace>
-</file>
-
-<file path=ppt/charts/chart5.xml><?xml version="1.0" encoding="utf-8"?>
-<c:chartSpace xmlns:c="http://schemas.openxmlformats.org/drawingml/2006/chart" xmlns:a="http://schemas.openxmlformats.org/drawingml/2006/main" xmlns:r="http://schemas.openxmlformats.org/officeDocument/2006/relationships">
-  <c:date1904 val="0"/>
-  <c:roundedCorners val="1"/>
-  <c:chart>
-    <c:autoTitleDeleted val="1"/>
-    <c:plotArea>
-      <c:layout/>
       <c:barChart>
         <c:barDir val="col"/>
         <c:grouping val="clustered"/>
@@ -3523,7 +2673,7 @@
 </c:chartSpace>
 </file>
 
-<file path=ppt/charts/chart6.xml><?xml version="1.0" encoding="utf-8"?>
+<file path=ppt/charts/chart5.xml><?xml version="1.0" encoding="utf-8"?>
 <c:chartSpace xmlns:c="http://schemas.openxmlformats.org/drawingml/2006/chart" xmlns:a="http://schemas.openxmlformats.org/drawingml/2006/main" xmlns:r="http://schemas.openxmlformats.org/officeDocument/2006/relationships">
   <c:date1904 val="0"/>
   <c:roundedCorners val="1"/>
@@ -4121,7 +3271,7 @@
 </c:chartSpace>
 </file>
 
-<file path=ppt/charts/chart7.xml><?xml version="1.0" encoding="utf-8"?>
+<file path=ppt/charts/chart6.xml><?xml version="1.0" encoding="utf-8"?>
 <c:chartSpace xmlns:c="http://schemas.openxmlformats.org/drawingml/2006/chart" xmlns:a="http://schemas.openxmlformats.org/drawingml/2006/main" xmlns:r="http://schemas.openxmlformats.org/officeDocument/2006/relationships">
   <c:date1904 val="0"/>
   <c:roundedCorners val="1"/>
@@ -4699,7 +3849,7 @@
 </c:chartSpace>
 </file>
 
-<file path=ppt/charts/chart8.xml><?xml version="1.0" encoding="utf-8"?>
+<file path=ppt/charts/chart7.xml><?xml version="1.0" encoding="utf-8"?>
 <c:chartSpace xmlns:c="http://schemas.openxmlformats.org/drawingml/2006/chart" xmlns:a="http://schemas.openxmlformats.org/drawingml/2006/main" xmlns:r="http://schemas.openxmlformats.org/officeDocument/2006/relationships">
   <c:date1904 val="0"/>
   <c:roundedCorners val="1"/>
@@ -5277,7 +4427,7 @@
 </c:chartSpace>
 </file>
 
-<file path=ppt/charts/chart9.xml><?xml version="1.0" encoding="utf-8"?>
+<file path=ppt/charts/chart8.xml><?xml version="1.0" encoding="utf-8"?>
 <c:chartSpace xmlns:c="http://schemas.openxmlformats.org/drawingml/2006/chart" xmlns:a="http://schemas.openxmlformats.org/drawingml/2006/main" xmlns:r="http://schemas.openxmlformats.org/officeDocument/2006/relationships">
   <c:date1904 val="0"/>
   <c:roundedCorners val="1"/>
@@ -5855,6 +5005,604 @@
 </c:chartSpace>
 </file>
 
+<file path=ppt/charts/chart9.xml><?xml version="1.0" encoding="utf-8"?>
+<c:chartSpace xmlns:c="http://schemas.openxmlformats.org/drawingml/2006/chart" xmlns:a="http://schemas.openxmlformats.org/drawingml/2006/main" xmlns:r="http://schemas.openxmlformats.org/officeDocument/2006/relationships">
+  <c:date1904 val="0"/>
+  <c:roundedCorners val="1"/>
+  <c:chart>
+    <c:autoTitleDeleted val="1"/>
+    <c:plotArea>
+      <c:layout/>
+      <c:barChart>
+        <c:barDir val="col"/>
+        <c:grouping val="clustered"/>
+        <c:varyColors val="0"/>
+        <c:ser>
+          <c:idx val="0"/>
+          <c:order val="0"/>
+          <c:tx>
+            <c:strRef>
+              <c:f>Sheet1!$B$1</c:f>
+              <c:strCache>
+                <c:ptCount val="1"/>
+                <c:pt idx="0">
+                  <c:v>BGE-M3</c:v>
+                </c:pt>
+              </c:strCache>
+            </c:strRef>
+          </c:tx>
+          <c:spPr>
+            <a:solidFill>
+              <a:srgbClr val="F59E0B"/>
+            </a:solidFill>
+            <a:effectLst/>
+          </c:spPr>
+          <c:invertIfNegative val="0"/>
+          <c:dLbls>
+            <c:numFmt formatCode="0.00" sourceLinked="0"/>
+            <c:txPr>
+              <a:bodyPr/>
+              <a:lstStyle/>
+              <a:p>
+                <a:pPr>
+                  <a:defRPr b="0" i="0" strike="noStrike" sz="750" u="none">
+                    <a:solidFill>
+                      <a:srgbClr val="1E293B"/>
+                    </a:solidFill>
+                    <a:latin typeface="Calibri"/>
+                  </a:defRPr>
+                </a:pPr>
+              </a:p>
+            </c:txPr>
+            <c:showLegendKey val="0"/>
+            <c:showVal val="1"/>
+            <c:showCatName val="0"/>
+            <c:showSerName val="0"/>
+            <c:showPercent val="0"/>
+            <c:showBubbleSize val="0"/>
+            <c:showLeaderLines val="0"/>
+          </c:dLbls>
+          <c:cat>
+            <c:multiLvlStrRef>
+              <c:f>Sheet1!$A$2:$A$4</c:f>
+              <c:multiLvlStrCache>
+                <c:ptCount val="3"/>
+                <c:lvl>
+                  <c:pt idx="0">
+                    <c:v>Технічний</c:v>
+                  </c:pt>
+                  <c:pt idx="1">
+                    <c:v>Юридичний</c:v>
+                  </c:pt>
+                  <c:pt idx="2">
+                    <c:v>Медичний</c:v>
+                  </c:pt>
+                </c:lvl>
+              </c:multiLvlStrCache>
+            </c:multiLvlStrRef>
+          </c:cat>
+          <c:val>
+            <c:numRef>
+              <c:f>Sheet1!$B$2:$B$4</c:f>
+              <c:numCache>
+                <c:formatCode>General</c:formatCode>
+                <c:ptCount val="3"/>
+                <c:pt idx="0">
+                  <c:v>0.904</c:v>
+                </c:pt>
+                <c:pt idx="1">
+                  <c:v>0.872</c:v>
+                </c:pt>
+                <c:pt idx="2">
+                  <c:v>0.912</c:v>
+                </c:pt>
+              </c:numCache>
+            </c:numRef>
+          </c:val>
+        </c:ser>
+        <c:ser>
+          <c:idx val="1"/>
+          <c:order val="1"/>
+          <c:tx>
+            <c:strRef>
+              <c:f>Sheet1!$C$1</c:f>
+              <c:strCache>
+                <c:ptCount val="1"/>
+                <c:pt idx="0">
+                  <c:v>Qwen3</c:v>
+                </c:pt>
+              </c:strCache>
+            </c:strRef>
+          </c:tx>
+          <c:spPr>
+            <a:solidFill>
+              <a:srgbClr val="1E40AF"/>
+            </a:solidFill>
+            <a:effectLst/>
+          </c:spPr>
+          <c:invertIfNegative val="0"/>
+          <c:dLbls>
+            <c:numFmt formatCode="0.00" sourceLinked="0"/>
+            <c:txPr>
+              <a:bodyPr/>
+              <a:lstStyle/>
+              <a:p>
+                <a:pPr>
+                  <a:defRPr b="0" i="0" strike="noStrike" sz="750" u="none">
+                    <a:solidFill>
+                      <a:srgbClr val="1E293B"/>
+                    </a:solidFill>
+                    <a:latin typeface="Calibri"/>
+                  </a:defRPr>
+                </a:pPr>
+              </a:p>
+            </c:txPr>
+            <c:showLegendKey val="0"/>
+            <c:showVal val="1"/>
+            <c:showCatName val="0"/>
+            <c:showSerName val="0"/>
+            <c:showPercent val="0"/>
+            <c:showBubbleSize val="0"/>
+            <c:showLeaderLines val="0"/>
+          </c:dLbls>
+          <c:cat>
+            <c:multiLvlStrRef>
+              <c:f>Sheet1!$A$2:$A$4</c:f>
+              <c:multiLvlStrCache>
+                <c:ptCount val="3"/>
+                <c:lvl>
+                  <c:pt idx="0">
+                    <c:v>Технічний</c:v>
+                  </c:pt>
+                  <c:pt idx="1">
+                    <c:v>Юридичний</c:v>
+                  </c:pt>
+                  <c:pt idx="2">
+                    <c:v>Медичний</c:v>
+                  </c:pt>
+                </c:lvl>
+              </c:multiLvlStrCache>
+            </c:multiLvlStrRef>
+          </c:cat>
+          <c:val>
+            <c:numRef>
+              <c:f>Sheet1!$C$2:$C$4</c:f>
+              <c:numCache>
+                <c:formatCode>General</c:formatCode>
+                <c:ptCount val="3"/>
+                <c:pt idx="0">
+                  <c:v>0.825</c:v>
+                </c:pt>
+                <c:pt idx="1">
+                  <c:v>0.914</c:v>
+                </c:pt>
+                <c:pt idx="2">
+                  <c:v>0.802</c:v>
+                </c:pt>
+              </c:numCache>
+            </c:numRef>
+          </c:val>
+        </c:ser>
+        <c:ser>
+          <c:idx val="2"/>
+          <c:order val="2"/>
+          <c:tx>
+            <c:strRef>
+              <c:f>Sheet1!$D$1</c:f>
+              <c:strCache>
+                <c:ptCount val="1"/>
+                <c:pt idx="0">
+                  <c:v>E5-base</c:v>
+                </c:pt>
+              </c:strCache>
+            </c:strRef>
+          </c:tx>
+          <c:spPr>
+            <a:solidFill>
+              <a:srgbClr val="0891B2"/>
+            </a:solidFill>
+            <a:effectLst/>
+          </c:spPr>
+          <c:invertIfNegative val="0"/>
+          <c:dLbls>
+            <c:numFmt formatCode="0.00" sourceLinked="0"/>
+            <c:txPr>
+              <a:bodyPr/>
+              <a:lstStyle/>
+              <a:p>
+                <a:pPr>
+                  <a:defRPr b="0" i="0" strike="noStrike" sz="750" u="none">
+                    <a:solidFill>
+                      <a:srgbClr val="1E293B"/>
+                    </a:solidFill>
+                    <a:latin typeface="Calibri"/>
+                  </a:defRPr>
+                </a:pPr>
+              </a:p>
+            </c:txPr>
+            <c:showLegendKey val="0"/>
+            <c:showVal val="1"/>
+            <c:showCatName val="0"/>
+            <c:showSerName val="0"/>
+            <c:showPercent val="0"/>
+            <c:showBubbleSize val="0"/>
+            <c:showLeaderLines val="0"/>
+          </c:dLbls>
+          <c:cat>
+            <c:multiLvlStrRef>
+              <c:f>Sheet1!$A$2:$A$4</c:f>
+              <c:multiLvlStrCache>
+                <c:ptCount val="3"/>
+                <c:lvl>
+                  <c:pt idx="0">
+                    <c:v>Технічний</c:v>
+                  </c:pt>
+                  <c:pt idx="1">
+                    <c:v>Юридичний</c:v>
+                  </c:pt>
+                  <c:pt idx="2">
+                    <c:v>Медичний</c:v>
+                  </c:pt>
+                </c:lvl>
+              </c:multiLvlStrCache>
+            </c:multiLvlStrRef>
+          </c:cat>
+          <c:val>
+            <c:numRef>
+              <c:f>Sheet1!$D$2:$D$4</c:f>
+              <c:numCache>
+                <c:formatCode>General</c:formatCode>
+                <c:ptCount val="3"/>
+                <c:pt idx="0">
+                  <c:v>0.875</c:v>
+                </c:pt>
+                <c:pt idx="1">
+                  <c:v>0.844</c:v>
+                </c:pt>
+                <c:pt idx="2">
+                  <c:v>0.901</c:v>
+                </c:pt>
+              </c:numCache>
+            </c:numRef>
+          </c:val>
+        </c:ser>
+        <c:ser>
+          <c:idx val="3"/>
+          <c:order val="3"/>
+          <c:tx>
+            <c:strRef>
+              <c:f>Sheet1!$E$1</c:f>
+              <c:strCache>
+                <c:ptCount val="1"/>
+                <c:pt idx="0">
+                  <c:v>BM25</c:v>
+                </c:pt>
+              </c:strCache>
+            </c:strRef>
+          </c:tx>
+          <c:spPr>
+            <a:solidFill>
+              <a:srgbClr val="64748B"/>
+            </a:solidFill>
+            <a:effectLst/>
+          </c:spPr>
+          <c:invertIfNegative val="0"/>
+          <c:dLbls>
+            <c:numFmt formatCode="0.00" sourceLinked="0"/>
+            <c:txPr>
+              <a:bodyPr/>
+              <a:lstStyle/>
+              <a:p>
+                <a:pPr>
+                  <a:defRPr b="0" i="0" strike="noStrike" sz="750" u="none">
+                    <a:solidFill>
+                      <a:srgbClr val="1E293B"/>
+                    </a:solidFill>
+                    <a:latin typeface="Calibri"/>
+                  </a:defRPr>
+                </a:pPr>
+              </a:p>
+            </c:txPr>
+            <c:showLegendKey val="0"/>
+            <c:showVal val="1"/>
+            <c:showCatName val="0"/>
+            <c:showSerName val="0"/>
+            <c:showPercent val="0"/>
+            <c:showBubbleSize val="0"/>
+            <c:showLeaderLines val="0"/>
+          </c:dLbls>
+          <c:cat>
+            <c:multiLvlStrRef>
+              <c:f>Sheet1!$A$2:$A$4</c:f>
+              <c:multiLvlStrCache>
+                <c:ptCount val="3"/>
+                <c:lvl>
+                  <c:pt idx="0">
+                    <c:v>Технічний</c:v>
+                  </c:pt>
+                  <c:pt idx="1">
+                    <c:v>Юридичний</c:v>
+                  </c:pt>
+                  <c:pt idx="2">
+                    <c:v>Медичний</c:v>
+                  </c:pt>
+                </c:lvl>
+              </c:multiLvlStrCache>
+            </c:multiLvlStrRef>
+          </c:cat>
+          <c:val>
+            <c:numRef>
+              <c:f>Sheet1!$E$2:$E$4</c:f>
+              <c:numCache>
+                <c:formatCode>General</c:formatCode>
+                <c:ptCount val="3"/>
+                <c:pt idx="0">
+                  <c:v>0.795</c:v>
+                </c:pt>
+                <c:pt idx="1">
+                  <c:v>0.741</c:v>
+                </c:pt>
+                <c:pt idx="2">
+                  <c:v>0.817</c:v>
+                </c:pt>
+              </c:numCache>
+            </c:numRef>
+          </c:val>
+        </c:ser>
+        <c:ser>
+          <c:idx val="4"/>
+          <c:order val="4"/>
+          <c:tx>
+            <c:strRef>
+              <c:f>Sheet1!$F$1</c:f>
+              <c:strCache>
+                <c:ptCount val="1"/>
+                <c:pt idx="0">
+                  <c:v>nomic</c:v>
+                </c:pt>
+              </c:strCache>
+            </c:strRef>
+          </c:tx>
+          <c:spPr>
+            <a:solidFill>
+              <a:srgbClr val="7C3AED"/>
+            </a:solidFill>
+            <a:effectLst/>
+          </c:spPr>
+          <c:invertIfNegative val="0"/>
+          <c:dLbls>
+            <c:numFmt formatCode="0.00" sourceLinked="0"/>
+            <c:txPr>
+              <a:bodyPr/>
+              <a:lstStyle/>
+              <a:p>
+                <a:pPr>
+                  <a:defRPr b="0" i="0" strike="noStrike" sz="750" u="none">
+                    <a:solidFill>
+                      <a:srgbClr val="1E293B"/>
+                    </a:solidFill>
+                    <a:latin typeface="Calibri"/>
+                  </a:defRPr>
+                </a:pPr>
+              </a:p>
+            </c:txPr>
+            <c:showLegendKey val="0"/>
+            <c:showVal val="1"/>
+            <c:showCatName val="0"/>
+            <c:showSerName val="0"/>
+            <c:showPercent val="0"/>
+            <c:showBubbleSize val="0"/>
+            <c:showLeaderLines val="0"/>
+          </c:dLbls>
+          <c:cat>
+            <c:multiLvlStrRef>
+              <c:f>Sheet1!$A$2:$A$4</c:f>
+              <c:multiLvlStrCache>
+                <c:ptCount val="3"/>
+                <c:lvl>
+                  <c:pt idx="0">
+                    <c:v>Технічний</c:v>
+                  </c:pt>
+                  <c:pt idx="1">
+                    <c:v>Юридичний</c:v>
+                  </c:pt>
+                  <c:pt idx="2">
+                    <c:v>Медичний</c:v>
+                  </c:pt>
+                </c:lvl>
+              </c:multiLvlStrCache>
+            </c:multiLvlStrRef>
+          </c:cat>
+          <c:val>
+            <c:numRef>
+              <c:f>Sheet1!$F$2:$F$4</c:f>
+              <c:numCache>
+                <c:formatCode>General</c:formatCode>
+                <c:ptCount val="3"/>
+                <c:pt idx="0">
+                  <c:v>0.611</c:v>
+                </c:pt>
+                <c:pt idx="1">
+                  <c:v>0.503</c:v>
+                </c:pt>
+                <c:pt idx="2">
+                  <c:v>0.568</c:v>
+                </c:pt>
+              </c:numCache>
+            </c:numRef>
+          </c:val>
+        </c:ser>
+        <c:dLbls>
+          <c:numFmt formatCode="0.00" sourceLinked="0"/>
+          <c:txPr>
+            <a:bodyPr/>
+            <a:lstStyle/>
+            <a:p>
+              <a:pPr>
+                <a:defRPr b="0" i="0" strike="noStrike" sz="750" u="none">
+                  <a:solidFill>
+                    <a:srgbClr val="1E293B"/>
+                  </a:solidFill>
+                  <a:latin typeface="Calibri"/>
+                </a:defRPr>
+              </a:pPr>
+            </a:p>
+          </c:txPr>
+          <c:showLegendKey val="0"/>
+          <c:showVal val="1"/>
+          <c:showCatName val="0"/>
+          <c:showSerName val="0"/>
+          <c:showPercent val="0"/>
+          <c:showBubbleSize val="0"/>
+          <c:showLeaderLines val="0"/>
+        </c:dLbls>
+        <c:gapWidth val="150"/>
+        <c:overlap val="0"/>
+        <c:axId val="2094734554"/>
+        <c:axId val="2094734552"/>
+        <c:axId val="2094734556"/>
+      </c:barChart>
+      <c:catAx>
+        <c:axId val="2094734554"/>
+        <c:scaling>
+          <c:orientation val="minMax"/>
+        </c:scaling>
+        <c:delete val="0"/>
+        <c:axPos val="b"/>
+        <c:numFmt formatCode="General" sourceLinked="1"/>
+        <c:majorTickMark val="out"/>
+        <c:minorTickMark val="none"/>
+        <c:tickLblPos val="low"/>
+        <c:spPr>
+          <a:ln w="12700" cap="flat">
+            <a:solidFill>
+              <a:srgbClr val="888888"/>
+            </a:solidFill>
+            <a:prstDash val="solid"/>
+            <a:round/>
+          </a:ln>
+        </c:spPr>
+        <c:txPr>
+          <a:bodyPr/>
+          <a:lstStyle/>
+          <a:p>
+            <a:pPr>
+              <a:defRPr sz="1000" b="0" i="0" u="none" strike="noStrike">
+                <a:solidFill>
+                  <a:srgbClr val="1E293B"/>
+                </a:solidFill>
+                <a:latin typeface="Calibri"/>
+              </a:defRPr>
+            </a:pPr>
+            <a:endParaRPr lang="en-US"/>
+          </a:p>
+        </c:txPr>
+        <c:crossAx val="2094734552"/>
+        <c:crosses val="autoZero"/>
+        <c:auto val="1"/>
+        <c:lblAlgn val="ctr"/>
+        <c:noMultiLvlLbl val="1"/>
+      </c:catAx>
+      <c:valAx>
+        <c:axId val="2094734552"/>
+        <c:scaling>
+          <c:orientation val="minMax"/>
+          <c:max val="1"/>
+          <c:min val="0"/>
+        </c:scaling>
+        <c:delete val="0"/>
+        <c:axPos val="l"/>
+        <c:majorGridlines>
+          <c:spPr>
+            <a:ln w="6350" cap="flat">
+              <a:solidFill>
+                <a:srgbClr val="E2E8F0"/>
+              </a:solidFill>
+              <a:prstDash val="solid"/>
+              <a:round/>
+            </a:ln>
+          </c:spPr>
+        </c:majorGridlines>
+        <c:numFmt formatCode="General" sourceLinked="0"/>
+        <c:majorTickMark val="out"/>
+        <c:minorTickMark val="none"/>
+        <c:tickLblPos val="nextTo"/>
+        <c:spPr>
+          <a:ln w="12700" cap="flat">
+            <a:solidFill>
+              <a:srgbClr val="888888"/>
+            </a:solidFill>
+            <a:prstDash val="solid"/>
+            <a:round/>
+          </a:ln>
+        </c:spPr>
+        <c:txPr>
+          <a:bodyPr/>
+          <a:lstStyle/>
+          <a:p>
+            <a:pPr>
+              <a:defRPr sz="900" b="0" i="0" u="none" strike="noStrike">
+                <a:solidFill>
+                  <a:srgbClr val="475569"/>
+                </a:solidFill>
+                <a:latin typeface="Calibri"/>
+              </a:defRPr>
+            </a:pPr>
+            <a:endParaRPr lang="en-US"/>
+          </a:p>
+        </c:txPr>
+        <c:crossAx val="2094734554"/>
+        <c:crosses val="autoZero"/>
+        <c:crossBetween val="between"/>
+      </c:valAx>
+      <c:spPr>
+        <a:solidFill>
+          <a:srgbClr val="F8FAFC"/>
+        </a:solidFill>
+        <a:ln>
+          <a:noFill/>
+        </a:ln>
+        <a:effectLst/>
+      </c:spPr>
+    </c:plotArea>
+    <c:legend>
+      <c:legendPos val="b"/>
+      <c:overlay val="0"/>
+      <c:txPr>
+        <a:bodyPr/>
+        <a:lstStyle/>
+        <a:p>
+          <a:pPr>
+            <a:defRPr sz="900">
+              <a:solidFill>
+                <a:srgbClr val="1E293B"/>
+              </a:solidFill>
+              <a:latin typeface="Calibri"/>
+              <a:cs typeface="Calibri"/>
+            </a:defRPr>
+          </a:pPr>
+          <a:endParaRPr lang="en-US"/>
+        </a:p>
+      </c:txPr>
+    </c:legend>
+    <c:plotVisOnly val="1"/>
+    <c:dispBlanksAs val="span"/>
+  </c:chart>
+  <c:spPr>
+    <a:solidFill>
+      <a:srgbClr val="F8FAFC"/>
+    </a:solidFill>
+    <a:ln>
+      <a:noFill/>
+    </a:ln>
+    <a:effectLst/>
+  </c:spPr>
+  <c:externalData r:id="rId1">
+    <c:autoUpdate val="0"/>
+  </c:externalData>
+</c:chartSpace>
+</file>
+
 <file path=ppt/notesMasters/notesMaster1.xml><?xml version="1.0" encoding="utf-8"?>
 <p:notesMaster xmlns:a="http://schemas.openxmlformats.org/drawingml/2006/main" xmlns:r="http://schemas.openxmlformats.org/officeDocument/2006/relationships" xmlns:p="http://schemas.openxmlformats.org/presentationml/2006/main">
   <p:cSld>
@@ -10412,7 +10160,7 @@
                 <a:ea typeface="Calibri" pitchFamily="34" charset="-122"/>
                 <a:cs typeface="Calibri" pitchFamily="34" charset="-120"/>
               </a:rPr>
-              <a:t>:  3 домени  ·  32 документи  ·  1 491 чанк  ·  300 запитів  ·  qrels вручну</a:t>
+              <a:t>:  3 домени  ·  32 документи  ·  300 запитів  ·  qrels сформовано вручну</a:t>
             </a:r>
             <a:endParaRPr lang="en-US" sz="1100" dirty="0"/>
           </a:p>
@@ -10608,7 +10356,7 @@
         <p:spPr>
           <a:xfrm>
             <a:off x="1325880" y="1905000"/>
-            <a:ext cx="1005840" cy="274320"/>
+            <a:ext cx="1508760" cy="274320"/>
           </a:xfrm>
           <a:prstGeom prst="rect">
             <a:avLst/>
@@ -10624,7 +10372,7 @@
               <a:buNone/>
             </a:pPr>
             <a:r>
-              <a:rPr lang="en-US" sz="1800" b="1" dirty="0">
+              <a:rPr lang="en-US" sz="2200" b="1" dirty="0">
                 <a:solidFill>
                   <a:srgbClr val="1E40AF"/>
                 </a:solidFill>
@@ -10634,7 +10382,7 @@
               </a:rPr>
               <a:t>10</a:t>
             </a:r>
-            <a:endParaRPr lang="en-US" sz="1800" dirty="0"/>
+            <a:endParaRPr lang="en-US" sz="2200" dirty="0"/>
           </a:p>
         </p:txBody>
       </p:sp>
@@ -10646,8 +10394,8 @@
         </p:nvSpPr>
         <p:spPr>
           <a:xfrm>
-            <a:off x="1325880" y="2161032"/>
-            <a:ext cx="1005840" cy="182880"/>
+            <a:off x="1325880" y="2179320"/>
+            <a:ext cx="1508760" cy="182880"/>
           </a:xfrm>
           <a:prstGeom prst="rect">
             <a:avLst/>
@@ -10685,8 +10433,8 @@
         </p:nvSpPr>
         <p:spPr>
           <a:xfrm>
-            <a:off x="2331720" y="1905000"/>
-            <a:ext cx="1005840" cy="274320"/>
+            <a:off x="2834640" y="1905000"/>
+            <a:ext cx="1508760" cy="274320"/>
           </a:xfrm>
           <a:prstGeom prst="rect">
             <a:avLst/>
@@ -10702,7 +10450,7 @@
               <a:buNone/>
             </a:pPr>
             <a:r>
-              <a:rPr lang="en-US" sz="1800" b="1" dirty="0">
+              <a:rPr lang="en-US" sz="2200" b="1" dirty="0">
                 <a:solidFill>
                   <a:srgbClr val="1E40AF"/>
                 </a:solidFill>
@@ -10710,9 +10458,9 @@
                 <a:ea typeface="Calibri" pitchFamily="34" charset="-122"/>
                 <a:cs typeface="Calibri" pitchFamily="34" charset="-120"/>
               </a:rPr>
-              <a:t>178</a:t>
-            </a:r>
-            <a:endParaRPr lang="en-US" sz="1800" dirty="0"/>
+              <a:t>100</a:t>
+            </a:r>
+            <a:endParaRPr lang="en-US" sz="2200" dirty="0"/>
           </a:p>
         </p:txBody>
       </p:sp>
@@ -10724,8 +10472,8 @@
         </p:nvSpPr>
         <p:spPr>
           <a:xfrm>
-            <a:off x="2331720" y="2161032"/>
-            <a:ext cx="1005840" cy="182880"/>
+            <a:off x="2834640" y="2179320"/>
+            <a:ext cx="1508760" cy="182880"/>
           </a:xfrm>
           <a:prstGeom prst="rect">
             <a:avLst/>
@@ -10749,7 +10497,7 @@
                 <a:ea typeface="Calibri" pitchFamily="34" charset="-122"/>
                 <a:cs typeface="Calibri" pitchFamily="34" charset="-120"/>
               </a:rPr>
-              <a:t>чанки</a:t>
+              <a:t>запити</a:t>
             </a:r>
             <a:endParaRPr lang="en-US" sz="900" dirty="0"/>
           </a:p>
@@ -10757,85 +10505,7 @@
       </p:sp>
       <p:sp>
         <p:nvSpPr>
-          <p:cNvPr id="16" name="Text 13"/>
-          <p:cNvSpPr/>
-          <p:nvPr/>
-        </p:nvSpPr>
-        <p:spPr>
-          <a:xfrm>
-            <a:off x="3337560" y="1905000"/>
-            <a:ext cx="1005840" cy="274320"/>
-          </a:xfrm>
-          <a:prstGeom prst="rect">
-            <a:avLst/>
-          </a:prstGeom>
-          <a:noFill/>
-          <a:ln/>
-        </p:spPr>
-        <p:txBody>
-          <a:bodyPr wrap="square" lIns="0" tIns="0" rIns="0" bIns="0" rtlCol="0" anchor="ctr"/>
-          <a:lstStyle/>
-          <a:p>
-            <a:pPr algn="l" indent="0" marL="0">
-              <a:buNone/>
-            </a:pPr>
-            <a:r>
-              <a:rPr lang="en-US" sz="1800" b="1" dirty="0">
-                <a:solidFill>
-                  <a:srgbClr val="1E40AF"/>
-                </a:solidFill>
-                <a:latin typeface="Calibri" pitchFamily="34" charset="0"/>
-                <a:ea typeface="Calibri" pitchFamily="34" charset="-122"/>
-                <a:cs typeface="Calibri" pitchFamily="34" charset="-120"/>
-              </a:rPr>
-              <a:t>100</a:t>
-            </a:r>
-            <a:endParaRPr lang="en-US" sz="1800" dirty="0"/>
-          </a:p>
-        </p:txBody>
-      </p:sp>
-      <p:sp>
-        <p:nvSpPr>
-          <p:cNvPr id="17" name="Text 14"/>
-          <p:cNvSpPr/>
-          <p:nvPr/>
-        </p:nvSpPr>
-        <p:spPr>
-          <a:xfrm>
-            <a:off x="3337560" y="2161032"/>
-            <a:ext cx="1005840" cy="182880"/>
-          </a:xfrm>
-          <a:prstGeom prst="rect">
-            <a:avLst/>
-          </a:prstGeom>
-          <a:noFill/>
-          <a:ln/>
-        </p:spPr>
-        <p:txBody>
-          <a:bodyPr wrap="square" lIns="0" tIns="0" rIns="0" bIns="0" rtlCol="0" anchor="ctr"/>
-          <a:lstStyle/>
-          <a:p>
-            <a:pPr algn="l" indent="0" marL="0">
-              <a:buNone/>
-            </a:pPr>
-            <a:r>
-              <a:rPr lang="en-US" sz="900" dirty="0">
-                <a:solidFill>
-                  <a:srgbClr val="64748B"/>
-                </a:solidFill>
-                <a:latin typeface="Calibri" pitchFamily="34" charset="0"/>
-                <a:ea typeface="Calibri" pitchFamily="34" charset="-122"/>
-                <a:cs typeface="Calibri" pitchFamily="34" charset="-120"/>
-              </a:rPr>
-              <a:t>запити</a:t>
-            </a:r>
-            <a:endParaRPr lang="en-US" sz="900" dirty="0"/>
-          </a:p>
-        </p:txBody>
-      </p:sp>
-      <p:sp>
-        <p:nvSpPr>
-          <p:cNvPr id="18" name="Shape 15"/>
+          <p:cNvPr id="16" name="Shape 13"/>
           <p:cNvSpPr/>
           <p:nvPr/>
         </p:nvSpPr>
@@ -10869,7 +10539,7 @@
       </p:sp>
       <p:sp>
         <p:nvSpPr>
-          <p:cNvPr id="19" name="Shape 16"/>
+          <p:cNvPr id="17" name="Shape 14"/>
           <p:cNvSpPr/>
           <p:nvPr/>
         </p:nvSpPr>
@@ -10889,7 +10559,7 @@
       </p:sp>
       <p:sp>
         <p:nvSpPr>
-          <p:cNvPr id="20" name="Shape 17"/>
+          <p:cNvPr id="18" name="Shape 15"/>
           <p:cNvSpPr/>
           <p:nvPr/>
         </p:nvSpPr>
@@ -10914,7 +10584,7 @@
       </p:sp>
       <p:pic>
         <p:nvPicPr>
-          <p:cNvPr id="21" name="Image 1" descr="preencoded.png">    </p:cNvPr>
+          <p:cNvPr id="19" name="Image 1" descr="preencoded.png">    </p:cNvPr>
           <p:cNvPicPr>
             <a:picLocks noChangeAspect="1"/>
           </p:cNvPicPr>
@@ -10938,7 +10608,7 @@
       </p:pic>
       <p:sp>
         <p:nvSpPr>
-          <p:cNvPr id="22" name="Text 18"/>
+          <p:cNvPr id="20" name="Text 16"/>
           <p:cNvSpPr/>
           <p:nvPr/>
         </p:nvSpPr>
@@ -10977,7 +10647,7 @@
       </p:sp>
       <p:sp>
         <p:nvSpPr>
-          <p:cNvPr id="23" name="Text 19"/>
+          <p:cNvPr id="21" name="Text 17"/>
           <p:cNvSpPr/>
           <p:nvPr/>
         </p:nvSpPr>
@@ -11016,14 +10686,92 @@
       </p:sp>
       <p:sp>
         <p:nvSpPr>
+          <p:cNvPr id="22" name="Text 18"/>
+          <p:cNvSpPr/>
+          <p:nvPr/>
+        </p:nvSpPr>
+        <p:spPr>
+          <a:xfrm>
+            <a:off x="1325880" y="3032760"/>
+            <a:ext cx="1508760" cy="274320"/>
+          </a:xfrm>
+          <a:prstGeom prst="rect">
+            <a:avLst/>
+          </a:prstGeom>
+          <a:noFill/>
+          <a:ln/>
+        </p:spPr>
+        <p:txBody>
+          <a:bodyPr wrap="square" lIns="0" tIns="0" rIns="0" bIns="0" rtlCol="0" anchor="ctr"/>
+          <a:lstStyle/>
+          <a:p>
+            <a:pPr algn="l" indent="0" marL="0">
+              <a:buNone/>
+            </a:pPr>
+            <a:r>
+              <a:rPr lang="en-US" sz="2200" b="1" dirty="0">
+                <a:solidFill>
+                  <a:srgbClr val="7C3AED"/>
+                </a:solidFill>
+                <a:latin typeface="Calibri" pitchFamily="34" charset="0"/>
+                <a:ea typeface="Calibri" pitchFamily="34" charset="-122"/>
+                <a:cs typeface="Calibri" pitchFamily="34" charset="-120"/>
+              </a:rPr>
+              <a:t>13</a:t>
+            </a:r>
+            <a:endParaRPr lang="en-US" sz="2200" dirty="0"/>
+          </a:p>
+        </p:txBody>
+      </p:sp>
+      <p:sp>
+        <p:nvSpPr>
+          <p:cNvPr id="23" name="Text 19"/>
+          <p:cNvSpPr/>
+          <p:nvPr/>
+        </p:nvSpPr>
+        <p:spPr>
+          <a:xfrm>
+            <a:off x="1325880" y="3307080"/>
+            <a:ext cx="1508760" cy="182880"/>
+          </a:xfrm>
+          <a:prstGeom prst="rect">
+            <a:avLst/>
+          </a:prstGeom>
+          <a:noFill/>
+          <a:ln/>
+        </p:spPr>
+        <p:txBody>
+          <a:bodyPr wrap="square" lIns="0" tIns="0" rIns="0" bIns="0" rtlCol="0" anchor="ctr"/>
+          <a:lstStyle/>
+          <a:p>
+            <a:pPr algn="l" indent="0" marL="0">
+              <a:buNone/>
+            </a:pPr>
+            <a:r>
+              <a:rPr lang="en-US" sz="900" dirty="0">
+                <a:solidFill>
+                  <a:srgbClr val="64748B"/>
+                </a:solidFill>
+                <a:latin typeface="Calibri" pitchFamily="34" charset="0"/>
+                <a:ea typeface="Calibri" pitchFamily="34" charset="-122"/>
+                <a:cs typeface="Calibri" pitchFamily="34" charset="-120"/>
+              </a:rPr>
+              <a:t>документи</a:t>
+            </a:r>
+            <a:endParaRPr lang="en-US" sz="900" dirty="0"/>
+          </a:p>
+        </p:txBody>
+      </p:sp>
+      <p:sp>
+        <p:nvSpPr>
           <p:cNvPr id="24" name="Text 20"/>
           <p:cNvSpPr/>
           <p:nvPr/>
         </p:nvSpPr>
         <p:spPr>
           <a:xfrm>
-            <a:off x="1325880" y="3032760"/>
-            <a:ext cx="1005840" cy="274320"/>
+            <a:off x="2834640" y="3032760"/>
+            <a:ext cx="1508760" cy="274320"/>
           </a:xfrm>
           <a:prstGeom prst="rect">
             <a:avLst/>
@@ -11039,7 +10787,7 @@
               <a:buNone/>
             </a:pPr>
             <a:r>
-              <a:rPr lang="en-US" sz="1800" b="1" dirty="0">
+              <a:rPr lang="en-US" sz="2200" b="1" dirty="0">
                 <a:solidFill>
                   <a:srgbClr val="7C3AED"/>
                 </a:solidFill>
@@ -11047,9 +10795,9 @@
                 <a:ea typeface="Calibri" pitchFamily="34" charset="-122"/>
                 <a:cs typeface="Calibri" pitchFamily="34" charset="-120"/>
               </a:rPr>
-              <a:t>13</a:t>
-            </a:r>
-            <a:endParaRPr lang="en-US" sz="1800" dirty="0"/>
+              <a:t>100</a:t>
+            </a:r>
+            <a:endParaRPr lang="en-US" sz="2200" dirty="0"/>
           </a:p>
         </p:txBody>
       </p:sp>
@@ -11061,8 +10809,8 @@
         </p:nvSpPr>
         <p:spPr>
           <a:xfrm>
-            <a:off x="1325880" y="3288792"/>
-            <a:ext cx="1005840" cy="182880"/>
+            <a:off x="2834640" y="3307080"/>
+            <a:ext cx="1508760" cy="182880"/>
           </a:xfrm>
           <a:prstGeom prst="rect">
             <a:avLst/>
@@ -11086,7 +10834,7 @@
                 <a:ea typeface="Calibri" pitchFamily="34" charset="-122"/>
                 <a:cs typeface="Calibri" pitchFamily="34" charset="-120"/>
               </a:rPr>
-              <a:t>документи</a:t>
+              <a:t>запити</a:t>
             </a:r>
             <a:endParaRPr lang="en-US" sz="900" dirty="0"/>
           </a:p>
@@ -11094,163 +10842,7 @@
       </p:sp>
       <p:sp>
         <p:nvSpPr>
-          <p:cNvPr id="26" name="Text 22"/>
-          <p:cNvSpPr/>
-          <p:nvPr/>
-        </p:nvSpPr>
-        <p:spPr>
-          <a:xfrm>
-            <a:off x="2331720" y="3032760"/>
-            <a:ext cx="1005840" cy="274320"/>
-          </a:xfrm>
-          <a:prstGeom prst="rect">
-            <a:avLst/>
-          </a:prstGeom>
-          <a:noFill/>
-          <a:ln/>
-        </p:spPr>
-        <p:txBody>
-          <a:bodyPr wrap="square" lIns="0" tIns="0" rIns="0" bIns="0" rtlCol="0" anchor="ctr"/>
-          <a:lstStyle/>
-          <a:p>
-            <a:pPr algn="l" indent="0" marL="0">
-              <a:buNone/>
-            </a:pPr>
-            <a:r>
-              <a:rPr lang="en-US" sz="1800" b="1" dirty="0">
-                <a:solidFill>
-                  <a:srgbClr val="7C3AED"/>
-                </a:solidFill>
-                <a:latin typeface="Calibri" pitchFamily="34" charset="0"/>
-                <a:ea typeface="Calibri" pitchFamily="34" charset="-122"/>
-                <a:cs typeface="Calibri" pitchFamily="34" charset="-120"/>
-              </a:rPr>
-              <a:t>1046</a:t>
-            </a:r>
-            <a:endParaRPr lang="en-US" sz="1800" dirty="0"/>
-          </a:p>
-        </p:txBody>
-      </p:sp>
-      <p:sp>
-        <p:nvSpPr>
-          <p:cNvPr id="27" name="Text 23"/>
-          <p:cNvSpPr/>
-          <p:nvPr/>
-        </p:nvSpPr>
-        <p:spPr>
-          <a:xfrm>
-            <a:off x="2331720" y="3288792"/>
-            <a:ext cx="1005840" cy="182880"/>
-          </a:xfrm>
-          <a:prstGeom prst="rect">
-            <a:avLst/>
-          </a:prstGeom>
-          <a:noFill/>
-          <a:ln/>
-        </p:spPr>
-        <p:txBody>
-          <a:bodyPr wrap="square" lIns="0" tIns="0" rIns="0" bIns="0" rtlCol="0" anchor="ctr"/>
-          <a:lstStyle/>
-          <a:p>
-            <a:pPr algn="l" indent="0" marL="0">
-              <a:buNone/>
-            </a:pPr>
-            <a:r>
-              <a:rPr lang="en-US" sz="900" dirty="0">
-                <a:solidFill>
-                  <a:srgbClr val="64748B"/>
-                </a:solidFill>
-                <a:latin typeface="Calibri" pitchFamily="34" charset="0"/>
-                <a:ea typeface="Calibri" pitchFamily="34" charset="-122"/>
-                <a:cs typeface="Calibri" pitchFamily="34" charset="-120"/>
-              </a:rPr>
-              <a:t>чанки</a:t>
-            </a:r>
-            <a:endParaRPr lang="en-US" sz="900" dirty="0"/>
-          </a:p>
-        </p:txBody>
-      </p:sp>
-      <p:sp>
-        <p:nvSpPr>
-          <p:cNvPr id="28" name="Text 24"/>
-          <p:cNvSpPr/>
-          <p:nvPr/>
-        </p:nvSpPr>
-        <p:spPr>
-          <a:xfrm>
-            <a:off x="3337560" y="3032760"/>
-            <a:ext cx="1005840" cy="274320"/>
-          </a:xfrm>
-          <a:prstGeom prst="rect">
-            <a:avLst/>
-          </a:prstGeom>
-          <a:noFill/>
-          <a:ln/>
-        </p:spPr>
-        <p:txBody>
-          <a:bodyPr wrap="square" lIns="0" tIns="0" rIns="0" bIns="0" rtlCol="0" anchor="ctr"/>
-          <a:lstStyle/>
-          <a:p>
-            <a:pPr algn="l" indent="0" marL="0">
-              <a:buNone/>
-            </a:pPr>
-            <a:r>
-              <a:rPr lang="en-US" sz="1800" b="1" dirty="0">
-                <a:solidFill>
-                  <a:srgbClr val="7C3AED"/>
-                </a:solidFill>
-                <a:latin typeface="Calibri" pitchFamily="34" charset="0"/>
-                <a:ea typeface="Calibri" pitchFamily="34" charset="-122"/>
-                <a:cs typeface="Calibri" pitchFamily="34" charset="-120"/>
-              </a:rPr>
-              <a:t>100</a:t>
-            </a:r>
-            <a:endParaRPr lang="en-US" sz="1800" dirty="0"/>
-          </a:p>
-        </p:txBody>
-      </p:sp>
-      <p:sp>
-        <p:nvSpPr>
-          <p:cNvPr id="29" name="Text 25"/>
-          <p:cNvSpPr/>
-          <p:nvPr/>
-        </p:nvSpPr>
-        <p:spPr>
-          <a:xfrm>
-            <a:off x="3337560" y="3288792"/>
-            <a:ext cx="1005840" cy="182880"/>
-          </a:xfrm>
-          <a:prstGeom prst="rect">
-            <a:avLst/>
-          </a:prstGeom>
-          <a:noFill/>
-          <a:ln/>
-        </p:spPr>
-        <p:txBody>
-          <a:bodyPr wrap="square" lIns="0" tIns="0" rIns="0" bIns="0" rtlCol="0" anchor="ctr"/>
-          <a:lstStyle/>
-          <a:p>
-            <a:pPr algn="l" indent="0" marL="0">
-              <a:buNone/>
-            </a:pPr>
-            <a:r>
-              <a:rPr lang="en-US" sz="900" dirty="0">
-                <a:solidFill>
-                  <a:srgbClr val="64748B"/>
-                </a:solidFill>
-                <a:latin typeface="Calibri" pitchFamily="34" charset="0"/>
-                <a:ea typeface="Calibri" pitchFamily="34" charset="-122"/>
-                <a:cs typeface="Calibri" pitchFamily="34" charset="-120"/>
-              </a:rPr>
-              <a:t>запити</a:t>
-            </a:r>
-            <a:endParaRPr lang="en-US" sz="900" dirty="0"/>
-          </a:p>
-        </p:txBody>
-      </p:sp>
-      <p:sp>
-        <p:nvSpPr>
-          <p:cNvPr id="30" name="Shape 26"/>
+          <p:cNvPr id="26" name="Shape 22"/>
           <p:cNvSpPr/>
           <p:nvPr/>
         </p:nvSpPr>
@@ -11284,7 +10876,7 @@
       </p:sp>
       <p:sp>
         <p:nvSpPr>
-          <p:cNvPr id="31" name="Shape 27"/>
+          <p:cNvPr id="27" name="Shape 23"/>
           <p:cNvSpPr/>
           <p:nvPr/>
         </p:nvSpPr>
@@ -11304,7 +10896,7 @@
       </p:sp>
       <p:sp>
         <p:nvSpPr>
-          <p:cNvPr id="32" name="Shape 28"/>
+          <p:cNvPr id="28" name="Shape 24"/>
           <p:cNvSpPr/>
           <p:nvPr/>
         </p:nvSpPr>
@@ -11329,7 +10921,7 @@
       </p:sp>
       <p:pic>
         <p:nvPicPr>
-          <p:cNvPr id="33" name="Image 2" descr="preencoded.png">    </p:cNvPr>
+          <p:cNvPr id="29" name="Image 2" descr="preencoded.png">    </p:cNvPr>
           <p:cNvPicPr>
             <a:picLocks noChangeAspect="1"/>
           </p:cNvPicPr>
@@ -11353,7 +10945,7 @@
       </p:pic>
       <p:sp>
         <p:nvSpPr>
-          <p:cNvPr id="34" name="Text 29"/>
+          <p:cNvPr id="30" name="Text 25"/>
           <p:cNvSpPr/>
           <p:nvPr/>
         </p:nvSpPr>
@@ -11392,7 +10984,7 @@
       </p:sp>
       <p:sp>
         <p:nvSpPr>
-          <p:cNvPr id="35" name="Text 30"/>
+          <p:cNvPr id="31" name="Text 26"/>
           <p:cNvSpPr/>
           <p:nvPr/>
         </p:nvSpPr>
@@ -11431,14 +11023,14 @@
       </p:sp>
       <p:sp>
         <p:nvSpPr>
-          <p:cNvPr id="36" name="Text 31"/>
+          <p:cNvPr id="32" name="Text 27"/>
           <p:cNvSpPr/>
           <p:nvPr/>
         </p:nvSpPr>
         <p:spPr>
           <a:xfrm>
             <a:off x="1325880" y="4160520"/>
-            <a:ext cx="1005840" cy="274320"/>
+            <a:ext cx="1508760" cy="274320"/>
           </a:xfrm>
           <a:prstGeom prst="rect">
             <a:avLst/>
@@ -11454,7 +11046,7 @@
               <a:buNone/>
             </a:pPr>
             <a:r>
-              <a:rPr lang="en-US" sz="1800" b="1" dirty="0">
+              <a:rPr lang="en-US" sz="2200" b="1" dirty="0">
                 <a:solidFill>
                   <a:srgbClr val="E11D48"/>
                 </a:solidFill>
@@ -11464,20 +11056,20 @@
               </a:rPr>
               <a:t>9</a:t>
             </a:r>
-            <a:endParaRPr lang="en-US" sz="1800" dirty="0"/>
-          </a:p>
-        </p:txBody>
-      </p:sp>
-      <p:sp>
-        <p:nvSpPr>
-          <p:cNvPr id="37" name="Text 32"/>
-          <p:cNvSpPr/>
-          <p:nvPr/>
-        </p:nvSpPr>
-        <p:spPr>
-          <a:xfrm>
-            <a:off x="1325880" y="4416552"/>
-            <a:ext cx="1005840" cy="182880"/>
+            <a:endParaRPr lang="en-US" sz="2200" dirty="0"/>
+          </a:p>
+        </p:txBody>
+      </p:sp>
+      <p:sp>
+        <p:nvSpPr>
+          <p:cNvPr id="33" name="Text 28"/>
+          <p:cNvSpPr/>
+          <p:nvPr/>
+        </p:nvSpPr>
+        <p:spPr>
+          <a:xfrm>
+            <a:off x="1325880" y="4434840"/>
+            <a:ext cx="1508760" cy="182880"/>
           </a:xfrm>
           <a:prstGeom prst="rect">
             <a:avLst/>
@@ -11509,14 +11101,14 @@
       </p:sp>
       <p:sp>
         <p:nvSpPr>
-          <p:cNvPr id="38" name="Text 33"/>
-          <p:cNvSpPr/>
-          <p:nvPr/>
-        </p:nvSpPr>
-        <p:spPr>
-          <a:xfrm>
-            <a:off x="2331720" y="4160520"/>
-            <a:ext cx="1005840" cy="274320"/>
+          <p:cNvPr id="34" name="Text 29"/>
+          <p:cNvSpPr/>
+          <p:nvPr/>
+        </p:nvSpPr>
+        <p:spPr>
+          <a:xfrm>
+            <a:off x="2834640" y="4160520"/>
+            <a:ext cx="1508760" cy="274320"/>
           </a:xfrm>
           <a:prstGeom prst="rect">
             <a:avLst/>
@@ -11532,7 +11124,7 @@
               <a:buNone/>
             </a:pPr>
             <a:r>
-              <a:rPr lang="en-US" sz="1800" b="1" dirty="0">
+              <a:rPr lang="en-US" sz="2200" b="1" dirty="0">
                 <a:solidFill>
                   <a:srgbClr val="E11D48"/>
                 </a:solidFill>
@@ -11540,22 +11132,22 @@
                 <a:ea typeface="Calibri" pitchFamily="34" charset="-122"/>
                 <a:cs typeface="Calibri" pitchFamily="34" charset="-120"/>
               </a:rPr>
-              <a:t>267</a:t>
-            </a:r>
-            <a:endParaRPr lang="en-US" sz="1800" dirty="0"/>
-          </a:p>
-        </p:txBody>
-      </p:sp>
-      <p:sp>
-        <p:nvSpPr>
-          <p:cNvPr id="39" name="Text 34"/>
-          <p:cNvSpPr/>
-          <p:nvPr/>
-        </p:nvSpPr>
-        <p:spPr>
-          <a:xfrm>
-            <a:off x="2331720" y="4416552"/>
-            <a:ext cx="1005840" cy="182880"/>
+              <a:t>100</a:t>
+            </a:r>
+            <a:endParaRPr lang="en-US" sz="2200" dirty="0"/>
+          </a:p>
+        </p:txBody>
+      </p:sp>
+      <p:sp>
+        <p:nvSpPr>
+          <p:cNvPr id="35" name="Text 30"/>
+          <p:cNvSpPr/>
+          <p:nvPr/>
+        </p:nvSpPr>
+        <p:spPr>
+          <a:xfrm>
+            <a:off x="2834640" y="4434840"/>
+            <a:ext cx="1508760" cy="182880"/>
           </a:xfrm>
           <a:prstGeom prst="rect">
             <a:avLst/>
@@ -11579,7 +11171,7 @@
                 <a:ea typeface="Calibri" pitchFamily="34" charset="-122"/>
                 <a:cs typeface="Calibri" pitchFamily="34" charset="-120"/>
               </a:rPr>
-              <a:t>чанки</a:t>
+              <a:t>запити</a:t>
             </a:r>
             <a:endParaRPr lang="en-US" sz="900" dirty="0"/>
           </a:p>
@@ -11587,85 +11179,7 @@
       </p:sp>
       <p:sp>
         <p:nvSpPr>
-          <p:cNvPr id="40" name="Text 35"/>
-          <p:cNvSpPr/>
-          <p:nvPr/>
-        </p:nvSpPr>
-        <p:spPr>
-          <a:xfrm>
-            <a:off x="3337560" y="4160520"/>
-            <a:ext cx="1005840" cy="274320"/>
-          </a:xfrm>
-          <a:prstGeom prst="rect">
-            <a:avLst/>
-          </a:prstGeom>
-          <a:noFill/>
-          <a:ln/>
-        </p:spPr>
-        <p:txBody>
-          <a:bodyPr wrap="square" lIns="0" tIns="0" rIns="0" bIns="0" rtlCol="0" anchor="ctr"/>
-          <a:lstStyle/>
-          <a:p>
-            <a:pPr algn="l" indent="0" marL="0">
-              <a:buNone/>
-            </a:pPr>
-            <a:r>
-              <a:rPr lang="en-US" sz="1800" b="1" dirty="0">
-                <a:solidFill>
-                  <a:srgbClr val="E11D48"/>
-                </a:solidFill>
-                <a:latin typeface="Calibri" pitchFamily="34" charset="0"/>
-                <a:ea typeface="Calibri" pitchFamily="34" charset="-122"/>
-                <a:cs typeface="Calibri" pitchFamily="34" charset="-120"/>
-              </a:rPr>
-              <a:t>100</a:t>
-            </a:r>
-            <a:endParaRPr lang="en-US" sz="1800" dirty="0"/>
-          </a:p>
-        </p:txBody>
-      </p:sp>
-      <p:sp>
-        <p:nvSpPr>
-          <p:cNvPr id="41" name="Text 36"/>
-          <p:cNvSpPr/>
-          <p:nvPr/>
-        </p:nvSpPr>
-        <p:spPr>
-          <a:xfrm>
-            <a:off x="3337560" y="4416552"/>
-            <a:ext cx="1005840" cy="182880"/>
-          </a:xfrm>
-          <a:prstGeom prst="rect">
-            <a:avLst/>
-          </a:prstGeom>
-          <a:noFill/>
-          <a:ln/>
-        </p:spPr>
-        <p:txBody>
-          <a:bodyPr wrap="square" lIns="0" tIns="0" rIns="0" bIns="0" rtlCol="0" anchor="ctr"/>
-          <a:lstStyle/>
-          <a:p>
-            <a:pPr algn="l" indent="0" marL="0">
-              <a:buNone/>
-            </a:pPr>
-            <a:r>
-              <a:rPr lang="en-US" sz="900" dirty="0">
-                <a:solidFill>
-                  <a:srgbClr val="64748B"/>
-                </a:solidFill>
-                <a:latin typeface="Calibri" pitchFamily="34" charset="0"/>
-                <a:ea typeface="Calibri" pitchFamily="34" charset="-122"/>
-                <a:cs typeface="Calibri" pitchFamily="34" charset="-120"/>
-              </a:rPr>
-              <a:t>запити</a:t>
-            </a:r>
-            <a:endParaRPr lang="en-US" sz="900" dirty="0"/>
-          </a:p>
-        </p:txBody>
-      </p:sp>
-      <p:sp>
-        <p:nvSpPr>
-          <p:cNvPr id="42" name="Shape 37"/>
+          <p:cNvPr id="36" name="Shape 31"/>
           <p:cNvSpPr/>
           <p:nvPr/>
         </p:nvSpPr>
@@ -11699,14 +11213,248 @@
       </p:sp>
       <p:sp>
         <p:nvSpPr>
+          <p:cNvPr id="37" name="Text 32"/>
+          <p:cNvSpPr/>
+          <p:nvPr/>
+        </p:nvSpPr>
+        <p:spPr>
+          <a:xfrm>
+            <a:off x="4892040" y="1508760"/>
+            <a:ext cx="3657600" cy="228600"/>
+          </a:xfrm>
+          <a:prstGeom prst="rect">
+            <a:avLst/>
+          </a:prstGeom>
+          <a:noFill/>
+          <a:ln/>
+        </p:spPr>
+        <p:txBody>
+          <a:bodyPr wrap="square" lIns="0" tIns="0" rIns="0" bIns="0" rtlCol="0" anchor="ctr"/>
+          <a:lstStyle/>
+          <a:p>
+            <a:pPr algn="l" indent="0" marL="0">
+              <a:buNone/>
+            </a:pPr>
+            <a:r>
+              <a:rPr lang="en-US" sz="900" b="1" spc="200" kern="0" dirty="0">
+                <a:solidFill>
+                  <a:srgbClr val="64748B"/>
+                </a:solidFill>
+                <a:latin typeface="Calibri" pitchFamily="34" charset="0"/>
+                <a:ea typeface="Calibri" pitchFamily="34" charset="-122"/>
+                <a:cs typeface="Calibri" pitchFamily="34" charset="-120"/>
+              </a:rPr>
+              <a:t>ЗБАЛАНСОВАНА ОЦІНКА</a:t>
+            </a:r>
+            <a:endParaRPr lang="en-US" sz="900" dirty="0"/>
+          </a:p>
+        </p:txBody>
+      </p:sp>
+      <p:sp>
+        <p:nvSpPr>
+          <p:cNvPr id="38" name="Text 33"/>
+          <p:cNvSpPr/>
+          <p:nvPr/>
+        </p:nvSpPr>
+        <p:spPr>
+          <a:xfrm>
+            <a:off x="4892040" y="1874520"/>
+            <a:ext cx="1219200" cy="1097280"/>
+          </a:xfrm>
+          <a:prstGeom prst="rect">
+            <a:avLst/>
+          </a:prstGeom>
+          <a:noFill/>
+          <a:ln/>
+        </p:spPr>
+        <p:txBody>
+          <a:bodyPr wrap="square" lIns="0" tIns="0" rIns="0" bIns="0" rtlCol="0" anchor="ctr"/>
+          <a:lstStyle/>
+          <a:p>
+            <a:pPr algn="ctr" indent="0" marL="0">
+              <a:buNone/>
+            </a:pPr>
+            <a:r>
+              <a:rPr lang="en-US" sz="6000" b="1" dirty="0">
+                <a:solidFill>
+                  <a:srgbClr val="1E40AF"/>
+                </a:solidFill>
+                <a:latin typeface="Calibri" pitchFamily="34" charset="0"/>
+                <a:ea typeface="Calibri" pitchFamily="34" charset="-122"/>
+                <a:cs typeface="Calibri" pitchFamily="34" charset="-120"/>
+              </a:rPr>
+              <a:t>100</a:t>
+            </a:r>
+            <a:endParaRPr lang="en-US" sz="6000" dirty="0"/>
+          </a:p>
+        </p:txBody>
+      </p:sp>
+      <p:sp>
+        <p:nvSpPr>
+          <p:cNvPr id="39" name="Text 34"/>
+          <p:cNvSpPr/>
+          <p:nvPr/>
+        </p:nvSpPr>
+        <p:spPr>
+          <a:xfrm>
+            <a:off x="4892040" y="2971800"/>
+            <a:ext cx="1219200" cy="274320"/>
+          </a:xfrm>
+          <a:prstGeom prst="rect">
+            <a:avLst/>
+          </a:prstGeom>
+          <a:noFill/>
+          <a:ln/>
+        </p:spPr>
+        <p:txBody>
+          <a:bodyPr wrap="square" lIns="0" tIns="0" rIns="0" bIns="0" rtlCol="0" anchor="ctr"/>
+          <a:lstStyle/>
+          <a:p>
+            <a:pPr algn="ctr" indent="0" marL="0">
+              <a:buNone/>
+            </a:pPr>
+            <a:r>
+              <a:rPr lang="en-US" sz="1100" b="1" dirty="0">
+                <a:solidFill>
+                  <a:srgbClr val="1E293B"/>
+                </a:solidFill>
+                <a:latin typeface="Calibri" pitchFamily="34" charset="0"/>
+                <a:ea typeface="Calibri" pitchFamily="34" charset="-122"/>
+                <a:cs typeface="Calibri" pitchFamily="34" charset="-120"/>
+              </a:rPr>
+              <a:t>Технічний</a:t>
+            </a:r>
+            <a:endParaRPr lang="en-US" sz="1100" dirty="0"/>
+          </a:p>
+        </p:txBody>
+      </p:sp>
+      <p:sp>
+        <p:nvSpPr>
+          <p:cNvPr id="40" name="Text 35"/>
+          <p:cNvSpPr/>
+          <p:nvPr/>
+        </p:nvSpPr>
+        <p:spPr>
+          <a:xfrm>
+            <a:off x="4892040" y="3227832"/>
+            <a:ext cx="1219200" cy="201168"/>
+          </a:xfrm>
+          <a:prstGeom prst="rect">
+            <a:avLst/>
+          </a:prstGeom>
+          <a:noFill/>
+          <a:ln/>
+        </p:spPr>
+        <p:txBody>
+          <a:bodyPr wrap="square" lIns="0" tIns="0" rIns="0" bIns="0" rtlCol="0" anchor="ctr"/>
+          <a:lstStyle/>
+          <a:p>
+            <a:pPr algn="ctr" indent="0" marL="0">
+              <a:buNone/>
+            </a:pPr>
+            <a:r>
+              <a:rPr lang="en-US" sz="900" dirty="0">
+                <a:solidFill>
+                  <a:srgbClr val="64748B"/>
+                </a:solidFill>
+                <a:latin typeface="Calibri" pitchFamily="34" charset="0"/>
+                <a:ea typeface="Calibri" pitchFamily="34" charset="-122"/>
+                <a:cs typeface="Calibri" pitchFamily="34" charset="-120"/>
+              </a:rPr>
+              <a:t>запитів</a:t>
+            </a:r>
+            <a:endParaRPr lang="en-US" sz="900" dirty="0"/>
+          </a:p>
+        </p:txBody>
+      </p:sp>
+      <p:sp>
+        <p:nvSpPr>
+          <p:cNvPr id="41" name="Text 36"/>
+          <p:cNvSpPr/>
+          <p:nvPr/>
+        </p:nvSpPr>
+        <p:spPr>
+          <a:xfrm>
+            <a:off x="6111240" y="1874520"/>
+            <a:ext cx="1219200" cy="1097280"/>
+          </a:xfrm>
+          <a:prstGeom prst="rect">
+            <a:avLst/>
+          </a:prstGeom>
+          <a:noFill/>
+          <a:ln/>
+        </p:spPr>
+        <p:txBody>
+          <a:bodyPr wrap="square" lIns="0" tIns="0" rIns="0" bIns="0" rtlCol="0" anchor="ctr"/>
+          <a:lstStyle/>
+          <a:p>
+            <a:pPr algn="ctr" indent="0" marL="0">
+              <a:buNone/>
+            </a:pPr>
+            <a:r>
+              <a:rPr lang="en-US" sz="6000" b="1" dirty="0">
+                <a:solidFill>
+                  <a:srgbClr val="7C3AED"/>
+                </a:solidFill>
+                <a:latin typeface="Calibri" pitchFamily="34" charset="0"/>
+                <a:ea typeface="Calibri" pitchFamily="34" charset="-122"/>
+                <a:cs typeface="Calibri" pitchFamily="34" charset="-120"/>
+              </a:rPr>
+              <a:t>100</a:t>
+            </a:r>
+            <a:endParaRPr lang="en-US" sz="6000" dirty="0"/>
+          </a:p>
+        </p:txBody>
+      </p:sp>
+      <p:sp>
+        <p:nvSpPr>
+          <p:cNvPr id="42" name="Text 37"/>
+          <p:cNvSpPr/>
+          <p:nvPr/>
+        </p:nvSpPr>
+        <p:spPr>
+          <a:xfrm>
+            <a:off x="6111240" y="2971800"/>
+            <a:ext cx="1219200" cy="274320"/>
+          </a:xfrm>
+          <a:prstGeom prst="rect">
+            <a:avLst/>
+          </a:prstGeom>
+          <a:noFill/>
+          <a:ln/>
+        </p:spPr>
+        <p:txBody>
+          <a:bodyPr wrap="square" lIns="0" tIns="0" rIns="0" bIns="0" rtlCol="0" anchor="ctr"/>
+          <a:lstStyle/>
+          <a:p>
+            <a:pPr algn="ctr" indent="0" marL="0">
+              <a:buNone/>
+            </a:pPr>
+            <a:r>
+              <a:rPr lang="en-US" sz="1100" b="1" dirty="0">
+                <a:solidFill>
+                  <a:srgbClr val="1E293B"/>
+                </a:solidFill>
+                <a:latin typeface="Calibri" pitchFamily="34" charset="0"/>
+                <a:ea typeface="Calibri" pitchFamily="34" charset="-122"/>
+                <a:cs typeface="Calibri" pitchFamily="34" charset="-120"/>
+              </a:rPr>
+              <a:t>Юридичний</a:t>
+            </a:r>
+            <a:endParaRPr lang="en-US" sz="1100" dirty="0"/>
+          </a:p>
+        </p:txBody>
+      </p:sp>
+      <p:sp>
+        <p:nvSpPr>
           <p:cNvPr id="43" name="Text 38"/>
           <p:cNvSpPr/>
           <p:nvPr/>
         </p:nvSpPr>
         <p:spPr>
           <a:xfrm>
-            <a:off x="4892040" y="1463040"/>
-            <a:ext cx="3657600" cy="228600"/>
+            <a:off x="6111240" y="3227832"/>
+            <a:ext cx="1219200" cy="201168"/>
           </a:xfrm>
           <a:prstGeom prst="rect">
             <a:avLst/>
@@ -11718,11 +11466,11 @@
           <a:bodyPr wrap="square" lIns="0" tIns="0" rIns="0" bIns="0" rtlCol="0" anchor="ctr"/>
           <a:lstStyle/>
           <a:p>
-            <a:pPr algn="l" indent="0" marL="0">
-              <a:buNone/>
-            </a:pPr>
-            <a:r>
-              <a:rPr lang="en-US" sz="900" b="1" spc="200" kern="0" dirty="0">
+            <a:pPr algn="ctr" indent="0" marL="0">
+              <a:buNone/>
+            </a:pPr>
+            <a:r>
+              <a:rPr lang="en-US" sz="900" dirty="0">
                 <a:solidFill>
                   <a:srgbClr val="64748B"/>
                 </a:solidFill>
@@ -11730,38 +11478,22 @@
                 <a:ea typeface="Calibri" pitchFamily="34" charset="-122"/>
                 <a:cs typeface="Calibri" pitchFamily="34" charset="-120"/>
               </a:rPr>
-              <a:t>РОЗПОДІЛ ЧАНКІВ ЗА ДОМЕНАМИ</a:t>
+              <a:t>запитів</a:t>
             </a:r>
             <a:endParaRPr lang="en-US" sz="900" dirty="0"/>
           </a:p>
         </p:txBody>
       </p:sp>
-      <p:graphicFrame>
-        <p:nvGraphicFramePr>
-          <p:cNvPr id="44" name="Chart 0" descr=""/>
-          <p:cNvGraphicFramePr/>
-          <p:nvPr/>
-        </p:nvGraphicFramePr>
-        <p:xfrm>
-          <a:off x="4800600" y="1737360"/>
-          <a:ext cx="3840480" cy="2377440"/>
-        </p:xfrm>
-        <a:graphic xmlns:a="http://schemas.openxmlformats.org/drawingml/2006/main">
-          <a:graphicData uri="http://schemas.openxmlformats.org/drawingml/2006/chart">
-            <c:chart xmlns:c="http://schemas.openxmlformats.org/drawingml/2006/chart" r:id="rId4"/>
-          </a:graphicData>
-        </a:graphic>
-      </p:graphicFrame>
-      <p:sp>
-        <p:nvSpPr>
-          <p:cNvPr id="45" name="Text 39"/>
-          <p:cNvSpPr/>
-          <p:nvPr/>
-        </p:nvSpPr>
-        <p:spPr>
-          <a:xfrm>
-            <a:off x="4800600" y="2507285"/>
-            <a:ext cx="3840480" cy="365760"/>
+      <p:sp>
+        <p:nvSpPr>
+          <p:cNvPr id="44" name="Text 39"/>
+          <p:cNvSpPr/>
+          <p:nvPr/>
+        </p:nvSpPr>
+        <p:spPr>
+          <a:xfrm>
+            <a:off x="7330440" y="1874520"/>
+            <a:ext cx="1219200" cy="1097280"/>
           </a:xfrm>
           <a:prstGeom prst="rect">
             <a:avLst/>
@@ -11777,7 +11509,46 @@
               <a:buNone/>
             </a:pPr>
             <a:r>
-              <a:rPr lang="en-US" sz="2000" b="1" dirty="0">
+              <a:rPr lang="en-US" sz="6000" b="1" dirty="0">
+                <a:solidFill>
+                  <a:srgbClr val="E11D48"/>
+                </a:solidFill>
+                <a:latin typeface="Calibri" pitchFamily="34" charset="0"/>
+                <a:ea typeface="Calibri" pitchFamily="34" charset="-122"/>
+                <a:cs typeface="Calibri" pitchFamily="34" charset="-120"/>
+              </a:rPr>
+              <a:t>100</a:t>
+            </a:r>
+            <a:endParaRPr lang="en-US" sz="6000" dirty="0"/>
+          </a:p>
+        </p:txBody>
+      </p:sp>
+      <p:sp>
+        <p:nvSpPr>
+          <p:cNvPr id="45" name="Text 40"/>
+          <p:cNvSpPr/>
+          <p:nvPr/>
+        </p:nvSpPr>
+        <p:spPr>
+          <a:xfrm>
+            <a:off x="7330440" y="2971800"/>
+            <a:ext cx="1219200" cy="274320"/>
+          </a:xfrm>
+          <a:prstGeom prst="rect">
+            <a:avLst/>
+          </a:prstGeom>
+          <a:noFill/>
+          <a:ln/>
+        </p:spPr>
+        <p:txBody>
+          <a:bodyPr wrap="square" lIns="0" tIns="0" rIns="0" bIns="0" rtlCol="0" anchor="ctr"/>
+          <a:lstStyle/>
+          <a:p>
+            <a:pPr algn="ctr" indent="0" marL="0">
+              <a:buNone/>
+            </a:pPr>
+            <a:r>
+              <a:rPr lang="en-US" sz="1100" b="1" dirty="0">
                 <a:solidFill>
                   <a:srgbClr val="1E293B"/>
                 </a:solidFill>
@@ -11785,22 +11556,22 @@
                 <a:ea typeface="Calibri" pitchFamily="34" charset="-122"/>
                 <a:cs typeface="Calibri" pitchFamily="34" charset="-120"/>
               </a:rPr>
-              <a:t>1 491</a:t>
-            </a:r>
-            <a:endParaRPr lang="en-US" sz="2000" dirty="0"/>
-          </a:p>
-        </p:txBody>
-      </p:sp>
-      <p:sp>
-        <p:nvSpPr>
-          <p:cNvPr id="46" name="Text 40"/>
-          <p:cNvSpPr/>
-          <p:nvPr/>
-        </p:nvSpPr>
-        <p:spPr>
-          <a:xfrm>
-            <a:off x="4800600" y="2873045"/>
-            <a:ext cx="3840480" cy="201168"/>
+              <a:t>Медичний</a:t>
+            </a:r>
+            <a:endParaRPr lang="en-US" sz="1100" dirty="0"/>
+          </a:p>
+        </p:txBody>
+      </p:sp>
+      <p:sp>
+        <p:nvSpPr>
+          <p:cNvPr id="46" name="Text 41"/>
+          <p:cNvSpPr/>
+          <p:nvPr/>
+        </p:nvSpPr>
+        <p:spPr>
+          <a:xfrm>
+            <a:off x="7330440" y="3227832"/>
+            <a:ext cx="1219200" cy="201168"/>
           </a:xfrm>
           <a:prstGeom prst="rect">
             <a:avLst/>
@@ -11824,22 +11595,95 @@
                 <a:ea typeface="Calibri" pitchFamily="34" charset="-122"/>
                 <a:cs typeface="Calibri" pitchFamily="34" charset="-120"/>
               </a:rPr>
-              <a:t>чанків усього</a:t>
+              <a:t>запитів</a:t>
             </a:r>
             <a:endParaRPr lang="en-US" sz="900" dirty="0"/>
+          </a:p>
+        </p:txBody>
+      </p:sp>
+      <p:sp>
+        <p:nvSpPr>
+          <p:cNvPr id="47" name="Shape 42"/>
+          <p:cNvSpPr/>
+          <p:nvPr/>
+        </p:nvSpPr>
+        <p:spPr>
+          <a:xfrm>
+            <a:off x="5074920" y="3630168"/>
+            <a:ext cx="3291840" cy="22860"/>
+          </a:xfrm>
+          <a:prstGeom prst="rect">
+            <a:avLst/>
+          </a:prstGeom>
+          <a:solidFill>
+            <a:srgbClr val="E2E8F0"/>
+          </a:solidFill>
+          <a:ln/>
+        </p:spPr>
+      </p:sp>
+      <p:sp>
+        <p:nvSpPr>
+          <p:cNvPr id="48" name="Text 43"/>
+          <p:cNvSpPr/>
+          <p:nvPr/>
+        </p:nvSpPr>
+        <p:spPr>
+          <a:xfrm>
+            <a:off x="4892040" y="3703320"/>
+            <a:ext cx="3657600" cy="457200"/>
+          </a:xfrm>
+          <a:prstGeom prst="rect">
+            <a:avLst/>
+          </a:prstGeom>
+          <a:noFill/>
+          <a:ln/>
+        </p:spPr>
+        <p:txBody>
+          <a:bodyPr wrap="square" lIns="0" tIns="0" rIns="0" bIns="0" rtlCol="0" anchor="ctr"/>
+          <a:lstStyle/>
+          <a:p>
+            <a:pPr algn="ctr" indent="0" marL="0">
+              <a:buNone/>
+            </a:pPr>
+            <a:r>
+              <a:rPr lang="en-US" sz="2400" b="1" dirty="0">
+                <a:solidFill>
+                  <a:srgbClr val="F59E0B"/>
+                </a:solidFill>
+                <a:latin typeface="Calibri" pitchFamily="34" charset="0"/>
+                <a:ea typeface="Calibri" pitchFamily="34" charset="-122"/>
+                <a:cs typeface="Calibri" pitchFamily="34" charset="-120"/>
+              </a:rPr>
+              <a:t>300</a:t>
+            </a:r>
+            <a:pPr algn="ctr" indent="0" marL="0">
+              <a:buNone/>
+            </a:pPr>
+            <a:r>
+              <a:rPr lang="en-US" sz="1000" dirty="0">
+                <a:solidFill>
+                  <a:srgbClr val="475569"/>
+                </a:solidFill>
+                <a:latin typeface="Calibri" pitchFamily="34" charset="0"/>
+                <a:ea typeface="Calibri" pitchFamily="34" charset="-122"/>
+                <a:cs typeface="Calibri" pitchFamily="34" charset="-120"/>
+              </a:rPr>
+              <a:t>  запитів усього  ·  на яких рахуються per-query метрики</a:t>
+            </a:r>
+            <a:endParaRPr lang="en-US" sz="2400" dirty="0"/>
           </a:p>
         </p:txBody>
       </p:sp>
       <p:pic>
         <p:nvPicPr>
-          <p:cNvPr id="47" name="Image 3" descr="D:\repos\kb-semantic-search-benchmark\thesis\scripts\_logo_hex.png">    </p:cNvPr>
+          <p:cNvPr id="49" name="Image 3" descr="D:\repos\kb-semantic-search-benchmark\thesis\scripts\_logo_hex.png">    </p:cNvPr>
           <p:cNvPicPr>
             <a:picLocks noChangeAspect="1"/>
           </p:cNvPicPr>
           <p:nvPr/>
         </p:nvPicPr>
         <p:blipFill>
-          <a:blip r:embed="rId5"/>
+          <a:blip r:embed="rId4"/>
           <a:stretch>
             <a:fillRect/>
           </a:stretch>
@@ -11856,7 +11700,7 @@
       </p:pic>
       <p:sp>
         <p:nvSpPr>
-          <p:cNvPr id="48" name="Text 41"/>
+          <p:cNvPr id="50" name="Text 44"/>
           <p:cNvSpPr/>
           <p:nvPr/>
         </p:nvSpPr>

</xml_diff>

<commit_message>
Slide 11: drop the "100/100/100" right callout, expand domain cards full-width
The right-hand callout duplicated the per-card "100 запитів" stat.
Dropped it and let the three domain cards span the full slide width —
icon + name/description on the left, "documents · queries" stats with a
hairline separator on the right.

Co-Authored-By: Claude Opus 4.7 (1M context) <noreply@anthropic.com>
</commit_message>
<xml_diff>
--- a/thesis/Nesterenko_Presentation.pptx
+++ b/thesis/Nesterenko_Presentation.pptx
@@ -10175,11 +10175,11 @@
         <p:spPr>
           <a:xfrm>
             <a:off x="411480" y="1371600"/>
-            <a:ext cx="4114800" cy="1036320"/>
+            <a:ext cx="8321040" cy="1024128"/>
           </a:xfrm>
           <a:prstGeom prst="roundRect">
             <a:avLst>
-              <a:gd name="adj" fmla="val 5294"/>
+              <a:gd name="adj" fmla="val 5357"/>
             </a:avLst>
           </a:prstGeom>
           <a:solidFill>
@@ -10209,7 +10209,7 @@
         <p:spPr>
           <a:xfrm>
             <a:off x="411480" y="1371600"/>
-            <a:ext cx="91440" cy="1036320"/>
+            <a:ext cx="91440" cy="1024128"/>
           </a:xfrm>
           <a:prstGeom prst="rect">
             <a:avLst/>
@@ -10228,8 +10228,8 @@
         </p:nvSpPr>
         <p:spPr>
           <a:xfrm>
-            <a:off x="685800" y="1554480"/>
-            <a:ext cx="502920" cy="502920"/>
+            <a:off x="685800" y="1609344"/>
+            <a:ext cx="548640" cy="548640"/>
           </a:xfrm>
           <a:prstGeom prst="ellipse">
             <a:avLst/>
@@ -10261,8 +10261,8 @@
         </p:blipFill>
         <p:spPr>
           <a:xfrm>
-            <a:off x="777240" y="1645920"/>
-            <a:ext cx="320040" cy="320040"/>
+            <a:off x="795528" y="1719072"/>
+            <a:ext cx="329184" cy="329184"/>
           </a:xfrm>
           <a:prstGeom prst="rect">
             <a:avLst/>
@@ -10277,8 +10277,8 @@
         </p:nvSpPr>
         <p:spPr>
           <a:xfrm>
-            <a:off x="1325880" y="1463040"/>
-            <a:ext cx="3017520" cy="274320"/>
+            <a:off x="1417320" y="1554480"/>
+            <a:ext cx="4846320" cy="329184"/>
           </a:xfrm>
           <a:prstGeom prst="rect">
             <a:avLst/>
@@ -10294,7 +10294,7 @@
               <a:buNone/>
             </a:pPr>
             <a:r>
-              <a:rPr lang="en-US" sz="1300" b="1" dirty="0">
+              <a:rPr lang="en-US" sz="1600" b="1" dirty="0">
                 <a:solidFill>
                   <a:srgbClr val="1E293B"/>
                 </a:solidFill>
@@ -10304,7 +10304,7 @@
               </a:rPr>
               <a:t>Технічний</a:t>
             </a:r>
-            <a:endParaRPr lang="en-US" sz="1300" dirty="0"/>
+            <a:endParaRPr lang="en-US" sz="1600" dirty="0"/>
           </a:p>
         </p:txBody>
       </p:sp>
@@ -10316,24 +10316,24 @@
         </p:nvSpPr>
         <p:spPr>
           <a:xfrm>
-            <a:off x="1325880" y="1691640"/>
-            <a:ext cx="3017520" cy="274320"/>
-          </a:xfrm>
-          <a:prstGeom prst="rect">
-            <a:avLst/>
-          </a:prstGeom>
-          <a:noFill/>
-          <a:ln/>
-        </p:spPr>
-        <p:txBody>
-          <a:bodyPr wrap="square" lIns="0" tIns="0" rIns="0" bIns="0" rtlCol="0" anchor="ctr"/>
+            <a:off x="1417320" y="1920240"/>
+            <a:ext cx="4846320" cy="365760"/>
+          </a:xfrm>
+          <a:prstGeom prst="rect">
+            <a:avLst/>
+          </a:prstGeom>
+          <a:noFill/>
+          <a:ln/>
+        </p:spPr>
+        <p:txBody>
+          <a:bodyPr wrap="square" lIns="0" tIns="0" rIns="0" bIns="0" rtlCol="0" anchor="t"/>
           <a:lstStyle/>
           <a:p>
             <a:pPr algn="l" indent="0" marL="0">
               <a:buNone/>
             </a:pPr>
             <a:r>
-              <a:rPr lang="en-US" sz="950" i="1" dirty="0">
+              <a:rPr lang="en-US" sz="1100" i="1" dirty="0">
                 <a:solidFill>
                   <a:srgbClr val="475569"/>
                 </a:solidFill>
@@ -10343,36 +10343,56 @@
               </a:rPr>
               <a:t>програмна інженерія, ML, RAG, аномалії, 3D-друк, лідарні системи</a:t>
             </a:r>
-            <a:endParaRPr lang="en-US" sz="950" dirty="0"/>
-          </a:p>
-        </p:txBody>
-      </p:sp>
-      <p:sp>
-        <p:nvSpPr>
-          <p:cNvPr id="12" name="Text 9"/>
-          <p:cNvSpPr/>
-          <p:nvPr/>
-        </p:nvSpPr>
-        <p:spPr>
-          <a:xfrm>
-            <a:off x="1325880" y="1905000"/>
-            <a:ext cx="1508760" cy="274320"/>
-          </a:xfrm>
-          <a:prstGeom prst="rect">
-            <a:avLst/>
-          </a:prstGeom>
-          <a:noFill/>
-          <a:ln/>
-        </p:spPr>
-        <p:txBody>
-          <a:bodyPr wrap="square" lIns="0" tIns="0" rIns="0" bIns="0" rtlCol="0" anchor="ctr"/>
-          <a:lstStyle/>
-          <a:p>
-            <a:pPr algn="l" indent="0" marL="0">
-              <a:buNone/>
-            </a:pPr>
-            <a:r>
-              <a:rPr lang="en-US" sz="2200" b="1" dirty="0">
+            <a:endParaRPr lang="en-US" sz="1100" dirty="0"/>
+          </a:p>
+        </p:txBody>
+      </p:sp>
+      <p:sp>
+        <p:nvSpPr>
+          <p:cNvPr id="12" name="Shape 9"/>
+          <p:cNvSpPr/>
+          <p:nvPr/>
+        </p:nvSpPr>
+        <p:spPr>
+          <a:xfrm>
+            <a:off x="5989320" y="1600200"/>
+            <a:ext cx="13716" cy="566928"/>
+          </a:xfrm>
+          <a:prstGeom prst="rect">
+            <a:avLst/>
+          </a:prstGeom>
+          <a:solidFill>
+            <a:srgbClr val="E2E8F0"/>
+          </a:solidFill>
+          <a:ln/>
+        </p:spPr>
+      </p:sp>
+      <p:sp>
+        <p:nvSpPr>
+          <p:cNvPr id="13" name="Text 10"/>
+          <p:cNvSpPr/>
+          <p:nvPr/>
+        </p:nvSpPr>
+        <p:spPr>
+          <a:xfrm>
+            <a:off x="6126480" y="1554480"/>
+            <a:ext cx="1188720" cy="460858"/>
+          </a:xfrm>
+          <a:prstGeom prst="rect">
+            <a:avLst/>
+          </a:prstGeom>
+          <a:noFill/>
+          <a:ln/>
+        </p:spPr>
+        <p:txBody>
+          <a:bodyPr wrap="square" lIns="0" tIns="0" rIns="0" bIns="0" rtlCol="0" anchor="b"/>
+          <a:lstStyle/>
+          <a:p>
+            <a:pPr algn="ctr" indent="0" marL="0">
+              <a:buNone/>
+            </a:pPr>
+            <a:r>
+              <a:rPr lang="en-US" sz="3000" b="1" dirty="0">
                 <a:solidFill>
                   <a:srgbClr val="1E40AF"/>
                 </a:solidFill>
@@ -10382,36 +10402,36 @@
               </a:rPr>
               <a:t>10</a:t>
             </a:r>
-            <a:endParaRPr lang="en-US" sz="2200" dirty="0"/>
-          </a:p>
-        </p:txBody>
-      </p:sp>
-      <p:sp>
-        <p:nvSpPr>
-          <p:cNvPr id="13" name="Text 10"/>
-          <p:cNvSpPr/>
-          <p:nvPr/>
-        </p:nvSpPr>
-        <p:spPr>
-          <a:xfrm>
-            <a:off x="1325880" y="2179320"/>
-            <a:ext cx="1508760" cy="182880"/>
-          </a:xfrm>
-          <a:prstGeom prst="rect">
-            <a:avLst/>
-          </a:prstGeom>
-          <a:noFill/>
-          <a:ln/>
-        </p:spPr>
-        <p:txBody>
-          <a:bodyPr wrap="square" lIns="0" tIns="0" rIns="0" bIns="0" rtlCol="0" anchor="ctr"/>
-          <a:lstStyle/>
-          <a:p>
-            <a:pPr algn="l" indent="0" marL="0">
-              <a:buNone/>
-            </a:pPr>
-            <a:r>
-              <a:rPr lang="en-US" sz="900" dirty="0">
+            <a:endParaRPr lang="en-US" sz="3000" dirty="0"/>
+          </a:p>
+        </p:txBody>
+      </p:sp>
+      <p:sp>
+        <p:nvSpPr>
+          <p:cNvPr id="14" name="Text 11"/>
+          <p:cNvSpPr/>
+          <p:nvPr/>
+        </p:nvSpPr>
+        <p:spPr>
+          <a:xfrm>
+            <a:off x="6126480" y="2033626"/>
+            <a:ext cx="1188720" cy="197510"/>
+          </a:xfrm>
+          <a:prstGeom prst="rect">
+            <a:avLst/>
+          </a:prstGeom>
+          <a:noFill/>
+          <a:ln/>
+        </p:spPr>
+        <p:txBody>
+          <a:bodyPr wrap="square" lIns="0" tIns="0" rIns="0" bIns="0" rtlCol="0" anchor="t"/>
+          <a:lstStyle/>
+          <a:p>
+            <a:pPr algn="ctr" indent="0" marL="0">
+              <a:buNone/>
+            </a:pPr>
+            <a:r>
+              <a:rPr lang="en-US" sz="1000" dirty="0">
                 <a:solidFill>
                   <a:srgbClr val="64748B"/>
                 </a:solidFill>
@@ -10421,36 +10441,36 @@
               </a:rPr>
               <a:t>документи</a:t>
             </a:r>
-            <a:endParaRPr lang="en-US" sz="900" dirty="0"/>
-          </a:p>
-        </p:txBody>
-      </p:sp>
-      <p:sp>
-        <p:nvSpPr>
-          <p:cNvPr id="14" name="Text 11"/>
-          <p:cNvSpPr/>
-          <p:nvPr/>
-        </p:nvSpPr>
-        <p:spPr>
-          <a:xfrm>
-            <a:off x="2834640" y="1905000"/>
-            <a:ext cx="1508760" cy="274320"/>
-          </a:xfrm>
-          <a:prstGeom prst="rect">
-            <a:avLst/>
-          </a:prstGeom>
-          <a:noFill/>
-          <a:ln/>
-        </p:spPr>
-        <p:txBody>
-          <a:bodyPr wrap="square" lIns="0" tIns="0" rIns="0" bIns="0" rtlCol="0" anchor="ctr"/>
-          <a:lstStyle/>
-          <a:p>
-            <a:pPr algn="l" indent="0" marL="0">
-              <a:buNone/>
-            </a:pPr>
-            <a:r>
-              <a:rPr lang="en-US" sz="2200" b="1" dirty="0">
+            <a:endParaRPr lang="en-US" sz="1000" dirty="0"/>
+          </a:p>
+        </p:txBody>
+      </p:sp>
+      <p:sp>
+        <p:nvSpPr>
+          <p:cNvPr id="15" name="Text 12"/>
+          <p:cNvSpPr/>
+          <p:nvPr/>
+        </p:nvSpPr>
+        <p:spPr>
+          <a:xfrm>
+            <a:off x="7452360" y="1554480"/>
+            <a:ext cx="1188720" cy="460858"/>
+          </a:xfrm>
+          <a:prstGeom prst="rect">
+            <a:avLst/>
+          </a:prstGeom>
+          <a:noFill/>
+          <a:ln/>
+        </p:spPr>
+        <p:txBody>
+          <a:bodyPr wrap="square" lIns="0" tIns="0" rIns="0" bIns="0" rtlCol="0" anchor="b"/>
+          <a:lstStyle/>
+          <a:p>
+            <a:pPr algn="ctr" indent="0" marL="0">
+              <a:buNone/>
+            </a:pPr>
+            <a:r>
+              <a:rPr lang="en-US" sz="3000" b="1" dirty="0">
                 <a:solidFill>
                   <a:srgbClr val="1E40AF"/>
                 </a:solidFill>
@@ -10460,36 +10480,36 @@
               </a:rPr>
               <a:t>100</a:t>
             </a:r>
-            <a:endParaRPr lang="en-US" sz="2200" dirty="0"/>
-          </a:p>
-        </p:txBody>
-      </p:sp>
-      <p:sp>
-        <p:nvSpPr>
-          <p:cNvPr id="15" name="Text 12"/>
-          <p:cNvSpPr/>
-          <p:nvPr/>
-        </p:nvSpPr>
-        <p:spPr>
-          <a:xfrm>
-            <a:off x="2834640" y="2179320"/>
-            <a:ext cx="1508760" cy="182880"/>
-          </a:xfrm>
-          <a:prstGeom prst="rect">
-            <a:avLst/>
-          </a:prstGeom>
-          <a:noFill/>
-          <a:ln/>
-        </p:spPr>
-        <p:txBody>
-          <a:bodyPr wrap="square" lIns="0" tIns="0" rIns="0" bIns="0" rtlCol="0" anchor="ctr"/>
-          <a:lstStyle/>
-          <a:p>
-            <a:pPr algn="l" indent="0" marL="0">
-              <a:buNone/>
-            </a:pPr>
-            <a:r>
-              <a:rPr lang="en-US" sz="900" dirty="0">
+            <a:endParaRPr lang="en-US" sz="3000" dirty="0"/>
+          </a:p>
+        </p:txBody>
+      </p:sp>
+      <p:sp>
+        <p:nvSpPr>
+          <p:cNvPr id="16" name="Text 13"/>
+          <p:cNvSpPr/>
+          <p:nvPr/>
+        </p:nvSpPr>
+        <p:spPr>
+          <a:xfrm>
+            <a:off x="7452360" y="2033626"/>
+            <a:ext cx="1188720" cy="197510"/>
+          </a:xfrm>
+          <a:prstGeom prst="rect">
+            <a:avLst/>
+          </a:prstGeom>
+          <a:noFill/>
+          <a:ln/>
+        </p:spPr>
+        <p:txBody>
+          <a:bodyPr wrap="square" lIns="0" tIns="0" rIns="0" bIns="0" rtlCol="0" anchor="t"/>
+          <a:lstStyle/>
+          <a:p>
+            <a:pPr algn="ctr" indent="0" marL="0">
+              <a:buNone/>
+            </a:pPr>
+            <a:r>
+              <a:rPr lang="en-US" sz="1000" dirty="0">
                 <a:solidFill>
                   <a:srgbClr val="64748B"/>
                 </a:solidFill>
@@ -10499,24 +10519,24 @@
               </a:rPr>
               <a:t>запити</a:t>
             </a:r>
-            <a:endParaRPr lang="en-US" sz="900" dirty="0"/>
-          </a:p>
-        </p:txBody>
-      </p:sp>
-      <p:sp>
-        <p:nvSpPr>
-          <p:cNvPr id="16" name="Shape 13"/>
-          <p:cNvSpPr/>
-          <p:nvPr/>
-        </p:nvSpPr>
-        <p:spPr>
-          <a:xfrm>
-            <a:off x="411480" y="2499360"/>
-            <a:ext cx="4114800" cy="1036320"/>
+            <a:endParaRPr lang="en-US" sz="1000" dirty="0"/>
+          </a:p>
+        </p:txBody>
+      </p:sp>
+      <p:sp>
+        <p:nvSpPr>
+          <p:cNvPr id="17" name="Shape 14"/>
+          <p:cNvSpPr/>
+          <p:nvPr/>
+        </p:nvSpPr>
+        <p:spPr>
+          <a:xfrm>
+            <a:off x="411480" y="2505456"/>
+            <a:ext cx="8321040" cy="1024128"/>
           </a:xfrm>
           <a:prstGeom prst="roundRect">
             <a:avLst>
-              <a:gd name="adj" fmla="val 5294"/>
+              <a:gd name="adj" fmla="val 5357"/>
             </a:avLst>
           </a:prstGeom>
           <a:solidFill>
@@ -10539,14 +10559,14 @@
       </p:sp>
       <p:sp>
         <p:nvSpPr>
-          <p:cNvPr id="17" name="Shape 14"/>
-          <p:cNvSpPr/>
-          <p:nvPr/>
-        </p:nvSpPr>
-        <p:spPr>
-          <a:xfrm>
-            <a:off x="411480" y="2499360"/>
-            <a:ext cx="91440" cy="1036320"/>
+          <p:cNvPr id="18" name="Shape 15"/>
+          <p:cNvSpPr/>
+          <p:nvPr/>
+        </p:nvSpPr>
+        <p:spPr>
+          <a:xfrm>
+            <a:off x="411480" y="2505456"/>
+            <a:ext cx="91440" cy="1024128"/>
           </a:xfrm>
           <a:prstGeom prst="rect">
             <a:avLst/>
@@ -10559,14 +10579,14 @@
       </p:sp>
       <p:sp>
         <p:nvSpPr>
-          <p:cNvPr id="18" name="Shape 15"/>
-          <p:cNvSpPr/>
-          <p:nvPr/>
-        </p:nvSpPr>
-        <p:spPr>
-          <a:xfrm>
-            <a:off x="685800" y="2682240"/>
-            <a:ext cx="502920" cy="502920"/>
+          <p:cNvPr id="19" name="Shape 16"/>
+          <p:cNvSpPr/>
+          <p:nvPr/>
+        </p:nvSpPr>
+        <p:spPr>
+          <a:xfrm>
+            <a:off x="685800" y="2743200"/>
+            <a:ext cx="548640" cy="548640"/>
           </a:xfrm>
           <a:prstGeom prst="ellipse">
             <a:avLst/>
@@ -10584,7 +10604,7 @@
       </p:sp>
       <p:pic>
         <p:nvPicPr>
-          <p:cNvPr id="19" name="Image 1" descr="preencoded.png">    </p:cNvPr>
+          <p:cNvPr id="20" name="Image 1" descr="preencoded.png">    </p:cNvPr>
           <p:cNvPicPr>
             <a:picLocks noChangeAspect="1"/>
           </p:cNvPicPr>
@@ -10598,8 +10618,8 @@
         </p:blipFill>
         <p:spPr>
           <a:xfrm>
-            <a:off x="777240" y="2773680"/>
-            <a:ext cx="320040" cy="320040"/>
+            <a:off x="795528" y="2852928"/>
+            <a:ext cx="329184" cy="329184"/>
           </a:xfrm>
           <a:prstGeom prst="rect">
             <a:avLst/>
@@ -10608,14 +10628,14 @@
       </p:pic>
       <p:sp>
         <p:nvSpPr>
-          <p:cNvPr id="20" name="Text 16"/>
-          <p:cNvSpPr/>
-          <p:nvPr/>
-        </p:nvSpPr>
-        <p:spPr>
-          <a:xfrm>
-            <a:off x="1325880" y="2590800"/>
-            <a:ext cx="3017520" cy="274320"/>
+          <p:cNvPr id="21" name="Text 17"/>
+          <p:cNvSpPr/>
+          <p:nvPr/>
+        </p:nvSpPr>
+        <p:spPr>
+          <a:xfrm>
+            <a:off x="1417320" y="2688336"/>
+            <a:ext cx="4846320" cy="329184"/>
           </a:xfrm>
           <a:prstGeom prst="rect">
             <a:avLst/>
@@ -10631,7 +10651,7 @@
               <a:buNone/>
             </a:pPr>
             <a:r>
-              <a:rPr lang="en-US" sz="1300" b="1" dirty="0">
+              <a:rPr lang="en-US" sz="1600" b="1" dirty="0">
                 <a:solidFill>
                   <a:srgbClr val="1E293B"/>
                 </a:solidFill>
@@ -10641,36 +10661,36 @@
               </a:rPr>
               <a:t>Юридичний</a:t>
             </a:r>
-            <a:endParaRPr lang="en-US" sz="1300" dirty="0"/>
-          </a:p>
-        </p:txBody>
-      </p:sp>
-      <p:sp>
-        <p:nvSpPr>
-          <p:cNvPr id="21" name="Text 17"/>
-          <p:cNvSpPr/>
-          <p:nvPr/>
-        </p:nvSpPr>
-        <p:spPr>
-          <a:xfrm>
-            <a:off x="1325880" y="2819400"/>
-            <a:ext cx="3017520" cy="274320"/>
-          </a:xfrm>
-          <a:prstGeom prst="rect">
-            <a:avLst/>
-          </a:prstGeom>
-          <a:noFill/>
-          <a:ln/>
-        </p:spPr>
-        <p:txBody>
-          <a:bodyPr wrap="square" lIns="0" tIns="0" rIns="0" bIns="0" rtlCol="0" anchor="ctr"/>
+            <a:endParaRPr lang="en-US" sz="1600" dirty="0"/>
+          </a:p>
+        </p:txBody>
+      </p:sp>
+      <p:sp>
+        <p:nvSpPr>
+          <p:cNvPr id="22" name="Text 18"/>
+          <p:cNvSpPr/>
+          <p:nvPr/>
+        </p:nvSpPr>
+        <p:spPr>
+          <a:xfrm>
+            <a:off x="1417320" y="3054096"/>
+            <a:ext cx="4846320" cy="365760"/>
+          </a:xfrm>
+          <a:prstGeom prst="rect">
+            <a:avLst/>
+          </a:prstGeom>
+          <a:noFill/>
+          <a:ln/>
+        </p:spPr>
+        <p:txBody>
+          <a:bodyPr wrap="square" lIns="0" tIns="0" rIns="0" bIns="0" rtlCol="0" anchor="t"/>
           <a:lstStyle/>
           <a:p>
             <a:pPr algn="l" indent="0" marL="0">
               <a:buNone/>
             </a:pPr>
             <a:r>
-              <a:rPr lang="en-US" sz="950" i="1" dirty="0">
+              <a:rPr lang="en-US" sz="1100" i="1" dirty="0">
                 <a:solidFill>
                   <a:srgbClr val="475569"/>
                 </a:solidFill>
@@ -10680,36 +10700,56 @@
               </a:rPr>
               <a:t>кодекси, нормативно-правові акти, законодавство</a:t>
             </a:r>
-            <a:endParaRPr lang="en-US" sz="950" dirty="0"/>
-          </a:p>
-        </p:txBody>
-      </p:sp>
-      <p:sp>
-        <p:nvSpPr>
-          <p:cNvPr id="22" name="Text 18"/>
-          <p:cNvSpPr/>
-          <p:nvPr/>
-        </p:nvSpPr>
-        <p:spPr>
-          <a:xfrm>
-            <a:off x="1325880" y="3032760"/>
-            <a:ext cx="1508760" cy="274320"/>
-          </a:xfrm>
-          <a:prstGeom prst="rect">
-            <a:avLst/>
-          </a:prstGeom>
-          <a:noFill/>
-          <a:ln/>
-        </p:spPr>
-        <p:txBody>
-          <a:bodyPr wrap="square" lIns="0" tIns="0" rIns="0" bIns="0" rtlCol="0" anchor="ctr"/>
-          <a:lstStyle/>
-          <a:p>
-            <a:pPr algn="l" indent="0" marL="0">
-              <a:buNone/>
-            </a:pPr>
-            <a:r>
-              <a:rPr lang="en-US" sz="2200" b="1" dirty="0">
+            <a:endParaRPr lang="en-US" sz="1100" dirty="0"/>
+          </a:p>
+        </p:txBody>
+      </p:sp>
+      <p:sp>
+        <p:nvSpPr>
+          <p:cNvPr id="23" name="Shape 19"/>
+          <p:cNvSpPr/>
+          <p:nvPr/>
+        </p:nvSpPr>
+        <p:spPr>
+          <a:xfrm>
+            <a:off x="5989320" y="2734056"/>
+            <a:ext cx="13716" cy="566928"/>
+          </a:xfrm>
+          <a:prstGeom prst="rect">
+            <a:avLst/>
+          </a:prstGeom>
+          <a:solidFill>
+            <a:srgbClr val="E2E8F0"/>
+          </a:solidFill>
+          <a:ln/>
+        </p:spPr>
+      </p:sp>
+      <p:sp>
+        <p:nvSpPr>
+          <p:cNvPr id="24" name="Text 20"/>
+          <p:cNvSpPr/>
+          <p:nvPr/>
+        </p:nvSpPr>
+        <p:spPr>
+          <a:xfrm>
+            <a:off x="6126480" y="2688336"/>
+            <a:ext cx="1188720" cy="460858"/>
+          </a:xfrm>
+          <a:prstGeom prst="rect">
+            <a:avLst/>
+          </a:prstGeom>
+          <a:noFill/>
+          <a:ln/>
+        </p:spPr>
+        <p:txBody>
+          <a:bodyPr wrap="square" lIns="0" tIns="0" rIns="0" bIns="0" rtlCol="0" anchor="b"/>
+          <a:lstStyle/>
+          <a:p>
+            <a:pPr algn="ctr" indent="0" marL="0">
+              <a:buNone/>
+            </a:pPr>
+            <a:r>
+              <a:rPr lang="en-US" sz="3000" b="1" dirty="0">
                 <a:solidFill>
                   <a:srgbClr val="7C3AED"/>
                 </a:solidFill>
@@ -10719,36 +10759,36 @@
               </a:rPr>
               <a:t>13</a:t>
             </a:r>
-            <a:endParaRPr lang="en-US" sz="2200" dirty="0"/>
-          </a:p>
-        </p:txBody>
-      </p:sp>
-      <p:sp>
-        <p:nvSpPr>
-          <p:cNvPr id="23" name="Text 19"/>
-          <p:cNvSpPr/>
-          <p:nvPr/>
-        </p:nvSpPr>
-        <p:spPr>
-          <a:xfrm>
-            <a:off x="1325880" y="3307080"/>
-            <a:ext cx="1508760" cy="182880"/>
-          </a:xfrm>
-          <a:prstGeom prst="rect">
-            <a:avLst/>
-          </a:prstGeom>
-          <a:noFill/>
-          <a:ln/>
-        </p:spPr>
-        <p:txBody>
-          <a:bodyPr wrap="square" lIns="0" tIns="0" rIns="0" bIns="0" rtlCol="0" anchor="ctr"/>
-          <a:lstStyle/>
-          <a:p>
-            <a:pPr algn="l" indent="0" marL="0">
-              <a:buNone/>
-            </a:pPr>
-            <a:r>
-              <a:rPr lang="en-US" sz="900" dirty="0">
+            <a:endParaRPr lang="en-US" sz="3000" dirty="0"/>
+          </a:p>
+        </p:txBody>
+      </p:sp>
+      <p:sp>
+        <p:nvSpPr>
+          <p:cNvPr id="25" name="Text 21"/>
+          <p:cNvSpPr/>
+          <p:nvPr/>
+        </p:nvSpPr>
+        <p:spPr>
+          <a:xfrm>
+            <a:off x="6126480" y="3167482"/>
+            <a:ext cx="1188720" cy="197510"/>
+          </a:xfrm>
+          <a:prstGeom prst="rect">
+            <a:avLst/>
+          </a:prstGeom>
+          <a:noFill/>
+          <a:ln/>
+        </p:spPr>
+        <p:txBody>
+          <a:bodyPr wrap="square" lIns="0" tIns="0" rIns="0" bIns="0" rtlCol="0" anchor="t"/>
+          <a:lstStyle/>
+          <a:p>
+            <a:pPr algn="ctr" indent="0" marL="0">
+              <a:buNone/>
+            </a:pPr>
+            <a:r>
+              <a:rPr lang="en-US" sz="1000" dirty="0">
                 <a:solidFill>
                   <a:srgbClr val="64748B"/>
                 </a:solidFill>
@@ -10758,36 +10798,36 @@
               </a:rPr>
               <a:t>документи</a:t>
             </a:r>
-            <a:endParaRPr lang="en-US" sz="900" dirty="0"/>
-          </a:p>
-        </p:txBody>
-      </p:sp>
-      <p:sp>
-        <p:nvSpPr>
-          <p:cNvPr id="24" name="Text 20"/>
-          <p:cNvSpPr/>
-          <p:nvPr/>
-        </p:nvSpPr>
-        <p:spPr>
-          <a:xfrm>
-            <a:off x="2834640" y="3032760"/>
-            <a:ext cx="1508760" cy="274320"/>
-          </a:xfrm>
-          <a:prstGeom prst="rect">
-            <a:avLst/>
-          </a:prstGeom>
-          <a:noFill/>
-          <a:ln/>
-        </p:spPr>
-        <p:txBody>
-          <a:bodyPr wrap="square" lIns="0" tIns="0" rIns="0" bIns="0" rtlCol="0" anchor="ctr"/>
-          <a:lstStyle/>
-          <a:p>
-            <a:pPr algn="l" indent="0" marL="0">
-              <a:buNone/>
-            </a:pPr>
-            <a:r>
-              <a:rPr lang="en-US" sz="2200" b="1" dirty="0">
+            <a:endParaRPr lang="en-US" sz="1000" dirty="0"/>
+          </a:p>
+        </p:txBody>
+      </p:sp>
+      <p:sp>
+        <p:nvSpPr>
+          <p:cNvPr id="26" name="Text 22"/>
+          <p:cNvSpPr/>
+          <p:nvPr/>
+        </p:nvSpPr>
+        <p:spPr>
+          <a:xfrm>
+            <a:off x="7452360" y="2688336"/>
+            <a:ext cx="1188720" cy="460858"/>
+          </a:xfrm>
+          <a:prstGeom prst="rect">
+            <a:avLst/>
+          </a:prstGeom>
+          <a:noFill/>
+          <a:ln/>
+        </p:spPr>
+        <p:txBody>
+          <a:bodyPr wrap="square" lIns="0" tIns="0" rIns="0" bIns="0" rtlCol="0" anchor="b"/>
+          <a:lstStyle/>
+          <a:p>
+            <a:pPr algn="ctr" indent="0" marL="0">
+              <a:buNone/>
+            </a:pPr>
+            <a:r>
+              <a:rPr lang="en-US" sz="3000" b="1" dirty="0">
                 <a:solidFill>
                   <a:srgbClr val="7C3AED"/>
                 </a:solidFill>
@@ -10797,36 +10837,36 @@
               </a:rPr>
               <a:t>100</a:t>
             </a:r>
-            <a:endParaRPr lang="en-US" sz="2200" dirty="0"/>
-          </a:p>
-        </p:txBody>
-      </p:sp>
-      <p:sp>
-        <p:nvSpPr>
-          <p:cNvPr id="25" name="Text 21"/>
-          <p:cNvSpPr/>
-          <p:nvPr/>
-        </p:nvSpPr>
-        <p:spPr>
-          <a:xfrm>
-            <a:off x="2834640" y="3307080"/>
-            <a:ext cx="1508760" cy="182880"/>
-          </a:xfrm>
-          <a:prstGeom prst="rect">
-            <a:avLst/>
-          </a:prstGeom>
-          <a:noFill/>
-          <a:ln/>
-        </p:spPr>
-        <p:txBody>
-          <a:bodyPr wrap="square" lIns="0" tIns="0" rIns="0" bIns="0" rtlCol="0" anchor="ctr"/>
-          <a:lstStyle/>
-          <a:p>
-            <a:pPr algn="l" indent="0" marL="0">
-              <a:buNone/>
-            </a:pPr>
-            <a:r>
-              <a:rPr lang="en-US" sz="900" dirty="0">
+            <a:endParaRPr lang="en-US" sz="3000" dirty="0"/>
+          </a:p>
+        </p:txBody>
+      </p:sp>
+      <p:sp>
+        <p:nvSpPr>
+          <p:cNvPr id="27" name="Text 23"/>
+          <p:cNvSpPr/>
+          <p:nvPr/>
+        </p:nvSpPr>
+        <p:spPr>
+          <a:xfrm>
+            <a:off x="7452360" y="3167482"/>
+            <a:ext cx="1188720" cy="197510"/>
+          </a:xfrm>
+          <a:prstGeom prst="rect">
+            <a:avLst/>
+          </a:prstGeom>
+          <a:noFill/>
+          <a:ln/>
+        </p:spPr>
+        <p:txBody>
+          <a:bodyPr wrap="square" lIns="0" tIns="0" rIns="0" bIns="0" rtlCol="0" anchor="t"/>
+          <a:lstStyle/>
+          <a:p>
+            <a:pPr algn="ctr" indent="0" marL="0">
+              <a:buNone/>
+            </a:pPr>
+            <a:r>
+              <a:rPr lang="en-US" sz="1000" dirty="0">
                 <a:solidFill>
                   <a:srgbClr val="64748B"/>
                 </a:solidFill>
@@ -10836,24 +10876,24 @@
               </a:rPr>
               <a:t>запити</a:t>
             </a:r>
-            <a:endParaRPr lang="en-US" sz="900" dirty="0"/>
-          </a:p>
-        </p:txBody>
-      </p:sp>
-      <p:sp>
-        <p:nvSpPr>
-          <p:cNvPr id="26" name="Shape 22"/>
-          <p:cNvSpPr/>
-          <p:nvPr/>
-        </p:nvSpPr>
-        <p:spPr>
-          <a:xfrm>
-            <a:off x="411480" y="3627120"/>
-            <a:ext cx="4114800" cy="1036320"/>
+            <a:endParaRPr lang="en-US" sz="1000" dirty="0"/>
+          </a:p>
+        </p:txBody>
+      </p:sp>
+      <p:sp>
+        <p:nvSpPr>
+          <p:cNvPr id="28" name="Shape 24"/>
+          <p:cNvSpPr/>
+          <p:nvPr/>
+        </p:nvSpPr>
+        <p:spPr>
+          <a:xfrm>
+            <a:off x="411480" y="3639312"/>
+            <a:ext cx="8321040" cy="1024128"/>
           </a:xfrm>
           <a:prstGeom prst="roundRect">
             <a:avLst>
-              <a:gd name="adj" fmla="val 5294"/>
+              <a:gd name="adj" fmla="val 5357"/>
             </a:avLst>
           </a:prstGeom>
           <a:solidFill>
@@ -10876,14 +10916,14 @@
       </p:sp>
       <p:sp>
         <p:nvSpPr>
-          <p:cNvPr id="27" name="Shape 23"/>
-          <p:cNvSpPr/>
-          <p:nvPr/>
-        </p:nvSpPr>
-        <p:spPr>
-          <a:xfrm>
-            <a:off x="411480" y="3627120"/>
-            <a:ext cx="91440" cy="1036320"/>
+          <p:cNvPr id="29" name="Shape 25"/>
+          <p:cNvSpPr/>
+          <p:nvPr/>
+        </p:nvSpPr>
+        <p:spPr>
+          <a:xfrm>
+            <a:off x="411480" y="3639312"/>
+            <a:ext cx="91440" cy="1024128"/>
           </a:xfrm>
           <a:prstGeom prst="rect">
             <a:avLst/>
@@ -10896,14 +10936,14 @@
       </p:sp>
       <p:sp>
         <p:nvSpPr>
-          <p:cNvPr id="28" name="Shape 24"/>
-          <p:cNvSpPr/>
-          <p:nvPr/>
-        </p:nvSpPr>
-        <p:spPr>
-          <a:xfrm>
-            <a:off x="685800" y="3810000"/>
-            <a:ext cx="502920" cy="502920"/>
+          <p:cNvPr id="30" name="Shape 26"/>
+          <p:cNvSpPr/>
+          <p:nvPr/>
+        </p:nvSpPr>
+        <p:spPr>
+          <a:xfrm>
+            <a:off x="685800" y="3877056"/>
+            <a:ext cx="548640" cy="548640"/>
           </a:xfrm>
           <a:prstGeom prst="ellipse">
             <a:avLst/>
@@ -10921,7 +10961,7 @@
       </p:sp>
       <p:pic>
         <p:nvPicPr>
-          <p:cNvPr id="29" name="Image 2" descr="preencoded.png">    </p:cNvPr>
+          <p:cNvPr id="31" name="Image 2" descr="preencoded.png">    </p:cNvPr>
           <p:cNvPicPr>
             <a:picLocks noChangeAspect="1"/>
           </p:cNvPicPr>
@@ -10935,8 +10975,8 @@
         </p:blipFill>
         <p:spPr>
           <a:xfrm>
-            <a:off x="777240" y="3901440"/>
-            <a:ext cx="320040" cy="320040"/>
+            <a:off x="795528" y="3986784"/>
+            <a:ext cx="329184" cy="329184"/>
           </a:xfrm>
           <a:prstGeom prst="rect">
             <a:avLst/>
@@ -10945,14 +10985,14 @@
       </p:pic>
       <p:sp>
         <p:nvSpPr>
-          <p:cNvPr id="30" name="Text 25"/>
-          <p:cNvSpPr/>
-          <p:nvPr/>
-        </p:nvSpPr>
-        <p:spPr>
-          <a:xfrm>
-            <a:off x="1325880" y="3718560"/>
-            <a:ext cx="3017520" cy="274320"/>
+          <p:cNvPr id="32" name="Text 27"/>
+          <p:cNvSpPr/>
+          <p:nvPr/>
+        </p:nvSpPr>
+        <p:spPr>
+          <a:xfrm>
+            <a:off x="1417320" y="3822192"/>
+            <a:ext cx="4846320" cy="329184"/>
           </a:xfrm>
           <a:prstGeom prst="rect">
             <a:avLst/>
@@ -10968,7 +11008,7 @@
               <a:buNone/>
             </a:pPr>
             <a:r>
-              <a:rPr lang="en-US" sz="1300" b="1" dirty="0">
+              <a:rPr lang="en-US" sz="1600" b="1" dirty="0">
                 <a:solidFill>
                   <a:srgbClr val="1E293B"/>
                 </a:solidFill>
@@ -10978,36 +11018,36 @@
               </a:rPr>
               <a:t>Медичний</a:t>
             </a:r>
-            <a:endParaRPr lang="en-US" sz="1300" dirty="0"/>
-          </a:p>
-        </p:txBody>
-      </p:sp>
-      <p:sp>
-        <p:nvSpPr>
-          <p:cNvPr id="31" name="Text 26"/>
-          <p:cNvSpPr/>
-          <p:nvPr/>
-        </p:nvSpPr>
-        <p:spPr>
-          <a:xfrm>
-            <a:off x="1325880" y="3947160"/>
-            <a:ext cx="3017520" cy="274320"/>
-          </a:xfrm>
-          <a:prstGeom prst="rect">
-            <a:avLst/>
-          </a:prstGeom>
-          <a:noFill/>
-          <a:ln/>
-        </p:spPr>
-        <p:txBody>
-          <a:bodyPr wrap="square" lIns="0" tIns="0" rIns="0" bIns="0" rtlCol="0" anchor="ctr"/>
+            <a:endParaRPr lang="en-US" sz="1600" dirty="0"/>
+          </a:p>
+        </p:txBody>
+      </p:sp>
+      <p:sp>
+        <p:nvSpPr>
+          <p:cNvPr id="33" name="Text 28"/>
+          <p:cNvSpPr/>
+          <p:nvPr/>
+        </p:nvSpPr>
+        <p:spPr>
+          <a:xfrm>
+            <a:off x="1417320" y="4187952"/>
+            <a:ext cx="4846320" cy="365760"/>
+          </a:xfrm>
+          <a:prstGeom prst="rect">
+            <a:avLst/>
+          </a:prstGeom>
+          <a:noFill/>
+          <a:ln/>
+        </p:spPr>
+        <p:txBody>
+          <a:bodyPr wrap="square" lIns="0" tIns="0" rIns="0" bIns="0" rtlCol="0" anchor="t"/>
           <a:lstStyle/>
           <a:p>
             <a:pPr algn="l" indent="0" marL="0">
               <a:buNone/>
             </a:pPr>
             <a:r>
-              <a:rPr lang="en-US" sz="950" i="1" dirty="0">
+              <a:rPr lang="en-US" sz="1100" i="1" dirty="0">
                 <a:solidFill>
                   <a:srgbClr val="475569"/>
                 </a:solidFill>
@@ -11017,600 +11057,20 @@
               </a:rPr>
               <a:t>клінічні протоколи, медичні рекомендації</a:t>
             </a:r>
-            <a:endParaRPr lang="en-US" sz="950" dirty="0"/>
-          </a:p>
-        </p:txBody>
-      </p:sp>
-      <p:sp>
-        <p:nvSpPr>
-          <p:cNvPr id="32" name="Text 27"/>
-          <p:cNvSpPr/>
-          <p:nvPr/>
-        </p:nvSpPr>
-        <p:spPr>
-          <a:xfrm>
-            <a:off x="1325880" y="4160520"/>
-            <a:ext cx="1508760" cy="274320"/>
-          </a:xfrm>
-          <a:prstGeom prst="rect">
-            <a:avLst/>
-          </a:prstGeom>
-          <a:noFill/>
-          <a:ln/>
-        </p:spPr>
-        <p:txBody>
-          <a:bodyPr wrap="square" lIns="0" tIns="0" rIns="0" bIns="0" rtlCol="0" anchor="ctr"/>
-          <a:lstStyle/>
-          <a:p>
-            <a:pPr algn="l" indent="0" marL="0">
-              <a:buNone/>
-            </a:pPr>
-            <a:r>
-              <a:rPr lang="en-US" sz="2200" b="1" dirty="0">
-                <a:solidFill>
-                  <a:srgbClr val="E11D48"/>
-                </a:solidFill>
-                <a:latin typeface="Calibri" pitchFamily="34" charset="0"/>
-                <a:ea typeface="Calibri" pitchFamily="34" charset="-122"/>
-                <a:cs typeface="Calibri" pitchFamily="34" charset="-120"/>
-              </a:rPr>
-              <a:t>9</a:t>
-            </a:r>
-            <a:endParaRPr lang="en-US" sz="2200" dirty="0"/>
-          </a:p>
-        </p:txBody>
-      </p:sp>
-      <p:sp>
-        <p:nvSpPr>
-          <p:cNvPr id="33" name="Text 28"/>
-          <p:cNvSpPr/>
-          <p:nvPr/>
-        </p:nvSpPr>
-        <p:spPr>
-          <a:xfrm>
-            <a:off x="1325880" y="4434840"/>
-            <a:ext cx="1508760" cy="182880"/>
-          </a:xfrm>
-          <a:prstGeom prst="rect">
-            <a:avLst/>
-          </a:prstGeom>
-          <a:noFill/>
-          <a:ln/>
-        </p:spPr>
-        <p:txBody>
-          <a:bodyPr wrap="square" lIns="0" tIns="0" rIns="0" bIns="0" rtlCol="0" anchor="ctr"/>
-          <a:lstStyle/>
-          <a:p>
-            <a:pPr algn="l" indent="0" marL="0">
-              <a:buNone/>
-            </a:pPr>
-            <a:r>
-              <a:rPr lang="en-US" sz="900" dirty="0">
-                <a:solidFill>
-                  <a:srgbClr val="64748B"/>
-                </a:solidFill>
-                <a:latin typeface="Calibri" pitchFamily="34" charset="0"/>
-                <a:ea typeface="Calibri" pitchFamily="34" charset="-122"/>
-                <a:cs typeface="Calibri" pitchFamily="34" charset="-120"/>
-              </a:rPr>
-              <a:t>документи</a:t>
-            </a:r>
-            <a:endParaRPr lang="en-US" sz="900" dirty="0"/>
-          </a:p>
-        </p:txBody>
-      </p:sp>
-      <p:sp>
-        <p:nvSpPr>
-          <p:cNvPr id="34" name="Text 29"/>
-          <p:cNvSpPr/>
-          <p:nvPr/>
-        </p:nvSpPr>
-        <p:spPr>
-          <a:xfrm>
-            <a:off x="2834640" y="4160520"/>
-            <a:ext cx="1508760" cy="274320"/>
-          </a:xfrm>
-          <a:prstGeom prst="rect">
-            <a:avLst/>
-          </a:prstGeom>
-          <a:noFill/>
-          <a:ln/>
-        </p:spPr>
-        <p:txBody>
-          <a:bodyPr wrap="square" lIns="0" tIns="0" rIns="0" bIns="0" rtlCol="0" anchor="ctr"/>
-          <a:lstStyle/>
-          <a:p>
-            <a:pPr algn="l" indent="0" marL="0">
-              <a:buNone/>
-            </a:pPr>
-            <a:r>
-              <a:rPr lang="en-US" sz="2200" b="1" dirty="0">
-                <a:solidFill>
-                  <a:srgbClr val="E11D48"/>
-                </a:solidFill>
-                <a:latin typeface="Calibri" pitchFamily="34" charset="0"/>
-                <a:ea typeface="Calibri" pitchFamily="34" charset="-122"/>
-                <a:cs typeface="Calibri" pitchFamily="34" charset="-120"/>
-              </a:rPr>
-              <a:t>100</a:t>
-            </a:r>
-            <a:endParaRPr lang="en-US" sz="2200" dirty="0"/>
-          </a:p>
-        </p:txBody>
-      </p:sp>
-      <p:sp>
-        <p:nvSpPr>
-          <p:cNvPr id="35" name="Text 30"/>
-          <p:cNvSpPr/>
-          <p:nvPr/>
-        </p:nvSpPr>
-        <p:spPr>
-          <a:xfrm>
-            <a:off x="2834640" y="4434840"/>
-            <a:ext cx="1508760" cy="182880"/>
-          </a:xfrm>
-          <a:prstGeom prst="rect">
-            <a:avLst/>
-          </a:prstGeom>
-          <a:noFill/>
-          <a:ln/>
-        </p:spPr>
-        <p:txBody>
-          <a:bodyPr wrap="square" lIns="0" tIns="0" rIns="0" bIns="0" rtlCol="0" anchor="ctr"/>
-          <a:lstStyle/>
-          <a:p>
-            <a:pPr algn="l" indent="0" marL="0">
-              <a:buNone/>
-            </a:pPr>
-            <a:r>
-              <a:rPr lang="en-US" sz="900" dirty="0">
-                <a:solidFill>
-                  <a:srgbClr val="64748B"/>
-                </a:solidFill>
-                <a:latin typeface="Calibri" pitchFamily="34" charset="0"/>
-                <a:ea typeface="Calibri" pitchFamily="34" charset="-122"/>
-                <a:cs typeface="Calibri" pitchFamily="34" charset="-120"/>
-              </a:rPr>
-              <a:t>запити</a:t>
-            </a:r>
-            <a:endParaRPr lang="en-US" sz="900" dirty="0"/>
-          </a:p>
-        </p:txBody>
-      </p:sp>
-      <p:sp>
-        <p:nvSpPr>
-          <p:cNvPr id="36" name="Shape 31"/>
-          <p:cNvSpPr/>
-          <p:nvPr/>
-        </p:nvSpPr>
-        <p:spPr>
-          <a:xfrm>
-            <a:off x="4709160" y="1371600"/>
-            <a:ext cx="4023360" cy="3291840"/>
-          </a:xfrm>
-          <a:prstGeom prst="roundRect">
-            <a:avLst>
-              <a:gd name="adj" fmla="val 1667"/>
-            </a:avLst>
-          </a:prstGeom>
-          <a:solidFill>
-            <a:srgbClr val="F8FAFC"/>
-          </a:solidFill>
-          <a:ln w="9525">
-            <a:solidFill>
-              <a:srgbClr val="E2E8F0"/>
-            </a:solidFill>
-            <a:prstDash val="solid"/>
-          </a:ln>
-          <a:effectLst>
-            <a:outerShdw sx="100000" sy="100000" kx="0" ky="0" algn="bl" rotWithShape="0" blurRad="76200" dist="12700" dir="5400000">
-              <a:srgbClr val="000000">
-                <a:alpha val="7000"/>
-              </a:srgbClr>
-            </a:outerShdw>
-          </a:effectLst>
-        </p:spPr>
-      </p:sp>
-      <p:sp>
-        <p:nvSpPr>
-          <p:cNvPr id="37" name="Text 32"/>
-          <p:cNvSpPr/>
-          <p:nvPr/>
-        </p:nvSpPr>
-        <p:spPr>
-          <a:xfrm>
-            <a:off x="4892040" y="1508760"/>
-            <a:ext cx="3657600" cy="228600"/>
-          </a:xfrm>
-          <a:prstGeom prst="rect">
-            <a:avLst/>
-          </a:prstGeom>
-          <a:noFill/>
-          <a:ln/>
-        </p:spPr>
-        <p:txBody>
-          <a:bodyPr wrap="square" lIns="0" tIns="0" rIns="0" bIns="0" rtlCol="0" anchor="ctr"/>
-          <a:lstStyle/>
-          <a:p>
-            <a:pPr algn="l" indent="0" marL="0">
-              <a:buNone/>
-            </a:pPr>
-            <a:r>
-              <a:rPr lang="en-US" sz="900" b="1" spc="200" kern="0" dirty="0">
-                <a:solidFill>
-                  <a:srgbClr val="64748B"/>
-                </a:solidFill>
-                <a:latin typeface="Calibri" pitchFamily="34" charset="0"/>
-                <a:ea typeface="Calibri" pitchFamily="34" charset="-122"/>
-                <a:cs typeface="Calibri" pitchFamily="34" charset="-120"/>
-              </a:rPr>
-              <a:t>ЗБАЛАНСОВАНА ОЦІНКА</a:t>
-            </a:r>
-            <a:endParaRPr lang="en-US" sz="900" dirty="0"/>
-          </a:p>
-        </p:txBody>
-      </p:sp>
-      <p:sp>
-        <p:nvSpPr>
-          <p:cNvPr id="38" name="Text 33"/>
-          <p:cNvSpPr/>
-          <p:nvPr/>
-        </p:nvSpPr>
-        <p:spPr>
-          <a:xfrm>
-            <a:off x="4892040" y="1874520"/>
-            <a:ext cx="1219200" cy="1097280"/>
-          </a:xfrm>
-          <a:prstGeom prst="rect">
-            <a:avLst/>
-          </a:prstGeom>
-          <a:noFill/>
-          <a:ln/>
-        </p:spPr>
-        <p:txBody>
-          <a:bodyPr wrap="square" lIns="0" tIns="0" rIns="0" bIns="0" rtlCol="0" anchor="ctr"/>
-          <a:lstStyle/>
-          <a:p>
-            <a:pPr algn="ctr" indent="0" marL="0">
-              <a:buNone/>
-            </a:pPr>
-            <a:r>
-              <a:rPr lang="en-US" sz="6000" b="1" dirty="0">
-                <a:solidFill>
-                  <a:srgbClr val="1E40AF"/>
-                </a:solidFill>
-                <a:latin typeface="Calibri" pitchFamily="34" charset="0"/>
-                <a:ea typeface="Calibri" pitchFamily="34" charset="-122"/>
-                <a:cs typeface="Calibri" pitchFamily="34" charset="-120"/>
-              </a:rPr>
-              <a:t>100</a:t>
-            </a:r>
-            <a:endParaRPr lang="en-US" sz="6000" dirty="0"/>
-          </a:p>
-        </p:txBody>
-      </p:sp>
-      <p:sp>
-        <p:nvSpPr>
-          <p:cNvPr id="39" name="Text 34"/>
-          <p:cNvSpPr/>
-          <p:nvPr/>
-        </p:nvSpPr>
-        <p:spPr>
-          <a:xfrm>
-            <a:off x="4892040" y="2971800"/>
-            <a:ext cx="1219200" cy="274320"/>
-          </a:xfrm>
-          <a:prstGeom prst="rect">
-            <a:avLst/>
-          </a:prstGeom>
-          <a:noFill/>
-          <a:ln/>
-        </p:spPr>
-        <p:txBody>
-          <a:bodyPr wrap="square" lIns="0" tIns="0" rIns="0" bIns="0" rtlCol="0" anchor="ctr"/>
-          <a:lstStyle/>
-          <a:p>
-            <a:pPr algn="ctr" indent="0" marL="0">
-              <a:buNone/>
-            </a:pPr>
-            <a:r>
-              <a:rPr lang="en-US" sz="1100" b="1" dirty="0">
-                <a:solidFill>
-                  <a:srgbClr val="1E293B"/>
-                </a:solidFill>
-                <a:latin typeface="Calibri" pitchFamily="34" charset="0"/>
-                <a:ea typeface="Calibri" pitchFamily="34" charset="-122"/>
-                <a:cs typeface="Calibri" pitchFamily="34" charset="-120"/>
-              </a:rPr>
-              <a:t>Технічний</a:t>
-            </a:r>
             <a:endParaRPr lang="en-US" sz="1100" dirty="0"/>
           </a:p>
         </p:txBody>
       </p:sp>
       <p:sp>
         <p:nvSpPr>
-          <p:cNvPr id="40" name="Text 35"/>
-          <p:cNvSpPr/>
-          <p:nvPr/>
-        </p:nvSpPr>
-        <p:spPr>
-          <a:xfrm>
-            <a:off x="4892040" y="3227832"/>
-            <a:ext cx="1219200" cy="201168"/>
-          </a:xfrm>
-          <a:prstGeom prst="rect">
-            <a:avLst/>
-          </a:prstGeom>
-          <a:noFill/>
-          <a:ln/>
-        </p:spPr>
-        <p:txBody>
-          <a:bodyPr wrap="square" lIns="0" tIns="0" rIns="0" bIns="0" rtlCol="0" anchor="ctr"/>
-          <a:lstStyle/>
-          <a:p>
-            <a:pPr algn="ctr" indent="0" marL="0">
-              <a:buNone/>
-            </a:pPr>
-            <a:r>
-              <a:rPr lang="en-US" sz="900" dirty="0">
-                <a:solidFill>
-                  <a:srgbClr val="64748B"/>
-                </a:solidFill>
-                <a:latin typeface="Calibri" pitchFamily="34" charset="0"/>
-                <a:ea typeface="Calibri" pitchFamily="34" charset="-122"/>
-                <a:cs typeface="Calibri" pitchFamily="34" charset="-120"/>
-              </a:rPr>
-              <a:t>запитів</a:t>
-            </a:r>
-            <a:endParaRPr lang="en-US" sz="900" dirty="0"/>
-          </a:p>
-        </p:txBody>
-      </p:sp>
-      <p:sp>
-        <p:nvSpPr>
-          <p:cNvPr id="41" name="Text 36"/>
-          <p:cNvSpPr/>
-          <p:nvPr/>
-        </p:nvSpPr>
-        <p:spPr>
-          <a:xfrm>
-            <a:off x="6111240" y="1874520"/>
-            <a:ext cx="1219200" cy="1097280"/>
-          </a:xfrm>
-          <a:prstGeom prst="rect">
-            <a:avLst/>
-          </a:prstGeom>
-          <a:noFill/>
-          <a:ln/>
-        </p:spPr>
-        <p:txBody>
-          <a:bodyPr wrap="square" lIns="0" tIns="0" rIns="0" bIns="0" rtlCol="0" anchor="ctr"/>
-          <a:lstStyle/>
-          <a:p>
-            <a:pPr algn="ctr" indent="0" marL="0">
-              <a:buNone/>
-            </a:pPr>
-            <a:r>
-              <a:rPr lang="en-US" sz="6000" b="1" dirty="0">
-                <a:solidFill>
-                  <a:srgbClr val="7C3AED"/>
-                </a:solidFill>
-                <a:latin typeface="Calibri" pitchFamily="34" charset="0"/>
-                <a:ea typeface="Calibri" pitchFamily="34" charset="-122"/>
-                <a:cs typeface="Calibri" pitchFamily="34" charset="-120"/>
-              </a:rPr>
-              <a:t>100</a:t>
-            </a:r>
-            <a:endParaRPr lang="en-US" sz="6000" dirty="0"/>
-          </a:p>
-        </p:txBody>
-      </p:sp>
-      <p:sp>
-        <p:nvSpPr>
-          <p:cNvPr id="42" name="Text 37"/>
-          <p:cNvSpPr/>
-          <p:nvPr/>
-        </p:nvSpPr>
-        <p:spPr>
-          <a:xfrm>
-            <a:off x="6111240" y="2971800"/>
-            <a:ext cx="1219200" cy="274320"/>
-          </a:xfrm>
-          <a:prstGeom prst="rect">
-            <a:avLst/>
-          </a:prstGeom>
-          <a:noFill/>
-          <a:ln/>
-        </p:spPr>
-        <p:txBody>
-          <a:bodyPr wrap="square" lIns="0" tIns="0" rIns="0" bIns="0" rtlCol="0" anchor="ctr"/>
-          <a:lstStyle/>
-          <a:p>
-            <a:pPr algn="ctr" indent="0" marL="0">
-              <a:buNone/>
-            </a:pPr>
-            <a:r>
-              <a:rPr lang="en-US" sz="1100" b="1" dirty="0">
-                <a:solidFill>
-                  <a:srgbClr val="1E293B"/>
-                </a:solidFill>
-                <a:latin typeface="Calibri" pitchFamily="34" charset="0"/>
-                <a:ea typeface="Calibri" pitchFamily="34" charset="-122"/>
-                <a:cs typeface="Calibri" pitchFamily="34" charset="-120"/>
-              </a:rPr>
-              <a:t>Юридичний</a:t>
-            </a:r>
-            <a:endParaRPr lang="en-US" sz="1100" dirty="0"/>
-          </a:p>
-        </p:txBody>
-      </p:sp>
-      <p:sp>
-        <p:nvSpPr>
-          <p:cNvPr id="43" name="Text 38"/>
-          <p:cNvSpPr/>
-          <p:nvPr/>
-        </p:nvSpPr>
-        <p:spPr>
-          <a:xfrm>
-            <a:off x="6111240" y="3227832"/>
-            <a:ext cx="1219200" cy="201168"/>
-          </a:xfrm>
-          <a:prstGeom prst="rect">
-            <a:avLst/>
-          </a:prstGeom>
-          <a:noFill/>
-          <a:ln/>
-        </p:spPr>
-        <p:txBody>
-          <a:bodyPr wrap="square" lIns="0" tIns="0" rIns="0" bIns="0" rtlCol="0" anchor="ctr"/>
-          <a:lstStyle/>
-          <a:p>
-            <a:pPr algn="ctr" indent="0" marL="0">
-              <a:buNone/>
-            </a:pPr>
-            <a:r>
-              <a:rPr lang="en-US" sz="900" dirty="0">
-                <a:solidFill>
-                  <a:srgbClr val="64748B"/>
-                </a:solidFill>
-                <a:latin typeface="Calibri" pitchFamily="34" charset="0"/>
-                <a:ea typeface="Calibri" pitchFamily="34" charset="-122"/>
-                <a:cs typeface="Calibri" pitchFamily="34" charset="-120"/>
-              </a:rPr>
-              <a:t>запитів</a:t>
-            </a:r>
-            <a:endParaRPr lang="en-US" sz="900" dirty="0"/>
-          </a:p>
-        </p:txBody>
-      </p:sp>
-      <p:sp>
-        <p:nvSpPr>
-          <p:cNvPr id="44" name="Text 39"/>
-          <p:cNvSpPr/>
-          <p:nvPr/>
-        </p:nvSpPr>
-        <p:spPr>
-          <a:xfrm>
-            <a:off x="7330440" y="1874520"/>
-            <a:ext cx="1219200" cy="1097280"/>
-          </a:xfrm>
-          <a:prstGeom prst="rect">
-            <a:avLst/>
-          </a:prstGeom>
-          <a:noFill/>
-          <a:ln/>
-        </p:spPr>
-        <p:txBody>
-          <a:bodyPr wrap="square" lIns="0" tIns="0" rIns="0" bIns="0" rtlCol="0" anchor="ctr"/>
-          <a:lstStyle/>
-          <a:p>
-            <a:pPr algn="ctr" indent="0" marL="0">
-              <a:buNone/>
-            </a:pPr>
-            <a:r>
-              <a:rPr lang="en-US" sz="6000" b="1" dirty="0">
-                <a:solidFill>
-                  <a:srgbClr val="E11D48"/>
-                </a:solidFill>
-                <a:latin typeface="Calibri" pitchFamily="34" charset="0"/>
-                <a:ea typeface="Calibri" pitchFamily="34" charset="-122"/>
-                <a:cs typeface="Calibri" pitchFamily="34" charset="-120"/>
-              </a:rPr>
-              <a:t>100</a:t>
-            </a:r>
-            <a:endParaRPr lang="en-US" sz="6000" dirty="0"/>
-          </a:p>
-        </p:txBody>
-      </p:sp>
-      <p:sp>
-        <p:nvSpPr>
-          <p:cNvPr id="45" name="Text 40"/>
-          <p:cNvSpPr/>
-          <p:nvPr/>
-        </p:nvSpPr>
-        <p:spPr>
-          <a:xfrm>
-            <a:off x="7330440" y="2971800"/>
-            <a:ext cx="1219200" cy="274320"/>
-          </a:xfrm>
-          <a:prstGeom prst="rect">
-            <a:avLst/>
-          </a:prstGeom>
-          <a:noFill/>
-          <a:ln/>
-        </p:spPr>
-        <p:txBody>
-          <a:bodyPr wrap="square" lIns="0" tIns="0" rIns="0" bIns="0" rtlCol="0" anchor="ctr"/>
-          <a:lstStyle/>
-          <a:p>
-            <a:pPr algn="ctr" indent="0" marL="0">
-              <a:buNone/>
-            </a:pPr>
-            <a:r>
-              <a:rPr lang="en-US" sz="1100" b="1" dirty="0">
-                <a:solidFill>
-                  <a:srgbClr val="1E293B"/>
-                </a:solidFill>
-                <a:latin typeface="Calibri" pitchFamily="34" charset="0"/>
-                <a:ea typeface="Calibri" pitchFamily="34" charset="-122"/>
-                <a:cs typeface="Calibri" pitchFamily="34" charset="-120"/>
-              </a:rPr>
-              <a:t>Медичний</a:t>
-            </a:r>
-            <a:endParaRPr lang="en-US" sz="1100" dirty="0"/>
-          </a:p>
-        </p:txBody>
-      </p:sp>
-      <p:sp>
-        <p:nvSpPr>
-          <p:cNvPr id="46" name="Text 41"/>
-          <p:cNvSpPr/>
-          <p:nvPr/>
-        </p:nvSpPr>
-        <p:spPr>
-          <a:xfrm>
-            <a:off x="7330440" y="3227832"/>
-            <a:ext cx="1219200" cy="201168"/>
-          </a:xfrm>
-          <a:prstGeom prst="rect">
-            <a:avLst/>
-          </a:prstGeom>
-          <a:noFill/>
-          <a:ln/>
-        </p:spPr>
-        <p:txBody>
-          <a:bodyPr wrap="square" lIns="0" tIns="0" rIns="0" bIns="0" rtlCol="0" anchor="ctr"/>
-          <a:lstStyle/>
-          <a:p>
-            <a:pPr algn="ctr" indent="0" marL="0">
-              <a:buNone/>
-            </a:pPr>
-            <a:r>
-              <a:rPr lang="en-US" sz="900" dirty="0">
-                <a:solidFill>
-                  <a:srgbClr val="64748B"/>
-                </a:solidFill>
-                <a:latin typeface="Calibri" pitchFamily="34" charset="0"/>
-                <a:ea typeface="Calibri" pitchFamily="34" charset="-122"/>
-                <a:cs typeface="Calibri" pitchFamily="34" charset="-120"/>
-              </a:rPr>
-              <a:t>запитів</a:t>
-            </a:r>
-            <a:endParaRPr lang="en-US" sz="900" dirty="0"/>
-          </a:p>
-        </p:txBody>
-      </p:sp>
-      <p:sp>
-        <p:nvSpPr>
-          <p:cNvPr id="47" name="Shape 42"/>
-          <p:cNvSpPr/>
-          <p:nvPr/>
-        </p:nvSpPr>
-        <p:spPr>
-          <a:xfrm>
-            <a:off x="5074920" y="3630168"/>
-            <a:ext cx="3291840" cy="22860"/>
+          <p:cNvPr id="34" name="Shape 29"/>
+          <p:cNvSpPr/>
+          <p:nvPr/>
+        </p:nvSpPr>
+        <p:spPr>
+          <a:xfrm>
+            <a:off x="5989320" y="3867912"/>
+            <a:ext cx="13716" cy="566928"/>
           </a:xfrm>
           <a:prstGeom prst="rect">
             <a:avLst/>
@@ -11623,60 +11083,163 @@
       </p:sp>
       <p:sp>
         <p:nvSpPr>
-          <p:cNvPr id="48" name="Text 43"/>
-          <p:cNvSpPr/>
-          <p:nvPr/>
-        </p:nvSpPr>
-        <p:spPr>
-          <a:xfrm>
-            <a:off x="4892040" y="3703320"/>
-            <a:ext cx="3657600" cy="457200"/>
-          </a:xfrm>
-          <a:prstGeom prst="rect">
-            <a:avLst/>
-          </a:prstGeom>
-          <a:noFill/>
-          <a:ln/>
-        </p:spPr>
-        <p:txBody>
-          <a:bodyPr wrap="square" lIns="0" tIns="0" rIns="0" bIns="0" rtlCol="0" anchor="ctr"/>
+          <p:cNvPr id="35" name="Text 30"/>
+          <p:cNvSpPr/>
+          <p:nvPr/>
+        </p:nvSpPr>
+        <p:spPr>
+          <a:xfrm>
+            <a:off x="6126480" y="3822192"/>
+            <a:ext cx="1188720" cy="460858"/>
+          </a:xfrm>
+          <a:prstGeom prst="rect">
+            <a:avLst/>
+          </a:prstGeom>
+          <a:noFill/>
+          <a:ln/>
+        </p:spPr>
+        <p:txBody>
+          <a:bodyPr wrap="square" lIns="0" tIns="0" rIns="0" bIns="0" rtlCol="0" anchor="b"/>
           <a:lstStyle/>
           <a:p>
             <a:pPr algn="ctr" indent="0" marL="0">
               <a:buNone/>
             </a:pPr>
             <a:r>
-              <a:rPr lang="en-US" sz="2400" b="1" dirty="0">
-                <a:solidFill>
-                  <a:srgbClr val="F59E0B"/>
-                </a:solidFill>
-                <a:latin typeface="Calibri" pitchFamily="34" charset="0"/>
-                <a:ea typeface="Calibri" pitchFamily="34" charset="-122"/>
-                <a:cs typeface="Calibri" pitchFamily="34" charset="-120"/>
-              </a:rPr>
-              <a:t>300</a:t>
-            </a:r>
+              <a:rPr lang="en-US" sz="3000" b="1" dirty="0">
+                <a:solidFill>
+                  <a:srgbClr val="E11D48"/>
+                </a:solidFill>
+                <a:latin typeface="Calibri" pitchFamily="34" charset="0"/>
+                <a:ea typeface="Calibri" pitchFamily="34" charset="-122"/>
+                <a:cs typeface="Calibri" pitchFamily="34" charset="-120"/>
+              </a:rPr>
+              <a:t>9</a:t>
+            </a:r>
+            <a:endParaRPr lang="en-US" sz="3000" dirty="0"/>
+          </a:p>
+        </p:txBody>
+      </p:sp>
+      <p:sp>
+        <p:nvSpPr>
+          <p:cNvPr id="36" name="Text 31"/>
+          <p:cNvSpPr/>
+          <p:nvPr/>
+        </p:nvSpPr>
+        <p:spPr>
+          <a:xfrm>
+            <a:off x="6126480" y="4301338"/>
+            <a:ext cx="1188720" cy="197510"/>
+          </a:xfrm>
+          <a:prstGeom prst="rect">
+            <a:avLst/>
+          </a:prstGeom>
+          <a:noFill/>
+          <a:ln/>
+        </p:spPr>
+        <p:txBody>
+          <a:bodyPr wrap="square" lIns="0" tIns="0" rIns="0" bIns="0" rtlCol="0" anchor="t"/>
+          <a:lstStyle/>
+          <a:p>
             <a:pPr algn="ctr" indent="0" marL="0">
               <a:buNone/>
             </a:pPr>
             <a:r>
               <a:rPr lang="en-US" sz="1000" dirty="0">
                 <a:solidFill>
-                  <a:srgbClr val="475569"/>
-                </a:solidFill>
-                <a:latin typeface="Calibri" pitchFamily="34" charset="0"/>
-                <a:ea typeface="Calibri" pitchFamily="34" charset="-122"/>
-                <a:cs typeface="Calibri" pitchFamily="34" charset="-120"/>
-              </a:rPr>
-              <a:t>  запитів усього  ·  на яких рахуються per-query метрики</a:t>
-            </a:r>
-            <a:endParaRPr lang="en-US" sz="2400" dirty="0"/>
+                  <a:srgbClr val="64748B"/>
+                </a:solidFill>
+                <a:latin typeface="Calibri" pitchFamily="34" charset="0"/>
+                <a:ea typeface="Calibri" pitchFamily="34" charset="-122"/>
+                <a:cs typeface="Calibri" pitchFamily="34" charset="-120"/>
+              </a:rPr>
+              <a:t>документи</a:t>
+            </a:r>
+            <a:endParaRPr lang="en-US" sz="1000" dirty="0"/>
+          </a:p>
+        </p:txBody>
+      </p:sp>
+      <p:sp>
+        <p:nvSpPr>
+          <p:cNvPr id="37" name="Text 32"/>
+          <p:cNvSpPr/>
+          <p:nvPr/>
+        </p:nvSpPr>
+        <p:spPr>
+          <a:xfrm>
+            <a:off x="7452360" y="3822192"/>
+            <a:ext cx="1188720" cy="460858"/>
+          </a:xfrm>
+          <a:prstGeom prst="rect">
+            <a:avLst/>
+          </a:prstGeom>
+          <a:noFill/>
+          <a:ln/>
+        </p:spPr>
+        <p:txBody>
+          <a:bodyPr wrap="square" lIns="0" tIns="0" rIns="0" bIns="0" rtlCol="0" anchor="b"/>
+          <a:lstStyle/>
+          <a:p>
+            <a:pPr algn="ctr" indent="0" marL="0">
+              <a:buNone/>
+            </a:pPr>
+            <a:r>
+              <a:rPr lang="en-US" sz="3000" b="1" dirty="0">
+                <a:solidFill>
+                  <a:srgbClr val="E11D48"/>
+                </a:solidFill>
+                <a:latin typeface="Calibri" pitchFamily="34" charset="0"/>
+                <a:ea typeface="Calibri" pitchFamily="34" charset="-122"/>
+                <a:cs typeface="Calibri" pitchFamily="34" charset="-120"/>
+              </a:rPr>
+              <a:t>100</a:t>
+            </a:r>
+            <a:endParaRPr lang="en-US" sz="3000" dirty="0"/>
+          </a:p>
+        </p:txBody>
+      </p:sp>
+      <p:sp>
+        <p:nvSpPr>
+          <p:cNvPr id="38" name="Text 33"/>
+          <p:cNvSpPr/>
+          <p:nvPr/>
+        </p:nvSpPr>
+        <p:spPr>
+          <a:xfrm>
+            <a:off x="7452360" y="4301338"/>
+            <a:ext cx="1188720" cy="197510"/>
+          </a:xfrm>
+          <a:prstGeom prst="rect">
+            <a:avLst/>
+          </a:prstGeom>
+          <a:noFill/>
+          <a:ln/>
+        </p:spPr>
+        <p:txBody>
+          <a:bodyPr wrap="square" lIns="0" tIns="0" rIns="0" bIns="0" rtlCol="0" anchor="t"/>
+          <a:lstStyle/>
+          <a:p>
+            <a:pPr algn="ctr" indent="0" marL="0">
+              <a:buNone/>
+            </a:pPr>
+            <a:r>
+              <a:rPr lang="en-US" sz="1000" dirty="0">
+                <a:solidFill>
+                  <a:srgbClr val="64748B"/>
+                </a:solidFill>
+                <a:latin typeface="Calibri" pitchFamily="34" charset="0"/>
+                <a:ea typeface="Calibri" pitchFamily="34" charset="-122"/>
+                <a:cs typeface="Calibri" pitchFamily="34" charset="-120"/>
+              </a:rPr>
+              <a:t>запити</a:t>
+            </a:r>
+            <a:endParaRPr lang="en-US" sz="1000" dirty="0"/>
           </a:p>
         </p:txBody>
       </p:sp>
       <p:pic>
         <p:nvPicPr>
-          <p:cNvPr id="49" name="Image 3" descr="D:\repos\kb-semantic-search-benchmark\thesis\scripts\_logo_hex.png">    </p:cNvPr>
+          <p:cNvPr id="39" name="Image 3" descr="D:\repos\kb-semantic-search-benchmark\thesis\scripts\_logo_hex.png">    </p:cNvPr>
           <p:cNvPicPr>
             <a:picLocks noChangeAspect="1"/>
           </p:cNvPicPr>
@@ -11700,7 +11263,7 @@
       </p:pic>
       <p:sp>
         <p:nvSpPr>
-          <p:cNvPr id="50" name="Text 44"/>
+          <p:cNvPr id="40" name="Text 34"/>
           <p:cNvSpPr/>
           <p:nvPr/>
         </p:nvSpPr>

</xml_diff>

<commit_message>
Slide 15: lift Pareto callout content off the card's bottom edge
The description "3 з 5 альтернатив..." sat at y=ly+0.78 with h=0.25
inside a 1.05" card, leaving its second wrapped line glued to the bottom
border. Shifted the three rows up (title +0.02, formula +0.06,
description +0.12) and grew the description container to h=0.34 so the
text now finishes ~0.05" above the card edge.

Co-Authored-By: Claude Opus 4.7 (1M context) <noreply@anthropic.com>
</commit_message>
<xml_diff>
--- a/thesis/Nesterenko_Presentation.pptx
+++ b/thesis/Nesterenko_Presentation.pptx
@@ -15081,8 +15081,8 @@
         </p:nvSpPr>
         <p:spPr>
           <a:xfrm>
-            <a:off x="594360" y="1051560"/>
-            <a:ext cx="3566160" cy="228600"/>
+            <a:off x="594360" y="1033272"/>
+            <a:ext cx="3566160" cy="201168"/>
           </a:xfrm>
           <a:prstGeom prst="rect">
             <a:avLst/>
@@ -15120,8 +15120,8 @@
         </p:nvSpPr>
         <p:spPr>
           <a:xfrm>
-            <a:off x="594360" y="1289304"/>
-            <a:ext cx="3566160" cy="365760"/>
+            <a:off x="594360" y="1234440"/>
+            <a:ext cx="3566160" cy="329184"/>
           </a:xfrm>
           <a:prstGeom prst="rect">
             <a:avLst/>
@@ -15159,17 +15159,17 @@
         </p:nvSpPr>
         <p:spPr>
           <a:xfrm>
-            <a:off x="594360" y="1673352"/>
-            <a:ext cx="3566160" cy="228600"/>
-          </a:xfrm>
-          <a:prstGeom prst="rect">
-            <a:avLst/>
-          </a:prstGeom>
-          <a:noFill/>
-          <a:ln/>
-        </p:spPr>
-        <p:txBody>
-          <a:bodyPr wrap="square" lIns="0" tIns="0" rIns="0" bIns="0" rtlCol="0" anchor="ctr"/>
+            <a:off x="594360" y="1563624"/>
+            <a:ext cx="3566160" cy="310896"/>
+          </a:xfrm>
+          <a:prstGeom prst="rect">
+            <a:avLst/>
+          </a:prstGeom>
+          <a:noFill/>
+          <a:ln/>
+        </p:spPr>
+        <p:txBody>
+          <a:bodyPr wrap="square" lIns="0" tIns="0" rIns="0" bIns="0" rtlCol="0" anchor="t"/>
           <a:lstStyle/>
           <a:p>
             <a:pPr algn="l" indent="0" marL="0">

</xml_diff>

<commit_message>
Slide 15: tighten insight cards — pull description up to the model name
The model name container reserved h=0.35 with valign:top, so its bold
13 pt text sat at the very top while the 0.15" of dead space below it
pushed the description down to the bottom of each card. Shrunk the
title container to h=0.24 and moved the description up by 0.11" — text
now reads as "name + one-line description", no awkward gap.

Co-Authored-By: Claude Opus 4.7 (1M context) <noreply@anthropic.com>
</commit_message>
<xml_diff>
--- a/thesis/Nesterenko_Presentation.pptx
+++ b/thesis/Nesterenko_Presentation.pptx
@@ -15253,7 +15253,7 @@
         <p:spPr>
           <a:xfrm>
             <a:off x="640080" y="2148840"/>
-            <a:ext cx="3566160" cy="320040"/>
+            <a:ext cx="3566160" cy="219456"/>
           </a:xfrm>
           <a:prstGeom prst="rect">
             <a:avLst/>
@@ -15291,8 +15291,8 @@
         </p:nvSpPr>
         <p:spPr>
           <a:xfrm>
-            <a:off x="640080" y="2468880"/>
-            <a:ext cx="3566160" cy="194310"/>
+            <a:off x="640080" y="2368296"/>
+            <a:ext cx="3566160" cy="267462"/>
           </a:xfrm>
           <a:prstGeom prst="rect">
             <a:avLst/>
@@ -15385,7 +15385,7 @@
         <p:spPr>
           <a:xfrm>
             <a:off x="640080" y="2800350"/>
-            <a:ext cx="3566160" cy="320040"/>
+            <a:ext cx="3566160" cy="219456"/>
           </a:xfrm>
           <a:prstGeom prst="rect">
             <a:avLst/>
@@ -15423,8 +15423,8 @@
         </p:nvSpPr>
         <p:spPr>
           <a:xfrm>
-            <a:off x="640080" y="3120390"/>
-            <a:ext cx="3566160" cy="194310"/>
+            <a:off x="640080" y="3019806"/>
+            <a:ext cx="3566160" cy="267462"/>
           </a:xfrm>
           <a:prstGeom prst="rect">
             <a:avLst/>
@@ -15517,7 +15517,7 @@
         <p:spPr>
           <a:xfrm>
             <a:off x="640080" y="3451860"/>
-            <a:ext cx="3566160" cy="320040"/>
+            <a:ext cx="3566160" cy="219456"/>
           </a:xfrm>
           <a:prstGeom prst="rect">
             <a:avLst/>
@@ -15555,8 +15555,8 @@
         </p:nvSpPr>
         <p:spPr>
           <a:xfrm>
-            <a:off x="640080" y="3771900"/>
-            <a:ext cx="3566160" cy="194310"/>
+            <a:off x="640080" y="3671316"/>
+            <a:ext cx="3566160" cy="267462"/>
           </a:xfrm>
           <a:prstGeom prst="rect">
             <a:avLst/>
@@ -15649,7 +15649,7 @@
         <p:spPr>
           <a:xfrm>
             <a:off x="640080" y="4103370"/>
-            <a:ext cx="3566160" cy="320040"/>
+            <a:ext cx="3566160" cy="219456"/>
           </a:xfrm>
           <a:prstGeom prst="rect">
             <a:avLst/>
@@ -15687,8 +15687,8 @@
         </p:nvSpPr>
         <p:spPr>
           <a:xfrm>
-            <a:off x="640080" y="4423410"/>
-            <a:ext cx="3566160" cy="194310"/>
+            <a:off x="640080" y="4322826"/>
+            <a:ext cx="3566160" cy="267462"/>
           </a:xfrm>
           <a:prstGeom prst="rect">
             <a:avLst/>

</xml_diff>

<commit_message>
Slide 16: tighten insight notes to one line — no more text overflow
Each note container is 0.20" tall, which only fits one line at 9 pt.
Earlier two-line notes ("найвища nDCG (0.672 на Tech), ~228 мс — основний
вибір" etc.) overflowed below the card edge. Tightened the text so every
card now reads as one clean line:

  BGE-M3   nDCG = 0.672  ·  ~228 мс  ·  основний вибір
  E5-base  ~70 мс  ·  3× швидше за BGE-M3
  BM25     <3 мс  ·  стеля якості ~0.49 nDCG
  Qwen3    0.320 на Legal  ·  на Tech домінується
  nomic    поступається BM25 за якістю

Also reduced the kicker label charSpacing 1.5 → 1.0 so the longest
titles ("Парето-оптимальна · sweet spot") stay on a single line at
~2.7" usable width, and centred the note vertically inside its row.

Co-Authored-By: Claude Opus 4.7 (1M context) <noreply@anthropic.com>
</commit_message>
<xml_diff>
--- a/thesis/Nesterenko_Presentation.pptx
+++ b/thesis/Nesterenko_Presentation.pptx
@@ -16487,7 +16487,7 @@
               <a:buNone/>
             </a:pPr>
             <a:r>
-              <a:rPr lang="en-US" sz="850" b="1" spc="150" kern="0" dirty="0">
+              <a:rPr lang="en-US" sz="850" b="1" spc="100" kern="0" dirty="0">
                 <a:solidFill>
                   <a:srgbClr val="64748B"/>
                 </a:solidFill>
@@ -16509,8 +16509,8 @@
         </p:nvSpPr>
         <p:spPr>
           <a:xfrm>
-            <a:off x="6062472" y="1472184"/>
-            <a:ext cx="2560320" cy="219456"/>
+            <a:off x="6062472" y="1490472"/>
+            <a:ext cx="2560320" cy="201168"/>
           </a:xfrm>
           <a:prstGeom prst="rect">
             <a:avLst/>
@@ -16558,7 +16558,7 @@
           <a:ln/>
         </p:spPr>
         <p:txBody>
-          <a:bodyPr wrap="square" lIns="0" tIns="0" rIns="0" bIns="0" rtlCol="0" anchor="t"/>
+          <a:bodyPr wrap="square" lIns="0" tIns="0" rIns="0" bIns="0" rtlCol="0" anchor="ctr"/>
           <a:lstStyle/>
           <a:p>
             <a:pPr algn="l" indent="0" marL="0">
@@ -16573,7 +16573,7 @@
                 <a:ea typeface="Calibri" pitchFamily="34" charset="-122"/>
                 <a:cs typeface="Calibri" pitchFamily="34" charset="-120"/>
               </a:rPr>
-              <a:t>найвища nDCG (0.672 на Tech), ~228 мс — основний вибір</a:t>
+              <a:t>nDCG = 0.672  ·  ~228 мс  ·  основний вибір</a:t>
             </a:r>
             <a:endParaRPr lang="en-US" sz="900" dirty="0"/>
           </a:p>
@@ -16658,7 +16658,7 @@
               <a:buNone/>
             </a:pPr>
             <a:r>
-              <a:rPr lang="en-US" sz="850" b="1" spc="150" kern="0" dirty="0">
+              <a:rPr lang="en-US" sz="850" b="1" spc="100" kern="0" dirty="0">
                 <a:solidFill>
                   <a:srgbClr val="64748B"/>
                 </a:solidFill>
@@ -16680,8 +16680,8 @@
         </p:nvSpPr>
         <p:spPr>
           <a:xfrm>
-            <a:off x="6062472" y="2157984"/>
-            <a:ext cx="2560320" cy="219456"/>
+            <a:off x="6062472" y="2176272"/>
+            <a:ext cx="2560320" cy="201168"/>
           </a:xfrm>
           <a:prstGeom prst="rect">
             <a:avLst/>
@@ -16729,7 +16729,7 @@
           <a:ln/>
         </p:spPr>
         <p:txBody>
-          <a:bodyPr wrap="square" lIns="0" tIns="0" rIns="0" bIns="0" rtlCol="0" anchor="t"/>
+          <a:bodyPr wrap="square" lIns="0" tIns="0" rIns="0" bIns="0" rtlCol="0" anchor="ctr"/>
           <a:lstStyle/>
           <a:p>
             <a:pPr algn="l" indent="0" marL="0">
@@ -16744,7 +16744,7 @@
                 <a:ea typeface="Calibri" pitchFamily="34" charset="-122"/>
                 <a:cs typeface="Calibri" pitchFamily="34" charset="-120"/>
               </a:rPr>
-              <a:t>~70 мс  ·  3× швидше за BGE-M3 з мінімальною втратою якості</a:t>
+              <a:t>~70 мс  ·  3× швидше за BGE-M3</a:t>
             </a:r>
             <a:endParaRPr lang="en-US" sz="900" dirty="0"/>
           </a:p>
@@ -16829,7 +16829,7 @@
               <a:buNone/>
             </a:pPr>
             <a:r>
-              <a:rPr lang="en-US" sz="850" b="1" spc="150" kern="0" dirty="0">
+              <a:rPr lang="en-US" sz="850" b="1" spc="100" kern="0" dirty="0">
                 <a:solidFill>
                   <a:srgbClr val="64748B"/>
                 </a:solidFill>
@@ -16851,8 +16851,8 @@
         </p:nvSpPr>
         <p:spPr>
           <a:xfrm>
-            <a:off x="6062472" y="2843784"/>
-            <a:ext cx="2560320" cy="219456"/>
+            <a:off x="6062472" y="2862072"/>
+            <a:ext cx="2560320" cy="201168"/>
           </a:xfrm>
           <a:prstGeom prst="rect">
             <a:avLst/>
@@ -16900,7 +16900,7 @@
           <a:ln/>
         </p:spPr>
         <p:txBody>
-          <a:bodyPr wrap="square" lIns="0" tIns="0" rIns="0" bIns="0" rtlCol="0" anchor="t"/>
+          <a:bodyPr wrap="square" lIns="0" tIns="0" rIns="0" bIns="0" rtlCol="0" anchor="ctr"/>
           <a:lstStyle/>
           <a:p>
             <a:pPr algn="l" indent="0" marL="0">
@@ -16915,7 +16915,7 @@
                 <a:ea typeface="Calibri" pitchFamily="34" charset="-122"/>
                 <a:cs typeface="Calibri" pitchFamily="34" charset="-120"/>
               </a:rPr>
-              <a:t>&lt;3 мс  ·  найшвидший, але стеля якості ~0.49 nDCG</a:t>
+              <a:t>&lt;3 мс  ·  стеля якості ~0.49 nDCG</a:t>
             </a:r>
             <a:endParaRPr lang="en-US" sz="900" dirty="0"/>
           </a:p>
@@ -17000,7 +17000,7 @@
               <a:buNone/>
             </a:pPr>
             <a:r>
-              <a:rPr lang="en-US" sz="850" b="1" spc="150" kern="0" dirty="0">
+              <a:rPr lang="en-US" sz="850" b="1" spc="100" kern="0" dirty="0">
                 <a:solidFill>
                   <a:srgbClr val="64748B"/>
                 </a:solidFill>
@@ -17022,8 +17022,8 @@
         </p:nvSpPr>
         <p:spPr>
           <a:xfrm>
-            <a:off x="6062472" y="3529584"/>
-            <a:ext cx="2560320" cy="219456"/>
+            <a:off x="6062472" y="3547872"/>
+            <a:ext cx="2560320" cy="201168"/>
           </a:xfrm>
           <a:prstGeom prst="rect">
             <a:avLst/>
@@ -17071,7 +17071,7 @@
           <a:ln/>
         </p:spPr>
         <p:txBody>
-          <a:bodyPr wrap="square" lIns="0" tIns="0" rIns="0" bIns="0" rtlCol="0" anchor="t"/>
+          <a:bodyPr wrap="square" lIns="0" tIns="0" rIns="0" bIns="0" rtlCol="0" anchor="ctr"/>
           <a:lstStyle/>
           <a:p>
             <a:pPr algn="l" indent="0" marL="0">
@@ -17086,7 +17086,7 @@
                 <a:ea typeface="Calibri" pitchFamily="34" charset="-122"/>
                 <a:cs typeface="Calibri" pitchFamily="34" charset="-120"/>
               </a:rPr>
-              <a:t>виграє лише на юридичному (nDCG=0.320), на Tech домінується BGE-M3</a:t>
+              <a:t>0.320 на Legal  ·  на Tech домінується</a:t>
             </a:r>
             <a:endParaRPr lang="en-US" sz="900" dirty="0"/>
           </a:p>
@@ -17171,7 +17171,7 @@
               <a:buNone/>
             </a:pPr>
             <a:r>
-              <a:rPr lang="en-US" sz="850" b="1" spc="150" kern="0" dirty="0">
+              <a:rPr lang="en-US" sz="850" b="1" spc="100" kern="0" dirty="0">
                 <a:solidFill>
                   <a:srgbClr val="64748B"/>
                 </a:solidFill>
@@ -17193,8 +17193,8 @@
         </p:nvSpPr>
         <p:spPr>
           <a:xfrm>
-            <a:off x="6062472" y="4215384"/>
-            <a:ext cx="2560320" cy="219456"/>
+            <a:off x="6062472" y="4233672"/>
+            <a:ext cx="2560320" cy="201168"/>
           </a:xfrm>
           <a:prstGeom prst="rect">
             <a:avLst/>
@@ -17242,7 +17242,7 @@
           <a:ln/>
         </p:spPr>
         <p:txBody>
-          <a:bodyPr wrap="square" lIns="0" tIns="0" rIns="0" bIns="0" rtlCol="0" anchor="t"/>
+          <a:bodyPr wrap="square" lIns="0" tIns="0" rIns="0" bIns="0" rtlCol="0" anchor="ctr"/>
           <a:lstStyle/>
           <a:p>
             <a:pPr algn="l" indent="0" marL="0">
@@ -17257,7 +17257,7 @@
                 <a:ea typeface="Calibri" pitchFamily="34" charset="-122"/>
                 <a:cs typeface="Calibri" pitchFamily="34" charset="-120"/>
               </a:rPr>
-              <a:t>поступається BM25 за якістю при більшій latency — ані швидко, ані точно</a:t>
+              <a:t>поступається BM25 за якістю</a:t>
             </a:r>
             <a:endParaRPr lang="en-US" sz="900" dirty="0"/>
           </a:p>

</xml_diff>

<commit_message>
Title slide: redesign date/venue as a structured right-side stamp
The original "📅 15 травня 2026 · Харків" floated alone in white space
without a visual anchor. Replaced with a three-line stamp that mirrors
the author / supervisor block on the left:

  [gold accent line]
  ДАТА ЗАХИСТУ
  15 травня 2026
  Харків

Right-aligned, kicker label + bold value + italic venue, with a small
gold accent line above to balance the gold separator under the title
on the left half.

Co-Authored-By: Claude Opus 4.7 (1M context) <noreply@anthropic.com>
</commit_message>
<xml_diff>
--- a/thesis/Nesterenko_Presentation.pptx
+++ b/thesis/Nesterenko_Presentation.pptx
@@ -8228,9 +8228,146 @@
           </a:p>
         </p:txBody>
       </p:sp>
+      <p:sp>
+        <p:nvSpPr>
+          <p:cNvPr id="12" name="Text 10"/>
+          <p:cNvSpPr/>
+          <p:nvPr/>
+        </p:nvSpPr>
+        <p:spPr>
+          <a:xfrm>
+            <a:off x="6583680" y="3886200"/>
+            <a:ext cx="2148840" cy="201168"/>
+          </a:xfrm>
+          <a:prstGeom prst="rect">
+            <a:avLst/>
+          </a:prstGeom>
+          <a:noFill/>
+          <a:ln/>
+        </p:spPr>
+        <p:txBody>
+          <a:bodyPr wrap="square" lIns="0" tIns="0" rIns="0" bIns="0" rtlCol="0" anchor="ctr"/>
+          <a:lstStyle/>
+          <a:p>
+            <a:pPr algn="r" indent="0" marL="0">
+              <a:buNone/>
+            </a:pPr>
+            <a:r>
+              <a:rPr lang="en-US" sz="900" b="1" spc="200" kern="0" dirty="0">
+                <a:solidFill>
+                  <a:srgbClr val="64748B"/>
+                </a:solidFill>
+                <a:latin typeface="Calibri" pitchFamily="34" charset="0"/>
+                <a:ea typeface="Calibri" pitchFamily="34" charset="-122"/>
+                <a:cs typeface="Calibri" pitchFamily="34" charset="-120"/>
+              </a:rPr>
+              <a:t>ДАТА ЗАХИСТУ</a:t>
+            </a:r>
+            <a:endParaRPr lang="en-US" sz="900" dirty="0"/>
+          </a:p>
+        </p:txBody>
+      </p:sp>
+      <p:sp>
+        <p:nvSpPr>
+          <p:cNvPr id="13" name="Text 11"/>
+          <p:cNvSpPr/>
+          <p:nvPr/>
+        </p:nvSpPr>
+        <p:spPr>
+          <a:xfrm>
+            <a:off x="6583680" y="4096512"/>
+            <a:ext cx="2148840" cy="292608"/>
+          </a:xfrm>
+          <a:prstGeom prst="rect">
+            <a:avLst/>
+          </a:prstGeom>
+          <a:noFill/>
+          <a:ln/>
+        </p:spPr>
+        <p:txBody>
+          <a:bodyPr wrap="square" lIns="0" tIns="0" rIns="0" bIns="0" rtlCol="0" anchor="ctr"/>
+          <a:lstStyle/>
+          <a:p>
+            <a:pPr algn="r" indent="0" marL="0">
+              <a:buNone/>
+            </a:pPr>
+            <a:r>
+              <a:rPr lang="en-US" sz="1700" b="1" dirty="0">
+                <a:solidFill>
+                  <a:srgbClr val="0F172A"/>
+                </a:solidFill>
+                <a:latin typeface="Calibri" pitchFamily="34" charset="0"/>
+                <a:ea typeface="Calibri" pitchFamily="34" charset="-122"/>
+                <a:cs typeface="Calibri" pitchFamily="34" charset="-120"/>
+              </a:rPr>
+              <a:t>15 травня 2026</a:t>
+            </a:r>
+            <a:endParaRPr lang="en-US" sz="1700" dirty="0"/>
+          </a:p>
+        </p:txBody>
+      </p:sp>
+      <p:sp>
+        <p:nvSpPr>
+          <p:cNvPr id="14" name="Text 12"/>
+          <p:cNvSpPr/>
+          <p:nvPr/>
+        </p:nvSpPr>
+        <p:spPr>
+          <a:xfrm>
+            <a:off x="6583680" y="4407408"/>
+            <a:ext cx="2148840" cy="201168"/>
+          </a:xfrm>
+          <a:prstGeom prst="rect">
+            <a:avLst/>
+          </a:prstGeom>
+          <a:noFill/>
+          <a:ln/>
+        </p:spPr>
+        <p:txBody>
+          <a:bodyPr wrap="square" lIns="0" tIns="0" rIns="0" bIns="0" rtlCol="0" anchor="ctr"/>
+          <a:lstStyle/>
+          <a:p>
+            <a:pPr algn="r" indent="0" marL="0">
+              <a:buNone/>
+            </a:pPr>
+            <a:r>
+              <a:rPr lang="en-US" sz="1100" i="1" dirty="0">
+                <a:solidFill>
+                  <a:srgbClr val="64748B"/>
+                </a:solidFill>
+                <a:latin typeface="Calibri" pitchFamily="34" charset="0"/>
+                <a:ea typeface="Calibri" pitchFamily="34" charset="-122"/>
+                <a:cs typeface="Calibri" pitchFamily="34" charset="-120"/>
+              </a:rPr>
+              <a:t>Харків</a:t>
+            </a:r>
+            <a:endParaRPr lang="en-US" sz="1100" dirty="0"/>
+          </a:p>
+        </p:txBody>
+      </p:sp>
+      <p:sp>
+        <p:nvSpPr>
+          <p:cNvPr id="15" name="Shape 13"/>
+          <p:cNvSpPr/>
+          <p:nvPr/>
+        </p:nvSpPr>
+        <p:spPr>
+          <a:xfrm>
+            <a:off x="8275320" y="3849624"/>
+            <a:ext cx="457200" cy="36576"/>
+          </a:xfrm>
+          <a:prstGeom prst="rect">
+            <a:avLst/>
+          </a:prstGeom>
+          <a:solidFill>
+            <a:srgbClr val="F59E0B"/>
+          </a:solidFill>
+          <a:ln/>
+        </p:spPr>
+      </p:sp>
       <p:pic>
         <p:nvPicPr>
-          <p:cNvPr id="12" name="Image 0" descr="preencoded.png">    </p:cNvPr>
+          <p:cNvPr id="16" name="Image 0" descr="D:\repos\kb-semantic-search-benchmark\thesis\scripts\_logo_xnure.png">    </p:cNvPr>
           <p:cNvPicPr>
             <a:picLocks noChangeAspect="1"/>
           </p:cNvPicPr>
@@ -8244,56 +8381,17 @@
         </p:blipFill>
         <p:spPr>
           <a:xfrm>
-            <a:off x="7178040" y="4069080"/>
-            <a:ext cx="182880" cy="182880"/>
+            <a:off x="411480" y="4686300"/>
+            <a:ext cx="1645920" cy="365760"/>
           </a:xfrm>
           <a:prstGeom prst="rect">
             <a:avLst/>
           </a:prstGeom>
         </p:spPr>
       </p:pic>
-      <p:sp>
-        <p:nvSpPr>
-          <p:cNvPr id="13" name="Text 10"/>
-          <p:cNvSpPr/>
-          <p:nvPr/>
-        </p:nvSpPr>
-        <p:spPr>
-          <a:xfrm>
-            <a:off x="7406640" y="4023360"/>
-            <a:ext cx="1691640" cy="274320"/>
-          </a:xfrm>
-          <a:prstGeom prst="rect">
-            <a:avLst/>
-          </a:prstGeom>
-          <a:noFill/>
-          <a:ln/>
-        </p:spPr>
-        <p:txBody>
-          <a:bodyPr wrap="square" lIns="0" tIns="0" rIns="0" bIns="0" rtlCol="0" anchor="ctr"/>
-          <a:lstStyle/>
-          <a:p>
-            <a:pPr algn="l" indent="0" marL="0">
-              <a:buNone/>
-            </a:pPr>
-            <a:r>
-              <a:rPr lang="en-US" sz="1100" dirty="0">
-                <a:solidFill>
-                  <a:srgbClr val="475569"/>
-                </a:solidFill>
-                <a:latin typeface="Calibri" pitchFamily="34" charset="0"/>
-                <a:ea typeface="Calibri" pitchFamily="34" charset="-122"/>
-                <a:cs typeface="Calibri" pitchFamily="34" charset="-120"/>
-              </a:rPr>
-              <a:t>15 травня 2026   ·   Харків</a:t>
-            </a:r>
-            <a:endParaRPr lang="en-US" sz="1100" dirty="0"/>
-          </a:p>
-        </p:txBody>
-      </p:sp>
       <p:pic>
         <p:nvPicPr>
-          <p:cNvPr id="14" name="Image 1" descr="D:\repos\kb-semantic-search-benchmark\thesis\scripts\_logo_xnure.png">    </p:cNvPr>
+          <p:cNvPr id="17" name="Image 1" descr="D:\repos\kb-semantic-search-benchmark\thesis\scripts\_logo_kafedra.png">    </p:cNvPr>
           <p:cNvPicPr>
             <a:picLocks noChangeAspect="1"/>
           </p:cNvPicPr>
@@ -8307,8 +8405,8 @@
         </p:blipFill>
         <p:spPr>
           <a:xfrm>
-            <a:off x="411480" y="4686300"/>
-            <a:ext cx="1645920" cy="365760"/>
+            <a:off x="2331720" y="4704588"/>
+            <a:ext cx="1645920" cy="329184"/>
           </a:xfrm>
           <a:prstGeom prst="rect">
             <a:avLst/>
@@ -8317,7 +8415,7 @@
       </p:pic>
       <p:pic>
         <p:nvPicPr>
-          <p:cNvPr id="15" name="Image 2" descr="D:\repos\kb-semantic-search-benchmark\thesis\scripts\_logo_kafedra.png">    </p:cNvPr>
+          <p:cNvPr id="18" name="Image 2" descr="D:\repos\kb-semantic-search-benchmark\thesis\scripts\_logo_hex.png">    </p:cNvPr>
           <p:cNvPicPr>
             <a:picLocks noChangeAspect="1"/>
           </p:cNvPicPr>
@@ -8325,30 +8423,6 @@
         </p:nvPicPr>
         <p:blipFill>
           <a:blip r:embed="rId3"/>
-          <a:stretch>
-            <a:fillRect/>
-          </a:stretch>
-        </p:blipFill>
-        <p:spPr>
-          <a:xfrm>
-            <a:off x="2331720" y="4704588"/>
-            <a:ext cx="1645920" cy="329184"/>
-          </a:xfrm>
-          <a:prstGeom prst="rect">
-            <a:avLst/>
-          </a:prstGeom>
-        </p:spPr>
-      </p:pic>
-      <p:pic>
-        <p:nvPicPr>
-          <p:cNvPr id="16" name="Image 3" descr="D:\repos\kb-semantic-search-benchmark\thesis\scripts\_logo_hex.png">    </p:cNvPr>
-          <p:cNvPicPr>
-            <a:picLocks noChangeAspect="1"/>
-          </p:cNvPicPr>
-          <p:nvPr/>
-        </p:nvPicPr>
-        <p:blipFill>
-          <a:blip r:embed="rId4"/>
           <a:stretch>
             <a:fillRect/>
           </a:stretch>

</xml_diff>

<commit_message>
Add speaker notes to all 18 presentation slides
15-minute defense budget allocated per slide (25–70s each, total ~895s).
Each note begins with a ⏱ timing header and slide N/18 marker so the
student sees the time budget while reading in PowerPoint's notes pane.

Content covers: greeting, motivation, methodology, results with exact
numbers (nDCG values, 95% CI [0.606; 0.737] vs [0.431; 0.541], latency
trade-offs), Pareto analysis, and closing.

Co-Authored-By: Claude Opus 4.7 <noreply@anthropic.com>
</commit_message>
<xml_diff>
--- a/thesis/Nesterenko_Presentation.pptx
+++ b/thesis/Nesterenko_Presentation.pptx
@@ -5366,7 +5366,15 @@
           <a:bodyPr/>
           <a:lstStyle/>
           <a:p>
+            <a:r>
+              <a:t>⏱ ~25 сек  ·  слайд 1/18</a:t>
+            </a:r>
             <a:endParaRPr lang="en-US" dirty="0"/>
+          </a:p>
+          <a:p>
+            <a:r>
+              <a:t>Шановні члени екзаменаційної комісії, шановний головуючий! Вашій увазі представляється кваліфікаційна магістерська робота на тему «Дослідження моделей векторних ембеддінгів для семантичного пошуку текстових даних у корпоративних базах знань». Виконав здобувач групи ІПЗм-24-1 Нестеренко Віталій Вячеславович. Науковий керівник — кандидат технічних наук, доцент Русакова Наталія Євгенівна.</a:t>
+            </a:r>
           </a:p>
         </p:txBody>
       </p:sp>
@@ -5450,7 +5458,25 @@
           <a:bodyPr/>
           <a:lstStyle/>
           <a:p>
+            <a:r>
+              <a:t>⏱ ~35 сек  ·  слайд 10/18</a:t>
+            </a:r>
             <a:endParaRPr lang="en-US" dirty="0"/>
+          </a:p>
+          <a:p>
+            <a:r>
+              <a:t>Програмне забезпечення реалізоване на Python 3.11. Для ML-частини використано бібліотеки sentence-transformers, transformers від Hugging Face та PyTorch у CPU-режимі.</a:t>
+            </a:r>
+          </a:p>
+          <a:p>
+            <a:r>
+              <a:t>Для retrieval — бібліотеки FAISS з точним індексом IndexFlatIP та rank_bm25 для лексичної baseline. Дані зберігаються у форматі JSONL — це і чанки, і релевантність qrels.</a:t>
+            </a:r>
+          </a:p>
+          <a:p>
+            <a:r>
+              <a:t>Веб-частина побудована на Flask. Аналіз результатів виконано через NumPy, scikit-learn та власну реалізацію бутстреп-довірчих інтервалів. Версіонування — Git і GitHub.</a:t>
+            </a:r>
           </a:p>
         </p:txBody>
       </p:sp>
@@ -5534,7 +5560,30 @@
           <a:bodyPr/>
           <a:lstStyle/>
           <a:p>
+            <a:r>
+              <a:t>⏱ ~45 сек  ·  слайд 11/18</a:t>
+            </a:r>
             <a:endParaRPr lang="en-US" dirty="0"/>
+          </a:p>
+          <a:p>
+            <a:r>
+              <a:t>Власноруч сформовано україномовний benchmark з трьох предметних доменів. Усього — 32 документи, 300 запитів. Якорі релевантності — qrels — сформовано вручну.</a:t>
+            </a:r>
+          </a:p>
+          <a:p>
+            <a:r>
+              <a:t>Технічний домен: 10 документів з тематики програмної інженерії, машинного навчання, систем RAG, виявлення аномалій, 3D-друку та лідарних систем — 100 запитів.</a:t>
+            </a:r>
+          </a:p>
+          <a:p>
+            <a:r>
+              <a:t>Юридичний домен: 13 документів — кодекси України, нормативно-правові акти, законодавчі тексти — 100 запитів.</a:t>
+            </a:r>
+          </a:p>
+          <a:p>
+            <a:r>
+              <a:t>Медичний домен: 9 документів — клінічні протоколи та медичні рекомендації — 100 запитів. У кожному домені по 100 україномовних запитів з ручною розміткою релевантних чанків.</a:t>
+            </a:r>
           </a:p>
         </p:txBody>
       </p:sp>
@@ -5618,7 +5667,15 @@
           <a:bodyPr/>
           <a:lstStyle/>
           <a:p>
+            <a:r>
+              <a:t>⏱ ~30 сек  ·  слайд 12/18</a:t>
+            </a:r>
             <a:endParaRPr lang="en-US" dirty="0"/>
+          </a:p>
+          <a:p>
+            <a:r>
+              <a:t>Приклади запитів для ілюстрації характеру benchmark-у. У технічному домені — запити на кшталт «виявлення аномалій у фінансових транзакціях» чи «прогноз відтоку клієнтів». У юридичному — «з якого віку настає повна цивільна дієздатність» або «що входить до складу спадщини». У медичному — «будова та функції серця людини», «велике і мале коло кровообігу». Тобто реальні питання, які могли б ставити користувачі корпоративних інформаційних систем.</a:t>
+            </a:r>
           </a:p>
         </p:txBody>
       </p:sp>
@@ -5702,7 +5759,30 @@
           <a:bodyPr/>
           <a:lstStyle/>
           <a:p>
+            <a:r>
+              <a:t>⏱ ~70 сек  ·  слайд 13/18</a:t>
+            </a:r>
             <a:endParaRPr lang="en-US" dirty="0"/>
+          </a:p>
+          <a:p>
+            <a:r>
+              <a:t>Перейдемо до головних результатів експерименту. У таблиці — середнє значення nDCG@10 по всіх трьох доменах.</a:t>
+            </a:r>
+          </a:p>
+          <a:p>
+            <a:r>
+              <a:t>Перше місце посідає BGE-M3 з результатом 0.4708. Друге — Qwen3 з результатом 0.4385. Третє — E5-base з 0.4199. Четверте — лексична baseline BM25 з результатом 0.3319. На останньому місці — nomic з результатом 0.2128, що навіть нижче BM25.</a:t>
+            </a:r>
+          </a:p>
+          <a:p>
+            <a:r>
+              <a:t>Ключовий висновок: три з чотирьох embedding-моделей перевершують лексичну baseline BM25.</a:t>
+            </a:r>
+          </a:p>
+          <a:p>
+            <a:r>
+              <a:t>Достовірність підтверджена бутстреп-аналізом: 2000 повторних вибірок з поверненням. На технічному домені 95% довірчий інтервал для BGE-M3 склав від 0.606 до 0.737, а для BM25 — від 0.431 до 0.541. Інтервали не перетинаються, отже перевага семантичного пошуку над лексичним є статистично значущою.</a:t>
+            </a:r>
           </a:p>
         </p:txBody>
       </p:sp>
@@ -5786,7 +5866,20 @@
           <a:bodyPr/>
           <a:lstStyle/>
           <a:p>
+            <a:r>
+              <a:t>⏱ ~40 сек  ·  слайд 14/18</a:t>
+            </a:r>
             <a:endParaRPr lang="en-US" dirty="0"/>
+          </a:p>
+          <a:p>
+            <a:r>
+              <a:t>На цьому слайді — деталізовані метрики у розрізі трьох доменів. Чотири підграфіки відповідають чотирьом метрикам якості: nDCG@10, MRR@10, Recall@10 та Precision@10.</a:t>
+            </a:r>
+          </a:p>
+          <a:p>
+            <a:r>
+              <a:t>Видно, що лідерство BGE-M3 є послідовним за всіма чотирма метриками — це додатковий доказ робастності результату. На юридичному домені усі моделі демонструють нижчі значення — він обʼєктивно складніший для семантичного пошуку через формальний стиль текстів і вузькоспеціалізовану термінологію.</a:t>
+            </a:r>
           </a:p>
         </p:txBody>
       </p:sp>
@@ -5870,7 +5963,40 @@
           <a:bodyPr/>
           <a:lstStyle/>
           <a:p>
+            <a:r>
+              <a:t>⏱ ~60 сек  ·  слайд 15/18</a:t>
+            </a:r>
             <a:endParaRPr lang="en-US" dirty="0"/>
+          </a:p>
+          <a:p>
+            <a:r>
+              <a:t>Тепер — багатокритеріальний вибір моделі. Парето-оптимальна множина складається з трьох альтернатив: BGE-M3, E5-base та BM25. Тобто три з п'яти моделей не домінуються жодною іншою за всіма критеріями одночасно.</a:t>
+            </a:r>
+          </a:p>
+          <a:p>
+            <a:r>
+              <a:t>BGE-M3 — лідер у всіх трьох доменах за nDCG, MRR та Recall.</a:t>
+            </a:r>
+          </a:p>
+          <a:p>
+            <a:r>
+              <a:t>E5-base — швидка альтернатива: близько 70 мілісекунд на запит проти 228 мілісекунд у BGE-M3, тобто приблизно у три рази швидше при прийнятній якості.</a:t>
+            </a:r>
+          </a:p>
+          <a:p>
+            <a:r>
+              <a:t>Qwen3 виявився лідером на юридичному домені з nDCG 0.320, але приблизно у два рази повільніший.</a:t>
+            </a:r>
+          </a:p>
+          <a:p>
+            <a:r>
+              <a:t>Nomic — найслабші результати; в окремих доменах поступається навіть BM25 за якістю.</a:t>
+            </a:r>
+          </a:p>
+          <a:p>
+            <a:r>
+              <a:t>Діаграма знизу показує інтегральні оцінки U по трьох доменах, обчислені за лінійною згорткою з рівними вагами.</a:t>
+            </a:r>
           </a:p>
         </p:txBody>
       </p:sp>
@@ -5954,7 +6080,40 @@
           <a:bodyPr/>
           <a:lstStyle/>
           <a:p>
+            <a:r>
+              <a:t>⏱ ~70 сек  ·  слайд 16/18</a:t>
+            </a:r>
             <a:endParaRPr lang="en-US" dirty="0"/>
+          </a:p>
+          <a:p>
+            <a:r>
+              <a:t>На цьому графіку — компроміс між якістю та швидкодією на технічному домені. По осі X — час відповіді в мілісекундах, по осі Y — nDCG@10. Парето-фронт виділено пунктирною лінією.</a:t>
+            </a:r>
+          </a:p>
+          <a:p>
+            <a:r>
+              <a:t>BGE-M3 — Парето-оптимальна, лідер за якістю: nDCG 0.672, приблизно 228 мілісекунд на запит. Це основний вибір для впровадження.</a:t>
+            </a:r>
+          </a:p>
+          <a:p>
+            <a:r>
+              <a:t>E5-base — також Парето-оптимальна, sweet spot: близько 70 мілісекунд, тобто у три рази швидше за BGE-M3 при незначній втраті якості.</a:t>
+            </a:r>
+          </a:p>
+          <a:p>
+            <a:r>
+              <a:t>BM25 — Парето-оптимальна як baseline: менше 3 мілісекунд, але стеля якості — приблизно 0.49 nDCG.</a:t>
+            </a:r>
+          </a:p>
+          <a:p>
+            <a:r>
+              <a:t>Qwen3 — спеціалізована модель, домінується на технічному домені, але краща на юридичному.</a:t>
+            </a:r>
+          </a:p>
+          <a:p>
+            <a:r>
+              <a:t>Nomic — не рекомендується: повністю домінується іншими моделями, поступається BM25 за якістю при більших вимогах до ресурсів.</a:t>
+            </a:r>
           </a:p>
         </p:txBody>
       </p:sp>
@@ -6038,7 +6197,30 @@
           <a:bodyPr/>
           <a:lstStyle/>
           <a:p>
+            <a:r>
+              <a:t>⏱ ~40 сек  ·  слайд 17/18</a:t>
+            </a:r>
             <a:endParaRPr lang="en-US" dirty="0"/>
+          </a:p>
+          <a:p>
+            <a:r>
+              <a:t>Апробація результатів дослідження. Опубліковано дві наукові праці у співавторстві з науковим керівником.</a:t>
+            </a:r>
+          </a:p>
+          <a:p>
+            <a:r>
+              <a:t>Перша — стаття на 2-й Міжнародній науково-практичній конференції «Innovative Research in Science and Economy» 2026 року, де представлено benchmark-методологію та порівняння чотирьох моделей.</a:t>
+            </a:r>
+          </a:p>
+          <a:p>
+            <a:r>
+              <a:t>Друга — тези на 30-му Міжнародному молодіжному форумі «Радіоелектроніка та молодь у XXI столітті» в ХНУРЕ, де подано підхід до підвищення якості семантичного пошуку на основі контрастивно-навчених embedding-моделей.</a:t>
+            </a:r>
+          </a:p>
+          <a:p>
+            <a:r>
+              <a:t>Загалом — два виступи на міжнародних конференціях.</a:t>
+            </a:r>
           </a:p>
         </p:txBody>
       </p:sp>
@@ -6122,7 +6304,45 @@
           <a:bodyPr/>
           <a:lstStyle/>
           <a:p>
+            <a:r>
+              <a:t>⏱ ~60 сек  ·  слайд 18/18</a:t>
+            </a:r>
             <a:endParaRPr lang="en-US" dirty="0"/>
+          </a:p>
+          <a:p>
+            <a:r>
+              <a:t>Підсумовуючи: у роботі обґрунтовано доцільність застосування сучасних embedding-моделей для семантичного пошуку у корпоративних базах знань. Сформульовано практичні рекомендації щодо вибору моделі.</a:t>
+            </a:r>
+          </a:p>
+          <a:p>
+            <a:r>
+              <a:t>BGE-M3 — основна модель для впровадження: найкраща якість і стабільність у різних доменах.</a:t>
+            </a:r>
+          </a:p>
+          <a:p>
+            <a:r>
+              <a:t>E5-base — швидка альтернатива з прийнятною якістю та триразовою перевагою за швидкодією.</a:t>
+            </a:r>
+          </a:p>
+          <a:p>
+            <a:r>
+              <a:t>Qwen3 — оптимальний вибір для юридичних колекцій, де він демонструє найвищу якість.</a:t>
+            </a:r>
+          </a:p>
+          <a:p>
+            <a:r>
+              <a:t>BM25 — залишається конкурентним baseline у певних доменах і за дуже жорстких вимог до швидкості.</a:t>
+            </a:r>
+          </a:p>
+          <a:p>
+            <a:r>
+              <a:t>Усі задачі, поставлені в роботі, виконано. Мета досягнута.</a:t>
+            </a:r>
+          </a:p>
+          <a:p>
+            <a:r>
+              <a:t>Дякую за увагу! Готовий відповісти на запитання.</a:t>
+            </a:r>
           </a:p>
         </p:txBody>
       </p:sp>
@@ -6206,7 +6426,30 @@
           <a:bodyPr/>
           <a:lstStyle/>
           <a:p>
+            <a:r>
+              <a:t>⏱ ~70 сек  ·  слайд 2/18</a:t>
+            </a:r>
             <a:endParaRPr lang="en-US" dirty="0"/>
+          </a:p>
+          <a:p>
+            <a:r>
+              <a:t>Актуальність роботи зумовлена тим, що обсяги корпоративної текстової інформації стрімко зростають, а традиційний лексичний пошук — за ключовими словами — погано працює з синонімією, перефразуванням і мультимовним контентом. Сучасні моделі векторних ембеддінгів дозволяють шукати за змістом, а не за збігом слів.</a:t>
+            </a:r>
+          </a:p>
+          <a:p>
+            <a:r>
+              <a:t>Мета дослідження — визначити доцільність застосування сучасних embedding-моделей для підвищення ефективності семантичного пошуку у корпоративних базах знань шляхом порівняльного експериментального дослідження.</a:t>
+            </a:r>
+          </a:p>
+          <a:p>
+            <a:r>
+              <a:t>Об'єктом дослідження є процеси формування та використання векторних подань текстових даних у системах семантичного пошуку. Предметом — самі моделі векторних ембеддінгів для застосування в корпоративних базах знань.</a:t>
+            </a:r>
+          </a:p>
+          <a:p>
+            <a:r>
+              <a:t>Для досягнення мети поставлено шість задач: проаналізувати предметну галузь; здійснити огляд сучасних embedding-моделей; сформувати україномовний benchmark-набір; реалізувати систему пошуку; оцінити якість моделей за стандартними метриками; та обґрунтовано обрати оптимальну модель.</a:t>
+            </a:r>
           </a:p>
         </p:txBody>
       </p:sp>
@@ -6290,7 +6533,20 @@
           <a:bodyPr/>
           <a:lstStyle/>
           <a:p>
+            <a:r>
+              <a:t>⏱ ~60 сек  ·  слайд 3/18</a:t>
+            </a:r>
             <a:endParaRPr lang="en-US" dirty="0"/>
+          </a:p>
+          <a:p>
+            <a:r>
+              <a:t>Огляд літератури охоплює період з 2013 по 2025 рік — понад дванадцять років еволюції embedding-моделей. На таймлайні представлено ключові віхи: Word2Vec Міколова 2013 року заклав статистичні векторні подання; BERT 2018 року Девліна приніс контекстність через трансформери; Sentence-BERT 2019 року Реймерса оптимізував архітектуру під семантичну схожість речень. У 2022 році з'явилась модель E5 з контрастивним навчанням та мультимовністю. У 2024 році — BGE-M3 та nomic-embed, які підтримують довгий контекст до восьми тисяч токенів. І найновіша — Qwen3-Embedding 2025 року, побудована на декодерній архітектурі з підтримкою інструкцій.</a:t>
+            </a:r>
+          </a:p>
+          <a:p>
+            <a:r>
+              <a:t>Усього опрацьовано 29 наукових джерел. Виявлено дослідницьку прогалину: на момент виконання роботи відсутні порівняльні дослідження сучасних embedding-моделей саме на україномовних доменно-специфічних колекціях.</a:t>
+            </a:r>
           </a:p>
         </p:txBody>
       </p:sp>
@@ -6374,7 +6630,20 @@
           <a:bodyPr/>
           <a:lstStyle/>
           <a:p>
+            <a:r>
+              <a:t>⏱ ~50 сек  ·  слайд 4/18</a:t>
+            </a:r>
             <a:endParaRPr lang="en-US" dirty="0"/>
+          </a:p>
+          <a:p>
+            <a:r>
+              <a:t>З огляду на виявлену прогалину сформульовано постановку задачі. Просто застосувати сучасну embedding-модель недостатньо — необхідно обґрунтовано вибрати модель, яка забезпечує оптимальний баланс між якістю пошуку, швидкодією, вимогами до ресурсів, мовною підтримкою та типом колекції документів.</a:t>
+            </a:r>
+          </a:p>
+          <a:p>
+            <a:r>
+              <a:t>Очікувані результати роботи: перше — повноцінна система семантичного пошуку з підтримкою форматів PDF, DOCX, TXT та Markdown. Друге — власноруч сформований україномовний benchmark з трьох доменів. Третє — кількісне порівняння чотирьох embedding-моделей та лексичної baseline-моделі BM25. Четверте — багатокритеріальний вибір моделі за Парето-фронтом і лінійною згорткою. І п'яте — обґрунтовані практичні рекомендації для впровадження у виробничі системи.</a:t>
+            </a:r>
           </a:p>
         </p:txBody>
       </p:sp>
@@ -6458,7 +6727,40 @@
           <a:bodyPr/>
           <a:lstStyle/>
           <a:p>
+            <a:r>
+              <a:t>⏱ ~60 сек  ·  слайд 5/18</a:t>
+            </a:r>
             <a:endParaRPr lang="en-US" dirty="0"/>
+          </a:p>
+          <a:p>
+            <a:r>
+              <a:t>Для дослідження обрано чотири сучасні моделі векторних ембеддінгів.</a:t>
+            </a:r>
+          </a:p>
+          <a:p>
+            <a:r>
+              <a:t>Перша — BGE-M3 від BAAI: 568 мільйонів параметрів, контекстне вікно до 8192 токенів, енкодерна архітектура. Її особливість — три режими роботи: dense, sparse та multi-vector.</a:t>
+            </a:r>
+          </a:p>
+          <a:p>
+            <a:r>
+              <a:t>Друга — multilingual E5-base від intfloat: 278 мільйонів параметрів, контекст 512 токенів. Особливість — обов'язкові префікси query та passage перед текстом для запитів і документів.</a:t>
+            </a:r>
+          </a:p>
+          <a:p>
+            <a:r>
+              <a:t>Третя — nomic-embed v1.5: всього 137 мільйонів параметрів, але контекст до 8192 токенів і техніка Matryoshka representations, що дозволяє динамічно зменшувати розмірність вектора.</a:t>
+            </a:r>
+          </a:p>
+          <a:p>
+            <a:r>
+              <a:t>Четверта — Qwen3-Embedding-0.6B від Alibaba: 596 мільйонів параметрів, контекст 32768 токенів. На відміну від інших трьох, побудована на декодерній LLM-архітектурі та підтримує інструкції.</a:t>
+            </a:r>
+          </a:p>
+          <a:p>
+            <a:r>
+              <a:t>Як лексична baseline використано BM25.</a:t>
+            </a:r>
           </a:p>
         </p:txBody>
       </p:sp>
@@ -6542,7 +6844,20 @@
           <a:bodyPr/>
           <a:lstStyle/>
           <a:p>
+            <a:r>
+              <a:t>⏱ ~50 сек  ·  слайд 6/18</a:t>
+            </a:r>
             <a:endParaRPr lang="en-US" dirty="0"/>
+          </a:p>
+          <a:p>
+            <a:r>
+              <a:t>Методологія оцінювання базується на чотирьох метриках retrieval-якості, які є стандартом у сфері інформаційного пошуку: nDCG@10 — основна метрика якості ранжування; MRR@10 — позиція першого релевантного документа; Recall@10 — повнота пошуку; та Precision@10 — точність видачі. Окремо вимірюється швидкодія в мілісекундах на запит.</a:t>
+            </a:r>
+          </a:p>
+          <a:p>
+            <a:r>
+              <a:t>Для забезпечення достовірності результатів застосовано три методи аналізу. Перший — бутстреп-довірчі інтервали: 2000 повторних вибірок із поверненням, що дозволяє оцінити 95% довірчий інтервал для nDCG@10. Другий — Парето-домінування для виявлення недомінованих альтернатив. Третій — лінійна адитивна згортка для обчислення інтегральної оцінки корисності з ваговими коефіцієнтами критеріїв.</a:t>
+            </a:r>
           </a:p>
         </p:txBody>
       </p:sp>
@@ -6626,7 +6941,35 @@
           <a:bodyPr/>
           <a:lstStyle/>
           <a:p>
+            <a:r>
+              <a:t>⏱ ~60 сек  ·  слайд 7/18</a:t>
+            </a:r>
             <a:endParaRPr lang="en-US" dirty="0"/>
+          </a:p>
+          <a:p>
+            <a:r>
+              <a:t>Розгляну формули метрик детальніше. nDCG@k — нормалізована якість ранжування, обчислюється як DCG поділене на ідеальне DCG. Сама DCG враховує і факт релевантності, і позицію документа — кожен документ ділиться на логарифм його позиції плюс один.</a:t>
+            </a:r>
+          </a:p>
+          <a:p>
+            <a:r>
+              <a:t>MRR — це середнє значення оберненої позиції першого релевантного документа по всіх запитах. Якщо релевантний документ на першому місці — MRR дорівнює одиниці; на десятому — одній десятій.</a:t>
+            </a:r>
+          </a:p>
+          <a:p>
+            <a:r>
+              <a:t>Recall@k — частка релевантних документів, знайдених у топ-k результатів, серед усіх релевантних у колекції.</a:t>
+            </a:r>
+          </a:p>
+          <a:p>
+            <a:r>
+              <a:t>Precision@k — частка релевантних документів серед перших k результатів видачі.</a:t>
+            </a:r>
+          </a:p>
+          <a:p>
+            <a:r>
+              <a:t>Усі чотири метрики приймають значення від нуля до одиниці, і чим вище — тим краще.</a:t>
+            </a:r>
           </a:p>
         </p:txBody>
       </p:sp>
@@ -6710,7 +7053,30 @@
           <a:bodyPr/>
           <a:lstStyle/>
           <a:p>
+            <a:r>
+              <a:t>⏱ ~60 сек  ·  слайд 8/18</a:t>
+            </a:r>
             <a:endParaRPr lang="en-US" dirty="0"/>
+          </a:p>
+          <a:p>
+            <a:r>
+              <a:t>Багатокритеріальний вибір моделі реалізовано у три кроки.</a:t>
+            </a:r>
+          </a:p>
+          <a:p>
+            <a:r>
+              <a:t>Крок перший — Парето-домінування. Альтернатива є Парето-оптимальною, якщо не існує іншої альтернативи, яка домінує над нею за всіма критеріями одночасно. Це дозволяє відсіяти заздалегідь гірші варіанти.</a:t>
+            </a:r>
+          </a:p>
+          <a:p>
+            <a:r>
+              <a:t>Крок другий — нормалізація шкал. Критерії мають різні одиниці виміру: nDCG в межах від нуля до одиниці, а швидкодія в мілісекундах. Тому всі критерії приводяться до спільної шкали від нуля до одиниці з урахуванням напряму оптимізації — максимізувати чи мінімізувати.</a:t>
+            </a:r>
+          </a:p>
+          <a:p>
+            <a:r>
+              <a:t>Крок третій — лінійна адитивна згортка. Інтегральна оцінка корисності U від альтернативи дорівнює сумі добутків ваг на нормалізовані значення критеріїв. Сума ваг дорівнює одиниці. Користувач задає ваги залежно від своїх пріоритетів — наприклад, якість важливіша за швидкість або навпаки.</a:t>
+            </a:r>
           </a:p>
         </p:txBody>
       </p:sp>
@@ -6794,7 +7160,25 @@
           <a:bodyPr/>
           <a:lstStyle/>
           <a:p>
+            <a:r>
+              <a:t>⏱ ~50 сек  ·  слайд 9/18</a:t>
+            </a:r>
             <a:endParaRPr lang="en-US" dirty="0"/>
+          </a:p>
+          <a:p>
+            <a:r>
+              <a:t>Архітектура системи побудована у вигляді pipeline. На вході — документи у форматах PDF, DOCX, TXT або Markdown. Документи розбиваються на чанки приблизно по 600 слів з перекриттям, що зберігає контекстну зв'язність.</a:t>
+            </a:r>
+          </a:p>
+          <a:p>
+            <a:r>
+              <a:t>Далі кожен чанк перетворюється на вектор за допомогою однієї з чотирьох embedding-моделей. Вектори L2-нормалізуються та індексуються у FAISS — використовується точний індекс IndexFlatIP, який обчислює внутрішній добуток, що для нормалізованих векторів еквівалентне косинусній мірі.</a:t>
+            </a:r>
+          </a:p>
+          <a:p>
+            <a:r>
+              <a:t>Запит користувача проходить ту саму обробку, і за косинусною схожістю повертаються топ-K найрелевантніших чанків. Усе це обгорнуто у Flask веб-застосунок. Основні модулі — build_index, evaluate_benchmark, embedding_models та app.</a:t>
+            </a:r>
           </a:p>
         </p:txBody>
       </p:sp>

</xml_diff>